<commit_message>
Presentación: lámina 7 con el flujograma definitivo de la propuesta
Se integra fig_flujo_propuesta (suma de ramas, r=25, m=0,0703) a la izquierda
de la lámina, con el banco de SE, las viñetas y la ecuación de la suma a la
derecha; notas del orador actualizadas para narrar sobre el flujograma.
</commit_message>
<xml_diff>
--- a/docs/Tesis_Defensa_Presentacion.pptx
+++ b/docs/Tesis_Defensa_Presentacion.pptx
@@ -1750,7 +1750,7 @@
           <a:p>
             <a:r>
               <a:rPr lang="en-US" dirty="0"/>
-              <a:t>El corazón de la tesis: cinco elementos estructurantes (un disco + cuatro líneas de largo 2r+1). Las respuestas lineales se promedian y se SUMAN a la del disco: la suma acumula evidencia de ambas geometrías, el máximo solo elige una. Entre fuentes sí se toma el máximo, y la reconstrucción pondera con m.</a:t>
+              <a:t>El corazón de la tesis, leído sobre el flujograma: cinco elementos estructurantes (un disco + cuatro líneas de largo 2r+1) por fuente; las respuestas lineales se promedian y se SUMAN a la del disco — la suma acumula evidencia de ambas geometrías, el máximo solo elige una. Entre fuentes sí se toma el máximo, y la reconstrucción pondera con m. El PSO (caja punteada) calibra r y m.</a:t>
             </a:r>
             <a:endParaRPr lang="en-US" dirty="0"/>
           </a:p>
@@ -9449,7 +9449,7 @@
       </p:sp>
       <p:pic>
         <p:nvPicPr>
-          <p:cNvPr id="4" name="Image 0" descr="C:/Users/Usuario/Documents/unv/mastertesis/tesis_mciencias_datos/docs/figures/fig_cinco_se.png">    </p:cNvPr>
+          <p:cNvPr id="4" name="Image 0" descr="C:/Users/Usuario/Documents/unv/mastertesis/tesis_mciencias_datos/docs/figures/fig_flujo_propuesta.png">    </p:cNvPr>
           <p:cNvPicPr>
             <a:picLocks noChangeAspect="1"/>
           </p:cNvPicPr>
@@ -9463,8 +9463,8 @@
         </p:blipFill>
         <p:spPr>
           <a:xfrm>
-            <a:off x="1371600" y="841248"/>
-            <a:ext cx="6400800" cy="1280160"/>
+            <a:off x="411480" y="777240"/>
+            <a:ext cx="3246120" cy="4206240"/>
           </a:xfrm>
           <a:prstGeom prst="rect">
             <a:avLst/>
@@ -9473,7 +9473,7 @@
       </p:pic>
       <p:pic>
         <p:nvPicPr>
-          <p:cNvPr id="5" name="Image 1" descr="C:\Users\Usuario\AppData\Local\Temp\claude\C--Users-Usuario-Documents-unv-mastertesis\fa0a2acc-a0da-4701-a920-18b20c70d3b2\scratchpad\pptx_build/assets/f_lineas.png">    </p:cNvPr>
+          <p:cNvPr id="5" name="Image 1" descr="C:/Users/Usuario/Documents/unv/mastertesis/tesis_mciencias_datos/docs/figures/fig_cinco_se.png">    </p:cNvPr>
           <p:cNvPicPr>
             <a:picLocks noChangeAspect="1"/>
           </p:cNvPicPr>
@@ -9487,17 +9487,144 @@
         </p:blipFill>
         <p:spPr>
           <a:xfrm>
-            <a:off x="822960" y="2487168"/>
-            <a:ext cx="4937760" cy="535838"/>
+            <a:off x="3977640" y="868680"/>
+            <a:ext cx="4754880" cy="950976"/>
           </a:xfrm>
           <a:prstGeom prst="rect">
             <a:avLst/>
           </a:prstGeom>
         </p:spPr>
       </p:pic>
+      <p:sp>
+        <p:nvSpPr>
+          <p:cNvPr id="6" name="Text 2"/>
+          <p:cNvSpPr/>
+          <p:nvPr/>
+        </p:nvSpPr>
+        <p:spPr>
+          <a:xfrm>
+            <a:off x="3977640" y="2057400"/>
+            <a:ext cx="4754880" cy="2011680"/>
+          </a:xfrm>
+          <a:prstGeom prst="rect">
+            <a:avLst/>
+          </a:prstGeom>
+          <a:noFill/>
+          <a:ln/>
+        </p:spPr>
+        <p:txBody>
+          <a:bodyPr wrap="square" lIns="0" tIns="0" rIns="0" bIns="0" rtlCol="0" anchor="t"/>
+          <a:lstStyle/>
+          <a:p>
+            <a:pPr marL="177800" indent="-177800">
+              <a:spcAft>
+                <a:spcPts val="600"/>
+              </a:spcAft>
+              <a:buSzPct val="100000"/>
+              <a:buChar char="•"/>
+            </a:pPr>
+            <a:r>
+              <a:rPr lang="en-US" sz="1200" dirty="0">
+                <a:solidFill>
+                  <a:srgbClr val="1A1A1A"/>
+                </a:solidFill>
+                <a:latin typeface="Times New Roman" pitchFamily="34" charset="0"/>
+                <a:ea typeface="Times New Roman" pitchFamily="34" charset="-122"/>
+                <a:cs typeface="Times New Roman" pitchFamily="34" charset="-120"/>
+              </a:rPr>
+              <a:t>Una sola escala (sin cascada multiescala).</a:t>
+            </a:r>
+            <a:endParaRPr lang="en-US" sz="1200" dirty="0"/>
+          </a:p>
+          <a:p>
+            <a:pPr marL="177800" indent="-177800">
+              <a:spcAft>
+                <a:spcPts val="600"/>
+              </a:spcAft>
+              <a:buSzPct val="100000"/>
+              <a:buChar char="•"/>
+            </a:pPr>
+            <a:r>
+              <a:rPr lang="en-US" sz="1200" dirty="0">
+                <a:solidFill>
+                  <a:srgbClr val="1A1A1A"/>
+                </a:solidFill>
+                <a:latin typeface="Times New Roman" pitchFamily="34" charset="0"/>
+                <a:ea typeface="Times New Roman" pitchFamily="34" charset="-122"/>
+                <a:cs typeface="Times New Roman" pitchFamily="34" charset="-120"/>
+              </a:rPr>
+              <a:t>Promedio de las 4 orientaciones lineales (ec. 7) + respuesta del disco (ec. 8).</a:t>
+            </a:r>
+            <a:endParaRPr lang="en-US" sz="1200" dirty="0"/>
+          </a:p>
+          <a:p>
+            <a:pPr marL="177800" indent="-177800">
+              <a:spcAft>
+                <a:spcPts val="600"/>
+              </a:spcAft>
+              <a:buSzPct val="100000"/>
+              <a:buChar char="•"/>
+            </a:pPr>
+            <a:r>
+              <a:rPr lang="en-US" sz="1200" b="1" dirty="0">
+                <a:solidFill>
+                  <a:srgbClr val="1A1A1A"/>
+                </a:solidFill>
+                <a:latin typeface="Times New Roman" pitchFamily="34" charset="0"/>
+                <a:ea typeface="Times New Roman" pitchFamily="34" charset="-122"/>
+                <a:cs typeface="Times New Roman" pitchFamily="34" charset="-120"/>
+              </a:rPr>
+              <a:t>Novedad: suma de la rama lineal y la del disco (en lugar del máximo).</a:t>
+            </a:r>
+            <a:endParaRPr lang="en-US" sz="1200" dirty="0"/>
+          </a:p>
+          <a:p>
+            <a:pPr marL="177800" indent="-177800">
+              <a:spcAft>
+                <a:spcPts val="600"/>
+              </a:spcAft>
+              <a:buSzPct val="100000"/>
+              <a:buChar char="•"/>
+            </a:pPr>
+            <a:r>
+              <a:rPr lang="en-US" sz="1200" dirty="0">
+                <a:solidFill>
+                  <a:srgbClr val="1A1A1A"/>
+                </a:solidFill>
+                <a:latin typeface="Times New Roman" pitchFamily="34" charset="0"/>
+                <a:ea typeface="Times New Roman" pitchFamily="34" charset="-122"/>
+                <a:cs typeface="Times New Roman" pitchFamily="34" charset="-120"/>
+              </a:rPr>
+              <a:t>Máximo entre fuentes (ec. 10) y reconstrucción ponderada con m (ec. 11).</a:t>
+            </a:r>
+            <a:endParaRPr lang="en-US" sz="1200" dirty="0"/>
+          </a:p>
+          <a:p>
+            <a:pPr marL="177800" indent="-177800">
+              <a:spcAft>
+                <a:spcPts val="600"/>
+              </a:spcAft>
+              <a:buSzPct val="100000"/>
+              <a:buChar char="•"/>
+            </a:pPr>
+            <a:r>
+              <a:rPr lang="en-US" sz="1200" dirty="0">
+                <a:solidFill>
+                  <a:srgbClr val="1A1A1A"/>
+                </a:solidFill>
+                <a:latin typeface="Times New Roman" pitchFamily="34" charset="0"/>
+                <a:ea typeface="Times New Roman" pitchFamily="34" charset="-122"/>
+                <a:cs typeface="Times New Roman" pitchFamily="34" charset="-120"/>
+              </a:rPr>
+              <a:t>Esquema de Bala et al. (2024), trasladado del realce de fondo de ojo a la fusión VIS/IR.</a:t>
+            </a:r>
+            <a:endParaRPr lang="en-US" sz="1200" dirty="0"/>
+          </a:p>
+        </p:txBody>
+      </p:sp>
       <p:pic>
         <p:nvPicPr>
-          <p:cNvPr id="6" name="Image 2" descr="C:\Users\Usuario\AppData\Local\Temp\claude\C--Users-Usuario-Documents-unv-mastertesis\fa0a2acc-a0da-4701-a920-18b20c70d3b2\scratchpad\pptx_build/assets/f_suma.png">    </p:cNvPr>
+          <p:cNvPr id="7" name="Image 2" descr="C:\Users\Usuario\AppData\Local\Temp\claude\C--Users-Usuario-Documents-unv-mastertesis\fa0a2acc-a0da-4701-a920-18b20c70d3b2\scratchpad\pptx_build/assets/f_suma.png">    </p:cNvPr>
           <p:cNvPicPr>
             <a:picLocks noChangeAspect="1"/>
           </p:cNvPicPr>
@@ -9511,144 +9638,14 @@
         </p:blipFill>
         <p:spPr>
           <a:xfrm>
-            <a:off x="822960" y="3246120"/>
-            <a:ext cx="4937760" cy="359359"/>
+            <a:off x="4114800" y="4343400"/>
+            <a:ext cx="4480560" cy="326441"/>
           </a:xfrm>
           <a:prstGeom prst="rect">
             <a:avLst/>
           </a:prstGeom>
         </p:spPr>
       </p:pic>
-      <p:pic>
-        <p:nvPicPr>
-          <p:cNvPr id="7" name="Image 3" descr="C:\Users\Usuario\AppData\Local\Temp\claude\C--Users-Usuario-Documents-unv-mastertesis\fa0a2acc-a0da-4701-a920-18b20c70d3b2\scratchpad\pptx_build/assets/f_fusion.png">    </p:cNvPr>
-          <p:cNvPicPr>
-            <a:picLocks noChangeAspect="1"/>
-          </p:cNvPicPr>
-          <p:nvPr/>
-        </p:nvPicPr>
-        <p:blipFill>
-          <a:blip r:embed="rId4"/>
-          <a:stretch>
-            <a:fillRect/>
-          </a:stretch>
-        </p:blipFill>
-        <p:spPr>
-          <a:xfrm>
-            <a:off x="822960" y="3858768"/>
-            <a:ext cx="4937760" cy="440741"/>
-          </a:xfrm>
-          <a:prstGeom prst="rect">
-            <a:avLst/>
-          </a:prstGeom>
-        </p:spPr>
-      </p:pic>
-      <p:sp>
-        <p:nvSpPr>
-          <p:cNvPr id="8" name="Text 2"/>
-          <p:cNvSpPr/>
-          <p:nvPr/>
-        </p:nvSpPr>
-        <p:spPr>
-          <a:xfrm>
-            <a:off x="5989320" y="2487168"/>
-            <a:ext cx="2743200" cy="2286000"/>
-          </a:xfrm>
-          <a:prstGeom prst="rect">
-            <a:avLst/>
-          </a:prstGeom>
-          <a:noFill/>
-          <a:ln/>
-        </p:spPr>
-        <p:txBody>
-          <a:bodyPr wrap="square" lIns="0" tIns="0" rIns="0" bIns="0" rtlCol="0" anchor="t"/>
-          <a:lstStyle/>
-          <a:p>
-            <a:pPr marL="177800" indent="-177800">
-              <a:spcAft>
-                <a:spcPts val="500"/>
-              </a:spcAft>
-              <a:buSzPct val="100000"/>
-              <a:buChar char="•"/>
-            </a:pPr>
-            <a:r>
-              <a:rPr lang="en-US" sz="1150" dirty="0">
-                <a:solidFill>
-                  <a:srgbClr val="1A1A1A"/>
-                </a:solidFill>
-                <a:latin typeface="Times New Roman" pitchFamily="34" charset="0"/>
-                <a:ea typeface="Times New Roman" pitchFamily="34" charset="-122"/>
-                <a:cs typeface="Times New Roman" pitchFamily="34" charset="-120"/>
-              </a:rPr>
-              <a:t>Una sola escala (sin cascada multiescala).</a:t>
-            </a:r>
-            <a:endParaRPr lang="en-US" sz="1150" dirty="0"/>
-          </a:p>
-          <a:p>
-            <a:pPr marL="177800" indent="-177800">
-              <a:spcAft>
-                <a:spcPts val="500"/>
-              </a:spcAft>
-              <a:buSzPct val="100000"/>
-              <a:buChar char="•"/>
-            </a:pPr>
-            <a:r>
-              <a:rPr lang="en-US" sz="1150" dirty="0">
-                <a:solidFill>
-                  <a:srgbClr val="1A1A1A"/>
-                </a:solidFill>
-                <a:latin typeface="Times New Roman" pitchFamily="34" charset="0"/>
-                <a:ea typeface="Times New Roman" pitchFamily="34" charset="-122"/>
-                <a:cs typeface="Times New Roman" pitchFamily="34" charset="-120"/>
-              </a:rPr>
-              <a:t>Promedio de las 4 orientaciones lineales.</a:t>
-            </a:r>
-            <a:endParaRPr lang="en-US" sz="1150" dirty="0"/>
-          </a:p>
-          <a:p>
-            <a:pPr marL="177800" indent="-177800">
-              <a:spcAft>
-                <a:spcPts val="500"/>
-              </a:spcAft>
-              <a:buSzPct val="100000"/>
-              <a:buChar char="•"/>
-            </a:pPr>
-            <a:r>
-              <a:rPr lang="en-US" sz="1150" b="1" dirty="0">
-                <a:solidFill>
-                  <a:srgbClr val="1A1A1A"/>
-                </a:solidFill>
-                <a:latin typeface="Times New Roman" pitchFamily="34" charset="0"/>
-                <a:ea typeface="Times New Roman" pitchFamily="34" charset="-122"/>
-                <a:cs typeface="Times New Roman" pitchFamily="34" charset="-120"/>
-              </a:rPr>
-              <a:t>Novedad: suma de la rama lineal y la del disco (en lugar del máximo).</a:t>
-            </a:r>
-            <a:endParaRPr lang="en-US" sz="1150" dirty="0"/>
-          </a:p>
-          <a:p>
-            <a:pPr marL="177800" indent="-177800">
-              <a:spcAft>
-                <a:spcPts val="500"/>
-              </a:spcAft>
-              <a:buSzPct val="100000"/>
-              <a:buChar char="•"/>
-            </a:pPr>
-            <a:r>
-              <a:rPr lang="en-US" sz="1150" dirty="0">
-                <a:solidFill>
-                  <a:srgbClr val="1A1A1A"/>
-                </a:solidFill>
-                <a:latin typeface="Times New Roman" pitchFamily="34" charset="0"/>
-                <a:ea typeface="Times New Roman" pitchFamily="34" charset="-122"/>
-                <a:cs typeface="Times New Roman" pitchFamily="34" charset="-120"/>
-              </a:rPr>
-              <a:t>Esquema de Bala et al. (2024), trasladado del realce de fondo de ojo a la fusión VIS/IR.</a:t>
-            </a:r>
-            <a:endParaRPr lang="en-US" sz="1150" dirty="0"/>
-          </a:p>
-        </p:txBody>
-      </p:sp>
     </p:spTree>
   </p:cSld>
   <p:clrMapOvr>

</xml_diff>

<commit_message>
Presentación: unifica el redondeo con el libro (Nabf 0,585; Qabf 0,305)
La auditoría de figuras detectó que el deck redondeaba 0,5845->0,584 y
0,3045->0,304 (numpy half-even) mientras el libro y su Figura 9 muestran
0,585/0,305; se alinean las láminas 11, 12 y 14 con el libro.
</commit_message>
<xml_diff>
--- a/docs/Tesis_Defensa_Presentacion.pptx
+++ b/docs/Tesis_Defensa_Presentacion.pptx
@@ -5367,7 +5367,7 @@
                           <a:ea typeface="Times New Roman" pitchFamily="34" charset="-122"/>
                           <a:cs typeface="Times New Roman" pitchFamily="34" charset="-120"/>
                         </a:rPr>
-                        <a:t>0,304</a:t>
+                        <a:t>0,305</a:t>
                       </a:r>
                       <a:endParaRPr lang="en-US" sz="1200" dirty="0">
                         <a:latin typeface="Times New Roman" charset="0"/>
@@ -5432,7 +5432,7 @@
                           <a:ea typeface="Times New Roman" pitchFamily="34" charset="-122"/>
                           <a:cs typeface="Times New Roman" pitchFamily="34" charset="-120"/>
                         </a:rPr>
-                        <a:t>0,584</a:t>
+                        <a:t>0,585</a:t>
                       </a:r>
                       <a:endParaRPr lang="en-US" sz="1200" dirty="0">
                         <a:latin typeface="Times New Roman" charset="0"/>
@@ -6388,7 +6388,7 @@
                 <a:ea typeface="Times New Roman" pitchFamily="34" charset="-122"/>
                 <a:cs typeface="Times New Roman" pitchFamily="34" charset="-120"/>
               </a:rPr>
-              <a:t>Frente al Top-Hat clásico, la propuesta mejora en todas las métricas de calidad de fusión (Qabf 0,500 vs 0,304 · Nabf 0,041 vs 0,584 · SSIM 0,782 vs 0,578).</a:t>
+              <a:t>Frente al Top-Hat clásico, la propuesta mejora en todas las métricas de calidad de fusión (Qabf 0,500 vs 0,305 · Nabf 0,041 vs 0,585 · SSIM 0,782 vs 0,578).</a:t>
             </a:r>
             <a:endParaRPr lang="en-US" sz="1300" dirty="0"/>
           </a:p>
@@ -6855,7 +6855,7 @@
                 <a:ea typeface="Times New Roman" pitchFamily="34" charset="-122"/>
                 <a:cs typeface="Times New Roman" pitchFamily="34" charset="-120"/>
               </a:rPr>
-              <a:t>El banco disco + líneas con suma de ramas mejora SSIM (0,782 vs 0,578) y reduce Nabf (0,041 vs 0,584) frente al Top-Hat clásico, con significancia estadística (Wilcoxon–Holm).</a:t>
+              <a:t>El banco disco + líneas con suma de ramas mejora SSIM (0,782 vs 0,578) y reduce Nabf (0,041 vs 0,585) frente al Top-Hat clásico, con significancia estadística (Wilcoxon–Holm).</a:t>
             </a:r>
             <a:endParaRPr lang="en-US" sz="1250" dirty="0"/>
           </a:p>

</xml_diff>

<commit_message>
Integra la ablación de la función de aptitud en toda la documentación
- Libro (59 págs): nuevo cierre de la sección 5.6 con la Figura 11 (curva
  aptitud vs m, sin restricciones de rango) y la Tabla 12 (óptimos de F_apt
  y Fo sobre los 20 pares), con actualización de las listas de figuras y
  tablas; el texto explica el piso m*=0,30 en las 50 corridas, el óptimo
  trivial r=1 de Fo sobre la propuesta y la coincidencia del máximo real de
  Fo con nuestro óptimo (m~0,07), reforzando H2.
- Informe de avances (28 págs): nueva sección 12 con la curva y la Tabla 9;
  conclusiones renumeradas a 13; próximos pasos incluyen el experimento M3FD.
- Excel (11 hojas): hoja nueva Ablacion_Fo con los barridos y la comparativa.
- Presentación (18 láminas): lámina nueva tras la de PSO con la curva y la
  lectura del experimento, con notas del orador para la pregunta del tribunal.
</commit_message>
<xml_diff>
--- a/docs/Tesis_Defensa_Presentacion.pptx
+++ b/docs/Tesis_Defensa_Presentacion.pptx
@@ -22,9 +22,10 @@
     <p:sldId id="270" r:id="rId16"/>
     <p:sldId id="271" r:id="rId17"/>
     <p:sldId id="272" r:id="rId18"/>
+    <p:sldId id="273" r:id="rId19"/>
   </p:sldIdLst>
   <p:notesMasterIdLst>
-    <p:notesMasterId r:id="rId19"/>
+    <p:notesMasterId r:id="rId20"/>
   </p:notesMasterIdLst>
   <p:sldSz cx="9144000" cy="5143500"/>
   <p:notesSz cx="5143500" cy="9144000"/>
@@ -606,7 +607,7 @@
           <a:p>
             <a:r>
               <a:rPr lang="en-US" dirty="0"/>
-              <a:t>Escena representativa: la propuesta (recuadro rojo) integra la firma térmica de las personas con la textura de la casa y la vegetación, con menos halos y ruido que RP/DWT y más contraste local que el clásico.</a:t>
+              <a:t>Dos evaluaciones complementarias: calidad de imagen (TNO, sin referencia) y utilidad en tarea (LLVIP, con verdad de campo). En LLVIP solo cambian los píxeles de entrada; las etiquetas son las mismas, así el mAP aísla el efecto de la fusión.</a:t>
             </a:r>
             <a:endParaRPr lang="en-US" dirty="0"/>
           </a:p>
@@ -694,7 +695,7 @@
           <a:p>
             <a:r>
               <a:rPr lang="en-US" dirty="0"/>
-              <a:t>Negritas = mejor por columna. No hay método universalmente dominante: DTCWT lidera bordes por una milésima, RP la correlación, LP el contraste. El perfil de la propuesta es limpieza (Nabf) y estructura (SSIM), quedando segunda en el resto a distancias mínimas.</a:t>
+              <a:t>Escena representativa: la propuesta (recuadro rojo) integra la firma térmica de las personas con la textura de la casa y la vegetación, con menos halos y ruido que RP/DWT y más contraste local que el clásico.</a:t>
             </a:r>
             <a:endParaRPr lang="en-US" dirty="0"/>
           </a:p>
@@ -782,7 +783,7 @@
           <a:p>
             <a:r>
               <a:rPr lang="en-US" dirty="0"/>
-              <a:t>La evidencia estadística sostiene las ventajas donde la propuesta las reclama: limpieza y estructura, con significancia tras corregir por comparaciones múltiples. El ranking global es honesto: la propuesta no domina todo; domina su perfil.</a:t>
+              <a:t>Negritas = mejor por columna. No hay método universalmente dominante: DTCWT lidera bordes por una milésima, RP la correlación, LP el contraste. El perfil de la propuesta es limpieza (Nabf) y estructura (SSIM), quedando segunda en el resto a distancias mínimas.</a:t>
             </a:r>
             <a:endParaRPr lang="en-US" dirty="0"/>
           </a:p>
@@ -870,7 +871,7 @@
           <a:p>
             <a:r>
               <a:rPr lang="en-US" dirty="0"/>
-              <a:t>El hallazgo más matizado: fusionar aporta muchísimo frente al VIS, pero ninguna fusión supera al IR puro en esta tarea nocturna. Entre fusiones, las diferencias son pequeñas: la calidad de imagen no se traslada automáticamente al mAP.</a:t>
+              <a:t>La evidencia estadística sostiene las ventajas donde la propuesta las reclama: limpieza y estructura, con significancia tras corregir por comparaciones múltiples. El ranking global es honesto: la propuesta no domina todo; domina su perfil.</a:t>
             </a:r>
             <a:endParaRPr lang="en-US" dirty="0"/>
           </a:p>
@@ -958,7 +959,7 @@
           <a:p>
             <a:r>
               <a:rPr lang="en-US" dirty="0"/>
-              <a:t>H1 y H2 quedan sostenidas con evidencia estadística. H3 solo parcialmente: es el resultado más honesto del trabajo y anticipa la pregunta natural del tribunal — calidad de imagen y utilidad en tarea son criterios distintos.</a:t>
+              <a:t>El hallazgo más matizado: fusionar aporta muchísimo frente al VIS, pero ninguna fusión supera al IR puro en esta tarea nocturna. Entre fusiones, las diferencias son pequeñas: la calidad de imagen no se traslada automáticamente al mAP.</a:t>
             </a:r>
             <a:endParaRPr lang="en-US" dirty="0"/>
           </a:p>
@@ -1046,7 +1047,7 @@
           <a:p>
             <a:r>
               <a:rPr lang="en-US" dirty="0"/>
-              <a:t>Cinco conclusiones: método formulado, óptimo hallado, perfil de calidad validado, ventaja sobre el clásico demostrada, y la lección sobre calidad vs. tarea.</a:t>
+              <a:t>H1 y H2 quedan sostenidas con evidencia estadística. H3 solo parcialmente: es el resultado más honesto del trabajo y anticipa la pregunta natural del tribunal — calidad de imagen y utilidad en tarea son criterios distintos.</a:t>
             </a:r>
             <a:endParaRPr lang="en-US" dirty="0"/>
           </a:p>
@@ -1134,7 +1135,7 @@
           <a:p>
             <a:r>
               <a:rPr lang="en-US" dirty="0"/>
-              <a:t>Cerrar con la recomendación práctica: qué método elegir según el criterio operativo. Dejar claro que el pipeline completo es reproducible desde el repositorio.</a:t>
+              <a:t>Cinco conclusiones: método formulado, óptimo hallado, perfil de calidad validado, ventaja sobre el clásico demostrada, y la lección sobre calidad vs. tarea.</a:t>
             </a:r>
             <a:endParaRPr lang="en-US" dirty="0"/>
           </a:p>
@@ -1222,7 +1223,7 @@
           <a:p>
             <a:r>
               <a:rPr lang="en-US" dirty="0"/>
-              <a:t>Agradecer a la mesa y al orientador. Ofrecer el repositorio para cualquier verificación.</a:t>
+              <a:t>Cerrar con la recomendación práctica: qué método elegir según el criterio operativo. Dejar claro que el pipeline completo es reproducible desde el repositorio.</a:t>
             </a:r>
             <a:endParaRPr lang="en-US" dirty="0"/>
           </a:p>
@@ -1246,6 +1247,94 @@
             <a:fld id="{F7021451-1387-4CA6-816F-3879F97B5CBC}" type="slidenum">
               <a:rPr lang="en-US"/>
               <a:t>17</a:t>
+            </a:fld>
+            <a:endParaRPr lang="en-US"/>
+          </a:p>
+        </p:txBody>
+      </p:sp>
+    </p:spTree>
+    <p:extLst>
+      <p:ext uri="{BB962C8B-B14F-4D97-AF65-F5344CB8AC3E}">
+        <p14:creationId xmlns:p14="http://schemas.microsoft.com/office/powerpoint/2010/main" val="1024086991"/>
+      </p:ext>
+    </p:extLst>
+  </p:cSld>
+  <p:clrMapOvr>
+    <a:masterClrMapping/>
+  </p:clrMapOvr>
+</p:notes>
+</file>
+
+<file path=ppt/notesSlides/notesSlide18.xml><?xml version="1.0" encoding="utf-8"?>
+<p:notes xmlns:a="http://schemas.openxmlformats.org/drawingml/2006/main" xmlns:r="http://schemas.openxmlformats.org/officeDocument/2006/relationships" xmlns:p="http://schemas.openxmlformats.org/presentationml/2006/main">
+  <p:cSld>
+    <p:spTree>
+      <p:nvGrpSpPr>
+        <p:cNvPr id="1" name=""/>
+        <p:cNvGrpSpPr/>
+        <p:nvPr/>
+      </p:nvGrpSpPr>
+      <p:grpSpPr>
+        <a:xfrm>
+          <a:off x="0" y="0"/>
+          <a:ext cx="0" cy="0"/>
+          <a:chOff x="0" y="0"/>
+          <a:chExt cx="0" cy="0"/>
+        </a:xfrm>
+      </p:grpSpPr>
+      <p:sp>
+        <p:nvSpPr>
+          <p:cNvPr id="2" name="Slide Image Placeholder 1"/>
+          <p:cNvSpPr>
+            <a:spLocks noGrp="1" noRot="1" noChangeAspect="1"/>
+          </p:cNvSpPr>
+          <p:nvPr>
+            <p:ph type="sldImg"/>
+          </p:nvPr>
+        </p:nvSpPr>
+        <p:spPr/>
+      </p:sp>
+      <p:sp>
+        <p:nvSpPr>
+          <p:cNvPr id="3" name="Notes Placeholder 2"/>
+          <p:cNvSpPr>
+            <a:spLocks noGrp="1"/>
+          </p:cNvSpPr>
+          <p:nvPr>
+            <p:ph type="body" idx="1"/>
+          </p:nvPr>
+        </p:nvSpPr>
+        <p:spPr/>
+        <p:txBody>
+          <a:bodyPr/>
+          <a:lstStyle/>
+          <a:p>
+            <a:r>
+              <a:rPr lang="en-US" dirty="0"/>
+              <a:t>Agradecer a la mesa y al orientador. Ofrecer el repositorio para cualquier verificación.</a:t>
+            </a:r>
+            <a:endParaRPr lang="en-US" dirty="0"/>
+          </a:p>
+        </p:txBody>
+      </p:sp>
+      <p:sp>
+        <p:nvSpPr>
+          <p:cNvPr id="4" name="Slide Number Placeholder 3"/>
+          <p:cNvSpPr>
+            <a:spLocks noGrp="1"/>
+          </p:cNvSpPr>
+          <p:nvPr>
+            <p:ph type="sldNum" sz="quarter" idx="10"/>
+          </p:nvPr>
+        </p:nvSpPr>
+        <p:spPr/>
+        <p:txBody>
+          <a:bodyPr/>
+          <a:lstStyle/>
+          <a:p>
+            <a:fld id="{F7021451-1387-4CA6-816F-3879F97B5CBC}" type="slidenum">
+              <a:rPr lang="en-US"/>
+              <a:t>18</a:t>
             </a:fld>
             <a:endParaRPr lang="en-US"/>
           </a:p>
@@ -1926,7 +2015,7 @@
           <a:p>
             <a:r>
               <a:rPr lang="en-US" dirty="0"/>
-              <a:t>Dos evaluaciones complementarias: calidad de imagen (TNO, sin referencia) y utilidad en tarea (LLVIP, con verdad de campo). En LLVIP solo cambian los píxeles de entrada; las etiquetas son las mismas, así el mAP aísla el efecto de la fusión.</a:t>
+              <a:t>Respuesta a la pregunta del tribunal sobre la elección de la aptitud: repetimos el barrido con la fórmula del trabajo replicado. Resultado: su propio óptimo cae al piso del rango (m=0,30) y, sin restricciones, coincide con el nuestro (m≈0,07). La aptitud de fidelidad pura además apaga el banco de SE (r=1). La curva demuestra que ningún enjambre puede converger en [0,5-2]: es el paisaje, no la búsqueda.</a:t>
             </a:r>
             <a:endParaRPr lang="en-US" dirty="0"/>
           </a:p>
@@ -2666,7 +2755,7 @@
                 <a:ea typeface="Times New Roman" pitchFamily="34" charset="-122"/>
                 <a:cs typeface="Times New Roman" pitchFamily="34" charset="-120"/>
               </a:rPr>
-              <a:t>7. Resultados cualitativos</a:t>
+              <a:t>6. Diseño experimental</a:t>
             </a:r>
             <a:endParaRPr lang="en-US" sz="2300" dirty="0"/>
           </a:p>
@@ -2705,46 +2794,22 @@
                 <a:ea typeface="Times New Roman" pitchFamily="34" charset="-122"/>
                 <a:cs typeface="Times New Roman" pitchFamily="34" charset="-120"/>
               </a:rPr>
-              <a:t>10 / 17</a:t>
+              <a:t>10 / 18</a:t>
             </a:r>
             <a:endParaRPr lang="en-US" sz="900" dirty="0"/>
           </a:p>
         </p:txBody>
       </p:sp>
-      <p:pic>
-        <p:nvPicPr>
-          <p:cNvPr id="4" name="Image 0" descr="C:/Users/Usuario/Documents/unv/mastertesis/tesis_mciencias_datos/docs/figures/cualitativas/montaje_07.png">    </p:cNvPr>
-          <p:cNvPicPr>
-            <a:picLocks noChangeAspect="1"/>
-          </p:cNvPicPr>
+      <p:sp>
+        <p:nvSpPr>
+          <p:cNvPr id="4" name="Text 2"/>
+          <p:cNvSpPr/>
           <p:nvPr/>
-        </p:nvPicPr>
-        <p:blipFill>
-          <a:blip r:embed="rId1"/>
-          <a:stretch>
-            <a:fillRect/>
-          </a:stretch>
-        </p:blipFill>
+        </p:nvSpPr>
         <p:spPr>
           <a:xfrm>
-            <a:off x="1764792" y="777240"/>
-            <a:ext cx="5623560" cy="4005072"/>
-          </a:xfrm>
-          <a:prstGeom prst="rect">
-            <a:avLst/>
-          </a:prstGeom>
-        </p:spPr>
-      </p:pic>
-      <p:sp>
-        <p:nvSpPr>
-          <p:cNvPr id="5" name="Text 2"/>
-          <p:cNvSpPr/>
-          <p:nvPr/>
-        </p:nvSpPr>
-        <p:spPr>
-          <a:xfrm>
-            <a:off x="457200" y="4828032"/>
-            <a:ext cx="7680960" cy="274320"/>
+            <a:off x="457200" y="868680"/>
+            <a:ext cx="4023360" cy="274320"/>
           </a:xfrm>
           <a:prstGeom prst="rect">
             <a:avLst/>
@@ -2760,17 +2825,247 @@
               <a:buNone/>
             </a:pPr>
             <a:r>
-              <a:rPr lang="en-US" sz="1000" i="1" dirty="0">
-                <a:solidFill>
-                  <a:srgbClr val="666666"/>
-                </a:solidFill>
-                <a:latin typeface="Times New Roman" pitchFamily="34" charset="0"/>
-                <a:ea typeface="Times New Roman" pitchFamily="34" charset="-122"/>
-                <a:cs typeface="Times New Roman" pitchFamily="34" charset="-120"/>
-              </a:rPr>
-              <a:t>Los 20 montajes por escena están disponibles en el repositorio (docs/figures/cualitativas/).</a:t>
-            </a:r>
-            <a:endParaRPr lang="en-US" sz="1000" dirty="0"/>
+              <a:rPr lang="en-US" sz="1400" b="1" dirty="0">
+                <a:solidFill>
+                  <a:srgbClr val="8B1A1A"/>
+                </a:solidFill>
+                <a:latin typeface="Times New Roman" pitchFamily="34" charset="0"/>
+                <a:ea typeface="Times New Roman" pitchFamily="34" charset="-122"/>
+                <a:cs typeface="Times New Roman" pitchFamily="34" charset="-120"/>
+              </a:rPr>
+              <a:t>Benchmark de calidad</a:t>
+            </a:r>
+            <a:endParaRPr lang="en-US" sz="1400" dirty="0"/>
+          </a:p>
+        </p:txBody>
+      </p:sp>
+      <p:sp>
+        <p:nvSpPr>
+          <p:cNvPr id="5" name="Text 3"/>
+          <p:cNvSpPr/>
+          <p:nvPr/>
+        </p:nvSpPr>
+        <p:spPr>
+          <a:xfrm>
+            <a:off x="457200" y="1188720"/>
+            <a:ext cx="4023360" cy="3291840"/>
+          </a:xfrm>
+          <a:prstGeom prst="rect">
+            <a:avLst/>
+          </a:prstGeom>
+          <a:noFill/>
+          <a:ln/>
+        </p:spPr>
+        <p:txBody>
+          <a:bodyPr wrap="square" lIns="0" tIns="0" rIns="0" bIns="0" rtlCol="0" anchor="t"/>
+          <a:lstStyle/>
+          <a:p>
+            <a:pPr marL="177800" indent="-177800">
+              <a:spcAft>
+                <a:spcPts val="800"/>
+              </a:spcAft>
+              <a:buSzPct val="100000"/>
+              <a:buChar char="•"/>
+            </a:pPr>
+            <a:r>
+              <a:rPr lang="en-US" sz="1250" dirty="0">
+                <a:solidFill>
+                  <a:srgbClr val="1A1A1A"/>
+                </a:solidFill>
+                <a:latin typeface="Times New Roman" pitchFamily="34" charset="0"/>
+                <a:ea typeface="Times New Roman" pitchFamily="34" charset="-122"/>
+                <a:cs typeface="Times New Roman" pitchFamily="34" charset="-120"/>
+              </a:rPr>
+              <a:t>20 pares VIS/IR del dataset TNO (Toet, 2014).</a:t>
+            </a:r>
+            <a:endParaRPr lang="en-US" sz="1250" dirty="0"/>
+          </a:p>
+          <a:p>
+            <a:pPr marL="177800" indent="-177800">
+              <a:spcAft>
+                <a:spcPts val="800"/>
+              </a:spcAft>
+              <a:buSzPct val="100000"/>
+              <a:buChar char="•"/>
+            </a:pPr>
+            <a:r>
+              <a:rPr lang="en-US" sz="1250" dirty="0">
+                <a:solidFill>
+                  <a:srgbClr val="1A1A1A"/>
+                </a:solidFill>
+                <a:latin typeface="Times New Roman" pitchFamily="34" charset="0"/>
+                <a:ea typeface="Times New Roman" pitchFamily="34" charset="-122"/>
+                <a:cs typeface="Times New Roman" pitchFamily="34" charset="-120"/>
+              </a:rPr>
+              <a:t>7 métodos: LP, RP, DWT, DTCWT, CVT, Top-Hat clásico y Propuesta → 140 fusiones.</a:t>
+            </a:r>
+            <a:endParaRPr lang="en-US" sz="1250" dirty="0"/>
+          </a:p>
+          <a:p>
+            <a:pPr marL="177800" indent="-177800">
+              <a:spcAft>
+                <a:spcPts val="800"/>
+              </a:spcAft>
+              <a:buSzPct val="100000"/>
+              <a:buChar char="•"/>
+            </a:pPr>
+            <a:r>
+              <a:rPr lang="en-US" sz="1250" dirty="0">
+                <a:solidFill>
+                  <a:srgbClr val="1A1A1A"/>
+                </a:solidFill>
+                <a:latin typeface="Times New Roman" pitchFamily="34" charset="0"/>
+                <a:ea typeface="Times New Roman" pitchFamily="34" charset="-122"/>
+                <a:cs typeface="Times New Roman" pitchFamily="34" charset="-120"/>
+              </a:rPr>
+              <a:t>12 métricas sin referencia (+ 4 descriptivas del review de Singh et al., 2023).</a:t>
+            </a:r>
+            <a:endParaRPr lang="en-US" sz="1250" dirty="0"/>
+          </a:p>
+          <a:p>
+            <a:pPr marL="177800" indent="-177800">
+              <a:spcAft>
+                <a:spcPts val="800"/>
+              </a:spcAft>
+              <a:buSzPct val="100000"/>
+              <a:buChar char="•"/>
+            </a:pPr>
+            <a:r>
+              <a:rPr lang="en-US" sz="1250" dirty="0">
+                <a:solidFill>
+                  <a:srgbClr val="1A1A1A"/>
+                </a:solidFill>
+                <a:latin typeface="Times New Roman" pitchFamily="34" charset="0"/>
+                <a:ea typeface="Times New Roman" pitchFamily="34" charset="-122"/>
+                <a:cs typeface="Times New Roman" pitchFamily="34" charset="-120"/>
+              </a:rPr>
+              <a:t>Friedman global + Wilcoxon pareado con corrección de Holm (α = 0,05).</a:t>
+            </a:r>
+            <a:endParaRPr lang="en-US" sz="1250" dirty="0"/>
+          </a:p>
+        </p:txBody>
+      </p:sp>
+      <p:sp>
+        <p:nvSpPr>
+          <p:cNvPr id="6" name="Text 4"/>
+          <p:cNvSpPr/>
+          <p:nvPr/>
+        </p:nvSpPr>
+        <p:spPr>
+          <a:xfrm>
+            <a:off x="4846320" y="868680"/>
+            <a:ext cx="3840480" cy="274320"/>
+          </a:xfrm>
+          <a:prstGeom prst="rect">
+            <a:avLst/>
+          </a:prstGeom>
+          <a:noFill/>
+          <a:ln/>
+        </p:spPr>
+        <p:txBody>
+          <a:bodyPr wrap="square" lIns="0" tIns="0" rIns="0" bIns="0" rtlCol="0" anchor="ctr"/>
+          <a:lstStyle/>
+          <a:p>
+            <a:pPr indent="0" marL="0">
+              <a:buNone/>
+            </a:pPr>
+            <a:r>
+              <a:rPr lang="en-US" sz="1400" b="1" dirty="0">
+                <a:solidFill>
+                  <a:srgbClr val="8B1A1A"/>
+                </a:solidFill>
+                <a:latin typeface="Times New Roman" pitchFamily="34" charset="0"/>
+                <a:ea typeface="Times New Roman" pitchFamily="34" charset="-122"/>
+                <a:cs typeface="Times New Roman" pitchFamily="34" charset="-120"/>
+              </a:rPr>
+              <a:t>Evaluación orientada a tarea</a:t>
+            </a:r>
+            <a:endParaRPr lang="en-US" sz="1400" dirty="0"/>
+          </a:p>
+        </p:txBody>
+      </p:sp>
+      <p:sp>
+        <p:nvSpPr>
+          <p:cNvPr id="7" name="Text 5"/>
+          <p:cNvSpPr/>
+          <p:nvPr/>
+        </p:nvSpPr>
+        <p:spPr>
+          <a:xfrm>
+            <a:off x="4846320" y="1188720"/>
+            <a:ext cx="3840480" cy="3291840"/>
+          </a:xfrm>
+          <a:prstGeom prst="rect">
+            <a:avLst/>
+          </a:prstGeom>
+          <a:noFill/>
+          <a:ln/>
+        </p:spPr>
+        <p:txBody>
+          <a:bodyPr wrap="square" lIns="0" tIns="0" rIns="0" bIns="0" rtlCol="0" anchor="t"/>
+          <a:lstStyle/>
+          <a:p>
+            <a:pPr marL="177800" indent="-177800">
+              <a:spcAft>
+                <a:spcPts val="800"/>
+              </a:spcAft>
+              <a:buSzPct val="100000"/>
+              <a:buChar char="•"/>
+            </a:pPr>
+            <a:r>
+              <a:rPr lang="en-US" sz="1250" dirty="0">
+                <a:solidFill>
+                  <a:srgbClr val="1A1A1A"/>
+                </a:solidFill>
+                <a:latin typeface="Times New Roman" pitchFamily="34" charset="0"/>
+                <a:ea typeface="Times New Roman" pitchFamily="34" charset="-122"/>
+                <a:cs typeface="Times New Roman" pitchFamily="34" charset="-120"/>
+              </a:rPr>
+              <a:t>Dataset etiquetado LLVIP (peatones nocturnos): 2.000 imágenes de entrenamiento y 500 de validación.</a:t>
+            </a:r>
+            <a:endParaRPr lang="en-US" sz="1250" dirty="0"/>
+          </a:p>
+          <a:p>
+            <a:pPr marL="177800" indent="-177800">
+              <a:spcAft>
+                <a:spcPts val="800"/>
+              </a:spcAft>
+              <a:buSzPct val="100000"/>
+              <a:buChar char="•"/>
+            </a:pPr>
+            <a:r>
+              <a:rPr lang="en-US" sz="1250" dirty="0">
+                <a:solidFill>
+                  <a:srgbClr val="1A1A1A"/>
+                </a:solidFill>
+                <a:latin typeface="Times New Roman" pitchFamily="34" charset="0"/>
+                <a:ea typeface="Times New Roman" pitchFamily="34" charset="-122"/>
+                <a:cs typeface="Times New Roman" pitchFamily="34" charset="-120"/>
+              </a:rPr>
+              <a:t>YOLOv8n reentrenado por modalidad (40 épocas), 9 entradas: VIS, IR y las 7 fusiones.</a:t>
+            </a:r>
+            <a:endParaRPr lang="en-US" sz="1250" dirty="0"/>
+          </a:p>
+          <a:p>
+            <a:pPr marL="177800" indent="-177800">
+              <a:spcAft>
+                <a:spcPts val="800"/>
+              </a:spcAft>
+              <a:buSzPct val="100000"/>
+              <a:buChar char="•"/>
+            </a:pPr>
+            <a:r>
+              <a:rPr lang="en-US" sz="1250" dirty="0">
+                <a:solidFill>
+                  <a:srgbClr val="1A1A1A"/>
+                </a:solidFill>
+                <a:latin typeface="Times New Roman" pitchFamily="34" charset="0"/>
+                <a:ea typeface="Times New Roman" pitchFamily="34" charset="-122"/>
+                <a:cs typeface="Times New Roman" pitchFamily="34" charset="-120"/>
+              </a:rPr>
+              <a:t>Etiquetas idénticas entre modalidades: la diferencia de mAP aísla el efecto del método de fusión.</a:t>
+            </a:r>
+            <a:endParaRPr lang="en-US" sz="1250" dirty="0"/>
           </a:p>
         </p:txBody>
       </p:sp>
@@ -2839,7 +3134,7 @@
                 <a:ea typeface="Times New Roman" pitchFamily="34" charset="-122"/>
                 <a:cs typeface="Times New Roman" pitchFamily="34" charset="-120"/>
               </a:rPr>
-              <a:t>Resultados cuantitativos — medias sobre 20 pares</a:t>
+              <a:t>7. Resultados cualitativos</a:t>
             </a:r>
             <a:endParaRPr lang="en-US" sz="2300" dirty="0"/>
           </a:p>
@@ -2878,7 +3173,180 @@
                 <a:ea typeface="Times New Roman" pitchFamily="34" charset="-122"/>
                 <a:cs typeface="Times New Roman" pitchFamily="34" charset="-120"/>
               </a:rPr>
-              <a:t>11 / 17</a:t>
+              <a:t>11 / 18</a:t>
+            </a:r>
+            <a:endParaRPr lang="en-US" sz="900" dirty="0"/>
+          </a:p>
+        </p:txBody>
+      </p:sp>
+      <p:pic>
+        <p:nvPicPr>
+          <p:cNvPr id="4" name="Image 0" descr="C:/Users/Usuario/Documents/unv/mastertesis/tesis_mciencias_datos/docs/figures/cualitativas/montaje_07.png">    </p:cNvPr>
+          <p:cNvPicPr>
+            <a:picLocks noChangeAspect="1"/>
+          </p:cNvPicPr>
+          <p:nvPr/>
+        </p:nvPicPr>
+        <p:blipFill>
+          <a:blip r:embed="rId1"/>
+          <a:stretch>
+            <a:fillRect/>
+          </a:stretch>
+        </p:blipFill>
+        <p:spPr>
+          <a:xfrm>
+            <a:off x="1764792" y="777240"/>
+            <a:ext cx="5623560" cy="4005072"/>
+          </a:xfrm>
+          <a:prstGeom prst="rect">
+            <a:avLst/>
+          </a:prstGeom>
+        </p:spPr>
+      </p:pic>
+      <p:sp>
+        <p:nvSpPr>
+          <p:cNvPr id="5" name="Text 2"/>
+          <p:cNvSpPr/>
+          <p:nvPr/>
+        </p:nvSpPr>
+        <p:spPr>
+          <a:xfrm>
+            <a:off x="457200" y="4828032"/>
+            <a:ext cx="7680960" cy="274320"/>
+          </a:xfrm>
+          <a:prstGeom prst="rect">
+            <a:avLst/>
+          </a:prstGeom>
+          <a:noFill/>
+          <a:ln/>
+        </p:spPr>
+        <p:txBody>
+          <a:bodyPr wrap="square" lIns="0" tIns="0" rIns="0" bIns="0" rtlCol="0" anchor="ctr"/>
+          <a:lstStyle/>
+          <a:p>
+            <a:pPr indent="0" marL="0">
+              <a:buNone/>
+            </a:pPr>
+            <a:r>
+              <a:rPr lang="en-US" sz="1000" i="1" dirty="0">
+                <a:solidFill>
+                  <a:srgbClr val="666666"/>
+                </a:solidFill>
+                <a:latin typeface="Times New Roman" pitchFamily="34" charset="0"/>
+                <a:ea typeface="Times New Roman" pitchFamily="34" charset="-122"/>
+                <a:cs typeface="Times New Roman" pitchFamily="34" charset="-120"/>
+              </a:rPr>
+              <a:t>Los 20 montajes por escena están disponibles en el repositorio (docs/figures/cualitativas/).</a:t>
+            </a:r>
+            <a:endParaRPr lang="en-US" sz="1000" dirty="0"/>
+          </a:p>
+        </p:txBody>
+      </p:sp>
+    </p:spTree>
+  </p:cSld>
+  <p:clrMapOvr>
+    <a:masterClrMapping/>
+  </p:clrMapOvr>
+</p:sld>
+</file>
+
+<file path=ppt/slides/slide12.xml><?xml version="1.0" encoding="utf-8"?>
+<p:sld xmlns:a="http://schemas.openxmlformats.org/drawingml/2006/main" xmlns:r="http://schemas.openxmlformats.org/officeDocument/2006/relationships" xmlns:p="http://schemas.openxmlformats.org/presentationml/2006/main">
+  <p:cSld name="Slide 12">
+    <p:bg>
+      <p:bgPr>
+        <a:solidFill>
+          <a:srgbClr val="FFFFFF"/>
+        </a:solidFill>
+      </p:bgPr>
+    </p:bg>
+    <p:spTree>
+      <p:nvGrpSpPr>
+        <p:cNvPr id="1" name=""/>
+        <p:cNvGrpSpPr/>
+        <p:nvPr/>
+      </p:nvGrpSpPr>
+      <p:grpSpPr>
+        <a:xfrm>
+          <a:off x="0" y="0"/>
+          <a:ext cx="0" cy="0"/>
+          <a:chOff x="0" y="0"/>
+          <a:chExt cx="0" cy="0"/>
+        </a:xfrm>
+      </p:grpSpPr>
+      <p:sp>
+        <p:nvSpPr>
+          <p:cNvPr id="2" name="Text 0"/>
+          <p:cNvSpPr/>
+          <p:nvPr/>
+        </p:nvSpPr>
+        <p:spPr>
+          <a:xfrm>
+            <a:off x="457200" y="256032"/>
+            <a:ext cx="8229600" cy="502920"/>
+          </a:xfrm>
+          <a:prstGeom prst="rect">
+            <a:avLst/>
+          </a:prstGeom>
+          <a:noFill/>
+          <a:ln/>
+        </p:spPr>
+        <p:txBody>
+          <a:bodyPr wrap="square" lIns="0" tIns="0" rIns="0" bIns="0" rtlCol="0" anchor="ctr"/>
+          <a:lstStyle/>
+          <a:p>
+            <a:pPr indent="0" marL="0">
+              <a:buNone/>
+            </a:pPr>
+            <a:r>
+              <a:rPr lang="en-US" sz="2300" b="1" dirty="0">
+                <a:solidFill>
+                  <a:srgbClr val="1A1A1A"/>
+                </a:solidFill>
+                <a:latin typeface="Times New Roman" pitchFamily="34" charset="0"/>
+                <a:ea typeface="Times New Roman" pitchFamily="34" charset="-122"/>
+                <a:cs typeface="Times New Roman" pitchFamily="34" charset="-120"/>
+              </a:rPr>
+              <a:t>Resultados cuantitativos — medias sobre 20 pares</a:t>
+            </a:r>
+            <a:endParaRPr lang="en-US" sz="2300" dirty="0"/>
+          </a:p>
+        </p:txBody>
+      </p:sp>
+      <p:sp>
+        <p:nvSpPr>
+          <p:cNvPr id="3" name="Text 1"/>
+          <p:cNvSpPr/>
+          <p:nvPr/>
+        </p:nvSpPr>
+        <p:spPr>
+          <a:xfrm>
+            <a:off x="8229600" y="4828032"/>
+            <a:ext cx="685800" cy="274320"/>
+          </a:xfrm>
+          <a:prstGeom prst="rect">
+            <a:avLst/>
+          </a:prstGeom>
+          <a:noFill/>
+          <a:ln/>
+        </p:spPr>
+        <p:txBody>
+          <a:bodyPr wrap="square" lIns="0" tIns="0" rIns="0" bIns="0" rtlCol="0" anchor="ctr"/>
+          <a:lstStyle/>
+          <a:p>
+            <a:pPr algn="r" indent="0" marL="0">
+              <a:buNone/>
+            </a:pPr>
+            <a:r>
+              <a:rPr lang="en-US" sz="900" dirty="0">
+                <a:solidFill>
+                  <a:srgbClr val="666666"/>
+                </a:solidFill>
+                <a:latin typeface="Times New Roman" pitchFamily="34" charset="0"/>
+                <a:ea typeface="Times New Roman" pitchFamily="34" charset="-122"/>
+                <a:cs typeface="Times New Roman" pitchFamily="34" charset="-120"/>
+              </a:rPr>
+              <a:t>12 / 18</a:t>
             </a:r>
             <a:endParaRPr lang="en-US" sz="900" dirty="0"/>
           </a:p>
@@ -2886,7 +3354,7 @@
       </p:sp>
       <p:graphicFrame>
         <p:nvGraphicFramePr>
-          <p:cNvPr id="12" name="Table 0"/>
+          <p:cNvPr id="13" name="Table 0"/>
           <p:cNvGraphicFramePr>
             <a:graphicFrameLocks noGrp="1"/>
           </p:cNvGraphicFramePr>
@@ -6144,285 +6612,6 @@
 </p:sld>
 </file>
 
-<file path=ppt/slides/slide12.xml><?xml version="1.0" encoding="utf-8"?>
-<p:sld xmlns:a="http://schemas.openxmlformats.org/drawingml/2006/main" xmlns:r="http://schemas.openxmlformats.org/officeDocument/2006/relationships" xmlns:p="http://schemas.openxmlformats.org/presentationml/2006/main">
-  <p:cSld name="Slide 12">
-    <p:bg>
-      <p:bgPr>
-        <a:solidFill>
-          <a:srgbClr val="FFFFFF"/>
-        </a:solidFill>
-      </p:bgPr>
-    </p:bg>
-    <p:spTree>
-      <p:nvGrpSpPr>
-        <p:cNvPr id="1" name=""/>
-        <p:cNvGrpSpPr/>
-        <p:nvPr/>
-      </p:nvGrpSpPr>
-      <p:grpSpPr>
-        <a:xfrm>
-          <a:off x="0" y="0"/>
-          <a:ext cx="0" cy="0"/>
-          <a:chOff x="0" y="0"/>
-          <a:chExt cx="0" cy="0"/>
-        </a:xfrm>
-      </p:grpSpPr>
-      <p:sp>
-        <p:nvSpPr>
-          <p:cNvPr id="2" name="Text 0"/>
-          <p:cNvSpPr/>
-          <p:nvPr/>
-        </p:nvSpPr>
-        <p:spPr>
-          <a:xfrm>
-            <a:off x="457200" y="256032"/>
-            <a:ext cx="8229600" cy="502920"/>
-          </a:xfrm>
-          <a:prstGeom prst="rect">
-            <a:avLst/>
-          </a:prstGeom>
-          <a:noFill/>
-          <a:ln/>
-        </p:spPr>
-        <p:txBody>
-          <a:bodyPr wrap="square" lIns="0" tIns="0" rIns="0" bIns="0" rtlCol="0" anchor="ctr"/>
-          <a:lstStyle/>
-          <a:p>
-            <a:pPr indent="0" marL="0">
-              <a:buNone/>
-            </a:pPr>
-            <a:r>
-              <a:rPr lang="en-US" sz="2300" b="1" dirty="0">
-                <a:solidFill>
-                  <a:srgbClr val="1A1A1A"/>
-                </a:solidFill>
-                <a:latin typeface="Times New Roman" pitchFamily="34" charset="0"/>
-                <a:ea typeface="Times New Roman" pitchFamily="34" charset="-122"/>
-                <a:cs typeface="Times New Roman" pitchFamily="34" charset="-120"/>
-              </a:rPr>
-              <a:t>Análisis estadístico</a:t>
-            </a:r>
-            <a:endParaRPr lang="en-US" sz="2300" dirty="0"/>
-          </a:p>
-        </p:txBody>
-      </p:sp>
-      <p:sp>
-        <p:nvSpPr>
-          <p:cNvPr id="3" name="Text 1"/>
-          <p:cNvSpPr/>
-          <p:nvPr/>
-        </p:nvSpPr>
-        <p:spPr>
-          <a:xfrm>
-            <a:off x="8229600" y="4828032"/>
-            <a:ext cx="685800" cy="274320"/>
-          </a:xfrm>
-          <a:prstGeom prst="rect">
-            <a:avLst/>
-          </a:prstGeom>
-          <a:noFill/>
-          <a:ln/>
-        </p:spPr>
-        <p:txBody>
-          <a:bodyPr wrap="square" lIns="0" tIns="0" rIns="0" bIns="0" rtlCol="0" anchor="ctr"/>
-          <a:lstStyle/>
-          <a:p>
-            <a:pPr algn="r" indent="0" marL="0">
-              <a:buNone/>
-            </a:pPr>
-            <a:r>
-              <a:rPr lang="en-US" sz="900" dirty="0">
-                <a:solidFill>
-                  <a:srgbClr val="666666"/>
-                </a:solidFill>
-                <a:latin typeface="Times New Roman" pitchFamily="34" charset="0"/>
-                <a:ea typeface="Times New Roman" pitchFamily="34" charset="-122"/>
-                <a:cs typeface="Times New Roman" pitchFamily="34" charset="-120"/>
-              </a:rPr>
-              <a:t>12 / 17</a:t>
-            </a:r>
-            <a:endParaRPr lang="en-US" sz="900" dirty="0"/>
-          </a:p>
-        </p:txBody>
-      </p:sp>
-      <p:sp>
-        <p:nvSpPr>
-          <p:cNvPr id="4" name="Text 2"/>
-          <p:cNvSpPr/>
-          <p:nvPr/>
-        </p:nvSpPr>
-        <p:spPr>
-          <a:xfrm>
-            <a:off x="457200" y="914400"/>
-            <a:ext cx="8229600" cy="3931920"/>
-          </a:xfrm>
-          <a:prstGeom prst="rect">
-            <a:avLst/>
-          </a:prstGeom>
-          <a:noFill/>
-          <a:ln/>
-        </p:spPr>
-        <p:txBody>
-          <a:bodyPr wrap="square" lIns="0" tIns="0" rIns="0" bIns="0" rtlCol="0" anchor="t"/>
-          <a:lstStyle/>
-          <a:p>
-            <a:pPr marL="177800" indent="-177800">
-              <a:spcAft>
-                <a:spcPts val="900"/>
-              </a:spcAft>
-              <a:buSzPct val="100000"/>
-              <a:buChar char="•"/>
-            </a:pPr>
-            <a:r>
-              <a:rPr lang="en-US" sz="1300" b="1" dirty="0">
-                <a:solidFill>
-                  <a:srgbClr val="1A1A1A"/>
-                </a:solidFill>
-                <a:latin typeface="Times New Roman" pitchFamily="34" charset="0"/>
-                <a:ea typeface="Times New Roman" pitchFamily="34" charset="-122"/>
-                <a:cs typeface="Times New Roman" pitchFamily="34" charset="-120"/>
-              </a:rPr>
-              <a:t>Friedman: diferencias significativas en las 12 métricas (p &lt; 0,05).</a:t>
-            </a:r>
-            <a:endParaRPr lang="en-US" sz="1300" dirty="0"/>
-          </a:p>
-          <a:p>
-            <a:pPr marL="177800" indent="-177800">
-              <a:spcAft>
-                <a:spcPts val="900"/>
-              </a:spcAft>
-              <a:buSzPct val="100000"/>
-              <a:buChar char="•"/>
-            </a:pPr>
-            <a:r>
-              <a:rPr lang="en-US" sz="1300" dirty="0">
-                <a:solidFill>
-                  <a:srgbClr val="1A1A1A"/>
-                </a:solidFill>
-                <a:latin typeface="Times New Roman" pitchFamily="34" charset="0"/>
-                <a:ea typeface="Times New Roman" pitchFamily="34" charset="-122"/>
-                <a:cs typeface="Times New Roman" pitchFamily="34" charset="-120"/>
-              </a:rPr>
-              <a:t>Wilcoxon pareado (corrección de Holm), Propuesta vs. los 5 métodos del estado del arte:</a:t>
-            </a:r>
-            <a:endParaRPr lang="en-US" sz="1300" dirty="0"/>
-          </a:p>
-          <a:p>
-            <a:pPr lvl="1" marL="304800" indent="-152400">
-              <a:spcAft>
-                <a:spcPts val="900"/>
-              </a:spcAft>
-              <a:buSzPct val="100000"/>
-              <a:buChar char="–"/>
-            </a:pPr>
-            <a:r>
-              <a:rPr lang="en-US" sz="1300" dirty="0">
-                <a:solidFill>
-                  <a:srgbClr val="1A1A1A"/>
-                </a:solidFill>
-                <a:latin typeface="Times New Roman" pitchFamily="34" charset="0"/>
-                <a:ea typeface="Times New Roman" pitchFamily="34" charset="-122"/>
-                <a:cs typeface="Times New Roman" pitchFamily="34" charset="-120"/>
-              </a:rPr>
-              <a:t>Nabf: mejor y significativa frente a los 5 rivales.</a:t>
-            </a:r>
-            <a:endParaRPr lang="en-US" sz="1300" dirty="0"/>
-          </a:p>
-          <a:p>
-            <a:pPr lvl="1" marL="304800" indent="-152400">
-              <a:spcAft>
-                <a:spcPts val="900"/>
-              </a:spcAft>
-              <a:buSzPct val="100000"/>
-              <a:buChar char="–"/>
-            </a:pPr>
-            <a:r>
-              <a:rPr lang="en-US" sz="1300" dirty="0">
-                <a:solidFill>
-                  <a:srgbClr val="1A1A1A"/>
-                </a:solidFill>
-                <a:latin typeface="Times New Roman" pitchFamily="34" charset="0"/>
-                <a:ea typeface="Times New Roman" pitchFamily="34" charset="-122"/>
-                <a:cs typeface="Times New Roman" pitchFamily="34" charset="-120"/>
-              </a:rPr>
-              <a:t>SSIM: mejor y significativa frente a los 5 rivales.</a:t>
-            </a:r>
-            <a:endParaRPr lang="en-US" sz="1300" dirty="0"/>
-          </a:p>
-          <a:p>
-            <a:pPr lvl="1" marL="304800" indent="-152400">
-              <a:spcAft>
-                <a:spcPts val="900"/>
-              </a:spcAft>
-              <a:buSzPct val="100000"/>
-              <a:buChar char="–"/>
-            </a:pPr>
-            <a:r>
-              <a:rPr lang="en-US" sz="1300" dirty="0">
-                <a:solidFill>
-                  <a:srgbClr val="1A1A1A"/>
-                </a:solidFill>
-                <a:latin typeface="Times New Roman" pitchFamily="34" charset="0"/>
-                <a:ea typeface="Times New Roman" pitchFamily="34" charset="-122"/>
-                <a:cs typeface="Times New Roman" pitchFamily="34" charset="-120"/>
-              </a:rPr>
-              <a:t>SCD y VIF: mejor y significativa frente a 3 de 5; Qabf frente a 2 de 5.</a:t>
-            </a:r>
-            <a:endParaRPr lang="en-US" sz="1300" dirty="0"/>
-          </a:p>
-          <a:p>
-            <a:pPr marL="177800" indent="-177800">
-              <a:spcAft>
-                <a:spcPts val="900"/>
-              </a:spcAft>
-              <a:buSzPct val="100000"/>
-              <a:buChar char="•"/>
-            </a:pPr>
-            <a:r>
-              <a:rPr lang="en-US" sz="1300" dirty="0">
-                <a:solidFill>
-                  <a:srgbClr val="1A1A1A"/>
-                </a:solidFill>
-                <a:latin typeface="Times New Roman" pitchFamily="34" charset="0"/>
-                <a:ea typeface="Times New Roman" pitchFamily="34" charset="-122"/>
-                <a:cs typeface="Times New Roman" pitchFamily="34" charset="-120"/>
-              </a:rPr>
-              <a:t>Frente al Top-Hat clásico, la propuesta mejora en todas las métricas de calidad de fusión (Qabf 0,500 vs 0,305 · Nabf 0,041 vs 0,585 · SSIM 0,782 vs 0,578).</a:t>
-            </a:r>
-            <a:endParaRPr lang="en-US" sz="1300" dirty="0"/>
-          </a:p>
-          <a:p>
-            <a:pPr marL="177800" indent="-177800">
-              <a:spcAft>
-                <a:spcPts val="900"/>
-              </a:spcAft>
-              <a:buSzPct val="100000"/>
-              <a:buChar char="•"/>
-            </a:pPr>
-            <a:r>
-              <a:rPr lang="en-US" sz="1300" dirty="0">
-                <a:solidFill>
-                  <a:srgbClr val="1A1A1A"/>
-                </a:solidFill>
-                <a:latin typeface="Times New Roman" pitchFamily="34" charset="0"/>
-                <a:ea typeface="Times New Roman" pitchFamily="34" charset="-122"/>
-                <a:cs typeface="Times New Roman" pitchFamily="34" charset="-120"/>
-              </a:rPr>
-              <a:t>Ranking global (12 métricas): LP 3,17 · RP 3,50 · DTCWT 3,58 · Propuesta 3,92 · TH clásico 4,17 · DWT 4,75 · CVT 4,92 — óptimos de criterios distintos y complementarios.</a:t>
-            </a:r>
-            <a:endParaRPr lang="en-US" sz="1300" dirty="0"/>
-          </a:p>
-        </p:txBody>
-      </p:sp>
-    </p:spTree>
-  </p:cSld>
-  <p:clrMapOvr>
-    <a:masterClrMapping/>
-  </p:clrMapOvr>
-</p:sld>
-</file>
-
 <file path=ppt/slides/slide13.xml><?xml version="1.0" encoding="utf-8"?>
 <p:sld xmlns:a="http://schemas.openxmlformats.org/drawingml/2006/main" xmlns:r="http://schemas.openxmlformats.org/officeDocument/2006/relationships" xmlns:p="http://schemas.openxmlformats.org/presentationml/2006/main">
   <p:cSld name="Slide 13">
@@ -6480,7 +6669,7 @@
                 <a:ea typeface="Times New Roman" pitchFamily="34" charset="-122"/>
                 <a:cs typeface="Times New Roman" pitchFamily="34" charset="-120"/>
               </a:rPr>
-              <a:t>8. Detección en LLVIP — mAP@0,5</a:t>
+              <a:t>Análisis estadístico</a:t>
             </a:r>
             <a:endParaRPr lang="en-US" sz="2300" dirty="0"/>
           </a:p>
@@ -6519,46 +6708,22 @@
                 <a:ea typeface="Times New Roman" pitchFamily="34" charset="-122"/>
                 <a:cs typeface="Times New Roman" pitchFamily="34" charset="-120"/>
               </a:rPr>
-              <a:t>13 / 17</a:t>
+              <a:t>13 / 18</a:t>
             </a:r>
             <a:endParaRPr lang="en-US" sz="900" dirty="0"/>
           </a:p>
         </p:txBody>
       </p:sp>
-      <p:pic>
-        <p:nvPicPr>
-          <p:cNvPr id="4" name="Image 0" descr="C:\Users\Usuario\AppData\Local\Temp\claude\C--Users-Usuario-Documents-unv-mastertesis\fa0a2acc-a0da-4701-a920-18b20c70d3b2\scratchpad\pptx_build/assets/map_llvip.png">    </p:cNvPr>
-          <p:cNvPicPr>
-            <a:picLocks noChangeAspect="1"/>
-          </p:cNvPicPr>
+      <p:sp>
+        <p:nvSpPr>
+          <p:cNvPr id="4" name="Text 2"/>
+          <p:cNvSpPr/>
           <p:nvPr/>
-        </p:nvPicPr>
-        <p:blipFill>
-          <a:blip r:embed="rId1"/>
-          <a:stretch>
-            <a:fillRect/>
-          </a:stretch>
-        </p:blipFill>
+        </p:nvSpPr>
         <p:spPr>
           <a:xfrm>
-            <a:off x="1179576" y="822960"/>
-            <a:ext cx="6766560" cy="3099816"/>
-          </a:xfrm>
-          <a:prstGeom prst="rect">
-            <a:avLst/>
-          </a:prstGeom>
-        </p:spPr>
-      </p:pic>
-      <p:sp>
-        <p:nvSpPr>
-          <p:cNvPr id="5" name="Text 2"/>
-          <p:cNvSpPr/>
-          <p:nvPr/>
-        </p:nvSpPr>
-        <p:spPr>
-          <a:xfrm>
-            <a:off x="457200" y="4023360"/>
-            <a:ext cx="8229600" cy="1005840"/>
+            <a:off x="457200" y="914400"/>
+            <a:ext cx="8229600" cy="3931920"/>
           </a:xfrm>
           <a:prstGeom prst="rect">
             <a:avLst/>
@@ -6572,13 +6737,13 @@
           <a:p>
             <a:pPr marL="177800" indent="-177800">
               <a:spcAft>
-                <a:spcPts val="400"/>
+                <a:spcPts val="900"/>
               </a:spcAft>
               <a:buSzPct val="100000"/>
               <a:buChar char="•"/>
             </a:pPr>
             <a:r>
-              <a:rPr lang="en-US" sz="1200" dirty="0">
+              <a:rPr lang="en-US" sz="1300" b="1" dirty="0">
                 <a:solidFill>
                   <a:srgbClr val="1A1A1A"/>
                 </a:solidFill>
@@ -6586,20 +6751,20 @@
                 <a:ea typeface="Times New Roman" pitchFamily="34" charset="-122"/>
                 <a:cs typeface="Times New Roman" pitchFamily="34" charset="-120"/>
               </a:rPr>
-              <a:t>Toda fusión supera con claridad al visible solo (+0,12 a +0,14 en mAP@0,5).</a:t>
-            </a:r>
-            <a:endParaRPr lang="en-US" sz="1200" dirty="0"/>
+              <a:t>Friedman: diferencias significativas en las 12 métricas (p &lt; 0,05).</a:t>
+            </a:r>
+            <a:endParaRPr lang="en-US" sz="1300" dirty="0"/>
           </a:p>
           <a:p>
             <a:pPr marL="177800" indent="-177800">
               <a:spcAft>
-                <a:spcPts val="400"/>
+                <a:spcPts val="900"/>
               </a:spcAft>
               <a:buSzPct val="100000"/>
               <a:buChar char="•"/>
             </a:pPr>
             <a:r>
-              <a:rPr lang="en-US" sz="1200" dirty="0">
+              <a:rPr lang="en-US" sz="1300" dirty="0">
                 <a:solidFill>
                   <a:srgbClr val="1A1A1A"/>
                 </a:solidFill>
@@ -6607,20 +6772,83 @@
                 <a:ea typeface="Times New Roman" pitchFamily="34" charset="-122"/>
                 <a:cs typeface="Times New Roman" pitchFamily="34" charset="-120"/>
               </a:rPr>
-              <a:t>El infrarrojo solo lidera (0,957): en peatones nocturnos la firma térmica domina.</a:t>
-            </a:r>
-            <a:endParaRPr lang="en-US" sz="1200" dirty="0"/>
+              <a:t>Wilcoxon pareado (corrección de Holm), Propuesta vs. los 5 métodos del estado del arte:</a:t>
+            </a:r>
+            <a:endParaRPr lang="en-US" sz="1300" dirty="0"/>
+          </a:p>
+          <a:p>
+            <a:pPr lvl="1" marL="304800" indent="-152400">
+              <a:spcAft>
+                <a:spcPts val="900"/>
+              </a:spcAft>
+              <a:buSzPct val="100000"/>
+              <a:buChar char="–"/>
+            </a:pPr>
+            <a:r>
+              <a:rPr lang="en-US" sz="1300" dirty="0">
+                <a:solidFill>
+                  <a:srgbClr val="1A1A1A"/>
+                </a:solidFill>
+                <a:latin typeface="Times New Roman" pitchFamily="34" charset="0"/>
+                <a:ea typeface="Times New Roman" pitchFamily="34" charset="-122"/>
+                <a:cs typeface="Times New Roman" pitchFamily="34" charset="-120"/>
+              </a:rPr>
+              <a:t>Nabf: mejor y significativa frente a los 5 rivales.</a:t>
+            </a:r>
+            <a:endParaRPr lang="en-US" sz="1300" dirty="0"/>
+          </a:p>
+          <a:p>
+            <a:pPr lvl="1" marL="304800" indent="-152400">
+              <a:spcAft>
+                <a:spcPts val="900"/>
+              </a:spcAft>
+              <a:buSzPct val="100000"/>
+              <a:buChar char="–"/>
+            </a:pPr>
+            <a:r>
+              <a:rPr lang="en-US" sz="1300" dirty="0">
+                <a:solidFill>
+                  <a:srgbClr val="1A1A1A"/>
+                </a:solidFill>
+                <a:latin typeface="Times New Roman" pitchFamily="34" charset="0"/>
+                <a:ea typeface="Times New Roman" pitchFamily="34" charset="-122"/>
+                <a:cs typeface="Times New Roman" pitchFamily="34" charset="-120"/>
+              </a:rPr>
+              <a:t>SSIM: mejor y significativa frente a los 5 rivales.</a:t>
+            </a:r>
+            <a:endParaRPr lang="en-US" sz="1300" dirty="0"/>
+          </a:p>
+          <a:p>
+            <a:pPr lvl="1" marL="304800" indent="-152400">
+              <a:spcAft>
+                <a:spcPts val="900"/>
+              </a:spcAft>
+              <a:buSzPct val="100000"/>
+              <a:buChar char="–"/>
+            </a:pPr>
+            <a:r>
+              <a:rPr lang="en-US" sz="1300" dirty="0">
+                <a:solidFill>
+                  <a:srgbClr val="1A1A1A"/>
+                </a:solidFill>
+                <a:latin typeface="Times New Roman" pitchFamily="34" charset="0"/>
+                <a:ea typeface="Times New Roman" pitchFamily="34" charset="-122"/>
+                <a:cs typeface="Times New Roman" pitchFamily="34" charset="-120"/>
+              </a:rPr>
+              <a:t>SCD y VIF: mejor y significativa frente a 3 de 5; Qabf frente a 2 de 5.</a:t>
+            </a:r>
+            <a:endParaRPr lang="en-US" sz="1300" dirty="0"/>
           </a:p>
           <a:p>
             <a:pPr marL="177800" indent="-177800">
               <a:spcAft>
-                <a:spcPts val="400"/>
+                <a:spcPts val="900"/>
               </a:spcAft>
               <a:buSzPct val="100000"/>
               <a:buChar char="•"/>
             </a:pPr>
             <a:r>
-              <a:rPr lang="en-US" sz="1200" dirty="0">
+              <a:rPr lang="en-US" sz="1300" dirty="0">
                 <a:solidFill>
                   <a:srgbClr val="1A1A1A"/>
                 </a:solidFill>
@@ -6628,9 +6856,30 @@
                 <a:ea typeface="Times New Roman" pitchFamily="34" charset="-122"/>
                 <a:cs typeface="Times New Roman" pitchFamily="34" charset="-120"/>
               </a:rPr>
-              <a:t>Entre las 7 fusiones la banda es estrecha (0,926–0,949); la propuesta es competitiva (0,936), pareja con el clásico (0,938).</a:t>
-            </a:r>
-            <a:endParaRPr lang="en-US" sz="1200" dirty="0"/>
+              <a:t>Frente al Top-Hat clásico, la propuesta mejora en todas las métricas de calidad de fusión (Qabf 0,500 vs 0,305 · Nabf 0,041 vs 0,585 · SSIM 0,782 vs 0,578).</a:t>
+            </a:r>
+            <a:endParaRPr lang="en-US" sz="1300" dirty="0"/>
+          </a:p>
+          <a:p>
+            <a:pPr marL="177800" indent="-177800">
+              <a:spcAft>
+                <a:spcPts val="900"/>
+              </a:spcAft>
+              <a:buSzPct val="100000"/>
+              <a:buChar char="•"/>
+            </a:pPr>
+            <a:r>
+              <a:rPr lang="en-US" sz="1300" dirty="0">
+                <a:solidFill>
+                  <a:srgbClr val="1A1A1A"/>
+                </a:solidFill>
+                <a:latin typeface="Times New Roman" pitchFamily="34" charset="0"/>
+                <a:ea typeface="Times New Roman" pitchFamily="34" charset="-122"/>
+                <a:cs typeface="Times New Roman" pitchFamily="34" charset="-120"/>
+              </a:rPr>
+              <a:t>Ranking global (12 métricas): LP 3,17 · RP 3,50 · DTCWT 3,58 · Propuesta 3,92 · TH clásico 4,17 · DWT 4,75 · CVT 4,92 — óptimos de criterios distintos y complementarios.</a:t>
+            </a:r>
+            <a:endParaRPr lang="en-US" sz="1300" dirty="0"/>
           </a:p>
         </p:txBody>
       </p:sp>
@@ -6699,7 +6948,7 @@
                 <a:ea typeface="Times New Roman" pitchFamily="34" charset="-122"/>
                 <a:cs typeface="Times New Roman" pitchFamily="34" charset="-120"/>
               </a:rPr>
-              <a:t>Contraste de hipótesis</a:t>
+              <a:t>8. Detección en LLVIP — mAP@0,5</a:t>
             </a:r>
             <a:endParaRPr lang="en-US" sz="2300" dirty="0"/>
           </a:p>
@@ -6738,22 +6987,46 @@
                 <a:ea typeface="Times New Roman" pitchFamily="34" charset="-122"/>
                 <a:cs typeface="Times New Roman" pitchFamily="34" charset="-120"/>
               </a:rPr>
-              <a:t>14 / 17</a:t>
+              <a:t>14 / 18</a:t>
             </a:r>
             <a:endParaRPr lang="en-US" sz="900" dirty="0"/>
           </a:p>
         </p:txBody>
       </p:sp>
-      <p:sp>
-        <p:nvSpPr>
-          <p:cNvPr id="4" name="Text 2"/>
+      <p:pic>
+        <p:nvPicPr>
+          <p:cNvPr id="4" name="Image 0" descr="C:\Users\Usuario\AppData\Local\Temp\claude\C--Users-Usuario-Documents-unv-mastertesis\fa0a2acc-a0da-4701-a920-18b20c70d3b2\scratchpad\pptx_build/assets/map_llvip.png">    </p:cNvPr>
+          <p:cNvPicPr>
+            <a:picLocks noChangeAspect="1"/>
+          </p:cNvPicPr>
+          <p:nvPr/>
+        </p:nvPicPr>
+        <p:blipFill>
+          <a:blip r:embed="rId1"/>
+          <a:stretch>
+            <a:fillRect/>
+          </a:stretch>
+        </p:blipFill>
+        <p:spPr>
+          <a:xfrm>
+            <a:off x="1179576" y="822960"/>
+            <a:ext cx="6766560" cy="3099816"/>
+          </a:xfrm>
+          <a:prstGeom prst="rect">
+            <a:avLst/>
+          </a:prstGeom>
+        </p:spPr>
+      </p:pic>
+      <p:sp>
+        <p:nvSpPr>
+          <p:cNvPr id="5" name="Text 2"/>
           <p:cNvSpPr/>
           <p:nvPr/>
         </p:nvSpPr>
         <p:spPr>
           <a:xfrm>
-            <a:off x="457200" y="960120"/>
-            <a:ext cx="640080" cy="411480"/>
+            <a:off x="457200" y="4023360"/>
+            <a:ext cx="8229600" cy="1005840"/>
           </a:xfrm>
           <a:prstGeom prst="rect">
             <a:avLst/>
@@ -6762,14 +7035,18 @@
           <a:ln/>
         </p:spPr>
         <p:txBody>
-          <a:bodyPr wrap="square" lIns="0" tIns="0" rIns="0" bIns="0" rtlCol="0" anchor="ctr"/>
-          <a:lstStyle/>
-          <a:p>
-            <a:pPr indent="0" marL="0">
-              <a:buNone/>
-            </a:pPr>
-            <a:r>
-              <a:rPr lang="en-US" sz="1900" b="1" dirty="0">
+          <a:bodyPr wrap="square" lIns="0" tIns="0" rIns="0" bIns="0" rtlCol="0" anchor="t"/>
+          <a:lstStyle/>
+          <a:p>
+            <a:pPr marL="177800" indent="-177800">
+              <a:spcAft>
+                <a:spcPts val="400"/>
+              </a:spcAft>
+              <a:buSzPct val="100000"/>
+              <a:buChar char="•"/>
+            </a:pPr>
+            <a:r>
+              <a:rPr lang="en-US" sz="1200" dirty="0">
                 <a:solidFill>
                   <a:srgbClr val="1A1A1A"/>
                 </a:solidFill>
@@ -6777,77 +7054,20 @@
                 <a:ea typeface="Times New Roman" pitchFamily="34" charset="-122"/>
                 <a:cs typeface="Times New Roman" pitchFamily="34" charset="-120"/>
               </a:rPr>
-              <a:t>H1</a:t>
-            </a:r>
-            <a:endParaRPr lang="en-US" sz="1900" dirty="0"/>
-          </a:p>
-        </p:txBody>
-      </p:sp>
-      <p:sp>
-        <p:nvSpPr>
-          <p:cNvPr id="5" name="Text 3"/>
-          <p:cNvSpPr/>
-          <p:nvPr/>
-        </p:nvSpPr>
-        <p:spPr>
-          <a:xfrm>
-            <a:off x="1143000" y="996696"/>
-            <a:ext cx="1417320" cy="365760"/>
-          </a:xfrm>
-          <a:prstGeom prst="rect">
-            <a:avLst/>
-          </a:prstGeom>
-          <a:noFill/>
-          <a:ln/>
-        </p:spPr>
-        <p:txBody>
-          <a:bodyPr wrap="square" lIns="0" tIns="0" rIns="0" bIns="0" rtlCol="0" anchor="ctr"/>
-          <a:lstStyle/>
-          <a:p>
-            <a:pPr indent="0" marL="0">
-              <a:buNone/>
-            </a:pPr>
-            <a:r>
-              <a:rPr lang="en-US" sz="1300" b="1" dirty="0">
-                <a:solidFill>
-                  <a:srgbClr val="1F5C2E"/>
-                </a:solidFill>
-                <a:latin typeface="Times New Roman" pitchFamily="34" charset="0"/>
-                <a:ea typeface="Times New Roman" pitchFamily="34" charset="-122"/>
-                <a:cs typeface="Times New Roman" pitchFamily="34" charset="-120"/>
-              </a:rPr>
-              <a:t>SOSTENIDA</a:t>
-            </a:r>
-            <a:endParaRPr lang="en-US" sz="1300" dirty="0"/>
-          </a:p>
-        </p:txBody>
-      </p:sp>
-      <p:sp>
-        <p:nvSpPr>
-          <p:cNvPr id="6" name="Text 4"/>
-          <p:cNvSpPr/>
-          <p:nvPr/>
-        </p:nvSpPr>
-        <p:spPr>
-          <a:xfrm>
-            <a:off x="2697480" y="960120"/>
-            <a:ext cx="5989320" cy="1143000"/>
-          </a:xfrm>
-          <a:prstGeom prst="rect">
-            <a:avLst/>
-          </a:prstGeom>
-          <a:noFill/>
-          <a:ln/>
-        </p:spPr>
-        <p:txBody>
-          <a:bodyPr wrap="square" lIns="0" tIns="0" rIns="0" bIns="0" rtlCol="0" anchor="t"/>
-          <a:lstStyle/>
-          <a:p>
-            <a:pPr indent="0" marL="0">
-              <a:buNone/>
-            </a:pPr>
-            <a:r>
-              <a:rPr lang="en-US" sz="1250" dirty="0">
+              <a:t>Toda fusión supera con claridad al visible solo (+0,12 a +0,14 en mAP@0,5).</a:t>
+            </a:r>
+            <a:endParaRPr lang="en-US" sz="1200" dirty="0"/>
+          </a:p>
+          <a:p>
+            <a:pPr marL="177800" indent="-177800">
+              <a:spcAft>
+                <a:spcPts val="400"/>
+              </a:spcAft>
+              <a:buSzPct val="100000"/>
+              <a:buChar char="•"/>
+            </a:pPr>
+            <a:r>
+              <a:rPr lang="en-US" sz="1200" dirty="0">
                 <a:solidFill>
                   <a:srgbClr val="1A1A1A"/>
                 </a:solidFill>
@@ -6855,38 +7075,20 @@
                 <a:ea typeface="Times New Roman" pitchFamily="34" charset="-122"/>
                 <a:cs typeface="Times New Roman" pitchFamily="34" charset="-120"/>
               </a:rPr>
-              <a:t>El banco disco + líneas con suma de ramas mejora SSIM (0,782 vs 0,578) y reduce Nabf (0,041 vs 0,585) frente al Top-Hat clásico, con significancia estadística (Wilcoxon–Holm).</a:t>
-            </a:r>
-            <a:endParaRPr lang="en-US" sz="1250" dirty="0"/>
-          </a:p>
-        </p:txBody>
-      </p:sp>
-      <p:sp>
-        <p:nvSpPr>
-          <p:cNvPr id="7" name="Text 5"/>
-          <p:cNvSpPr/>
-          <p:nvPr/>
-        </p:nvSpPr>
-        <p:spPr>
-          <a:xfrm>
-            <a:off x="457200" y="2258568"/>
-            <a:ext cx="640080" cy="411480"/>
-          </a:xfrm>
-          <a:prstGeom prst="rect">
-            <a:avLst/>
-          </a:prstGeom>
-          <a:noFill/>
-          <a:ln/>
-        </p:spPr>
-        <p:txBody>
-          <a:bodyPr wrap="square" lIns="0" tIns="0" rIns="0" bIns="0" rtlCol="0" anchor="ctr"/>
-          <a:lstStyle/>
-          <a:p>
-            <a:pPr indent="0" marL="0">
-              <a:buNone/>
-            </a:pPr>
-            <a:r>
-              <a:rPr lang="en-US" sz="1900" b="1" dirty="0">
+              <a:t>El infrarrojo solo lidera (0,957): en peatones nocturnos la firma térmica domina.</a:t>
+            </a:r>
+            <a:endParaRPr lang="en-US" sz="1200" dirty="0"/>
+          </a:p>
+          <a:p>
+            <a:pPr marL="177800" indent="-177800">
+              <a:spcAft>
+                <a:spcPts val="400"/>
+              </a:spcAft>
+              <a:buSzPct val="100000"/>
+              <a:buChar char="•"/>
+            </a:pPr>
+            <a:r>
+              <a:rPr lang="en-US" sz="1200" dirty="0">
                 <a:solidFill>
                   <a:srgbClr val="1A1A1A"/>
                 </a:solidFill>
@@ -6894,204 +7096,9 @@
                 <a:ea typeface="Times New Roman" pitchFamily="34" charset="-122"/>
                 <a:cs typeface="Times New Roman" pitchFamily="34" charset="-120"/>
               </a:rPr>
-              <a:t>H2</a:t>
-            </a:r>
-            <a:endParaRPr lang="en-US" sz="1900" dirty="0"/>
-          </a:p>
-        </p:txBody>
-      </p:sp>
-      <p:sp>
-        <p:nvSpPr>
-          <p:cNvPr id="8" name="Text 6"/>
-          <p:cNvSpPr/>
-          <p:nvPr/>
-        </p:nvSpPr>
-        <p:spPr>
-          <a:xfrm>
-            <a:off x="1143000" y="2295144"/>
-            <a:ext cx="1417320" cy="365760"/>
-          </a:xfrm>
-          <a:prstGeom prst="rect">
-            <a:avLst/>
-          </a:prstGeom>
-          <a:noFill/>
-          <a:ln/>
-        </p:spPr>
-        <p:txBody>
-          <a:bodyPr wrap="square" lIns="0" tIns="0" rIns="0" bIns="0" rtlCol="0" anchor="ctr"/>
-          <a:lstStyle/>
-          <a:p>
-            <a:pPr indent="0" marL="0">
-              <a:buNone/>
-            </a:pPr>
-            <a:r>
-              <a:rPr lang="en-US" sz="1300" b="1" dirty="0">
-                <a:solidFill>
-                  <a:srgbClr val="1F5C2E"/>
-                </a:solidFill>
-                <a:latin typeface="Times New Roman" pitchFamily="34" charset="0"/>
-                <a:ea typeface="Times New Roman" pitchFamily="34" charset="-122"/>
-                <a:cs typeface="Times New Roman" pitchFamily="34" charset="-120"/>
-              </a:rPr>
-              <a:t>SOSTENIDA</a:t>
-            </a:r>
-            <a:endParaRPr lang="en-US" sz="1300" dirty="0"/>
-          </a:p>
-        </p:txBody>
-      </p:sp>
-      <p:sp>
-        <p:nvSpPr>
-          <p:cNvPr id="9" name="Text 7"/>
-          <p:cNvSpPr/>
-          <p:nvPr/>
-        </p:nvSpPr>
-        <p:spPr>
-          <a:xfrm>
-            <a:off x="2697480" y="2258568"/>
-            <a:ext cx="5989320" cy="1143000"/>
-          </a:xfrm>
-          <a:prstGeom prst="rect">
-            <a:avLst/>
-          </a:prstGeom>
-          <a:noFill/>
-          <a:ln/>
-        </p:spPr>
-        <p:txBody>
-          <a:bodyPr wrap="square" lIns="0" tIns="0" rIns="0" bIns="0" rtlCol="0" anchor="t"/>
-          <a:lstStyle/>
-          <a:p>
-            <a:pPr indent="0" marL="0">
-              <a:buNone/>
-            </a:pPr>
-            <a:r>
-              <a:rPr lang="en-US" sz="1250" dirty="0">
-                <a:solidFill>
-                  <a:srgbClr val="1A1A1A"/>
-                </a:solidFill>
-                <a:latin typeface="Times New Roman" pitchFamily="34" charset="0"/>
-                <a:ea typeface="Times New Roman" pitchFamily="34" charset="-122"/>
-                <a:cs typeface="Times New Roman" pitchFamily="34" charset="-120"/>
-              </a:rPr>
-              <a:t>La configuración hallada por PSO (r = 25; m = 0,0703) supera a la parametrización manual del operador clásico (r = 5; m = 1) en todas las métricas de calidad de fusión.</a:t>
-            </a:r>
-            <a:endParaRPr lang="en-US" sz="1250" dirty="0"/>
-          </a:p>
-        </p:txBody>
-      </p:sp>
-      <p:sp>
-        <p:nvSpPr>
-          <p:cNvPr id="10" name="Text 8"/>
-          <p:cNvSpPr/>
-          <p:nvPr/>
-        </p:nvSpPr>
-        <p:spPr>
-          <a:xfrm>
-            <a:off x="457200" y="3557016"/>
-            <a:ext cx="640080" cy="411480"/>
-          </a:xfrm>
-          <a:prstGeom prst="rect">
-            <a:avLst/>
-          </a:prstGeom>
-          <a:noFill/>
-          <a:ln/>
-        </p:spPr>
-        <p:txBody>
-          <a:bodyPr wrap="square" lIns="0" tIns="0" rIns="0" bIns="0" rtlCol="0" anchor="ctr"/>
-          <a:lstStyle/>
-          <a:p>
-            <a:pPr indent="0" marL="0">
-              <a:buNone/>
-            </a:pPr>
-            <a:r>
-              <a:rPr lang="en-US" sz="1900" b="1" dirty="0">
-                <a:solidFill>
-                  <a:srgbClr val="1A1A1A"/>
-                </a:solidFill>
-                <a:latin typeface="Times New Roman" pitchFamily="34" charset="0"/>
-                <a:ea typeface="Times New Roman" pitchFamily="34" charset="-122"/>
-                <a:cs typeface="Times New Roman" pitchFamily="34" charset="-120"/>
-              </a:rPr>
-              <a:t>H3</a:t>
-            </a:r>
-            <a:endParaRPr lang="en-US" sz="1900" dirty="0"/>
-          </a:p>
-        </p:txBody>
-      </p:sp>
-      <p:sp>
-        <p:nvSpPr>
-          <p:cNvPr id="11" name="Text 9"/>
-          <p:cNvSpPr/>
-          <p:nvPr/>
-        </p:nvSpPr>
-        <p:spPr>
-          <a:xfrm>
-            <a:off x="1143000" y="3593592"/>
-            <a:ext cx="1417320" cy="365760"/>
-          </a:xfrm>
-          <a:prstGeom prst="rect">
-            <a:avLst/>
-          </a:prstGeom>
-          <a:noFill/>
-          <a:ln/>
-        </p:spPr>
-        <p:txBody>
-          <a:bodyPr wrap="square" lIns="0" tIns="0" rIns="0" bIns="0" rtlCol="0" anchor="ctr"/>
-          <a:lstStyle/>
-          <a:p>
-            <a:pPr indent="0" marL="0">
-              <a:buNone/>
-            </a:pPr>
-            <a:r>
-              <a:rPr lang="en-US" sz="1300" b="1" dirty="0">
-                <a:solidFill>
-                  <a:srgbClr val="8B1A1A"/>
-                </a:solidFill>
-                <a:latin typeface="Times New Roman" pitchFamily="34" charset="0"/>
-                <a:ea typeface="Times New Roman" pitchFamily="34" charset="-122"/>
-                <a:cs typeface="Times New Roman" pitchFamily="34" charset="-120"/>
-              </a:rPr>
-              <a:t>PARCIAL</a:t>
-            </a:r>
-            <a:endParaRPr lang="en-US" sz="1300" dirty="0"/>
-          </a:p>
-        </p:txBody>
-      </p:sp>
-      <p:sp>
-        <p:nvSpPr>
-          <p:cNvPr id="12" name="Text 10"/>
-          <p:cNvSpPr/>
-          <p:nvPr/>
-        </p:nvSpPr>
-        <p:spPr>
-          <a:xfrm>
-            <a:off x="2697480" y="3557016"/>
-            <a:ext cx="5989320" cy="1143000"/>
-          </a:xfrm>
-          <a:prstGeom prst="rect">
-            <a:avLst/>
-          </a:prstGeom>
-          <a:noFill/>
-          <a:ln/>
-        </p:spPr>
-        <p:txBody>
-          <a:bodyPr wrap="square" lIns="0" tIns="0" rIns="0" bIns="0" rtlCol="0" anchor="t"/>
-          <a:lstStyle/>
-          <a:p>
-            <a:pPr indent="0" marL="0">
-              <a:buNone/>
-            </a:pPr>
-            <a:r>
-              <a:rPr lang="en-US" sz="1250" dirty="0">
-                <a:solidFill>
-                  <a:srgbClr val="1A1A1A"/>
-                </a:solidFill>
-                <a:latin typeface="Times New Roman" pitchFamily="34" charset="0"/>
-                <a:ea typeface="Times New Roman" pitchFamily="34" charset="-122"/>
-                <a:cs typeface="Times New Roman" pitchFamily="34" charset="-120"/>
-              </a:rPr>
-              <a:t>La fusión supera al visible solo en detección, pero ninguna fusión supera al infrarrojo solo; la mejor calidad de imagen no garantiza el mejor mAP.</a:t>
-            </a:r>
-            <a:endParaRPr lang="en-US" sz="1250" dirty="0"/>
+              <a:t>Entre las 7 fusiones la banda es estrecha (0,926–0,949); la propuesta es competitiva (0,936), pareja con el clásico (0,938).</a:t>
+            </a:r>
+            <a:endParaRPr lang="en-US" sz="1200" dirty="0"/>
           </a:p>
         </p:txBody>
       </p:sp>
@@ -7160,7 +7167,7 @@
                 <a:ea typeface="Times New Roman" pitchFamily="34" charset="-122"/>
                 <a:cs typeface="Times New Roman" pitchFamily="34" charset="-120"/>
               </a:rPr>
-              <a:t>9. Conclusiones</a:t>
+              <a:t>Contraste de hipótesis</a:t>
             </a:r>
             <a:endParaRPr lang="en-US" sz="2300" dirty="0"/>
           </a:p>
@@ -7199,7 +7206,7 @@
                 <a:ea typeface="Times New Roman" pitchFamily="34" charset="-122"/>
                 <a:cs typeface="Times New Roman" pitchFamily="34" charset="-120"/>
               </a:rPr>
-              <a:t>15 / 17</a:t>
+              <a:t>15 / 18</a:t>
             </a:r>
             <a:endParaRPr lang="en-US" sz="900" dirty="0"/>
           </a:p>
@@ -7213,8 +7220,8 @@
         </p:nvSpPr>
         <p:spPr>
           <a:xfrm>
-            <a:off x="457200" y="914400"/>
-            <a:ext cx="8229600" cy="3931920"/>
+            <a:off x="457200" y="960120"/>
+            <a:ext cx="640080" cy="411480"/>
           </a:xfrm>
           <a:prstGeom prst="rect">
             <a:avLst/>
@@ -7223,18 +7230,92 @@
           <a:ln/>
         </p:spPr>
         <p:txBody>
+          <a:bodyPr wrap="square" lIns="0" tIns="0" rIns="0" bIns="0" rtlCol="0" anchor="ctr"/>
+          <a:lstStyle/>
+          <a:p>
+            <a:pPr indent="0" marL="0">
+              <a:buNone/>
+            </a:pPr>
+            <a:r>
+              <a:rPr lang="en-US" sz="1900" b="1" dirty="0">
+                <a:solidFill>
+                  <a:srgbClr val="1A1A1A"/>
+                </a:solidFill>
+                <a:latin typeface="Times New Roman" pitchFamily="34" charset="0"/>
+                <a:ea typeface="Times New Roman" pitchFamily="34" charset="-122"/>
+                <a:cs typeface="Times New Roman" pitchFamily="34" charset="-120"/>
+              </a:rPr>
+              <a:t>H1</a:t>
+            </a:r>
+            <a:endParaRPr lang="en-US" sz="1900" dirty="0"/>
+          </a:p>
+        </p:txBody>
+      </p:sp>
+      <p:sp>
+        <p:nvSpPr>
+          <p:cNvPr id="5" name="Text 3"/>
+          <p:cNvSpPr/>
+          <p:nvPr/>
+        </p:nvSpPr>
+        <p:spPr>
+          <a:xfrm>
+            <a:off x="1143000" y="996696"/>
+            <a:ext cx="1417320" cy="365760"/>
+          </a:xfrm>
+          <a:prstGeom prst="rect">
+            <a:avLst/>
+          </a:prstGeom>
+          <a:noFill/>
+          <a:ln/>
+        </p:spPr>
+        <p:txBody>
+          <a:bodyPr wrap="square" lIns="0" tIns="0" rIns="0" bIns="0" rtlCol="0" anchor="ctr"/>
+          <a:lstStyle/>
+          <a:p>
+            <a:pPr indent="0" marL="0">
+              <a:buNone/>
+            </a:pPr>
+            <a:r>
+              <a:rPr lang="en-US" sz="1300" b="1" dirty="0">
+                <a:solidFill>
+                  <a:srgbClr val="1F5C2E"/>
+                </a:solidFill>
+                <a:latin typeface="Times New Roman" pitchFamily="34" charset="0"/>
+                <a:ea typeface="Times New Roman" pitchFamily="34" charset="-122"/>
+                <a:cs typeface="Times New Roman" pitchFamily="34" charset="-120"/>
+              </a:rPr>
+              <a:t>SOSTENIDA</a:t>
+            </a:r>
+            <a:endParaRPr lang="en-US" sz="1300" dirty="0"/>
+          </a:p>
+        </p:txBody>
+      </p:sp>
+      <p:sp>
+        <p:nvSpPr>
+          <p:cNvPr id="6" name="Text 4"/>
+          <p:cNvSpPr/>
+          <p:nvPr/>
+        </p:nvSpPr>
+        <p:spPr>
+          <a:xfrm>
+            <a:off x="2697480" y="960120"/>
+            <a:ext cx="5989320" cy="1143000"/>
+          </a:xfrm>
+          <a:prstGeom prst="rect">
+            <a:avLst/>
+          </a:prstGeom>
+          <a:noFill/>
+          <a:ln/>
+        </p:spPr>
+        <p:txBody>
           <a:bodyPr wrap="square" lIns="0" tIns="0" rIns="0" bIns="0" rtlCol="0" anchor="t"/>
           <a:lstStyle/>
           <a:p>
-            <a:pPr marL="177800" indent="-177800">
-              <a:spcAft>
-                <a:spcPts val="1100"/>
-              </a:spcAft>
-              <a:buSzPct val="100000"/>
-              <a:buChar char="•"/>
-            </a:pPr>
-            <a:r>
-              <a:rPr lang="en-US" sz="1350" dirty="0">
+            <a:pPr indent="0" marL="0">
+              <a:buNone/>
+            </a:pPr>
+            <a:r>
+              <a:rPr lang="en-US" sz="1250" dirty="0">
                 <a:solidFill>
                   <a:srgbClr val="1A1A1A"/>
                 </a:solidFill>
@@ -7242,20 +7323,38 @@
                 <a:ea typeface="Times New Roman" pitchFamily="34" charset="-122"/>
                 <a:cs typeface="Times New Roman" pitchFamily="34" charset="-120"/>
               </a:rPr>
-              <a:t>Se formuló e implementó de forma reproducible un operador Top-Hat de una sola escala con banco de disco + líneas orientadas y suma de ramas.</a:t>
-            </a:r>
-            <a:endParaRPr lang="en-US" sz="1350" dirty="0"/>
-          </a:p>
-          <a:p>
-            <a:pPr marL="177800" indent="-177800">
-              <a:spcAft>
-                <a:spcPts val="1100"/>
-              </a:spcAft>
-              <a:buSzPct val="100000"/>
-              <a:buChar char="•"/>
-            </a:pPr>
-            <a:r>
-              <a:rPr lang="en-US" sz="1350" dirty="0">
+              <a:t>El banco disco + líneas con suma de ramas mejora SSIM (0,782 vs 0,578) y reduce Nabf (0,041 vs 0,585) frente al Top-Hat clásico, con significancia estadística (Wilcoxon–Holm).</a:t>
+            </a:r>
+            <a:endParaRPr lang="en-US" sz="1250" dirty="0"/>
+          </a:p>
+        </p:txBody>
+      </p:sp>
+      <p:sp>
+        <p:nvSpPr>
+          <p:cNvPr id="7" name="Text 5"/>
+          <p:cNvSpPr/>
+          <p:nvPr/>
+        </p:nvSpPr>
+        <p:spPr>
+          <a:xfrm>
+            <a:off x="457200" y="2258568"/>
+            <a:ext cx="640080" cy="411480"/>
+          </a:xfrm>
+          <a:prstGeom prst="rect">
+            <a:avLst/>
+          </a:prstGeom>
+          <a:noFill/>
+          <a:ln/>
+        </p:spPr>
+        <p:txBody>
+          <a:bodyPr wrap="square" lIns="0" tIns="0" rIns="0" bIns="0" rtlCol="0" anchor="ctr"/>
+          <a:lstStyle/>
+          <a:p>
+            <a:pPr indent="0" marL="0">
+              <a:buNone/>
+            </a:pPr>
+            <a:r>
+              <a:rPr lang="en-US" sz="1900" b="1" dirty="0">
                 <a:solidFill>
                   <a:srgbClr val="1A1A1A"/>
                 </a:solidFill>
@@ -7263,20 +7362,77 @@
                 <a:ea typeface="Times New Roman" pitchFamily="34" charset="-122"/>
                 <a:cs typeface="Times New Roman" pitchFamily="34" charset="-120"/>
               </a:rPr>
-              <a:t>El barrido PSO de 25 configuraciones halló el óptimo r = 25, m = 0,0703 (F = 1,9843) de manera consistente.</a:t>
-            </a:r>
-            <a:endParaRPr lang="en-US" sz="1350" dirty="0"/>
-          </a:p>
-          <a:p>
-            <a:pPr marL="177800" indent="-177800">
-              <a:spcAft>
-                <a:spcPts val="1100"/>
-              </a:spcAft>
-              <a:buSzPct val="100000"/>
-              <a:buChar char="•"/>
-            </a:pPr>
-            <a:r>
-              <a:rPr lang="en-US" sz="1350" dirty="0">
+              <a:t>H2</a:t>
+            </a:r>
+            <a:endParaRPr lang="en-US" sz="1900" dirty="0"/>
+          </a:p>
+        </p:txBody>
+      </p:sp>
+      <p:sp>
+        <p:nvSpPr>
+          <p:cNvPr id="8" name="Text 6"/>
+          <p:cNvSpPr/>
+          <p:nvPr/>
+        </p:nvSpPr>
+        <p:spPr>
+          <a:xfrm>
+            <a:off x="1143000" y="2295144"/>
+            <a:ext cx="1417320" cy="365760"/>
+          </a:xfrm>
+          <a:prstGeom prst="rect">
+            <a:avLst/>
+          </a:prstGeom>
+          <a:noFill/>
+          <a:ln/>
+        </p:spPr>
+        <p:txBody>
+          <a:bodyPr wrap="square" lIns="0" tIns="0" rIns="0" bIns="0" rtlCol="0" anchor="ctr"/>
+          <a:lstStyle/>
+          <a:p>
+            <a:pPr indent="0" marL="0">
+              <a:buNone/>
+            </a:pPr>
+            <a:r>
+              <a:rPr lang="en-US" sz="1300" b="1" dirty="0">
+                <a:solidFill>
+                  <a:srgbClr val="1F5C2E"/>
+                </a:solidFill>
+                <a:latin typeface="Times New Roman" pitchFamily="34" charset="0"/>
+                <a:ea typeface="Times New Roman" pitchFamily="34" charset="-122"/>
+                <a:cs typeface="Times New Roman" pitchFamily="34" charset="-120"/>
+              </a:rPr>
+              <a:t>SOSTENIDA</a:t>
+            </a:r>
+            <a:endParaRPr lang="en-US" sz="1300" dirty="0"/>
+          </a:p>
+        </p:txBody>
+      </p:sp>
+      <p:sp>
+        <p:nvSpPr>
+          <p:cNvPr id="9" name="Text 7"/>
+          <p:cNvSpPr/>
+          <p:nvPr/>
+        </p:nvSpPr>
+        <p:spPr>
+          <a:xfrm>
+            <a:off x="2697480" y="2258568"/>
+            <a:ext cx="5989320" cy="1143000"/>
+          </a:xfrm>
+          <a:prstGeom prst="rect">
+            <a:avLst/>
+          </a:prstGeom>
+          <a:noFill/>
+          <a:ln/>
+        </p:spPr>
+        <p:txBody>
+          <a:bodyPr wrap="square" lIns="0" tIns="0" rIns="0" bIns="0" rtlCol="0" anchor="t"/>
+          <a:lstStyle/>
+          <a:p>
+            <a:pPr indent="0" marL="0">
+              <a:buNone/>
+            </a:pPr>
+            <a:r>
+              <a:rPr lang="en-US" sz="1250" dirty="0">
                 <a:solidFill>
                   <a:srgbClr val="1A1A1A"/>
                 </a:solidFill>
@@ -7284,20 +7440,38 @@
                 <a:ea typeface="Times New Roman" pitchFamily="34" charset="-122"/>
                 <a:cs typeface="Times New Roman" pitchFamily="34" charset="-120"/>
               </a:rPr>
-              <a:t>La propuesta exhibe el mejor perfil de calidad del benchmark: menor Nabf y mayor SSIM, con significancia estadística; segunda en Qabf, SCD y VIF.</a:t>
-            </a:r>
-            <a:endParaRPr lang="en-US" sz="1350" dirty="0"/>
-          </a:p>
-          <a:p>
-            <a:pPr marL="177800" indent="-177800">
-              <a:spcAft>
-                <a:spcPts val="1100"/>
-              </a:spcAft>
-              <a:buSzPct val="100000"/>
-              <a:buChar char="•"/>
-            </a:pPr>
-            <a:r>
-              <a:rPr lang="en-US" sz="1350" dirty="0">
+              <a:t>La configuración hallada por PSO (r = 25; m = 0,0703) supera a la parametrización manual del operador clásico (r = 5; m = 1) en todas las métricas de calidad de fusión.</a:t>
+            </a:r>
+            <a:endParaRPr lang="en-US" sz="1250" dirty="0"/>
+          </a:p>
+        </p:txBody>
+      </p:sp>
+      <p:sp>
+        <p:nvSpPr>
+          <p:cNvPr id="10" name="Text 8"/>
+          <p:cNvSpPr/>
+          <p:nvPr/>
+        </p:nvSpPr>
+        <p:spPr>
+          <a:xfrm>
+            <a:off x="457200" y="3557016"/>
+            <a:ext cx="640080" cy="411480"/>
+          </a:xfrm>
+          <a:prstGeom prst="rect">
+            <a:avLst/>
+          </a:prstGeom>
+          <a:noFill/>
+          <a:ln/>
+        </p:spPr>
+        <p:txBody>
+          <a:bodyPr wrap="square" lIns="0" tIns="0" rIns="0" bIns="0" rtlCol="0" anchor="ctr"/>
+          <a:lstStyle/>
+          <a:p>
+            <a:pPr indent="0" marL="0">
+              <a:buNone/>
+            </a:pPr>
+            <a:r>
+              <a:rPr lang="en-US" sz="1900" b="1" dirty="0">
                 <a:solidFill>
                   <a:srgbClr val="1A1A1A"/>
                 </a:solidFill>
@@ -7305,20 +7479,77 @@
                 <a:ea typeface="Times New Roman" pitchFamily="34" charset="-122"/>
                 <a:cs typeface="Times New Roman" pitchFamily="34" charset="-120"/>
               </a:rPr>
-              <a:t>Frente a la metodología clásica Top-Hat, mejora todas las métricas de calidad de fusión: el banco de SE y el ajuste automático aportan valor real.</a:t>
-            </a:r>
-            <a:endParaRPr lang="en-US" sz="1350" dirty="0"/>
-          </a:p>
-          <a:p>
-            <a:pPr marL="177800" indent="-177800">
-              <a:spcAft>
-                <a:spcPts val="1100"/>
-              </a:spcAft>
-              <a:buSzPct val="100000"/>
-              <a:buChar char="•"/>
-            </a:pPr>
-            <a:r>
-              <a:rPr lang="en-US" sz="1350" dirty="0">
+              <a:t>H3</a:t>
+            </a:r>
+            <a:endParaRPr lang="en-US" sz="1900" dirty="0"/>
+          </a:p>
+        </p:txBody>
+      </p:sp>
+      <p:sp>
+        <p:nvSpPr>
+          <p:cNvPr id="11" name="Text 9"/>
+          <p:cNvSpPr/>
+          <p:nvPr/>
+        </p:nvSpPr>
+        <p:spPr>
+          <a:xfrm>
+            <a:off x="1143000" y="3593592"/>
+            <a:ext cx="1417320" cy="365760"/>
+          </a:xfrm>
+          <a:prstGeom prst="rect">
+            <a:avLst/>
+          </a:prstGeom>
+          <a:noFill/>
+          <a:ln/>
+        </p:spPr>
+        <p:txBody>
+          <a:bodyPr wrap="square" lIns="0" tIns="0" rIns="0" bIns="0" rtlCol="0" anchor="ctr"/>
+          <a:lstStyle/>
+          <a:p>
+            <a:pPr indent="0" marL="0">
+              <a:buNone/>
+            </a:pPr>
+            <a:r>
+              <a:rPr lang="en-US" sz="1300" b="1" dirty="0">
+                <a:solidFill>
+                  <a:srgbClr val="8B1A1A"/>
+                </a:solidFill>
+                <a:latin typeface="Times New Roman" pitchFamily="34" charset="0"/>
+                <a:ea typeface="Times New Roman" pitchFamily="34" charset="-122"/>
+                <a:cs typeface="Times New Roman" pitchFamily="34" charset="-120"/>
+              </a:rPr>
+              <a:t>PARCIAL</a:t>
+            </a:r>
+            <a:endParaRPr lang="en-US" sz="1300" dirty="0"/>
+          </a:p>
+        </p:txBody>
+      </p:sp>
+      <p:sp>
+        <p:nvSpPr>
+          <p:cNvPr id="12" name="Text 10"/>
+          <p:cNvSpPr/>
+          <p:nvPr/>
+        </p:nvSpPr>
+        <p:spPr>
+          <a:xfrm>
+            <a:off x="2697480" y="3557016"/>
+            <a:ext cx="5989320" cy="1143000"/>
+          </a:xfrm>
+          <a:prstGeom prst="rect">
+            <a:avLst/>
+          </a:prstGeom>
+          <a:noFill/>
+          <a:ln/>
+        </p:spPr>
+        <p:txBody>
+          <a:bodyPr wrap="square" lIns="0" tIns="0" rIns="0" bIns="0" rtlCol="0" anchor="t"/>
+          <a:lstStyle/>
+          <a:p>
+            <a:pPr indent="0" marL="0">
+              <a:buNone/>
+            </a:pPr>
+            <a:r>
+              <a:rPr lang="en-US" sz="1250" dirty="0">
                 <a:solidFill>
                   <a:srgbClr val="1A1A1A"/>
                 </a:solidFill>
@@ -7326,9 +7557,9 @@
                 <a:ea typeface="Times New Roman" pitchFamily="34" charset="-122"/>
                 <a:cs typeface="Times New Roman" pitchFamily="34" charset="-120"/>
               </a:rPr>
-              <a:t>En detección, la superioridad en calidad de imagen no se traslada automáticamente al mAP: la elección del método debe guiarse por el criterio operativo prioritario.</a:t>
-            </a:r>
-            <a:endParaRPr lang="en-US" sz="1350" dirty="0"/>
+              <a:t>La fusión supera al visible solo en detección, pero ninguna fusión supera al infrarrojo solo; la mejor calidad de imagen no garantiza el mejor mAP.</a:t>
+            </a:r>
+            <a:endParaRPr lang="en-US" sz="1250" dirty="0"/>
           </a:p>
         </p:txBody>
       </p:sp>
@@ -7397,7 +7628,7 @@
                 <a:ea typeface="Times New Roman" pitchFamily="34" charset="-122"/>
                 <a:cs typeface="Times New Roman" pitchFamily="34" charset="-120"/>
               </a:rPr>
-              <a:t>Recomendaciones y trabajo futuro</a:t>
+              <a:t>9. Conclusiones</a:t>
             </a:r>
             <a:endParaRPr lang="en-US" sz="2300" dirty="0"/>
           </a:p>
@@ -7436,7 +7667,7 @@
                 <a:ea typeface="Times New Roman" pitchFamily="34" charset="-122"/>
                 <a:cs typeface="Times New Roman" pitchFamily="34" charset="-120"/>
               </a:rPr>
-              <a:t>16 / 17</a:t>
+              <a:t>16 / 18</a:t>
             </a:r>
             <a:endParaRPr lang="en-US" sz="900" dirty="0"/>
           </a:p>
@@ -7479,7 +7710,7 @@
                 <a:ea typeface="Times New Roman" pitchFamily="34" charset="-122"/>
                 <a:cs typeface="Times New Roman" pitchFamily="34" charset="-120"/>
               </a:rPr>
-              <a:t>Extender la evaluación de detección a otros detectores y al conjunto completo de LLVIP.</a:t>
+              <a:t>Se formuló e implementó de forma reproducible un operador Top-Hat de una sola escala con banco de disco + líneas orientadas y suma de ramas.</a:t>
             </a:r>
             <a:endParaRPr lang="en-US" sz="1350" dirty="0"/>
           </a:p>
@@ -7500,7 +7731,7 @@
                 <a:ea typeface="Times New Roman" pitchFamily="34" charset="-122"/>
                 <a:cs typeface="Times New Roman" pitchFamily="34" charset="-120"/>
               </a:rPr>
-              <a:t>Explorar reglas de fusión adaptativas para la rama Black Top-Hat.</a:t>
+              <a:t>El barrido PSO de 25 configuraciones halló el óptimo r = 25, m = 0,0703 (F = 1,9843) de manera consistente.</a:t>
             </a:r>
             <a:endParaRPr lang="en-US" sz="1350" dirty="0"/>
           </a:p>
@@ -7521,7 +7752,7 @@
                 <a:ea typeface="Times New Roman" pitchFamily="34" charset="-122"/>
                 <a:cs typeface="Times New Roman" pitchFamily="34" charset="-120"/>
               </a:rPr>
-              <a:t>Complementar las métricas objetivas con una validación perceptual por observadores.</a:t>
+              <a:t>La propuesta exhibe el mejor perfil de calidad del benchmark: menor Nabf y mayor SSIM, con significancia estadística; segunda en Qabf, SCD y VIF.</a:t>
             </a:r>
             <a:endParaRPr lang="en-US" sz="1350" dirty="0"/>
           </a:p>
@@ -7542,7 +7773,7 @@
                 <a:ea typeface="Times New Roman" pitchFamily="34" charset="-122"/>
                 <a:cs typeface="Times New Roman" pitchFamily="34" charset="-120"/>
               </a:rPr>
-              <a:t>Evaluar la transferencia a otros dominios (imágenes médicas, aéreas).</a:t>
+              <a:t>Frente a la metodología clásica Top-Hat, mejora todas las métricas de calidad de fusión: el banco de SE y el ajuste automático aportan valor real.</a:t>
             </a:r>
             <a:endParaRPr lang="en-US" sz="1350" dirty="0"/>
           </a:p>
@@ -7563,7 +7794,7 @@
                 <a:ea typeface="Times New Roman" pitchFamily="34" charset="-122"/>
                 <a:cs typeface="Times New Roman" pitchFamily="34" charset="-120"/>
               </a:rPr>
-              <a:t>Para aplicaciones donde los artefactos son críticos (interpretación humana, diagnóstico), la propuesta es la opción recomendada; donde prima el contraste bruto, LP sigue siendo competitiva.</a:t>
+              <a:t>En detección, la superioridad en calidad de imagen no se traslada automáticamente al mAP: la elección del método debe guiarse por el criterio operativo prioritario.</a:t>
             </a:r>
             <a:endParaRPr lang="en-US" sz="1350" dirty="0"/>
           </a:p>
@@ -7609,6 +7840,243 @@
         </p:nvSpPr>
         <p:spPr>
           <a:xfrm>
+            <a:off x="457200" y="256032"/>
+            <a:ext cx="8229600" cy="502920"/>
+          </a:xfrm>
+          <a:prstGeom prst="rect">
+            <a:avLst/>
+          </a:prstGeom>
+          <a:noFill/>
+          <a:ln/>
+        </p:spPr>
+        <p:txBody>
+          <a:bodyPr wrap="square" lIns="0" tIns="0" rIns="0" bIns="0" rtlCol="0" anchor="ctr"/>
+          <a:lstStyle/>
+          <a:p>
+            <a:pPr indent="0" marL="0">
+              <a:buNone/>
+            </a:pPr>
+            <a:r>
+              <a:rPr lang="en-US" sz="2300" b="1" dirty="0">
+                <a:solidFill>
+                  <a:srgbClr val="1A1A1A"/>
+                </a:solidFill>
+                <a:latin typeface="Times New Roman" pitchFamily="34" charset="0"/>
+                <a:ea typeface="Times New Roman" pitchFamily="34" charset="-122"/>
+                <a:cs typeface="Times New Roman" pitchFamily="34" charset="-120"/>
+              </a:rPr>
+              <a:t>Recomendaciones y trabajo futuro</a:t>
+            </a:r>
+            <a:endParaRPr lang="en-US" sz="2300" dirty="0"/>
+          </a:p>
+        </p:txBody>
+      </p:sp>
+      <p:sp>
+        <p:nvSpPr>
+          <p:cNvPr id="3" name="Text 1"/>
+          <p:cNvSpPr/>
+          <p:nvPr/>
+        </p:nvSpPr>
+        <p:spPr>
+          <a:xfrm>
+            <a:off x="8229600" y="4828032"/>
+            <a:ext cx="685800" cy="274320"/>
+          </a:xfrm>
+          <a:prstGeom prst="rect">
+            <a:avLst/>
+          </a:prstGeom>
+          <a:noFill/>
+          <a:ln/>
+        </p:spPr>
+        <p:txBody>
+          <a:bodyPr wrap="square" lIns="0" tIns="0" rIns="0" bIns="0" rtlCol="0" anchor="ctr"/>
+          <a:lstStyle/>
+          <a:p>
+            <a:pPr algn="r" indent="0" marL="0">
+              <a:buNone/>
+            </a:pPr>
+            <a:r>
+              <a:rPr lang="en-US" sz="900" dirty="0">
+                <a:solidFill>
+                  <a:srgbClr val="666666"/>
+                </a:solidFill>
+                <a:latin typeface="Times New Roman" pitchFamily="34" charset="0"/>
+                <a:ea typeface="Times New Roman" pitchFamily="34" charset="-122"/>
+                <a:cs typeface="Times New Roman" pitchFamily="34" charset="-120"/>
+              </a:rPr>
+              <a:t>17 / 18</a:t>
+            </a:r>
+            <a:endParaRPr lang="en-US" sz="900" dirty="0"/>
+          </a:p>
+        </p:txBody>
+      </p:sp>
+      <p:sp>
+        <p:nvSpPr>
+          <p:cNvPr id="4" name="Text 2"/>
+          <p:cNvSpPr/>
+          <p:nvPr/>
+        </p:nvSpPr>
+        <p:spPr>
+          <a:xfrm>
+            <a:off x="457200" y="914400"/>
+            <a:ext cx="8229600" cy="3931920"/>
+          </a:xfrm>
+          <a:prstGeom prst="rect">
+            <a:avLst/>
+          </a:prstGeom>
+          <a:noFill/>
+          <a:ln/>
+        </p:spPr>
+        <p:txBody>
+          <a:bodyPr wrap="square" lIns="0" tIns="0" rIns="0" bIns="0" rtlCol="0" anchor="t"/>
+          <a:lstStyle/>
+          <a:p>
+            <a:pPr marL="177800" indent="-177800">
+              <a:spcAft>
+                <a:spcPts val="1100"/>
+              </a:spcAft>
+              <a:buSzPct val="100000"/>
+              <a:buChar char="•"/>
+            </a:pPr>
+            <a:r>
+              <a:rPr lang="en-US" sz="1350" dirty="0">
+                <a:solidFill>
+                  <a:srgbClr val="1A1A1A"/>
+                </a:solidFill>
+                <a:latin typeface="Times New Roman" pitchFamily="34" charset="0"/>
+                <a:ea typeface="Times New Roman" pitchFamily="34" charset="-122"/>
+                <a:cs typeface="Times New Roman" pitchFamily="34" charset="-120"/>
+              </a:rPr>
+              <a:t>Extender la evaluación de detección a otros detectores y al conjunto completo de LLVIP.</a:t>
+            </a:r>
+            <a:endParaRPr lang="en-US" sz="1350" dirty="0"/>
+          </a:p>
+          <a:p>
+            <a:pPr marL="177800" indent="-177800">
+              <a:spcAft>
+                <a:spcPts val="1100"/>
+              </a:spcAft>
+              <a:buSzPct val="100000"/>
+              <a:buChar char="•"/>
+            </a:pPr>
+            <a:r>
+              <a:rPr lang="en-US" sz="1350" dirty="0">
+                <a:solidFill>
+                  <a:srgbClr val="1A1A1A"/>
+                </a:solidFill>
+                <a:latin typeface="Times New Roman" pitchFamily="34" charset="0"/>
+                <a:ea typeface="Times New Roman" pitchFamily="34" charset="-122"/>
+                <a:cs typeface="Times New Roman" pitchFamily="34" charset="-120"/>
+              </a:rPr>
+              <a:t>Explorar reglas de fusión adaptativas para la rama Black Top-Hat.</a:t>
+            </a:r>
+            <a:endParaRPr lang="en-US" sz="1350" dirty="0"/>
+          </a:p>
+          <a:p>
+            <a:pPr marL="177800" indent="-177800">
+              <a:spcAft>
+                <a:spcPts val="1100"/>
+              </a:spcAft>
+              <a:buSzPct val="100000"/>
+              <a:buChar char="•"/>
+            </a:pPr>
+            <a:r>
+              <a:rPr lang="en-US" sz="1350" dirty="0">
+                <a:solidFill>
+                  <a:srgbClr val="1A1A1A"/>
+                </a:solidFill>
+                <a:latin typeface="Times New Roman" pitchFamily="34" charset="0"/>
+                <a:ea typeface="Times New Roman" pitchFamily="34" charset="-122"/>
+                <a:cs typeface="Times New Roman" pitchFamily="34" charset="-120"/>
+              </a:rPr>
+              <a:t>Complementar las métricas objetivas con una validación perceptual por observadores.</a:t>
+            </a:r>
+            <a:endParaRPr lang="en-US" sz="1350" dirty="0"/>
+          </a:p>
+          <a:p>
+            <a:pPr marL="177800" indent="-177800">
+              <a:spcAft>
+                <a:spcPts val="1100"/>
+              </a:spcAft>
+              <a:buSzPct val="100000"/>
+              <a:buChar char="•"/>
+            </a:pPr>
+            <a:r>
+              <a:rPr lang="en-US" sz="1350" dirty="0">
+                <a:solidFill>
+                  <a:srgbClr val="1A1A1A"/>
+                </a:solidFill>
+                <a:latin typeface="Times New Roman" pitchFamily="34" charset="0"/>
+                <a:ea typeface="Times New Roman" pitchFamily="34" charset="-122"/>
+                <a:cs typeface="Times New Roman" pitchFamily="34" charset="-120"/>
+              </a:rPr>
+              <a:t>Evaluar la transferencia a otros dominios (imágenes médicas, aéreas).</a:t>
+            </a:r>
+            <a:endParaRPr lang="en-US" sz="1350" dirty="0"/>
+          </a:p>
+          <a:p>
+            <a:pPr marL="177800" indent="-177800">
+              <a:spcAft>
+                <a:spcPts val="1100"/>
+              </a:spcAft>
+              <a:buSzPct val="100000"/>
+              <a:buChar char="•"/>
+            </a:pPr>
+            <a:r>
+              <a:rPr lang="en-US" sz="1350" dirty="0">
+                <a:solidFill>
+                  <a:srgbClr val="1A1A1A"/>
+                </a:solidFill>
+                <a:latin typeface="Times New Roman" pitchFamily="34" charset="0"/>
+                <a:ea typeface="Times New Roman" pitchFamily="34" charset="-122"/>
+                <a:cs typeface="Times New Roman" pitchFamily="34" charset="-120"/>
+              </a:rPr>
+              <a:t>Para aplicaciones donde los artefactos son críticos (interpretación humana, diagnóstico), la propuesta es la opción recomendada; donde prima el contraste bruto, LP sigue siendo competitiva.</a:t>
+            </a:r>
+            <a:endParaRPr lang="en-US" sz="1350" dirty="0"/>
+          </a:p>
+        </p:txBody>
+      </p:sp>
+    </p:spTree>
+  </p:cSld>
+  <p:clrMapOvr>
+    <a:masterClrMapping/>
+  </p:clrMapOvr>
+</p:sld>
+</file>
+
+<file path=ppt/slides/slide18.xml><?xml version="1.0" encoding="utf-8"?>
+<p:sld xmlns:a="http://schemas.openxmlformats.org/drawingml/2006/main" xmlns:r="http://schemas.openxmlformats.org/officeDocument/2006/relationships" xmlns:p="http://schemas.openxmlformats.org/presentationml/2006/main">
+  <p:cSld name="Slide 18">
+    <p:bg>
+      <p:bgPr>
+        <a:solidFill>
+          <a:srgbClr val="FFFFFF"/>
+        </a:solidFill>
+      </p:bgPr>
+    </p:bg>
+    <p:spTree>
+      <p:nvGrpSpPr>
+        <p:cNvPr id="1" name=""/>
+        <p:cNvGrpSpPr/>
+        <p:nvPr/>
+      </p:nvGrpSpPr>
+      <p:grpSpPr>
+        <a:xfrm>
+          <a:off x="0" y="0"/>
+          <a:ext cx="0" cy="0"/>
+          <a:chOff x="0" y="0"/>
+          <a:chExt cx="0" cy="0"/>
+        </a:xfrm>
+      </p:grpSpPr>
+      <p:sp>
+        <p:nvSpPr>
+          <p:cNvPr id="2" name="Text 0"/>
+          <p:cNvSpPr/>
+          <p:nvPr/>
+        </p:nvSpPr>
+        <p:spPr>
+          <a:xfrm>
             <a:off x="457200" y="1828800"/>
             <a:ext cx="8229600" cy="731520"/>
           </a:xfrm>
@@ -7861,7 +8329,7 @@
                 <a:ea typeface="Times New Roman" pitchFamily="34" charset="-122"/>
                 <a:cs typeface="Times New Roman" pitchFamily="34" charset="-120"/>
               </a:rPr>
-              <a:t>2 / 17</a:t>
+              <a:t>2 / 18</a:t>
             </a:r>
             <a:endParaRPr lang="en-US" sz="900" dirty="0"/>
           </a:p>
@@ -8182,7 +8650,7 @@
                 <a:ea typeface="Times New Roman" pitchFamily="34" charset="-122"/>
                 <a:cs typeface="Times New Roman" pitchFamily="34" charset="-120"/>
               </a:rPr>
-              <a:t>3 / 17</a:t>
+              <a:t>3 / 18</a:t>
             </a:r>
             <a:endParaRPr lang="en-US" sz="900" dirty="0"/>
           </a:p>
@@ -8443,7 +8911,7 @@
                 <a:ea typeface="Times New Roman" pitchFamily="34" charset="-122"/>
                 <a:cs typeface="Times New Roman" pitchFamily="34" charset="-120"/>
               </a:rPr>
-              <a:t>4 / 17</a:t>
+              <a:t>4 / 18</a:t>
             </a:r>
             <a:endParaRPr lang="en-US" sz="900" dirty="0"/>
           </a:p>
@@ -8776,7 +9244,7 @@
                 <a:ea typeface="Times New Roman" pitchFamily="34" charset="-122"/>
                 <a:cs typeface="Times New Roman" pitchFamily="34" charset="-120"/>
               </a:rPr>
-              <a:t>5 / 17</a:t>
+              <a:t>5 / 18</a:t>
             </a:r>
             <a:endParaRPr lang="en-US" sz="900" dirty="0"/>
           </a:p>
@@ -9120,7 +9588,7 @@
                 <a:ea typeface="Times New Roman" pitchFamily="34" charset="-122"/>
                 <a:cs typeface="Times New Roman" pitchFamily="34" charset="-120"/>
               </a:rPr>
-              <a:t>6 / 17</a:t>
+              <a:t>6 / 18</a:t>
             </a:r>
             <a:endParaRPr lang="en-US" sz="900" dirty="0"/>
           </a:p>
@@ -9441,7 +9909,7 @@
                 <a:ea typeface="Times New Roman" pitchFamily="34" charset="-122"/>
                 <a:cs typeface="Times New Roman" pitchFamily="34" charset="-120"/>
               </a:rPr>
-              <a:t>7 / 17</a:t>
+              <a:t>7 / 18</a:t>
             </a:r>
             <a:endParaRPr lang="en-US" sz="900" dirty="0"/>
           </a:p>
@@ -9750,7 +10218,7 @@
                 <a:ea typeface="Times New Roman" pitchFamily="34" charset="-122"/>
                 <a:cs typeface="Times New Roman" pitchFamily="34" charset="-120"/>
               </a:rPr>
-              <a:t>8 / 17</a:t>
+              <a:t>8 / 18</a:t>
             </a:r>
             <a:endParaRPr lang="en-US" sz="900" dirty="0"/>
           </a:p>
@@ -10036,7 +10504,7 @@
                 <a:ea typeface="Times New Roman" pitchFamily="34" charset="-122"/>
                 <a:cs typeface="Times New Roman" pitchFamily="34" charset="-120"/>
               </a:rPr>
-              <a:t>6. Diseño experimental</a:t>
+              <a:t>Ablación de la función de aptitud (pedido de la revisión)</a:t>
             </a:r>
             <a:endParaRPr lang="en-US" sz="2300" dirty="0"/>
           </a:p>
@@ -10075,22 +10543,46 @@
                 <a:ea typeface="Times New Roman" pitchFamily="34" charset="-122"/>
                 <a:cs typeface="Times New Roman" pitchFamily="34" charset="-120"/>
               </a:rPr>
-              <a:t>9 / 17</a:t>
+              <a:t>9 / 18</a:t>
             </a:r>
             <a:endParaRPr lang="en-US" sz="900" dirty="0"/>
           </a:p>
         </p:txBody>
       </p:sp>
-      <p:sp>
-        <p:nvSpPr>
-          <p:cNvPr id="4" name="Text 2"/>
+      <p:pic>
+        <p:nvPicPr>
+          <p:cNvPr id="4" name="Image 0" descr="C:/Users/Usuario/Documents/unv/mastertesis/tesis_mciencias_datos/docs/figures/fig_aptitud_vs_m.png">    </p:cNvPr>
+          <p:cNvPicPr>
+            <a:picLocks noChangeAspect="1"/>
+          </p:cNvPicPr>
+          <p:nvPr/>
+        </p:nvPicPr>
+        <p:blipFill>
+          <a:blip r:embed="rId1"/>
+          <a:stretch>
+            <a:fillRect/>
+          </a:stretch>
+        </p:blipFill>
+        <p:spPr>
+          <a:xfrm>
+            <a:off x="411480" y="1051560"/>
+            <a:ext cx="5212080" cy="2734056"/>
+          </a:xfrm>
+          <a:prstGeom prst="rect">
+            <a:avLst/>
+          </a:prstGeom>
+        </p:spPr>
+      </p:pic>
+      <p:sp>
+        <p:nvSpPr>
+          <p:cNvPr id="5" name="Text 2"/>
           <p:cNvSpPr/>
           <p:nvPr/>
         </p:nvSpPr>
         <p:spPr>
           <a:xfrm>
-            <a:off x="457200" y="868680"/>
-            <a:ext cx="4023360" cy="274320"/>
+            <a:off x="5760720" y="1051560"/>
+            <a:ext cx="2971800" cy="3291840"/>
           </a:xfrm>
           <a:prstGeom prst="rect">
             <a:avLst/>
@@ -10099,37 +10591,125 @@
           <a:ln/>
         </p:spPr>
         <p:txBody>
-          <a:bodyPr wrap="square" lIns="0" tIns="0" rIns="0" bIns="0" rtlCol="0" anchor="ctr"/>
-          <a:lstStyle/>
-          <a:p>
-            <a:pPr indent="0" marL="0">
-              <a:buNone/>
-            </a:pPr>
-            <a:r>
-              <a:rPr lang="en-US" sz="1400" b="1" dirty="0">
-                <a:solidFill>
-                  <a:srgbClr val="8B1A1A"/>
-                </a:solidFill>
-                <a:latin typeface="Times New Roman" pitchFamily="34" charset="0"/>
-                <a:ea typeface="Times New Roman" pitchFamily="34" charset="-122"/>
-                <a:cs typeface="Times New Roman" pitchFamily="34" charset="-120"/>
-              </a:rPr>
-              <a:t>Benchmark de calidad</a:t>
-            </a:r>
-            <a:endParaRPr lang="en-US" sz="1400" dirty="0"/>
-          </a:p>
-        </p:txBody>
-      </p:sp>
-      <p:sp>
-        <p:nvSpPr>
-          <p:cNvPr id="5" name="Text 3"/>
+          <a:bodyPr wrap="square" lIns="0" tIns="0" rIns="0" bIns="0" rtlCol="0" anchor="t"/>
+          <a:lstStyle/>
+          <a:p>
+            <a:pPr marL="177800" indent="-177800">
+              <a:spcAft>
+                <a:spcPts val="700"/>
+              </a:spcAft>
+              <a:buSzPct val="100000"/>
+              <a:buChar char="•"/>
+            </a:pPr>
+            <a:r>
+              <a:rPr lang="en-US" sz="1150" dirty="0">
+                <a:solidFill>
+                  <a:srgbClr val="1A1A1A"/>
+                </a:solidFill>
+                <a:latin typeface="Times New Roman" pitchFamily="34" charset="0"/>
+                <a:ea typeface="Times New Roman" pitchFamily="34" charset="-122"/>
+                <a:cs typeface="Times New Roman" pitchFamily="34" charset="-120"/>
+              </a:rPr>
+              <a:t>Mismo barrido 5×5 con la Fo del trabajo de referencia (SSIM_avg + E_n + PSNR_n) y su rango m ∈ [0,3–2,0].</a:t>
+            </a:r>
+            <a:endParaRPr lang="en-US" sz="1150" dirty="0"/>
+          </a:p>
+          <a:p>
+            <a:pPr marL="177800" indent="-177800">
+              <a:spcAft>
+                <a:spcPts val="700"/>
+              </a:spcAft>
+              <a:buSzPct val="100000"/>
+              <a:buChar char="•"/>
+            </a:pPr>
+            <a:r>
+              <a:rPr lang="en-US" sz="1150" b="1" dirty="0">
+                <a:solidFill>
+                  <a:srgbClr val="1A1A1A"/>
+                </a:solidFill>
+                <a:latin typeface="Times New Roman" pitchFamily="34" charset="0"/>
+                <a:ea typeface="Times New Roman" pitchFamily="34" charset="-122"/>
+                <a:cs typeface="Times New Roman" pitchFamily="34" charset="-120"/>
+              </a:rPr>
+              <a:t>En las 50 corridas, m* = 0,30: el piso del rango.</a:t>
+            </a:r>
+            <a:endParaRPr lang="en-US" sz="1150" dirty="0"/>
+          </a:p>
+          <a:p>
+            <a:pPr marL="177800" indent="-177800">
+              <a:spcAft>
+                <a:spcPts val="700"/>
+              </a:spcAft>
+              <a:buSzPct val="100000"/>
+              <a:buChar char="•"/>
+            </a:pPr>
+            <a:r>
+              <a:rPr lang="en-US" sz="1150" dirty="0">
+                <a:solidFill>
+                  <a:srgbClr val="1A1A1A"/>
+                </a:solidFill>
+                <a:latin typeface="Times New Roman" pitchFamily="34" charset="0"/>
+                <a:ea typeface="Times New Roman" pitchFamily="34" charset="-122"/>
+                <a:cs typeface="Times New Roman" pitchFamily="34" charset="-120"/>
+              </a:rPr>
+              <a:t>Las tres curvas decrecen en [0,5–2]: ningún tamaño de enjambre ni número de iteraciones puede converger allí.</a:t>
+            </a:r>
+            <a:endParaRPr lang="en-US" sz="1150" dirty="0"/>
+          </a:p>
+          <a:p>
+            <a:pPr marL="177800" indent="-177800">
+              <a:spcAft>
+                <a:spcPts val="700"/>
+              </a:spcAft>
+              <a:buSzPct val="100000"/>
+              <a:buChar char="•"/>
+            </a:pPr>
+            <a:r>
+              <a:rPr lang="en-US" sz="1150" b="1" dirty="0">
+                <a:solidFill>
+                  <a:srgbClr val="1A1A1A"/>
+                </a:solidFill>
+                <a:latin typeface="Times New Roman" pitchFamily="34" charset="0"/>
+                <a:ea typeface="Times New Roman" pitchFamily="34" charset="-122"/>
+                <a:cs typeface="Times New Roman" pitchFamily="34" charset="-120"/>
+              </a:rPr>
+              <a:t>El máximo real de Fo sobre la propuesta está en m ≈ 0,07 — coincide con nuestro óptimo (0,0703).</a:t>
+            </a:r>
+            <a:endParaRPr lang="en-US" sz="1150" dirty="0"/>
+          </a:p>
+          <a:p>
+            <a:pPr marL="177800" indent="-177800">
+              <a:spcAft>
+                <a:spcPts val="700"/>
+              </a:spcAft>
+              <a:buSzPct val="100000"/>
+              <a:buChar char="•"/>
+            </a:pPr>
+            <a:r>
+              <a:rPr lang="en-US" sz="1150" dirty="0">
+                <a:solidFill>
+                  <a:srgbClr val="1A1A1A"/>
+                </a:solidFill>
+                <a:latin typeface="Times New Roman" pitchFamily="34" charset="0"/>
+                <a:ea typeface="Times New Roman" pitchFamily="34" charset="-122"/>
+                <a:cs typeface="Times New Roman" pitchFamily="34" charset="-120"/>
+              </a:rPr>
+              <a:t>Sobre la propuesta, Fo elige r = 1 (óptimo trivial); sobre el clásico, r = 25 con 4,5× más artefactos que F_apt.</a:t>
+            </a:r>
+            <a:endParaRPr lang="en-US" sz="1150" dirty="0"/>
+          </a:p>
+        </p:txBody>
+      </p:sp>
+      <p:sp>
+        <p:nvSpPr>
+          <p:cNvPr id="6" name="Text 3"/>
           <p:cNvSpPr/>
           <p:nvPr/>
         </p:nvSpPr>
         <p:spPr>
           <a:xfrm>
-            <a:off x="457200" y="1188720"/>
-            <a:ext cx="4023360" cy="3291840"/>
+            <a:off x="457200" y="4206240"/>
+            <a:ext cx="8229600" cy="548640"/>
           </a:xfrm>
           <a:prstGeom prst="rect">
             <a:avLst/>
@@ -10138,112 +10718,6 @@
           <a:ln/>
         </p:spPr>
         <p:txBody>
-          <a:bodyPr wrap="square" lIns="0" tIns="0" rIns="0" bIns="0" rtlCol="0" anchor="t"/>
-          <a:lstStyle/>
-          <a:p>
-            <a:pPr marL="177800" indent="-177800">
-              <a:spcAft>
-                <a:spcPts val="800"/>
-              </a:spcAft>
-              <a:buSzPct val="100000"/>
-              <a:buChar char="•"/>
-            </a:pPr>
-            <a:r>
-              <a:rPr lang="en-US" sz="1250" dirty="0">
-                <a:solidFill>
-                  <a:srgbClr val="1A1A1A"/>
-                </a:solidFill>
-                <a:latin typeface="Times New Roman" pitchFamily="34" charset="0"/>
-                <a:ea typeface="Times New Roman" pitchFamily="34" charset="-122"/>
-                <a:cs typeface="Times New Roman" pitchFamily="34" charset="-120"/>
-              </a:rPr>
-              <a:t>20 pares VIS/IR del dataset TNO (Toet, 2014).</a:t>
-            </a:r>
-            <a:endParaRPr lang="en-US" sz="1250" dirty="0"/>
-          </a:p>
-          <a:p>
-            <a:pPr marL="177800" indent="-177800">
-              <a:spcAft>
-                <a:spcPts val="800"/>
-              </a:spcAft>
-              <a:buSzPct val="100000"/>
-              <a:buChar char="•"/>
-            </a:pPr>
-            <a:r>
-              <a:rPr lang="en-US" sz="1250" dirty="0">
-                <a:solidFill>
-                  <a:srgbClr val="1A1A1A"/>
-                </a:solidFill>
-                <a:latin typeface="Times New Roman" pitchFamily="34" charset="0"/>
-                <a:ea typeface="Times New Roman" pitchFamily="34" charset="-122"/>
-                <a:cs typeface="Times New Roman" pitchFamily="34" charset="-120"/>
-              </a:rPr>
-              <a:t>7 métodos: LP, RP, DWT, DTCWT, CVT, Top-Hat clásico y Propuesta → 140 fusiones.</a:t>
-            </a:r>
-            <a:endParaRPr lang="en-US" sz="1250" dirty="0"/>
-          </a:p>
-          <a:p>
-            <a:pPr marL="177800" indent="-177800">
-              <a:spcAft>
-                <a:spcPts val="800"/>
-              </a:spcAft>
-              <a:buSzPct val="100000"/>
-              <a:buChar char="•"/>
-            </a:pPr>
-            <a:r>
-              <a:rPr lang="en-US" sz="1250" dirty="0">
-                <a:solidFill>
-                  <a:srgbClr val="1A1A1A"/>
-                </a:solidFill>
-                <a:latin typeface="Times New Roman" pitchFamily="34" charset="0"/>
-                <a:ea typeface="Times New Roman" pitchFamily="34" charset="-122"/>
-                <a:cs typeface="Times New Roman" pitchFamily="34" charset="-120"/>
-              </a:rPr>
-              <a:t>12 métricas sin referencia (+ 4 descriptivas del review de Singh et al., 2023).</a:t>
-            </a:r>
-            <a:endParaRPr lang="en-US" sz="1250" dirty="0"/>
-          </a:p>
-          <a:p>
-            <a:pPr marL="177800" indent="-177800">
-              <a:spcAft>
-                <a:spcPts val="800"/>
-              </a:spcAft>
-              <a:buSzPct val="100000"/>
-              <a:buChar char="•"/>
-            </a:pPr>
-            <a:r>
-              <a:rPr lang="en-US" sz="1250" dirty="0">
-                <a:solidFill>
-                  <a:srgbClr val="1A1A1A"/>
-                </a:solidFill>
-                <a:latin typeface="Times New Roman" pitchFamily="34" charset="0"/>
-                <a:ea typeface="Times New Roman" pitchFamily="34" charset="-122"/>
-                <a:cs typeface="Times New Roman" pitchFamily="34" charset="-120"/>
-              </a:rPr>
-              <a:t>Friedman global + Wilcoxon pareado con corrección de Holm (α = 0,05).</a:t>
-            </a:r>
-            <a:endParaRPr lang="en-US" sz="1250" dirty="0"/>
-          </a:p>
-        </p:txBody>
-      </p:sp>
-      <p:sp>
-        <p:nvSpPr>
-          <p:cNvPr id="6" name="Text 4"/>
-          <p:cNvSpPr/>
-          <p:nvPr/>
-        </p:nvSpPr>
-        <p:spPr>
-          <a:xfrm>
-            <a:off x="4846320" y="868680"/>
-            <a:ext cx="3840480" cy="274320"/>
-          </a:xfrm>
-          <a:prstGeom prst="rect">
-            <a:avLst/>
-          </a:prstGeom>
-          <a:noFill/>
-          <a:ln/>
-        </p:spPr>
-        <p:txBody>
           <a:bodyPr wrap="square" lIns="0" tIns="0" rIns="0" bIns="0" rtlCol="0" anchor="ctr"/>
           <a:lstStyle/>
           <a:p>
@@ -10251,7 +10725,7 @@
               <a:buNone/>
             </a:pPr>
             <a:r>
-              <a:rPr lang="en-US" sz="1400" b="1" dirty="0">
+              <a:rPr lang="en-US" sz="1200" i="1" dirty="0">
                 <a:solidFill>
                   <a:srgbClr val="8B1A1A"/>
                 </a:solidFill>
@@ -10259,94 +10733,9 @@
                 <a:ea typeface="Times New Roman" pitchFamily="34" charset="-122"/>
                 <a:cs typeface="Times New Roman" pitchFamily="34" charset="-120"/>
               </a:rPr>
-              <a:t>Evaluación orientada a tarea</a:t>
-            </a:r>
-            <a:endParaRPr lang="en-US" sz="1400" dirty="0"/>
-          </a:p>
-        </p:txBody>
-      </p:sp>
-      <p:sp>
-        <p:nvSpPr>
-          <p:cNvPr id="7" name="Text 5"/>
-          <p:cNvSpPr/>
-          <p:nvPr/>
-        </p:nvSpPr>
-        <p:spPr>
-          <a:xfrm>
-            <a:off x="4846320" y="1188720"/>
-            <a:ext cx="3840480" cy="3291840"/>
-          </a:xfrm>
-          <a:prstGeom prst="rect">
-            <a:avLst/>
-          </a:prstGeom>
-          <a:noFill/>
-          <a:ln/>
-        </p:spPr>
-        <p:txBody>
-          <a:bodyPr wrap="square" lIns="0" tIns="0" rIns="0" bIns="0" rtlCol="0" anchor="t"/>
-          <a:lstStyle/>
-          <a:p>
-            <a:pPr marL="177800" indent="-177800">
-              <a:spcAft>
-                <a:spcPts val="800"/>
-              </a:spcAft>
-              <a:buSzPct val="100000"/>
-              <a:buChar char="•"/>
-            </a:pPr>
-            <a:r>
-              <a:rPr lang="en-US" sz="1250" dirty="0">
-                <a:solidFill>
-                  <a:srgbClr val="1A1A1A"/>
-                </a:solidFill>
-                <a:latin typeface="Times New Roman" pitchFamily="34" charset="0"/>
-                <a:ea typeface="Times New Roman" pitchFamily="34" charset="-122"/>
-                <a:cs typeface="Times New Roman" pitchFamily="34" charset="-120"/>
-              </a:rPr>
-              <a:t>Dataset etiquetado LLVIP (peatones nocturnos): 2.000 imágenes de entrenamiento y 500 de validación.</a:t>
-            </a:r>
-            <a:endParaRPr lang="en-US" sz="1250" dirty="0"/>
-          </a:p>
-          <a:p>
-            <a:pPr marL="177800" indent="-177800">
-              <a:spcAft>
-                <a:spcPts val="800"/>
-              </a:spcAft>
-              <a:buSzPct val="100000"/>
-              <a:buChar char="•"/>
-            </a:pPr>
-            <a:r>
-              <a:rPr lang="en-US" sz="1250" dirty="0">
-                <a:solidFill>
-                  <a:srgbClr val="1A1A1A"/>
-                </a:solidFill>
-                <a:latin typeface="Times New Roman" pitchFamily="34" charset="0"/>
-                <a:ea typeface="Times New Roman" pitchFamily="34" charset="-122"/>
-                <a:cs typeface="Times New Roman" pitchFamily="34" charset="-120"/>
-              </a:rPr>
-              <a:t>YOLOv8n reentrenado por modalidad (40 épocas), 9 entradas: VIS, IR y las 7 fusiones.</a:t>
-            </a:r>
-            <a:endParaRPr lang="en-US" sz="1250" dirty="0"/>
-          </a:p>
-          <a:p>
-            <a:pPr marL="177800" indent="-177800">
-              <a:spcAft>
-                <a:spcPts val="800"/>
-              </a:spcAft>
-              <a:buSzPct val="100000"/>
-              <a:buChar char="•"/>
-            </a:pPr>
-            <a:r>
-              <a:rPr lang="en-US" sz="1250" dirty="0">
-                <a:solidFill>
-                  <a:srgbClr val="1A1A1A"/>
-                </a:solidFill>
-                <a:latin typeface="Times New Roman" pitchFamily="34" charset="0"/>
-                <a:ea typeface="Times New Roman" pitchFamily="34" charset="-122"/>
-                <a:cs typeface="Times New Roman" pitchFamily="34" charset="-120"/>
-              </a:rPr>
-              <a:t>Etiquetas idénticas entre modalidades: la diferencia de mAP aísla el efecto del método de fusión.</a:t>
-            </a:r>
-            <a:endParaRPr lang="en-US" sz="1250" dirty="0"/>
+              <a:t>Ambas aptitudes acuerdan el peso del operador con suma; la orientada a la fusión controla además los artefactos (refuerza H2).</a:t>
+            </a:r>
+            <a:endParaRPr lang="en-US" sz="1200" dirty="0"/>
           </a:p>
         </p:txBody>
       </p:sp>

</xml_diff>

<commit_message>
Integra los resultados M3FD en libro, avances, Excel, presentación y README
- Libro (61 págs): sección 5.5 retitulada (LLVIP y M3FD) y cerrada con el
  bloque de clases complementarias (Tabla 13); sexto hallazgo en 5.7,
  conclusión ampliada, RESUMEN/SUMMARY actualizados y referencia Liu et al.
  (2022). Se normalizan las negritas de las Tablas 12 y 13.
- Avances (29 págs): sección 13 con Tabla 10 y lectura; conclusiones a 14.
- Excel (12 hojas): hoja nueva Deteccion_M3FD (0 errores de fórmula).
- Presentación (19 láminas): lámina de clases complementarias con barras
  agrupadas People/Lamp; agenda actualizada.
- README: resultados del experimento en la sección 8.1.
</commit_message>
<xml_diff>
--- a/docs/Tesis_Defensa_Presentacion.pptx
+++ b/docs/Tesis_Defensa_Presentacion.pptx
@@ -23,9 +23,10 @@
     <p:sldId id="271" r:id="rId17"/>
     <p:sldId id="272" r:id="rId18"/>
     <p:sldId id="273" r:id="rId19"/>
+    <p:sldId id="274" r:id="rId20"/>
   </p:sldIdLst>
   <p:notesMasterIdLst>
-    <p:notesMasterId r:id="rId20"/>
+    <p:notesMasterId r:id="rId21"/>
   </p:notesMasterIdLst>
   <p:sldSz cx="9144000" cy="5143500"/>
   <p:notesSz cx="5143500" cy="9144000"/>
@@ -1047,7 +1048,7 @@
           <a:p>
             <a:r>
               <a:rPr lang="en-US" dirty="0"/>
-              <a:t>H1 y H2 quedan sostenidas con evidencia estadística. H3 solo parcialmente: es el resultado más honesto del trabajo y anticipa la pregunta natural del tribunal — calidad de imagen y utilidad en tarea son criterios distintos.</a:t>
+              <a:t>El experimento que delimita el valor de la fusión: un único YOLOv8n entrenado con VIS+IR mezcladas (4.000 imágenes, 40 épocas) e inferencia por método. Las personas solo se ven bien en IR y las luces solo en VIS; la fusión es la única entrada que detecta ambas a la vez. La propuesta lidera entre las fusiones y su ventaja sobre el óptimo Fo confirma la elección de la aptitud también en tarea.</a:t>
             </a:r>
             <a:endParaRPr lang="en-US" dirty="0"/>
           </a:p>
@@ -1135,7 +1136,7 @@
           <a:p>
             <a:r>
               <a:rPr lang="en-US" dirty="0"/>
-              <a:t>Cinco conclusiones: método formulado, óptimo hallado, perfil de calidad validado, ventaja sobre el clásico demostrada, y la lección sobre calidad vs. tarea.</a:t>
+              <a:t>H1 y H2 quedan sostenidas con evidencia estadística. H3 solo parcialmente: es el resultado más honesto del trabajo y anticipa la pregunta natural del tribunal — calidad de imagen y utilidad en tarea son criterios distintos.</a:t>
             </a:r>
             <a:endParaRPr lang="en-US" dirty="0"/>
           </a:p>
@@ -1223,7 +1224,7 @@
           <a:p>
             <a:r>
               <a:rPr lang="en-US" dirty="0"/>
-              <a:t>Cerrar con la recomendación práctica: qué método elegir según el criterio operativo. Dejar claro que el pipeline completo es reproducible desde el repositorio.</a:t>
+              <a:t>Cinco conclusiones: método formulado, óptimo hallado, perfil de calidad validado, ventaja sobre el clásico demostrada, y la lección sobre calidad vs. tarea.</a:t>
             </a:r>
             <a:endParaRPr lang="en-US" dirty="0"/>
           </a:p>
@@ -1311,7 +1312,7 @@
           <a:p>
             <a:r>
               <a:rPr lang="en-US" dirty="0"/>
-              <a:t>Agradecer a la mesa y al orientador. Ofrecer el repositorio para cualquier verificación.</a:t>
+              <a:t>Cerrar con la recomendación práctica: qué método elegir según el criterio operativo. Dejar claro que el pipeline completo es reproducible desde el repositorio.</a:t>
             </a:r>
             <a:endParaRPr lang="en-US" dirty="0"/>
           </a:p>
@@ -1335,6 +1336,94 @@
             <a:fld id="{F7021451-1387-4CA6-816F-3879F97B5CBC}" type="slidenum">
               <a:rPr lang="en-US"/>
               <a:t>18</a:t>
+            </a:fld>
+            <a:endParaRPr lang="en-US"/>
+          </a:p>
+        </p:txBody>
+      </p:sp>
+    </p:spTree>
+    <p:extLst>
+      <p:ext uri="{BB962C8B-B14F-4D97-AF65-F5344CB8AC3E}">
+        <p14:creationId xmlns:p14="http://schemas.microsoft.com/office/powerpoint/2010/main" val="1024086991"/>
+      </p:ext>
+    </p:extLst>
+  </p:cSld>
+  <p:clrMapOvr>
+    <a:masterClrMapping/>
+  </p:clrMapOvr>
+</p:notes>
+</file>
+
+<file path=ppt/notesSlides/notesSlide19.xml><?xml version="1.0" encoding="utf-8"?>
+<p:notes xmlns:a="http://schemas.openxmlformats.org/drawingml/2006/main" xmlns:r="http://schemas.openxmlformats.org/officeDocument/2006/relationships" xmlns:p="http://schemas.openxmlformats.org/presentationml/2006/main">
+  <p:cSld>
+    <p:spTree>
+      <p:nvGrpSpPr>
+        <p:cNvPr id="1" name=""/>
+        <p:cNvGrpSpPr/>
+        <p:nvPr/>
+      </p:nvGrpSpPr>
+      <p:grpSpPr>
+        <a:xfrm>
+          <a:off x="0" y="0"/>
+          <a:ext cx="0" cy="0"/>
+          <a:chOff x="0" y="0"/>
+          <a:chExt cx="0" cy="0"/>
+        </a:xfrm>
+      </p:grpSpPr>
+      <p:sp>
+        <p:nvSpPr>
+          <p:cNvPr id="2" name="Slide Image Placeholder 1"/>
+          <p:cNvSpPr>
+            <a:spLocks noGrp="1" noRot="1" noChangeAspect="1"/>
+          </p:cNvSpPr>
+          <p:nvPr>
+            <p:ph type="sldImg"/>
+          </p:nvPr>
+        </p:nvSpPr>
+        <p:spPr/>
+      </p:sp>
+      <p:sp>
+        <p:nvSpPr>
+          <p:cNvPr id="3" name="Notes Placeholder 2"/>
+          <p:cNvSpPr>
+            <a:spLocks noGrp="1"/>
+          </p:cNvSpPr>
+          <p:nvPr>
+            <p:ph type="body" idx="1"/>
+          </p:nvPr>
+        </p:nvSpPr>
+        <p:spPr/>
+        <p:txBody>
+          <a:bodyPr/>
+          <a:lstStyle/>
+          <a:p>
+            <a:r>
+              <a:rPr lang="en-US" dirty="0"/>
+              <a:t>Agradecer a la mesa y al orientador. Ofrecer el repositorio para cualquier verificación.</a:t>
+            </a:r>
+            <a:endParaRPr lang="en-US" dirty="0"/>
+          </a:p>
+        </p:txBody>
+      </p:sp>
+      <p:sp>
+        <p:nvSpPr>
+          <p:cNvPr id="4" name="Slide Number Placeholder 3"/>
+          <p:cNvSpPr>
+            <a:spLocks noGrp="1"/>
+          </p:cNvSpPr>
+          <p:nvPr>
+            <p:ph type="sldNum" sz="quarter" idx="10"/>
+          </p:nvPr>
+        </p:nvSpPr>
+        <p:spPr/>
+        <p:txBody>
+          <a:bodyPr/>
+          <a:lstStyle/>
+          <a:p>
+            <a:fld id="{F7021451-1387-4CA6-816F-3879F97B5CBC}" type="slidenum">
+              <a:rPr lang="en-US"/>
+              <a:t>19</a:t>
             </a:fld>
             <a:endParaRPr lang="en-US"/>
           </a:p>
@@ -2794,7 +2883,7 @@
                 <a:ea typeface="Times New Roman" pitchFamily="34" charset="-122"/>
                 <a:cs typeface="Times New Roman" pitchFamily="34" charset="-120"/>
               </a:rPr>
-              <a:t>10 / 18</a:t>
+              <a:t>10 / 19</a:t>
             </a:r>
             <a:endParaRPr lang="en-US" sz="900" dirty="0"/>
           </a:p>
@@ -3173,7 +3262,7 @@
                 <a:ea typeface="Times New Roman" pitchFamily="34" charset="-122"/>
                 <a:cs typeface="Times New Roman" pitchFamily="34" charset="-120"/>
               </a:rPr>
-              <a:t>11 / 18</a:t>
+              <a:t>11 / 19</a:t>
             </a:r>
             <a:endParaRPr lang="en-US" sz="900" dirty="0"/>
           </a:p>
@@ -3346,7 +3435,7 @@
                 <a:ea typeface="Times New Roman" pitchFamily="34" charset="-122"/>
                 <a:cs typeface="Times New Roman" pitchFamily="34" charset="-120"/>
               </a:rPr>
-              <a:t>12 / 18</a:t>
+              <a:t>12 / 19</a:t>
             </a:r>
             <a:endParaRPr lang="en-US" sz="900" dirty="0"/>
           </a:p>
@@ -6708,7 +6797,7 @@
                 <a:ea typeface="Times New Roman" pitchFamily="34" charset="-122"/>
                 <a:cs typeface="Times New Roman" pitchFamily="34" charset="-120"/>
               </a:rPr>
-              <a:t>13 / 18</a:t>
+              <a:t>13 / 19</a:t>
             </a:r>
             <a:endParaRPr lang="en-US" sz="900" dirty="0"/>
           </a:p>
@@ -6987,7 +7076,7 @@
                 <a:ea typeface="Times New Roman" pitchFamily="34" charset="-122"/>
                 <a:cs typeface="Times New Roman" pitchFamily="34" charset="-120"/>
               </a:rPr>
-              <a:t>14 / 18</a:t>
+              <a:t>14 / 19</a:t>
             </a:r>
             <a:endParaRPr lang="en-US" sz="900" dirty="0"/>
           </a:p>
@@ -7167,7 +7256,7 @@
                 <a:ea typeface="Times New Roman" pitchFamily="34" charset="-122"/>
                 <a:cs typeface="Times New Roman" pitchFamily="34" charset="-120"/>
               </a:rPr>
-              <a:t>Contraste de hipótesis</a:t>
+              <a:t>Clases complementarias en M3FD — un detector único VIS+IR</a:t>
             </a:r>
             <a:endParaRPr lang="en-US" sz="2300" dirty="0"/>
           </a:p>
@@ -7206,22 +7295,46 @@
                 <a:ea typeface="Times New Roman" pitchFamily="34" charset="-122"/>
                 <a:cs typeface="Times New Roman" pitchFamily="34" charset="-120"/>
               </a:rPr>
-              <a:t>15 / 18</a:t>
+              <a:t>15 / 19</a:t>
             </a:r>
             <a:endParaRPr lang="en-US" sz="900" dirty="0"/>
           </a:p>
         </p:txBody>
       </p:sp>
-      <p:sp>
-        <p:nvSpPr>
-          <p:cNvPr id="4" name="Text 2"/>
+      <p:pic>
+        <p:nvPicPr>
+          <p:cNvPr id="4" name="Image 0" descr="C:\Users\Usuario\AppData\Local\Temp\claude\C--Users-Usuario-Documents-unv-mastertesis\fa0a2acc-a0da-4701-a920-18b20c70d3b2\scratchpad\pptx_build/assets/m3fd_par.png">    </p:cNvPr>
+          <p:cNvPicPr>
+            <a:picLocks noChangeAspect="1"/>
+          </p:cNvPicPr>
+          <p:nvPr/>
+        </p:nvPicPr>
+        <p:blipFill>
+          <a:blip r:embed="rId1"/>
+          <a:stretch>
+            <a:fillRect/>
+          </a:stretch>
+        </p:blipFill>
+        <p:spPr>
+          <a:xfrm>
+            <a:off x="640080" y="868680"/>
+            <a:ext cx="7863840" cy="2944368"/>
+          </a:xfrm>
+          <a:prstGeom prst="rect">
+            <a:avLst/>
+          </a:prstGeom>
+        </p:spPr>
+      </p:pic>
+      <p:sp>
+        <p:nvSpPr>
+          <p:cNvPr id="5" name="Text 2"/>
           <p:cNvSpPr/>
           <p:nvPr/>
         </p:nvSpPr>
         <p:spPr>
           <a:xfrm>
-            <a:off x="457200" y="960120"/>
-            <a:ext cx="640080" cy="411480"/>
+            <a:off x="457200" y="3913632"/>
+            <a:ext cx="8229600" cy="1143000"/>
           </a:xfrm>
           <a:prstGeom prst="rect">
             <a:avLst/>
@@ -7230,14 +7343,18 @@
           <a:ln/>
         </p:spPr>
         <p:txBody>
-          <a:bodyPr wrap="square" lIns="0" tIns="0" rIns="0" bIns="0" rtlCol="0" anchor="ctr"/>
-          <a:lstStyle/>
-          <a:p>
-            <a:pPr indent="0" marL="0">
-              <a:buNone/>
-            </a:pPr>
-            <a:r>
-              <a:rPr lang="en-US" sz="1900" b="1" dirty="0">
+          <a:bodyPr wrap="square" lIns="0" tIns="0" rIns="0" bIns="0" rtlCol="0" anchor="t"/>
+          <a:lstStyle/>
+          <a:p>
+            <a:pPr marL="177800" indent="-177800">
+              <a:spcAft>
+                <a:spcPts val="400"/>
+              </a:spcAft>
+              <a:buSzPct val="100000"/>
+              <a:buChar char="•"/>
+            </a:pPr>
+            <a:r>
+              <a:rPr lang="en-US" sz="1150" dirty="0">
                 <a:solidFill>
                   <a:srgbClr val="1A1A1A"/>
                 </a:solidFill>
@@ -7245,77 +7362,20 @@
                 <a:ea typeface="Times New Roman" pitchFamily="34" charset="-122"/>
                 <a:cs typeface="Times New Roman" pitchFamily="34" charset="-120"/>
               </a:rPr>
-              <a:t>H1</a:t>
-            </a:r>
-            <a:endParaRPr lang="en-US" sz="1900" dirty="0"/>
-          </a:p>
-        </p:txBody>
-      </p:sp>
-      <p:sp>
-        <p:nvSpPr>
-          <p:cNvPr id="5" name="Text 3"/>
-          <p:cNvSpPr/>
-          <p:nvPr/>
-        </p:nvSpPr>
-        <p:spPr>
-          <a:xfrm>
-            <a:off x="1143000" y="996696"/>
-            <a:ext cx="1417320" cy="365760"/>
-          </a:xfrm>
-          <a:prstGeom prst="rect">
-            <a:avLst/>
-          </a:prstGeom>
-          <a:noFill/>
-          <a:ln/>
-        </p:spPr>
-        <p:txBody>
-          <a:bodyPr wrap="square" lIns="0" tIns="0" rIns="0" bIns="0" rtlCol="0" anchor="ctr"/>
-          <a:lstStyle/>
-          <a:p>
-            <a:pPr indent="0" marL="0">
-              <a:buNone/>
-            </a:pPr>
-            <a:r>
-              <a:rPr lang="en-US" sz="1300" b="1" dirty="0">
-                <a:solidFill>
-                  <a:srgbClr val="1F5C2E"/>
-                </a:solidFill>
-                <a:latin typeface="Times New Roman" pitchFamily="34" charset="0"/>
-                <a:ea typeface="Times New Roman" pitchFamily="34" charset="-122"/>
-                <a:cs typeface="Times New Roman" pitchFamily="34" charset="-120"/>
-              </a:rPr>
-              <a:t>SOSTENIDA</a:t>
-            </a:r>
-            <a:endParaRPr lang="en-US" sz="1300" dirty="0"/>
-          </a:p>
-        </p:txBody>
-      </p:sp>
-      <p:sp>
-        <p:nvSpPr>
-          <p:cNvPr id="6" name="Text 4"/>
-          <p:cNvSpPr/>
-          <p:nvPr/>
-        </p:nvSpPr>
-        <p:spPr>
-          <a:xfrm>
-            <a:off x="2697480" y="960120"/>
-            <a:ext cx="5989320" cy="1143000"/>
-          </a:xfrm>
-          <a:prstGeom prst="rect">
-            <a:avLst/>
-          </a:prstGeom>
-          <a:noFill/>
-          <a:ln/>
-        </p:spPr>
-        <p:txBody>
-          <a:bodyPr wrap="square" lIns="0" tIns="0" rIns="0" bIns="0" rtlCol="0" anchor="t"/>
-          <a:lstStyle/>
-          <a:p>
-            <a:pPr indent="0" marL="0">
-              <a:buNone/>
-            </a:pPr>
-            <a:r>
-              <a:rPr lang="en-US" sz="1250" dirty="0">
+              <a:t>Complementariedad extrema: el IR domina People (0,220) pero es ciego a Lamp (0,018); el VIS es el espejo (0,178 / 0,135).</a:t>
+            </a:r>
+            <a:endParaRPr lang="en-US" sz="1150" dirty="0"/>
+          </a:p>
+          <a:p>
+            <a:pPr marL="177800" indent="-177800">
+              <a:spcAft>
+                <a:spcPts val="400"/>
+              </a:spcAft>
+              <a:buSzPct val="100000"/>
+              <a:buChar char="•"/>
+            </a:pPr>
+            <a:r>
+              <a:rPr lang="en-US" sz="1150" b="1" dirty="0">
                 <a:solidFill>
                   <a:srgbClr val="1A1A1A"/>
                 </a:solidFill>
@@ -7323,38 +7383,20 @@
                 <a:ea typeface="Times New Roman" pitchFamily="34" charset="-122"/>
                 <a:cs typeface="Times New Roman" pitchFamily="34" charset="-120"/>
               </a:rPr>
-              <a:t>El banco disco + líneas con suma de ramas mejora SSIM (0,782 vs 0,578) y reduce Nabf (0,041 vs 0,585) frente al Top-Hat clásico, con significancia estadística (Wilcoxon–Holm).</a:t>
-            </a:r>
-            <a:endParaRPr lang="en-US" sz="1250" dirty="0"/>
-          </a:p>
-        </p:txBody>
-      </p:sp>
-      <p:sp>
-        <p:nvSpPr>
-          <p:cNvPr id="7" name="Text 5"/>
-          <p:cNvSpPr/>
-          <p:nvPr/>
-        </p:nvSpPr>
-        <p:spPr>
-          <a:xfrm>
-            <a:off x="457200" y="2258568"/>
-            <a:ext cx="640080" cy="411480"/>
-          </a:xfrm>
-          <a:prstGeom prst="rect">
-            <a:avLst/>
-          </a:prstGeom>
-          <a:noFill/>
-          <a:ln/>
-        </p:spPr>
-        <p:txBody>
-          <a:bodyPr wrap="square" lIns="0" tIns="0" rIns="0" bIns="0" rtlCol="0" anchor="ctr"/>
-          <a:lstStyle/>
-          <a:p>
-            <a:pPr indent="0" marL="0">
-              <a:buNone/>
-            </a:pPr>
-            <a:r>
-              <a:rPr lang="en-US" sz="1900" b="1" dirty="0">
+              <a:t>Las mejores fusiones superan a AMBAS modalidades en el promedio del par (propuesta 0,162; RP 0,165 vs VIS 0,157 e IR 0,119): ambas clases en una sola imagen.</a:t>
+            </a:r>
+            <a:endParaRPr lang="en-US" sz="1150" dirty="0"/>
+          </a:p>
+          <a:p>
+            <a:pPr marL="177800" indent="-177800">
+              <a:spcAft>
+                <a:spcPts val="400"/>
+              </a:spcAft>
+              <a:buSzPct val="100000"/>
+              <a:buChar char="•"/>
+            </a:pPr>
+            <a:r>
+              <a:rPr lang="en-US" sz="1150" dirty="0">
                 <a:solidFill>
                   <a:srgbClr val="1A1A1A"/>
                 </a:solidFill>
@@ -7362,204 +7404,9 @@
                 <a:ea typeface="Times New Roman" pitchFamily="34" charset="-122"/>
                 <a:cs typeface="Times New Roman" pitchFamily="34" charset="-120"/>
               </a:rPr>
-              <a:t>H2</a:t>
-            </a:r>
-            <a:endParaRPr lang="en-US" sz="1900" dirty="0"/>
-          </a:p>
-        </p:txBody>
-      </p:sp>
-      <p:sp>
-        <p:nvSpPr>
-          <p:cNvPr id="8" name="Text 6"/>
-          <p:cNvSpPr/>
-          <p:nvPr/>
-        </p:nvSpPr>
-        <p:spPr>
-          <a:xfrm>
-            <a:off x="1143000" y="2295144"/>
-            <a:ext cx="1417320" cy="365760"/>
-          </a:xfrm>
-          <a:prstGeom prst="rect">
-            <a:avLst/>
-          </a:prstGeom>
-          <a:noFill/>
-          <a:ln/>
-        </p:spPr>
-        <p:txBody>
-          <a:bodyPr wrap="square" lIns="0" tIns="0" rIns="0" bIns="0" rtlCol="0" anchor="ctr"/>
-          <a:lstStyle/>
-          <a:p>
-            <a:pPr indent="0" marL="0">
-              <a:buNone/>
-            </a:pPr>
-            <a:r>
-              <a:rPr lang="en-US" sz="1300" b="1" dirty="0">
-                <a:solidFill>
-                  <a:srgbClr val="1F5C2E"/>
-                </a:solidFill>
-                <a:latin typeface="Times New Roman" pitchFamily="34" charset="0"/>
-                <a:ea typeface="Times New Roman" pitchFamily="34" charset="-122"/>
-                <a:cs typeface="Times New Roman" pitchFamily="34" charset="-120"/>
-              </a:rPr>
-              <a:t>SOSTENIDA</a:t>
-            </a:r>
-            <a:endParaRPr lang="en-US" sz="1300" dirty="0"/>
-          </a:p>
-        </p:txBody>
-      </p:sp>
-      <p:sp>
-        <p:nvSpPr>
-          <p:cNvPr id="9" name="Text 7"/>
-          <p:cNvSpPr/>
-          <p:nvPr/>
-        </p:nvSpPr>
-        <p:spPr>
-          <a:xfrm>
-            <a:off x="2697480" y="2258568"/>
-            <a:ext cx="5989320" cy="1143000"/>
-          </a:xfrm>
-          <a:prstGeom prst="rect">
-            <a:avLst/>
-          </a:prstGeom>
-          <a:noFill/>
-          <a:ln/>
-        </p:spPr>
-        <p:txBody>
-          <a:bodyPr wrap="square" lIns="0" tIns="0" rIns="0" bIns="0" rtlCol="0" anchor="t"/>
-          <a:lstStyle/>
-          <a:p>
-            <a:pPr indent="0" marL="0">
-              <a:buNone/>
-            </a:pPr>
-            <a:r>
-              <a:rPr lang="en-US" sz="1250" dirty="0">
-                <a:solidFill>
-                  <a:srgbClr val="1A1A1A"/>
-                </a:solidFill>
-                <a:latin typeface="Times New Roman" pitchFamily="34" charset="0"/>
-                <a:ea typeface="Times New Roman" pitchFamily="34" charset="-122"/>
-                <a:cs typeface="Times New Roman" pitchFamily="34" charset="-120"/>
-              </a:rPr>
-              <a:t>La configuración hallada por PSO (r = 25; m = 0,0703) supera a la parametrización manual del operador clásico (r = 5; m = 1) en todas las métricas de calidad de fusión.</a:t>
-            </a:r>
-            <a:endParaRPr lang="en-US" sz="1250" dirty="0"/>
-          </a:p>
-        </p:txBody>
-      </p:sp>
-      <p:sp>
-        <p:nvSpPr>
-          <p:cNvPr id="10" name="Text 8"/>
-          <p:cNvSpPr/>
-          <p:nvPr/>
-        </p:nvSpPr>
-        <p:spPr>
-          <a:xfrm>
-            <a:off x="457200" y="3557016"/>
-            <a:ext cx="640080" cy="411480"/>
-          </a:xfrm>
-          <a:prstGeom prst="rect">
-            <a:avLst/>
-          </a:prstGeom>
-          <a:noFill/>
-          <a:ln/>
-        </p:spPr>
-        <p:txBody>
-          <a:bodyPr wrap="square" lIns="0" tIns="0" rIns="0" bIns="0" rtlCol="0" anchor="ctr"/>
-          <a:lstStyle/>
-          <a:p>
-            <a:pPr indent="0" marL="0">
-              <a:buNone/>
-            </a:pPr>
-            <a:r>
-              <a:rPr lang="en-US" sz="1900" b="1" dirty="0">
-                <a:solidFill>
-                  <a:srgbClr val="1A1A1A"/>
-                </a:solidFill>
-                <a:latin typeface="Times New Roman" pitchFamily="34" charset="0"/>
-                <a:ea typeface="Times New Roman" pitchFamily="34" charset="-122"/>
-                <a:cs typeface="Times New Roman" pitchFamily="34" charset="-120"/>
-              </a:rPr>
-              <a:t>H3</a:t>
-            </a:r>
-            <a:endParaRPr lang="en-US" sz="1900" dirty="0"/>
-          </a:p>
-        </p:txBody>
-      </p:sp>
-      <p:sp>
-        <p:nvSpPr>
-          <p:cNvPr id="11" name="Text 9"/>
-          <p:cNvSpPr/>
-          <p:nvPr/>
-        </p:nvSpPr>
-        <p:spPr>
-          <a:xfrm>
-            <a:off x="1143000" y="3593592"/>
-            <a:ext cx="1417320" cy="365760"/>
-          </a:xfrm>
-          <a:prstGeom prst="rect">
-            <a:avLst/>
-          </a:prstGeom>
-          <a:noFill/>
-          <a:ln/>
-        </p:spPr>
-        <p:txBody>
-          <a:bodyPr wrap="square" lIns="0" tIns="0" rIns="0" bIns="0" rtlCol="0" anchor="ctr"/>
-          <a:lstStyle/>
-          <a:p>
-            <a:pPr indent="0" marL="0">
-              <a:buNone/>
-            </a:pPr>
-            <a:r>
-              <a:rPr lang="en-US" sz="1300" b="1" dirty="0">
-                <a:solidFill>
-                  <a:srgbClr val="8B1A1A"/>
-                </a:solidFill>
-                <a:latin typeface="Times New Roman" pitchFamily="34" charset="0"/>
-                <a:ea typeface="Times New Roman" pitchFamily="34" charset="-122"/>
-                <a:cs typeface="Times New Roman" pitchFamily="34" charset="-120"/>
-              </a:rPr>
-              <a:t>PARCIAL</a:t>
-            </a:r>
-            <a:endParaRPr lang="en-US" sz="1300" dirty="0"/>
-          </a:p>
-        </p:txBody>
-      </p:sp>
-      <p:sp>
-        <p:nvSpPr>
-          <p:cNvPr id="12" name="Text 10"/>
-          <p:cNvSpPr/>
-          <p:nvPr/>
-        </p:nvSpPr>
-        <p:spPr>
-          <a:xfrm>
-            <a:off x="2697480" y="3557016"/>
-            <a:ext cx="5989320" cy="1143000"/>
-          </a:xfrm>
-          <a:prstGeom prst="rect">
-            <a:avLst/>
-          </a:prstGeom>
-          <a:noFill/>
-          <a:ln/>
-        </p:spPr>
-        <p:txBody>
-          <a:bodyPr wrap="square" lIns="0" tIns="0" rIns="0" bIns="0" rtlCol="0" anchor="t"/>
-          <a:lstStyle/>
-          <a:p>
-            <a:pPr indent="0" marL="0">
-              <a:buNone/>
-            </a:pPr>
-            <a:r>
-              <a:rPr lang="en-US" sz="1250" dirty="0">
-                <a:solidFill>
-                  <a:srgbClr val="1A1A1A"/>
-                </a:solidFill>
-                <a:latin typeface="Times New Roman" pitchFamily="34" charset="0"/>
-                <a:ea typeface="Times New Roman" pitchFamily="34" charset="-122"/>
-                <a:cs typeface="Times New Roman" pitchFamily="34" charset="-120"/>
-              </a:rPr>
-              <a:t>La fusión supera al visible solo en detección, pero ninguna fusión supera al infrarrojo solo; la mejor calidad de imagen no garantiza el mejor mAP.</a:t>
-            </a:r>
-            <a:endParaRPr lang="en-US" sz="1250" dirty="0"/>
+              <a:t>La propuesta es la mejor fusión en mAP global (0,239) y en People (0,207); su óptimo F_apt supera al de Fo en las dos clases clave.</a:t>
+            </a:r>
+            <a:endParaRPr lang="en-US" sz="1150" dirty="0"/>
           </a:p>
         </p:txBody>
       </p:sp>
@@ -7628,7 +7475,7 @@
                 <a:ea typeface="Times New Roman" pitchFamily="34" charset="-122"/>
                 <a:cs typeface="Times New Roman" pitchFamily="34" charset="-120"/>
               </a:rPr>
-              <a:t>9. Conclusiones</a:t>
+              <a:t>Contraste de hipótesis</a:t>
             </a:r>
             <a:endParaRPr lang="en-US" sz="2300" dirty="0"/>
           </a:p>
@@ -7667,7 +7514,7 @@
                 <a:ea typeface="Times New Roman" pitchFamily="34" charset="-122"/>
                 <a:cs typeface="Times New Roman" pitchFamily="34" charset="-120"/>
               </a:rPr>
-              <a:t>16 / 18</a:t>
+              <a:t>16 / 19</a:t>
             </a:r>
             <a:endParaRPr lang="en-US" sz="900" dirty="0"/>
           </a:p>
@@ -7681,8 +7528,8 @@
         </p:nvSpPr>
         <p:spPr>
           <a:xfrm>
-            <a:off x="457200" y="914400"/>
-            <a:ext cx="8229600" cy="3931920"/>
+            <a:off x="457200" y="960120"/>
+            <a:ext cx="640080" cy="411480"/>
           </a:xfrm>
           <a:prstGeom prst="rect">
             <a:avLst/>
@@ -7691,18 +7538,92 @@
           <a:ln/>
         </p:spPr>
         <p:txBody>
+          <a:bodyPr wrap="square" lIns="0" tIns="0" rIns="0" bIns="0" rtlCol="0" anchor="ctr"/>
+          <a:lstStyle/>
+          <a:p>
+            <a:pPr indent="0" marL="0">
+              <a:buNone/>
+            </a:pPr>
+            <a:r>
+              <a:rPr lang="en-US" sz="1900" b="1" dirty="0">
+                <a:solidFill>
+                  <a:srgbClr val="1A1A1A"/>
+                </a:solidFill>
+                <a:latin typeface="Times New Roman" pitchFamily="34" charset="0"/>
+                <a:ea typeface="Times New Roman" pitchFamily="34" charset="-122"/>
+                <a:cs typeface="Times New Roman" pitchFamily="34" charset="-120"/>
+              </a:rPr>
+              <a:t>H1</a:t>
+            </a:r>
+            <a:endParaRPr lang="en-US" sz="1900" dirty="0"/>
+          </a:p>
+        </p:txBody>
+      </p:sp>
+      <p:sp>
+        <p:nvSpPr>
+          <p:cNvPr id="5" name="Text 3"/>
+          <p:cNvSpPr/>
+          <p:nvPr/>
+        </p:nvSpPr>
+        <p:spPr>
+          <a:xfrm>
+            <a:off x="1143000" y="996696"/>
+            <a:ext cx="1417320" cy="365760"/>
+          </a:xfrm>
+          <a:prstGeom prst="rect">
+            <a:avLst/>
+          </a:prstGeom>
+          <a:noFill/>
+          <a:ln/>
+        </p:spPr>
+        <p:txBody>
+          <a:bodyPr wrap="square" lIns="0" tIns="0" rIns="0" bIns="0" rtlCol="0" anchor="ctr"/>
+          <a:lstStyle/>
+          <a:p>
+            <a:pPr indent="0" marL="0">
+              <a:buNone/>
+            </a:pPr>
+            <a:r>
+              <a:rPr lang="en-US" sz="1300" b="1" dirty="0">
+                <a:solidFill>
+                  <a:srgbClr val="1F5C2E"/>
+                </a:solidFill>
+                <a:latin typeface="Times New Roman" pitchFamily="34" charset="0"/>
+                <a:ea typeface="Times New Roman" pitchFamily="34" charset="-122"/>
+                <a:cs typeface="Times New Roman" pitchFamily="34" charset="-120"/>
+              </a:rPr>
+              <a:t>SOSTENIDA</a:t>
+            </a:r>
+            <a:endParaRPr lang="en-US" sz="1300" dirty="0"/>
+          </a:p>
+        </p:txBody>
+      </p:sp>
+      <p:sp>
+        <p:nvSpPr>
+          <p:cNvPr id="6" name="Text 4"/>
+          <p:cNvSpPr/>
+          <p:nvPr/>
+        </p:nvSpPr>
+        <p:spPr>
+          <a:xfrm>
+            <a:off x="2697480" y="960120"/>
+            <a:ext cx="5989320" cy="1143000"/>
+          </a:xfrm>
+          <a:prstGeom prst="rect">
+            <a:avLst/>
+          </a:prstGeom>
+          <a:noFill/>
+          <a:ln/>
+        </p:spPr>
+        <p:txBody>
           <a:bodyPr wrap="square" lIns="0" tIns="0" rIns="0" bIns="0" rtlCol="0" anchor="t"/>
           <a:lstStyle/>
           <a:p>
-            <a:pPr marL="177800" indent="-177800">
-              <a:spcAft>
-                <a:spcPts val="1100"/>
-              </a:spcAft>
-              <a:buSzPct val="100000"/>
-              <a:buChar char="•"/>
-            </a:pPr>
-            <a:r>
-              <a:rPr lang="en-US" sz="1350" dirty="0">
+            <a:pPr indent="0" marL="0">
+              <a:buNone/>
+            </a:pPr>
+            <a:r>
+              <a:rPr lang="en-US" sz="1250" dirty="0">
                 <a:solidFill>
                   <a:srgbClr val="1A1A1A"/>
                 </a:solidFill>
@@ -7710,20 +7631,38 @@
                 <a:ea typeface="Times New Roman" pitchFamily="34" charset="-122"/>
                 <a:cs typeface="Times New Roman" pitchFamily="34" charset="-120"/>
               </a:rPr>
-              <a:t>Se formuló e implementó de forma reproducible un operador Top-Hat de una sola escala con banco de disco + líneas orientadas y suma de ramas.</a:t>
-            </a:r>
-            <a:endParaRPr lang="en-US" sz="1350" dirty="0"/>
-          </a:p>
-          <a:p>
-            <a:pPr marL="177800" indent="-177800">
-              <a:spcAft>
-                <a:spcPts val="1100"/>
-              </a:spcAft>
-              <a:buSzPct val="100000"/>
-              <a:buChar char="•"/>
-            </a:pPr>
-            <a:r>
-              <a:rPr lang="en-US" sz="1350" dirty="0">
+              <a:t>El banco disco + líneas con suma de ramas mejora SSIM (0,782 vs 0,578) y reduce Nabf (0,041 vs 0,585) frente al Top-Hat clásico, con significancia estadística (Wilcoxon–Holm).</a:t>
+            </a:r>
+            <a:endParaRPr lang="en-US" sz="1250" dirty="0"/>
+          </a:p>
+        </p:txBody>
+      </p:sp>
+      <p:sp>
+        <p:nvSpPr>
+          <p:cNvPr id="7" name="Text 5"/>
+          <p:cNvSpPr/>
+          <p:nvPr/>
+        </p:nvSpPr>
+        <p:spPr>
+          <a:xfrm>
+            <a:off x="457200" y="2258568"/>
+            <a:ext cx="640080" cy="411480"/>
+          </a:xfrm>
+          <a:prstGeom prst="rect">
+            <a:avLst/>
+          </a:prstGeom>
+          <a:noFill/>
+          <a:ln/>
+        </p:spPr>
+        <p:txBody>
+          <a:bodyPr wrap="square" lIns="0" tIns="0" rIns="0" bIns="0" rtlCol="0" anchor="ctr"/>
+          <a:lstStyle/>
+          <a:p>
+            <a:pPr indent="0" marL="0">
+              <a:buNone/>
+            </a:pPr>
+            <a:r>
+              <a:rPr lang="en-US" sz="1900" b="1" dirty="0">
                 <a:solidFill>
                   <a:srgbClr val="1A1A1A"/>
                 </a:solidFill>
@@ -7731,20 +7670,77 @@
                 <a:ea typeface="Times New Roman" pitchFamily="34" charset="-122"/>
                 <a:cs typeface="Times New Roman" pitchFamily="34" charset="-120"/>
               </a:rPr>
-              <a:t>El barrido PSO de 25 configuraciones halló el óptimo r = 25, m = 0,0703 (F = 1,9843) de manera consistente.</a:t>
-            </a:r>
-            <a:endParaRPr lang="en-US" sz="1350" dirty="0"/>
-          </a:p>
-          <a:p>
-            <a:pPr marL="177800" indent="-177800">
-              <a:spcAft>
-                <a:spcPts val="1100"/>
-              </a:spcAft>
-              <a:buSzPct val="100000"/>
-              <a:buChar char="•"/>
-            </a:pPr>
-            <a:r>
-              <a:rPr lang="en-US" sz="1350" dirty="0">
+              <a:t>H2</a:t>
+            </a:r>
+            <a:endParaRPr lang="en-US" sz="1900" dirty="0"/>
+          </a:p>
+        </p:txBody>
+      </p:sp>
+      <p:sp>
+        <p:nvSpPr>
+          <p:cNvPr id="8" name="Text 6"/>
+          <p:cNvSpPr/>
+          <p:nvPr/>
+        </p:nvSpPr>
+        <p:spPr>
+          <a:xfrm>
+            <a:off x="1143000" y="2295144"/>
+            <a:ext cx="1417320" cy="365760"/>
+          </a:xfrm>
+          <a:prstGeom prst="rect">
+            <a:avLst/>
+          </a:prstGeom>
+          <a:noFill/>
+          <a:ln/>
+        </p:spPr>
+        <p:txBody>
+          <a:bodyPr wrap="square" lIns="0" tIns="0" rIns="0" bIns="0" rtlCol="0" anchor="ctr"/>
+          <a:lstStyle/>
+          <a:p>
+            <a:pPr indent="0" marL="0">
+              <a:buNone/>
+            </a:pPr>
+            <a:r>
+              <a:rPr lang="en-US" sz="1300" b="1" dirty="0">
+                <a:solidFill>
+                  <a:srgbClr val="1F5C2E"/>
+                </a:solidFill>
+                <a:latin typeface="Times New Roman" pitchFamily="34" charset="0"/>
+                <a:ea typeface="Times New Roman" pitchFamily="34" charset="-122"/>
+                <a:cs typeface="Times New Roman" pitchFamily="34" charset="-120"/>
+              </a:rPr>
+              <a:t>SOSTENIDA</a:t>
+            </a:r>
+            <a:endParaRPr lang="en-US" sz="1300" dirty="0"/>
+          </a:p>
+        </p:txBody>
+      </p:sp>
+      <p:sp>
+        <p:nvSpPr>
+          <p:cNvPr id="9" name="Text 7"/>
+          <p:cNvSpPr/>
+          <p:nvPr/>
+        </p:nvSpPr>
+        <p:spPr>
+          <a:xfrm>
+            <a:off x="2697480" y="2258568"/>
+            <a:ext cx="5989320" cy="1143000"/>
+          </a:xfrm>
+          <a:prstGeom prst="rect">
+            <a:avLst/>
+          </a:prstGeom>
+          <a:noFill/>
+          <a:ln/>
+        </p:spPr>
+        <p:txBody>
+          <a:bodyPr wrap="square" lIns="0" tIns="0" rIns="0" bIns="0" rtlCol="0" anchor="t"/>
+          <a:lstStyle/>
+          <a:p>
+            <a:pPr indent="0" marL="0">
+              <a:buNone/>
+            </a:pPr>
+            <a:r>
+              <a:rPr lang="en-US" sz="1250" dirty="0">
                 <a:solidFill>
                   <a:srgbClr val="1A1A1A"/>
                 </a:solidFill>
@@ -7752,20 +7748,38 @@
                 <a:ea typeface="Times New Roman" pitchFamily="34" charset="-122"/>
                 <a:cs typeface="Times New Roman" pitchFamily="34" charset="-120"/>
               </a:rPr>
-              <a:t>La propuesta exhibe el mejor perfil de calidad del benchmark: menor Nabf y mayor SSIM, con significancia estadística; segunda en Qabf, SCD y VIF.</a:t>
-            </a:r>
-            <a:endParaRPr lang="en-US" sz="1350" dirty="0"/>
-          </a:p>
-          <a:p>
-            <a:pPr marL="177800" indent="-177800">
-              <a:spcAft>
-                <a:spcPts val="1100"/>
-              </a:spcAft>
-              <a:buSzPct val="100000"/>
-              <a:buChar char="•"/>
-            </a:pPr>
-            <a:r>
-              <a:rPr lang="en-US" sz="1350" dirty="0">
+              <a:t>La configuración hallada por PSO (r = 25; m = 0,0703) supera a la parametrización manual del operador clásico (r = 5; m = 1) en todas las métricas de calidad de fusión.</a:t>
+            </a:r>
+            <a:endParaRPr lang="en-US" sz="1250" dirty="0"/>
+          </a:p>
+        </p:txBody>
+      </p:sp>
+      <p:sp>
+        <p:nvSpPr>
+          <p:cNvPr id="10" name="Text 8"/>
+          <p:cNvSpPr/>
+          <p:nvPr/>
+        </p:nvSpPr>
+        <p:spPr>
+          <a:xfrm>
+            <a:off x="457200" y="3557016"/>
+            <a:ext cx="640080" cy="411480"/>
+          </a:xfrm>
+          <a:prstGeom prst="rect">
+            <a:avLst/>
+          </a:prstGeom>
+          <a:noFill/>
+          <a:ln/>
+        </p:spPr>
+        <p:txBody>
+          <a:bodyPr wrap="square" lIns="0" tIns="0" rIns="0" bIns="0" rtlCol="0" anchor="ctr"/>
+          <a:lstStyle/>
+          <a:p>
+            <a:pPr indent="0" marL="0">
+              <a:buNone/>
+            </a:pPr>
+            <a:r>
+              <a:rPr lang="en-US" sz="1900" b="1" dirty="0">
                 <a:solidFill>
                   <a:srgbClr val="1A1A1A"/>
                 </a:solidFill>
@@ -7773,20 +7787,77 @@
                 <a:ea typeface="Times New Roman" pitchFamily="34" charset="-122"/>
                 <a:cs typeface="Times New Roman" pitchFamily="34" charset="-120"/>
               </a:rPr>
-              <a:t>Frente a la metodología clásica Top-Hat, mejora todas las métricas de calidad de fusión: el banco de SE y el ajuste automático aportan valor real.</a:t>
-            </a:r>
-            <a:endParaRPr lang="en-US" sz="1350" dirty="0"/>
-          </a:p>
-          <a:p>
-            <a:pPr marL="177800" indent="-177800">
-              <a:spcAft>
-                <a:spcPts val="1100"/>
-              </a:spcAft>
-              <a:buSzPct val="100000"/>
-              <a:buChar char="•"/>
-            </a:pPr>
-            <a:r>
-              <a:rPr lang="en-US" sz="1350" dirty="0">
+              <a:t>H3</a:t>
+            </a:r>
+            <a:endParaRPr lang="en-US" sz="1900" dirty="0"/>
+          </a:p>
+        </p:txBody>
+      </p:sp>
+      <p:sp>
+        <p:nvSpPr>
+          <p:cNvPr id="11" name="Text 9"/>
+          <p:cNvSpPr/>
+          <p:nvPr/>
+        </p:nvSpPr>
+        <p:spPr>
+          <a:xfrm>
+            <a:off x="1143000" y="3593592"/>
+            <a:ext cx="1417320" cy="365760"/>
+          </a:xfrm>
+          <a:prstGeom prst="rect">
+            <a:avLst/>
+          </a:prstGeom>
+          <a:noFill/>
+          <a:ln/>
+        </p:spPr>
+        <p:txBody>
+          <a:bodyPr wrap="square" lIns="0" tIns="0" rIns="0" bIns="0" rtlCol="0" anchor="ctr"/>
+          <a:lstStyle/>
+          <a:p>
+            <a:pPr indent="0" marL="0">
+              <a:buNone/>
+            </a:pPr>
+            <a:r>
+              <a:rPr lang="en-US" sz="1300" b="1" dirty="0">
+                <a:solidFill>
+                  <a:srgbClr val="8B1A1A"/>
+                </a:solidFill>
+                <a:latin typeface="Times New Roman" pitchFamily="34" charset="0"/>
+                <a:ea typeface="Times New Roman" pitchFamily="34" charset="-122"/>
+                <a:cs typeface="Times New Roman" pitchFamily="34" charset="-120"/>
+              </a:rPr>
+              <a:t>PARCIAL</a:t>
+            </a:r>
+            <a:endParaRPr lang="en-US" sz="1300" dirty="0"/>
+          </a:p>
+        </p:txBody>
+      </p:sp>
+      <p:sp>
+        <p:nvSpPr>
+          <p:cNvPr id="12" name="Text 10"/>
+          <p:cNvSpPr/>
+          <p:nvPr/>
+        </p:nvSpPr>
+        <p:spPr>
+          <a:xfrm>
+            <a:off x="2697480" y="3557016"/>
+            <a:ext cx="5989320" cy="1143000"/>
+          </a:xfrm>
+          <a:prstGeom prst="rect">
+            <a:avLst/>
+          </a:prstGeom>
+          <a:noFill/>
+          <a:ln/>
+        </p:spPr>
+        <p:txBody>
+          <a:bodyPr wrap="square" lIns="0" tIns="0" rIns="0" bIns="0" rtlCol="0" anchor="t"/>
+          <a:lstStyle/>
+          <a:p>
+            <a:pPr indent="0" marL="0">
+              <a:buNone/>
+            </a:pPr>
+            <a:r>
+              <a:rPr lang="en-US" sz="1250" dirty="0">
                 <a:solidFill>
                   <a:srgbClr val="1A1A1A"/>
                 </a:solidFill>
@@ -7794,9 +7865,9 @@
                 <a:ea typeface="Times New Roman" pitchFamily="34" charset="-122"/>
                 <a:cs typeface="Times New Roman" pitchFamily="34" charset="-120"/>
               </a:rPr>
-              <a:t>En detección, la superioridad en calidad de imagen no se traslada automáticamente al mAP: la elección del método debe guiarse por el criterio operativo prioritario.</a:t>
-            </a:r>
-            <a:endParaRPr lang="en-US" sz="1350" dirty="0"/>
+              <a:t>La fusión supera al visible solo en detección, pero ninguna fusión supera al infrarrojo solo; la mejor calidad de imagen no garantiza el mejor mAP.</a:t>
+            </a:r>
+            <a:endParaRPr lang="en-US" sz="1250" dirty="0"/>
           </a:p>
         </p:txBody>
       </p:sp>
@@ -7865,7 +7936,7 @@
                 <a:ea typeface="Times New Roman" pitchFamily="34" charset="-122"/>
                 <a:cs typeface="Times New Roman" pitchFamily="34" charset="-120"/>
               </a:rPr>
-              <a:t>Recomendaciones y trabajo futuro</a:t>
+              <a:t>9. Conclusiones</a:t>
             </a:r>
             <a:endParaRPr lang="en-US" sz="2300" dirty="0"/>
           </a:p>
@@ -7904,7 +7975,7 @@
                 <a:ea typeface="Times New Roman" pitchFamily="34" charset="-122"/>
                 <a:cs typeface="Times New Roman" pitchFamily="34" charset="-120"/>
               </a:rPr>
-              <a:t>17 / 18</a:t>
+              <a:t>17 / 19</a:t>
             </a:r>
             <a:endParaRPr lang="en-US" sz="900" dirty="0"/>
           </a:p>
@@ -7947,7 +8018,7 @@
                 <a:ea typeface="Times New Roman" pitchFamily="34" charset="-122"/>
                 <a:cs typeface="Times New Roman" pitchFamily="34" charset="-120"/>
               </a:rPr>
-              <a:t>Extender la evaluación de detección a otros detectores y al conjunto completo de LLVIP.</a:t>
+              <a:t>Se formuló e implementó de forma reproducible un operador Top-Hat de una sola escala con banco de disco + líneas orientadas y suma de ramas.</a:t>
             </a:r>
             <a:endParaRPr lang="en-US" sz="1350" dirty="0"/>
           </a:p>
@@ -7968,7 +8039,7 @@
                 <a:ea typeface="Times New Roman" pitchFamily="34" charset="-122"/>
                 <a:cs typeface="Times New Roman" pitchFamily="34" charset="-120"/>
               </a:rPr>
-              <a:t>Explorar reglas de fusión adaptativas para la rama Black Top-Hat.</a:t>
+              <a:t>El barrido PSO de 25 configuraciones halló el óptimo r = 25, m = 0,0703 (F = 1,9843) de manera consistente.</a:t>
             </a:r>
             <a:endParaRPr lang="en-US" sz="1350" dirty="0"/>
           </a:p>
@@ -7989,7 +8060,7 @@
                 <a:ea typeface="Times New Roman" pitchFamily="34" charset="-122"/>
                 <a:cs typeface="Times New Roman" pitchFamily="34" charset="-120"/>
               </a:rPr>
-              <a:t>Complementar las métricas objetivas con una validación perceptual por observadores.</a:t>
+              <a:t>La propuesta exhibe el mejor perfil de calidad del benchmark: menor Nabf y mayor SSIM, con significancia estadística; segunda en Qabf, SCD y VIF.</a:t>
             </a:r>
             <a:endParaRPr lang="en-US" sz="1350" dirty="0"/>
           </a:p>
@@ -8010,7 +8081,7 @@
                 <a:ea typeface="Times New Roman" pitchFamily="34" charset="-122"/>
                 <a:cs typeface="Times New Roman" pitchFamily="34" charset="-120"/>
               </a:rPr>
-              <a:t>Evaluar la transferencia a otros dominios (imágenes médicas, aéreas).</a:t>
+              <a:t>Frente a la metodología clásica Top-Hat, mejora todas las métricas de calidad de fusión: el banco de SE y el ajuste automático aportan valor real.</a:t>
             </a:r>
             <a:endParaRPr lang="en-US" sz="1350" dirty="0"/>
           </a:p>
@@ -8031,7 +8102,7 @@
                 <a:ea typeface="Times New Roman" pitchFamily="34" charset="-122"/>
                 <a:cs typeface="Times New Roman" pitchFamily="34" charset="-120"/>
               </a:rPr>
-              <a:t>Para aplicaciones donde los artefactos son críticos (interpretación humana, diagnóstico), la propuesta es la opción recomendada; donde prima el contraste bruto, LP sigue siendo competitiva.</a:t>
+              <a:t>En detección, la superioridad en calidad de imagen no se traslada automáticamente al mAP: la elección del método debe guiarse por el criterio operativo prioritario.</a:t>
             </a:r>
             <a:endParaRPr lang="en-US" sz="1350" dirty="0"/>
           </a:p>
@@ -8077,6 +8148,243 @@
         </p:nvSpPr>
         <p:spPr>
           <a:xfrm>
+            <a:off x="457200" y="256032"/>
+            <a:ext cx="8229600" cy="502920"/>
+          </a:xfrm>
+          <a:prstGeom prst="rect">
+            <a:avLst/>
+          </a:prstGeom>
+          <a:noFill/>
+          <a:ln/>
+        </p:spPr>
+        <p:txBody>
+          <a:bodyPr wrap="square" lIns="0" tIns="0" rIns="0" bIns="0" rtlCol="0" anchor="ctr"/>
+          <a:lstStyle/>
+          <a:p>
+            <a:pPr indent="0" marL="0">
+              <a:buNone/>
+            </a:pPr>
+            <a:r>
+              <a:rPr lang="en-US" sz="2300" b="1" dirty="0">
+                <a:solidFill>
+                  <a:srgbClr val="1A1A1A"/>
+                </a:solidFill>
+                <a:latin typeface="Times New Roman" pitchFamily="34" charset="0"/>
+                <a:ea typeface="Times New Roman" pitchFamily="34" charset="-122"/>
+                <a:cs typeface="Times New Roman" pitchFamily="34" charset="-120"/>
+              </a:rPr>
+              <a:t>Recomendaciones y trabajo futuro</a:t>
+            </a:r>
+            <a:endParaRPr lang="en-US" sz="2300" dirty="0"/>
+          </a:p>
+        </p:txBody>
+      </p:sp>
+      <p:sp>
+        <p:nvSpPr>
+          <p:cNvPr id="3" name="Text 1"/>
+          <p:cNvSpPr/>
+          <p:nvPr/>
+        </p:nvSpPr>
+        <p:spPr>
+          <a:xfrm>
+            <a:off x="8229600" y="4828032"/>
+            <a:ext cx="685800" cy="274320"/>
+          </a:xfrm>
+          <a:prstGeom prst="rect">
+            <a:avLst/>
+          </a:prstGeom>
+          <a:noFill/>
+          <a:ln/>
+        </p:spPr>
+        <p:txBody>
+          <a:bodyPr wrap="square" lIns="0" tIns="0" rIns="0" bIns="0" rtlCol="0" anchor="ctr"/>
+          <a:lstStyle/>
+          <a:p>
+            <a:pPr algn="r" indent="0" marL="0">
+              <a:buNone/>
+            </a:pPr>
+            <a:r>
+              <a:rPr lang="en-US" sz="900" dirty="0">
+                <a:solidFill>
+                  <a:srgbClr val="666666"/>
+                </a:solidFill>
+                <a:latin typeface="Times New Roman" pitchFamily="34" charset="0"/>
+                <a:ea typeface="Times New Roman" pitchFamily="34" charset="-122"/>
+                <a:cs typeface="Times New Roman" pitchFamily="34" charset="-120"/>
+              </a:rPr>
+              <a:t>18 / 19</a:t>
+            </a:r>
+            <a:endParaRPr lang="en-US" sz="900" dirty="0"/>
+          </a:p>
+        </p:txBody>
+      </p:sp>
+      <p:sp>
+        <p:nvSpPr>
+          <p:cNvPr id="4" name="Text 2"/>
+          <p:cNvSpPr/>
+          <p:nvPr/>
+        </p:nvSpPr>
+        <p:spPr>
+          <a:xfrm>
+            <a:off x="457200" y="914400"/>
+            <a:ext cx="8229600" cy="3931920"/>
+          </a:xfrm>
+          <a:prstGeom prst="rect">
+            <a:avLst/>
+          </a:prstGeom>
+          <a:noFill/>
+          <a:ln/>
+        </p:spPr>
+        <p:txBody>
+          <a:bodyPr wrap="square" lIns="0" tIns="0" rIns="0" bIns="0" rtlCol="0" anchor="t"/>
+          <a:lstStyle/>
+          <a:p>
+            <a:pPr marL="177800" indent="-177800">
+              <a:spcAft>
+                <a:spcPts val="1100"/>
+              </a:spcAft>
+              <a:buSzPct val="100000"/>
+              <a:buChar char="•"/>
+            </a:pPr>
+            <a:r>
+              <a:rPr lang="en-US" sz="1350" dirty="0">
+                <a:solidFill>
+                  <a:srgbClr val="1A1A1A"/>
+                </a:solidFill>
+                <a:latin typeface="Times New Roman" pitchFamily="34" charset="0"/>
+                <a:ea typeface="Times New Roman" pitchFamily="34" charset="-122"/>
+                <a:cs typeface="Times New Roman" pitchFamily="34" charset="-120"/>
+              </a:rPr>
+              <a:t>Extender la evaluación de detección a otros detectores y al conjunto completo de LLVIP.</a:t>
+            </a:r>
+            <a:endParaRPr lang="en-US" sz="1350" dirty="0"/>
+          </a:p>
+          <a:p>
+            <a:pPr marL="177800" indent="-177800">
+              <a:spcAft>
+                <a:spcPts val="1100"/>
+              </a:spcAft>
+              <a:buSzPct val="100000"/>
+              <a:buChar char="•"/>
+            </a:pPr>
+            <a:r>
+              <a:rPr lang="en-US" sz="1350" dirty="0">
+                <a:solidFill>
+                  <a:srgbClr val="1A1A1A"/>
+                </a:solidFill>
+                <a:latin typeface="Times New Roman" pitchFamily="34" charset="0"/>
+                <a:ea typeface="Times New Roman" pitchFamily="34" charset="-122"/>
+                <a:cs typeface="Times New Roman" pitchFamily="34" charset="-120"/>
+              </a:rPr>
+              <a:t>Explorar reglas de fusión adaptativas para la rama Black Top-Hat.</a:t>
+            </a:r>
+            <a:endParaRPr lang="en-US" sz="1350" dirty="0"/>
+          </a:p>
+          <a:p>
+            <a:pPr marL="177800" indent="-177800">
+              <a:spcAft>
+                <a:spcPts val="1100"/>
+              </a:spcAft>
+              <a:buSzPct val="100000"/>
+              <a:buChar char="•"/>
+            </a:pPr>
+            <a:r>
+              <a:rPr lang="en-US" sz="1350" dirty="0">
+                <a:solidFill>
+                  <a:srgbClr val="1A1A1A"/>
+                </a:solidFill>
+                <a:latin typeface="Times New Roman" pitchFamily="34" charset="0"/>
+                <a:ea typeface="Times New Roman" pitchFamily="34" charset="-122"/>
+                <a:cs typeface="Times New Roman" pitchFamily="34" charset="-120"/>
+              </a:rPr>
+              <a:t>Complementar las métricas objetivas con una validación perceptual por observadores.</a:t>
+            </a:r>
+            <a:endParaRPr lang="en-US" sz="1350" dirty="0"/>
+          </a:p>
+          <a:p>
+            <a:pPr marL="177800" indent="-177800">
+              <a:spcAft>
+                <a:spcPts val="1100"/>
+              </a:spcAft>
+              <a:buSzPct val="100000"/>
+              <a:buChar char="•"/>
+            </a:pPr>
+            <a:r>
+              <a:rPr lang="en-US" sz="1350" dirty="0">
+                <a:solidFill>
+                  <a:srgbClr val="1A1A1A"/>
+                </a:solidFill>
+                <a:latin typeface="Times New Roman" pitchFamily="34" charset="0"/>
+                <a:ea typeface="Times New Roman" pitchFamily="34" charset="-122"/>
+                <a:cs typeface="Times New Roman" pitchFamily="34" charset="-120"/>
+              </a:rPr>
+              <a:t>Evaluar la transferencia a otros dominios (imágenes médicas, aéreas).</a:t>
+            </a:r>
+            <a:endParaRPr lang="en-US" sz="1350" dirty="0"/>
+          </a:p>
+          <a:p>
+            <a:pPr marL="177800" indent="-177800">
+              <a:spcAft>
+                <a:spcPts val="1100"/>
+              </a:spcAft>
+              <a:buSzPct val="100000"/>
+              <a:buChar char="•"/>
+            </a:pPr>
+            <a:r>
+              <a:rPr lang="en-US" sz="1350" dirty="0">
+                <a:solidFill>
+                  <a:srgbClr val="1A1A1A"/>
+                </a:solidFill>
+                <a:latin typeface="Times New Roman" pitchFamily="34" charset="0"/>
+                <a:ea typeface="Times New Roman" pitchFamily="34" charset="-122"/>
+                <a:cs typeface="Times New Roman" pitchFamily="34" charset="-120"/>
+              </a:rPr>
+              <a:t>Para aplicaciones donde los artefactos son críticos (interpretación humana, diagnóstico), la propuesta es la opción recomendada; donde prima el contraste bruto, LP sigue siendo competitiva.</a:t>
+            </a:r>
+            <a:endParaRPr lang="en-US" sz="1350" dirty="0"/>
+          </a:p>
+        </p:txBody>
+      </p:sp>
+    </p:spTree>
+  </p:cSld>
+  <p:clrMapOvr>
+    <a:masterClrMapping/>
+  </p:clrMapOvr>
+</p:sld>
+</file>
+
+<file path=ppt/slides/slide19.xml><?xml version="1.0" encoding="utf-8"?>
+<p:sld xmlns:a="http://schemas.openxmlformats.org/drawingml/2006/main" xmlns:r="http://schemas.openxmlformats.org/officeDocument/2006/relationships" xmlns:p="http://schemas.openxmlformats.org/presentationml/2006/main">
+  <p:cSld name="Slide 19">
+    <p:bg>
+      <p:bgPr>
+        <a:solidFill>
+          <a:srgbClr val="FFFFFF"/>
+        </a:solidFill>
+      </p:bgPr>
+    </p:bg>
+    <p:spTree>
+      <p:nvGrpSpPr>
+        <p:cNvPr id="1" name=""/>
+        <p:cNvGrpSpPr/>
+        <p:nvPr/>
+      </p:nvGrpSpPr>
+      <p:grpSpPr>
+        <a:xfrm>
+          <a:off x="0" y="0"/>
+          <a:ext cx="0" cy="0"/>
+          <a:chOff x="0" y="0"/>
+          <a:chExt cx="0" cy="0"/>
+        </a:xfrm>
+      </p:grpSpPr>
+      <p:sp>
+        <p:nvSpPr>
+          <p:cNvPr id="2" name="Text 0"/>
+          <p:cNvSpPr/>
+          <p:nvPr/>
+        </p:nvSpPr>
+        <p:spPr>
+          <a:xfrm>
             <a:off x="457200" y="1828800"/>
             <a:ext cx="8229600" cy="731520"/>
           </a:xfrm>
@@ -8329,7 +8637,7 @@
                 <a:ea typeface="Times New Roman" pitchFamily="34" charset="-122"/>
                 <a:cs typeface="Times New Roman" pitchFamily="34" charset="-120"/>
               </a:rPr>
-              <a:t>2 / 18</a:t>
+              <a:t>2 / 19</a:t>
             </a:r>
             <a:endParaRPr lang="en-US" sz="900" dirty="0"/>
           </a:p>
@@ -8519,7 +8827,7 @@
                 <a:ea typeface="Times New Roman" pitchFamily="34" charset="-122"/>
                 <a:cs typeface="Times New Roman" pitchFamily="34" charset="-120"/>
               </a:rPr>
-              <a:t>8.  Evaluación orientada a tarea: detección en LLVIP</a:t>
+              <a:t>8.  Evaluación orientada a tarea: detección en LLVIP y M3FD</a:t>
             </a:r>
             <a:endParaRPr lang="en-US" sz="1500" dirty="0"/>
           </a:p>
@@ -8650,7 +8958,7 @@
                 <a:ea typeface="Times New Roman" pitchFamily="34" charset="-122"/>
                 <a:cs typeface="Times New Roman" pitchFamily="34" charset="-120"/>
               </a:rPr>
-              <a:t>3 / 18</a:t>
+              <a:t>3 / 19</a:t>
             </a:r>
             <a:endParaRPr lang="en-US" sz="900" dirty="0"/>
           </a:p>
@@ -8911,7 +9219,7 @@
                 <a:ea typeface="Times New Roman" pitchFamily="34" charset="-122"/>
                 <a:cs typeface="Times New Roman" pitchFamily="34" charset="-120"/>
               </a:rPr>
-              <a:t>4 / 18</a:t>
+              <a:t>4 / 19</a:t>
             </a:r>
             <a:endParaRPr lang="en-US" sz="900" dirty="0"/>
           </a:p>
@@ -9244,7 +9552,7 @@
                 <a:ea typeface="Times New Roman" pitchFamily="34" charset="-122"/>
                 <a:cs typeface="Times New Roman" pitchFamily="34" charset="-120"/>
               </a:rPr>
-              <a:t>5 / 18</a:t>
+              <a:t>5 / 19</a:t>
             </a:r>
             <a:endParaRPr lang="en-US" sz="900" dirty="0"/>
           </a:p>
@@ -9588,7 +9896,7 @@
                 <a:ea typeface="Times New Roman" pitchFamily="34" charset="-122"/>
                 <a:cs typeface="Times New Roman" pitchFamily="34" charset="-120"/>
               </a:rPr>
-              <a:t>6 / 18</a:t>
+              <a:t>6 / 19</a:t>
             </a:r>
             <a:endParaRPr lang="en-US" sz="900" dirty="0"/>
           </a:p>
@@ -9909,7 +10217,7 @@
                 <a:ea typeface="Times New Roman" pitchFamily="34" charset="-122"/>
                 <a:cs typeface="Times New Roman" pitchFamily="34" charset="-120"/>
               </a:rPr>
-              <a:t>7 / 18</a:t>
+              <a:t>7 / 19</a:t>
             </a:r>
             <a:endParaRPr lang="en-US" sz="900" dirty="0"/>
           </a:p>
@@ -10218,7 +10526,7 @@
                 <a:ea typeface="Times New Roman" pitchFamily="34" charset="-122"/>
                 <a:cs typeface="Times New Roman" pitchFamily="34" charset="-120"/>
               </a:rPr>
-              <a:t>8 / 18</a:t>
+              <a:t>8 / 19</a:t>
             </a:r>
             <a:endParaRPr lang="en-US" sz="900" dirty="0"/>
           </a:p>
@@ -10543,7 +10851,7 @@
                 <a:ea typeface="Times New Roman" pitchFamily="34" charset="-122"/>
                 <a:cs typeface="Times New Roman" pitchFamily="34" charset="-120"/>
               </a:rPr>
-              <a:t>9 / 18</a:t>
+              <a:t>9 / 19</a:t>
             </a:r>
             <a:endParaRPr lang="en-US" sz="900" dirty="0"/>
           </a:p>

</xml_diff>

<commit_message>
Figura de la prueba visual M3FD: detecciones VIS/IR/fusión en dos escenas
- experiments/make_figura_detecciones_m3fd.py: selecciona automáticamente las
  dos escenas de validación que mejor muestran la complementariedad (una por
  lado: el VIS no detecta ninguna persona que la fusión recupera; el IR no
  detecta ninguna luz que la fusión conserva) y dibuja las detecciones del
  modelo único (People granate, Lamp azul, conf>=0.25).
- Libro (62 págs): nueva Figura 9 al cierre de 5.5 con renumeración en
  cascada (9-11 -> 10-12), referencia en el texto y lista actualizada.
- Avances (30 págs): página de continuación de la sección 13 con la figura.
- Presentación (20 láminas): lámina nueva tras las barras M3FD con la
  evidencia visual y notas del orador.
</commit_message>
<xml_diff>
--- a/docs/Tesis_Defensa_Presentacion.pptx
+++ b/docs/Tesis_Defensa_Presentacion.pptx
@@ -24,9 +24,10 @@
     <p:sldId id="272" r:id="rId18"/>
     <p:sldId id="273" r:id="rId19"/>
     <p:sldId id="274" r:id="rId20"/>
+    <p:sldId id="275" r:id="rId21"/>
   </p:sldIdLst>
   <p:notesMasterIdLst>
-    <p:notesMasterId r:id="rId21"/>
+    <p:notesMasterId r:id="rId22"/>
   </p:notesMasterIdLst>
   <p:sldSz cx="9144000" cy="5143500"/>
   <p:notesSz cx="5143500" cy="9144000"/>
@@ -1136,7 +1137,7 @@
           <a:p>
             <a:r>
               <a:rPr lang="en-US" dirty="0"/>
-              <a:t>H1 y H2 quedan sostenidas con evidencia estadística. H3 solo parcialmente: es el resultado más honesto del trabajo y anticipa la pregunta natural del tribunal — calidad de imagen y utilidad en tarea son criterios distintos.</a:t>
+              <a:t>Cerrar M3FD con la evidencia visual: dos escenas reales de la validación. En la primera, las personas están bajo el puente a contraluz: invisibles para el detector en VIS, obvias en IR y recuperadas por la fusión. En la segunda, el semáforo y las luces no emiten calor: el IR no los ve, la fusión sí — junto con las personas. Una sola imagen, ambas clases: eso es lo que la fusión compra.</a:t>
             </a:r>
             <a:endParaRPr lang="en-US" dirty="0"/>
           </a:p>
@@ -1224,7 +1225,7 @@
           <a:p>
             <a:r>
               <a:rPr lang="en-US" dirty="0"/>
-              <a:t>Cinco conclusiones: método formulado, óptimo hallado, perfil de calidad validado, ventaja sobre el clásico demostrada, y la lección sobre calidad vs. tarea.</a:t>
+              <a:t>H1 y H2 quedan sostenidas con evidencia estadística. H3 solo parcialmente: es el resultado más honesto del trabajo y anticipa la pregunta natural del tribunal — calidad de imagen y utilidad en tarea son criterios distintos.</a:t>
             </a:r>
             <a:endParaRPr lang="en-US" dirty="0"/>
           </a:p>
@@ -1312,7 +1313,7 @@
           <a:p>
             <a:r>
               <a:rPr lang="en-US" dirty="0"/>
-              <a:t>Cerrar con la recomendación práctica: qué método elegir según el criterio operativo. Dejar claro que el pipeline completo es reproducible desde el repositorio.</a:t>
+              <a:t>Cinco conclusiones: método formulado, óptimo hallado, perfil de calidad validado, ventaja sobre el clásico demostrada, y la lección sobre calidad vs. tarea.</a:t>
             </a:r>
             <a:endParaRPr lang="en-US" dirty="0"/>
           </a:p>
@@ -1400,7 +1401,7 @@
           <a:p>
             <a:r>
               <a:rPr lang="en-US" dirty="0"/>
-              <a:t>Agradecer a la mesa y al orientador. Ofrecer el repositorio para cualquier verificación.</a:t>
+              <a:t>Cerrar con la recomendación práctica: qué método elegir según el criterio operativo. Dejar claro que el pipeline completo es reproducible desde el repositorio.</a:t>
             </a:r>
             <a:endParaRPr lang="en-US" dirty="0"/>
           </a:p>
@@ -1512,6 +1513,94 @@
             <a:fld id="{F7021451-1387-4CA6-816F-3879F97B5CBC}" type="slidenum">
               <a:rPr lang="en-US"/>
               <a:t>2</a:t>
+            </a:fld>
+            <a:endParaRPr lang="en-US"/>
+          </a:p>
+        </p:txBody>
+      </p:sp>
+    </p:spTree>
+    <p:extLst>
+      <p:ext uri="{BB962C8B-B14F-4D97-AF65-F5344CB8AC3E}">
+        <p14:creationId xmlns:p14="http://schemas.microsoft.com/office/powerpoint/2010/main" val="1024086991"/>
+      </p:ext>
+    </p:extLst>
+  </p:cSld>
+  <p:clrMapOvr>
+    <a:masterClrMapping/>
+  </p:clrMapOvr>
+</p:notes>
+</file>
+
+<file path=ppt/notesSlides/notesSlide20.xml><?xml version="1.0" encoding="utf-8"?>
+<p:notes xmlns:a="http://schemas.openxmlformats.org/drawingml/2006/main" xmlns:r="http://schemas.openxmlformats.org/officeDocument/2006/relationships" xmlns:p="http://schemas.openxmlformats.org/presentationml/2006/main">
+  <p:cSld>
+    <p:spTree>
+      <p:nvGrpSpPr>
+        <p:cNvPr id="1" name=""/>
+        <p:cNvGrpSpPr/>
+        <p:nvPr/>
+      </p:nvGrpSpPr>
+      <p:grpSpPr>
+        <a:xfrm>
+          <a:off x="0" y="0"/>
+          <a:ext cx="0" cy="0"/>
+          <a:chOff x="0" y="0"/>
+          <a:chExt cx="0" cy="0"/>
+        </a:xfrm>
+      </p:grpSpPr>
+      <p:sp>
+        <p:nvSpPr>
+          <p:cNvPr id="2" name="Slide Image Placeholder 1"/>
+          <p:cNvSpPr>
+            <a:spLocks noGrp="1" noRot="1" noChangeAspect="1"/>
+          </p:cNvSpPr>
+          <p:nvPr>
+            <p:ph type="sldImg"/>
+          </p:nvPr>
+        </p:nvSpPr>
+        <p:spPr/>
+      </p:sp>
+      <p:sp>
+        <p:nvSpPr>
+          <p:cNvPr id="3" name="Notes Placeholder 2"/>
+          <p:cNvSpPr>
+            <a:spLocks noGrp="1"/>
+          </p:cNvSpPr>
+          <p:nvPr>
+            <p:ph type="body" idx="1"/>
+          </p:nvPr>
+        </p:nvSpPr>
+        <p:spPr/>
+        <p:txBody>
+          <a:bodyPr/>
+          <a:lstStyle/>
+          <a:p>
+            <a:r>
+              <a:rPr lang="en-US" dirty="0"/>
+              <a:t>Agradecer a la mesa y al orientador. Ofrecer el repositorio para cualquier verificación.</a:t>
+            </a:r>
+            <a:endParaRPr lang="en-US" dirty="0"/>
+          </a:p>
+        </p:txBody>
+      </p:sp>
+      <p:sp>
+        <p:nvSpPr>
+          <p:cNvPr id="4" name="Slide Number Placeholder 3"/>
+          <p:cNvSpPr>
+            <a:spLocks noGrp="1"/>
+          </p:cNvSpPr>
+          <p:nvPr>
+            <p:ph type="sldNum" sz="quarter" idx="10"/>
+          </p:nvPr>
+        </p:nvSpPr>
+        <p:spPr/>
+        <p:txBody>
+          <a:bodyPr/>
+          <a:lstStyle/>
+          <a:p>
+            <a:fld id="{F7021451-1387-4CA6-816F-3879F97B5CBC}" type="slidenum">
+              <a:rPr lang="en-US"/>
+              <a:t>20</a:t>
             </a:fld>
             <a:endParaRPr lang="en-US"/>
           </a:p>
@@ -2883,7 +2972,7 @@
                 <a:ea typeface="Times New Roman" pitchFamily="34" charset="-122"/>
                 <a:cs typeface="Times New Roman" pitchFamily="34" charset="-120"/>
               </a:rPr>
-              <a:t>10 / 19</a:t>
+              <a:t>10 / 20</a:t>
             </a:r>
             <a:endParaRPr lang="en-US" sz="900" dirty="0"/>
           </a:p>
@@ -3262,7 +3351,7 @@
                 <a:ea typeface="Times New Roman" pitchFamily="34" charset="-122"/>
                 <a:cs typeface="Times New Roman" pitchFamily="34" charset="-120"/>
               </a:rPr>
-              <a:t>11 / 19</a:t>
+              <a:t>11 / 20</a:t>
             </a:r>
             <a:endParaRPr lang="en-US" sz="900" dirty="0"/>
           </a:p>
@@ -3435,7 +3524,7 @@
                 <a:ea typeface="Times New Roman" pitchFamily="34" charset="-122"/>
                 <a:cs typeface="Times New Roman" pitchFamily="34" charset="-120"/>
               </a:rPr>
-              <a:t>12 / 19</a:t>
+              <a:t>12 / 20</a:t>
             </a:r>
             <a:endParaRPr lang="en-US" sz="900" dirty="0"/>
           </a:p>
@@ -6797,7 +6886,7 @@
                 <a:ea typeface="Times New Roman" pitchFamily="34" charset="-122"/>
                 <a:cs typeface="Times New Roman" pitchFamily="34" charset="-120"/>
               </a:rPr>
-              <a:t>13 / 19</a:t>
+              <a:t>13 / 20</a:t>
             </a:r>
             <a:endParaRPr lang="en-US" sz="900" dirty="0"/>
           </a:p>
@@ -7076,7 +7165,7 @@
                 <a:ea typeface="Times New Roman" pitchFamily="34" charset="-122"/>
                 <a:cs typeface="Times New Roman" pitchFamily="34" charset="-120"/>
               </a:rPr>
-              <a:t>14 / 19</a:t>
+              <a:t>14 / 20</a:t>
             </a:r>
             <a:endParaRPr lang="en-US" sz="900" dirty="0"/>
           </a:p>
@@ -7295,7 +7384,7 @@
                 <a:ea typeface="Times New Roman" pitchFamily="34" charset="-122"/>
                 <a:cs typeface="Times New Roman" pitchFamily="34" charset="-120"/>
               </a:rPr>
-              <a:t>15 / 19</a:t>
+              <a:t>15 / 20</a:t>
             </a:r>
             <a:endParaRPr lang="en-US" sz="900" dirty="0"/>
           </a:p>
@@ -7475,7 +7564,7 @@
                 <a:ea typeface="Times New Roman" pitchFamily="34" charset="-122"/>
                 <a:cs typeface="Times New Roman" pitchFamily="34" charset="-120"/>
               </a:rPr>
-              <a:t>Contraste de hipótesis</a:t>
+              <a:t>La prueba visual: ambas clases en una sola imagen</a:t>
             </a:r>
             <a:endParaRPr lang="en-US" sz="2300" dirty="0"/>
           </a:p>
@@ -7514,22 +7603,46 @@
                 <a:ea typeface="Times New Roman" pitchFamily="34" charset="-122"/>
                 <a:cs typeface="Times New Roman" pitchFamily="34" charset="-120"/>
               </a:rPr>
-              <a:t>16 / 19</a:t>
+              <a:t>16 / 20</a:t>
             </a:r>
             <a:endParaRPr lang="en-US" sz="900" dirty="0"/>
           </a:p>
         </p:txBody>
       </p:sp>
-      <p:sp>
-        <p:nvSpPr>
-          <p:cNvPr id="4" name="Text 2"/>
+      <p:pic>
+        <p:nvPicPr>
+          <p:cNvPr id="4" name="Image 0" descr="C:/Users/Usuario/Documents/unv/mastertesis/tesis_mciencias_datos/docs/figures/fig_m3fd_detecciones.png">    </p:cNvPr>
+          <p:cNvPicPr>
+            <a:picLocks noChangeAspect="1"/>
+          </p:cNvPicPr>
+          <p:nvPr/>
+        </p:nvPicPr>
+        <p:blipFill>
+          <a:blip r:embed="rId1"/>
+          <a:stretch>
+            <a:fillRect/>
+          </a:stretch>
+        </p:blipFill>
+        <p:spPr>
+          <a:xfrm>
+            <a:off x="1417320" y="822960"/>
+            <a:ext cx="6309360" cy="4069080"/>
+          </a:xfrm>
+          <a:prstGeom prst="rect">
+            <a:avLst/>
+          </a:prstGeom>
+        </p:spPr>
+      </p:pic>
+      <p:sp>
+        <p:nvSpPr>
+          <p:cNvPr id="5" name="Text 2"/>
           <p:cNvSpPr/>
           <p:nvPr/>
         </p:nvSpPr>
         <p:spPr>
           <a:xfrm>
-            <a:off x="457200" y="960120"/>
-            <a:ext cx="640080" cy="411480"/>
+            <a:off x="457200" y="4864608"/>
+            <a:ext cx="7680960" cy="256032"/>
           </a:xfrm>
           <a:prstGeom prst="rect">
             <a:avLst/>
@@ -7545,329 +7658,17 @@
               <a:buNone/>
             </a:pPr>
             <a:r>
-              <a:rPr lang="en-US" sz="1900" b="1" dirty="0">
-                <a:solidFill>
-                  <a:srgbClr val="1A1A1A"/>
-                </a:solidFill>
-                <a:latin typeface="Times New Roman" pitchFamily="34" charset="0"/>
-                <a:ea typeface="Times New Roman" pitchFamily="34" charset="-122"/>
-                <a:cs typeface="Times New Roman" pitchFamily="34" charset="-120"/>
-              </a:rPr>
-              <a:t>H1</a:t>
-            </a:r>
-            <a:endParaRPr lang="en-US" sz="1900" dirty="0"/>
-          </a:p>
-        </p:txBody>
-      </p:sp>
-      <p:sp>
-        <p:nvSpPr>
-          <p:cNvPr id="5" name="Text 3"/>
-          <p:cNvSpPr/>
-          <p:nvPr/>
-        </p:nvSpPr>
-        <p:spPr>
-          <a:xfrm>
-            <a:off x="1143000" y="996696"/>
-            <a:ext cx="1417320" cy="365760"/>
-          </a:xfrm>
-          <a:prstGeom prst="rect">
-            <a:avLst/>
-          </a:prstGeom>
-          <a:noFill/>
-          <a:ln/>
-        </p:spPr>
-        <p:txBody>
-          <a:bodyPr wrap="square" lIns="0" tIns="0" rIns="0" bIns="0" rtlCol="0" anchor="ctr"/>
-          <a:lstStyle/>
-          <a:p>
-            <a:pPr indent="0" marL="0">
-              <a:buNone/>
-            </a:pPr>
-            <a:r>
-              <a:rPr lang="en-US" sz="1300" b="1" dirty="0">
-                <a:solidFill>
-                  <a:srgbClr val="1F5C2E"/>
-                </a:solidFill>
-                <a:latin typeface="Times New Roman" pitchFamily="34" charset="0"/>
-                <a:ea typeface="Times New Roman" pitchFamily="34" charset="-122"/>
-                <a:cs typeface="Times New Roman" pitchFamily="34" charset="-120"/>
-              </a:rPr>
-              <a:t>SOSTENIDA</a:t>
-            </a:r>
-            <a:endParaRPr lang="en-US" sz="1300" dirty="0"/>
-          </a:p>
-        </p:txBody>
-      </p:sp>
-      <p:sp>
-        <p:nvSpPr>
-          <p:cNvPr id="6" name="Text 4"/>
-          <p:cNvSpPr/>
-          <p:nvPr/>
-        </p:nvSpPr>
-        <p:spPr>
-          <a:xfrm>
-            <a:off x="2697480" y="960120"/>
-            <a:ext cx="5989320" cy="1143000"/>
-          </a:xfrm>
-          <a:prstGeom prst="rect">
-            <a:avLst/>
-          </a:prstGeom>
-          <a:noFill/>
-          <a:ln/>
-        </p:spPr>
-        <p:txBody>
-          <a:bodyPr wrap="square" lIns="0" tIns="0" rIns="0" bIns="0" rtlCol="0" anchor="t"/>
-          <a:lstStyle/>
-          <a:p>
-            <a:pPr indent="0" marL="0">
-              <a:buNone/>
-            </a:pPr>
-            <a:r>
-              <a:rPr lang="en-US" sz="1250" dirty="0">
-                <a:solidFill>
-                  <a:srgbClr val="1A1A1A"/>
-                </a:solidFill>
-                <a:latin typeface="Times New Roman" pitchFamily="34" charset="0"/>
-                <a:ea typeface="Times New Roman" pitchFamily="34" charset="-122"/>
-                <a:cs typeface="Times New Roman" pitchFamily="34" charset="-120"/>
-              </a:rPr>
-              <a:t>El banco disco + líneas con suma de ramas mejora SSIM (0,782 vs 0,578) y reduce Nabf (0,041 vs 0,585) frente al Top-Hat clásico, con significancia estadística (Wilcoxon–Holm).</a:t>
-            </a:r>
-            <a:endParaRPr lang="en-US" sz="1250" dirty="0"/>
-          </a:p>
-        </p:txBody>
-      </p:sp>
-      <p:sp>
-        <p:nvSpPr>
-          <p:cNvPr id="7" name="Text 5"/>
-          <p:cNvSpPr/>
-          <p:nvPr/>
-        </p:nvSpPr>
-        <p:spPr>
-          <a:xfrm>
-            <a:off x="457200" y="2258568"/>
-            <a:ext cx="640080" cy="411480"/>
-          </a:xfrm>
-          <a:prstGeom prst="rect">
-            <a:avLst/>
-          </a:prstGeom>
-          <a:noFill/>
-          <a:ln/>
-        </p:spPr>
-        <p:txBody>
-          <a:bodyPr wrap="square" lIns="0" tIns="0" rIns="0" bIns="0" rtlCol="0" anchor="ctr"/>
-          <a:lstStyle/>
-          <a:p>
-            <a:pPr indent="0" marL="0">
-              <a:buNone/>
-            </a:pPr>
-            <a:r>
-              <a:rPr lang="en-US" sz="1900" b="1" dirty="0">
-                <a:solidFill>
-                  <a:srgbClr val="1A1A1A"/>
-                </a:solidFill>
-                <a:latin typeface="Times New Roman" pitchFamily="34" charset="0"/>
-                <a:ea typeface="Times New Roman" pitchFamily="34" charset="-122"/>
-                <a:cs typeface="Times New Roman" pitchFamily="34" charset="-120"/>
-              </a:rPr>
-              <a:t>H2</a:t>
-            </a:r>
-            <a:endParaRPr lang="en-US" sz="1900" dirty="0"/>
-          </a:p>
-        </p:txBody>
-      </p:sp>
-      <p:sp>
-        <p:nvSpPr>
-          <p:cNvPr id="8" name="Text 6"/>
-          <p:cNvSpPr/>
-          <p:nvPr/>
-        </p:nvSpPr>
-        <p:spPr>
-          <a:xfrm>
-            <a:off x="1143000" y="2295144"/>
-            <a:ext cx="1417320" cy="365760"/>
-          </a:xfrm>
-          <a:prstGeom prst="rect">
-            <a:avLst/>
-          </a:prstGeom>
-          <a:noFill/>
-          <a:ln/>
-        </p:spPr>
-        <p:txBody>
-          <a:bodyPr wrap="square" lIns="0" tIns="0" rIns="0" bIns="0" rtlCol="0" anchor="ctr"/>
-          <a:lstStyle/>
-          <a:p>
-            <a:pPr indent="0" marL="0">
-              <a:buNone/>
-            </a:pPr>
-            <a:r>
-              <a:rPr lang="en-US" sz="1300" b="1" dirty="0">
-                <a:solidFill>
-                  <a:srgbClr val="1F5C2E"/>
-                </a:solidFill>
-                <a:latin typeface="Times New Roman" pitchFamily="34" charset="0"/>
-                <a:ea typeface="Times New Roman" pitchFamily="34" charset="-122"/>
-                <a:cs typeface="Times New Roman" pitchFamily="34" charset="-120"/>
-              </a:rPr>
-              <a:t>SOSTENIDA</a:t>
-            </a:r>
-            <a:endParaRPr lang="en-US" sz="1300" dirty="0"/>
-          </a:p>
-        </p:txBody>
-      </p:sp>
-      <p:sp>
-        <p:nvSpPr>
-          <p:cNvPr id="9" name="Text 7"/>
-          <p:cNvSpPr/>
-          <p:nvPr/>
-        </p:nvSpPr>
-        <p:spPr>
-          <a:xfrm>
-            <a:off x="2697480" y="2258568"/>
-            <a:ext cx="5989320" cy="1143000"/>
-          </a:xfrm>
-          <a:prstGeom prst="rect">
-            <a:avLst/>
-          </a:prstGeom>
-          <a:noFill/>
-          <a:ln/>
-        </p:spPr>
-        <p:txBody>
-          <a:bodyPr wrap="square" lIns="0" tIns="0" rIns="0" bIns="0" rtlCol="0" anchor="t"/>
-          <a:lstStyle/>
-          <a:p>
-            <a:pPr indent="0" marL="0">
-              <a:buNone/>
-            </a:pPr>
-            <a:r>
-              <a:rPr lang="en-US" sz="1250" dirty="0">
-                <a:solidFill>
-                  <a:srgbClr val="1A1A1A"/>
-                </a:solidFill>
-                <a:latin typeface="Times New Roman" pitchFamily="34" charset="0"/>
-                <a:ea typeface="Times New Roman" pitchFamily="34" charset="-122"/>
-                <a:cs typeface="Times New Roman" pitchFamily="34" charset="-120"/>
-              </a:rPr>
-              <a:t>La configuración hallada por PSO (r = 25; m = 0,0703) supera a la parametrización manual del operador clásico (r = 5; m = 1) en todas las métricas de calidad de fusión.</a:t>
-            </a:r>
-            <a:endParaRPr lang="en-US" sz="1250" dirty="0"/>
-          </a:p>
-        </p:txBody>
-      </p:sp>
-      <p:sp>
-        <p:nvSpPr>
-          <p:cNvPr id="10" name="Text 8"/>
-          <p:cNvSpPr/>
-          <p:nvPr/>
-        </p:nvSpPr>
-        <p:spPr>
-          <a:xfrm>
-            <a:off x="457200" y="3557016"/>
-            <a:ext cx="640080" cy="411480"/>
-          </a:xfrm>
-          <a:prstGeom prst="rect">
-            <a:avLst/>
-          </a:prstGeom>
-          <a:noFill/>
-          <a:ln/>
-        </p:spPr>
-        <p:txBody>
-          <a:bodyPr wrap="square" lIns="0" tIns="0" rIns="0" bIns="0" rtlCol="0" anchor="ctr"/>
-          <a:lstStyle/>
-          <a:p>
-            <a:pPr indent="0" marL="0">
-              <a:buNone/>
-            </a:pPr>
-            <a:r>
-              <a:rPr lang="en-US" sz="1900" b="1" dirty="0">
-                <a:solidFill>
-                  <a:srgbClr val="1A1A1A"/>
-                </a:solidFill>
-                <a:latin typeface="Times New Roman" pitchFamily="34" charset="0"/>
-                <a:ea typeface="Times New Roman" pitchFamily="34" charset="-122"/>
-                <a:cs typeface="Times New Roman" pitchFamily="34" charset="-120"/>
-              </a:rPr>
-              <a:t>H3</a:t>
-            </a:r>
-            <a:endParaRPr lang="en-US" sz="1900" dirty="0"/>
-          </a:p>
-        </p:txBody>
-      </p:sp>
-      <p:sp>
-        <p:nvSpPr>
-          <p:cNvPr id="11" name="Text 9"/>
-          <p:cNvSpPr/>
-          <p:nvPr/>
-        </p:nvSpPr>
-        <p:spPr>
-          <a:xfrm>
-            <a:off x="1143000" y="3593592"/>
-            <a:ext cx="1417320" cy="365760"/>
-          </a:xfrm>
-          <a:prstGeom prst="rect">
-            <a:avLst/>
-          </a:prstGeom>
-          <a:noFill/>
-          <a:ln/>
-        </p:spPr>
-        <p:txBody>
-          <a:bodyPr wrap="square" lIns="0" tIns="0" rIns="0" bIns="0" rtlCol="0" anchor="ctr"/>
-          <a:lstStyle/>
-          <a:p>
-            <a:pPr indent="0" marL="0">
-              <a:buNone/>
-            </a:pPr>
-            <a:r>
-              <a:rPr lang="en-US" sz="1300" b="1" dirty="0">
-                <a:solidFill>
-                  <a:srgbClr val="8B1A1A"/>
-                </a:solidFill>
-                <a:latin typeface="Times New Roman" pitchFamily="34" charset="0"/>
-                <a:ea typeface="Times New Roman" pitchFamily="34" charset="-122"/>
-                <a:cs typeface="Times New Roman" pitchFamily="34" charset="-120"/>
-              </a:rPr>
-              <a:t>PARCIAL</a:t>
-            </a:r>
-            <a:endParaRPr lang="en-US" sz="1300" dirty="0"/>
-          </a:p>
-        </p:txBody>
-      </p:sp>
-      <p:sp>
-        <p:nvSpPr>
-          <p:cNvPr id="12" name="Text 10"/>
-          <p:cNvSpPr/>
-          <p:nvPr/>
-        </p:nvSpPr>
-        <p:spPr>
-          <a:xfrm>
-            <a:off x="2697480" y="3557016"/>
-            <a:ext cx="5989320" cy="1143000"/>
-          </a:xfrm>
-          <a:prstGeom prst="rect">
-            <a:avLst/>
-          </a:prstGeom>
-          <a:noFill/>
-          <a:ln/>
-        </p:spPr>
-        <p:txBody>
-          <a:bodyPr wrap="square" lIns="0" tIns="0" rIns="0" bIns="0" rtlCol="0" anchor="t"/>
-          <a:lstStyle/>
-          <a:p>
-            <a:pPr indent="0" marL="0">
-              <a:buNone/>
-            </a:pPr>
-            <a:r>
-              <a:rPr lang="en-US" sz="1250" dirty="0">
-                <a:solidFill>
-                  <a:srgbClr val="1A1A1A"/>
-                </a:solidFill>
-                <a:latin typeface="Times New Roman" pitchFamily="34" charset="0"/>
-                <a:ea typeface="Times New Roman" pitchFamily="34" charset="-122"/>
-                <a:cs typeface="Times New Roman" pitchFamily="34" charset="-120"/>
-              </a:rPr>
-              <a:t>La fusión supera al visible solo en detección, pero ninguna fusión supera al infrarrojo solo; la mejor calidad de imagen no garantiza el mejor mAP.</a:t>
-            </a:r>
-            <a:endParaRPr lang="en-US" sz="1250" dirty="0"/>
+              <a:rPr lang="en-US" sz="1050" i="1" dirty="0">
+                <a:solidFill>
+                  <a:srgbClr val="666666"/>
+                </a:solidFill>
+                <a:latin typeface="Times New Roman" pitchFamily="34" charset="0"/>
+                <a:ea typeface="Times New Roman" pitchFamily="34" charset="-122"/>
+                <a:cs typeface="Times New Roman" pitchFamily="34" charset="-120"/>
+              </a:rPr>
+              <a:t>Arriba: el VIS no detecta a nadie (0 personas) — la fusión las recupera. Abajo: el IR no ve ninguna luz — la fusión las conserva.</a:t>
+            </a:r>
+            <a:endParaRPr lang="en-US" sz="1050" dirty="0"/>
           </a:p>
         </p:txBody>
       </p:sp>
@@ -7936,7 +7737,7 @@
                 <a:ea typeface="Times New Roman" pitchFamily="34" charset="-122"/>
                 <a:cs typeface="Times New Roman" pitchFamily="34" charset="-120"/>
               </a:rPr>
-              <a:t>9. Conclusiones</a:t>
+              <a:t>Contraste de hipótesis</a:t>
             </a:r>
             <a:endParaRPr lang="en-US" sz="2300" dirty="0"/>
           </a:p>
@@ -7975,7 +7776,7 @@
                 <a:ea typeface="Times New Roman" pitchFamily="34" charset="-122"/>
                 <a:cs typeface="Times New Roman" pitchFamily="34" charset="-120"/>
               </a:rPr>
-              <a:t>17 / 19</a:t>
+              <a:t>17 / 20</a:t>
             </a:r>
             <a:endParaRPr lang="en-US" sz="900" dirty="0"/>
           </a:p>
@@ -7989,8 +7790,8 @@
         </p:nvSpPr>
         <p:spPr>
           <a:xfrm>
-            <a:off x="457200" y="914400"/>
-            <a:ext cx="8229600" cy="3931920"/>
+            <a:off x="457200" y="960120"/>
+            <a:ext cx="640080" cy="411480"/>
           </a:xfrm>
           <a:prstGeom prst="rect">
             <a:avLst/>
@@ -7999,18 +7800,92 @@
           <a:ln/>
         </p:spPr>
         <p:txBody>
+          <a:bodyPr wrap="square" lIns="0" tIns="0" rIns="0" bIns="0" rtlCol="0" anchor="ctr"/>
+          <a:lstStyle/>
+          <a:p>
+            <a:pPr indent="0" marL="0">
+              <a:buNone/>
+            </a:pPr>
+            <a:r>
+              <a:rPr lang="en-US" sz="1900" b="1" dirty="0">
+                <a:solidFill>
+                  <a:srgbClr val="1A1A1A"/>
+                </a:solidFill>
+                <a:latin typeface="Times New Roman" pitchFamily="34" charset="0"/>
+                <a:ea typeface="Times New Roman" pitchFamily="34" charset="-122"/>
+                <a:cs typeface="Times New Roman" pitchFamily="34" charset="-120"/>
+              </a:rPr>
+              <a:t>H1</a:t>
+            </a:r>
+            <a:endParaRPr lang="en-US" sz="1900" dirty="0"/>
+          </a:p>
+        </p:txBody>
+      </p:sp>
+      <p:sp>
+        <p:nvSpPr>
+          <p:cNvPr id="5" name="Text 3"/>
+          <p:cNvSpPr/>
+          <p:nvPr/>
+        </p:nvSpPr>
+        <p:spPr>
+          <a:xfrm>
+            <a:off x="1143000" y="996696"/>
+            <a:ext cx="1417320" cy="365760"/>
+          </a:xfrm>
+          <a:prstGeom prst="rect">
+            <a:avLst/>
+          </a:prstGeom>
+          <a:noFill/>
+          <a:ln/>
+        </p:spPr>
+        <p:txBody>
+          <a:bodyPr wrap="square" lIns="0" tIns="0" rIns="0" bIns="0" rtlCol="0" anchor="ctr"/>
+          <a:lstStyle/>
+          <a:p>
+            <a:pPr indent="0" marL="0">
+              <a:buNone/>
+            </a:pPr>
+            <a:r>
+              <a:rPr lang="en-US" sz="1300" b="1" dirty="0">
+                <a:solidFill>
+                  <a:srgbClr val="1F5C2E"/>
+                </a:solidFill>
+                <a:latin typeface="Times New Roman" pitchFamily="34" charset="0"/>
+                <a:ea typeface="Times New Roman" pitchFamily="34" charset="-122"/>
+                <a:cs typeface="Times New Roman" pitchFamily="34" charset="-120"/>
+              </a:rPr>
+              <a:t>SOSTENIDA</a:t>
+            </a:r>
+            <a:endParaRPr lang="en-US" sz="1300" dirty="0"/>
+          </a:p>
+        </p:txBody>
+      </p:sp>
+      <p:sp>
+        <p:nvSpPr>
+          <p:cNvPr id="6" name="Text 4"/>
+          <p:cNvSpPr/>
+          <p:nvPr/>
+        </p:nvSpPr>
+        <p:spPr>
+          <a:xfrm>
+            <a:off x="2697480" y="960120"/>
+            <a:ext cx="5989320" cy="1143000"/>
+          </a:xfrm>
+          <a:prstGeom prst="rect">
+            <a:avLst/>
+          </a:prstGeom>
+          <a:noFill/>
+          <a:ln/>
+        </p:spPr>
+        <p:txBody>
           <a:bodyPr wrap="square" lIns="0" tIns="0" rIns="0" bIns="0" rtlCol="0" anchor="t"/>
           <a:lstStyle/>
           <a:p>
-            <a:pPr marL="177800" indent="-177800">
-              <a:spcAft>
-                <a:spcPts val="1100"/>
-              </a:spcAft>
-              <a:buSzPct val="100000"/>
-              <a:buChar char="•"/>
-            </a:pPr>
-            <a:r>
-              <a:rPr lang="en-US" sz="1350" dirty="0">
+            <a:pPr indent="0" marL="0">
+              <a:buNone/>
+            </a:pPr>
+            <a:r>
+              <a:rPr lang="en-US" sz="1250" dirty="0">
                 <a:solidFill>
                   <a:srgbClr val="1A1A1A"/>
                 </a:solidFill>
@@ -8018,20 +7893,38 @@
                 <a:ea typeface="Times New Roman" pitchFamily="34" charset="-122"/>
                 <a:cs typeface="Times New Roman" pitchFamily="34" charset="-120"/>
               </a:rPr>
-              <a:t>Se formuló e implementó de forma reproducible un operador Top-Hat de una sola escala con banco de disco + líneas orientadas y suma de ramas.</a:t>
-            </a:r>
-            <a:endParaRPr lang="en-US" sz="1350" dirty="0"/>
-          </a:p>
-          <a:p>
-            <a:pPr marL="177800" indent="-177800">
-              <a:spcAft>
-                <a:spcPts val="1100"/>
-              </a:spcAft>
-              <a:buSzPct val="100000"/>
-              <a:buChar char="•"/>
-            </a:pPr>
-            <a:r>
-              <a:rPr lang="en-US" sz="1350" dirty="0">
+              <a:t>El banco disco + líneas con suma de ramas mejora SSIM (0,782 vs 0,578) y reduce Nabf (0,041 vs 0,585) frente al Top-Hat clásico, con significancia estadística (Wilcoxon–Holm).</a:t>
+            </a:r>
+            <a:endParaRPr lang="en-US" sz="1250" dirty="0"/>
+          </a:p>
+        </p:txBody>
+      </p:sp>
+      <p:sp>
+        <p:nvSpPr>
+          <p:cNvPr id="7" name="Text 5"/>
+          <p:cNvSpPr/>
+          <p:nvPr/>
+        </p:nvSpPr>
+        <p:spPr>
+          <a:xfrm>
+            <a:off x="457200" y="2258568"/>
+            <a:ext cx="640080" cy="411480"/>
+          </a:xfrm>
+          <a:prstGeom prst="rect">
+            <a:avLst/>
+          </a:prstGeom>
+          <a:noFill/>
+          <a:ln/>
+        </p:spPr>
+        <p:txBody>
+          <a:bodyPr wrap="square" lIns="0" tIns="0" rIns="0" bIns="0" rtlCol="0" anchor="ctr"/>
+          <a:lstStyle/>
+          <a:p>
+            <a:pPr indent="0" marL="0">
+              <a:buNone/>
+            </a:pPr>
+            <a:r>
+              <a:rPr lang="en-US" sz="1900" b="1" dirty="0">
                 <a:solidFill>
                   <a:srgbClr val="1A1A1A"/>
                 </a:solidFill>
@@ -8039,20 +7932,77 @@
                 <a:ea typeface="Times New Roman" pitchFamily="34" charset="-122"/>
                 <a:cs typeface="Times New Roman" pitchFamily="34" charset="-120"/>
               </a:rPr>
-              <a:t>El barrido PSO de 25 configuraciones halló el óptimo r = 25, m = 0,0703 (F = 1,9843) de manera consistente.</a:t>
-            </a:r>
-            <a:endParaRPr lang="en-US" sz="1350" dirty="0"/>
-          </a:p>
-          <a:p>
-            <a:pPr marL="177800" indent="-177800">
-              <a:spcAft>
-                <a:spcPts val="1100"/>
-              </a:spcAft>
-              <a:buSzPct val="100000"/>
-              <a:buChar char="•"/>
-            </a:pPr>
-            <a:r>
-              <a:rPr lang="en-US" sz="1350" dirty="0">
+              <a:t>H2</a:t>
+            </a:r>
+            <a:endParaRPr lang="en-US" sz="1900" dirty="0"/>
+          </a:p>
+        </p:txBody>
+      </p:sp>
+      <p:sp>
+        <p:nvSpPr>
+          <p:cNvPr id="8" name="Text 6"/>
+          <p:cNvSpPr/>
+          <p:nvPr/>
+        </p:nvSpPr>
+        <p:spPr>
+          <a:xfrm>
+            <a:off x="1143000" y="2295144"/>
+            <a:ext cx="1417320" cy="365760"/>
+          </a:xfrm>
+          <a:prstGeom prst="rect">
+            <a:avLst/>
+          </a:prstGeom>
+          <a:noFill/>
+          <a:ln/>
+        </p:spPr>
+        <p:txBody>
+          <a:bodyPr wrap="square" lIns="0" tIns="0" rIns="0" bIns="0" rtlCol="0" anchor="ctr"/>
+          <a:lstStyle/>
+          <a:p>
+            <a:pPr indent="0" marL="0">
+              <a:buNone/>
+            </a:pPr>
+            <a:r>
+              <a:rPr lang="en-US" sz="1300" b="1" dirty="0">
+                <a:solidFill>
+                  <a:srgbClr val="1F5C2E"/>
+                </a:solidFill>
+                <a:latin typeface="Times New Roman" pitchFamily="34" charset="0"/>
+                <a:ea typeface="Times New Roman" pitchFamily="34" charset="-122"/>
+                <a:cs typeface="Times New Roman" pitchFamily="34" charset="-120"/>
+              </a:rPr>
+              <a:t>SOSTENIDA</a:t>
+            </a:r>
+            <a:endParaRPr lang="en-US" sz="1300" dirty="0"/>
+          </a:p>
+        </p:txBody>
+      </p:sp>
+      <p:sp>
+        <p:nvSpPr>
+          <p:cNvPr id="9" name="Text 7"/>
+          <p:cNvSpPr/>
+          <p:nvPr/>
+        </p:nvSpPr>
+        <p:spPr>
+          <a:xfrm>
+            <a:off x="2697480" y="2258568"/>
+            <a:ext cx="5989320" cy="1143000"/>
+          </a:xfrm>
+          <a:prstGeom prst="rect">
+            <a:avLst/>
+          </a:prstGeom>
+          <a:noFill/>
+          <a:ln/>
+        </p:spPr>
+        <p:txBody>
+          <a:bodyPr wrap="square" lIns="0" tIns="0" rIns="0" bIns="0" rtlCol="0" anchor="t"/>
+          <a:lstStyle/>
+          <a:p>
+            <a:pPr indent="0" marL="0">
+              <a:buNone/>
+            </a:pPr>
+            <a:r>
+              <a:rPr lang="en-US" sz="1250" dirty="0">
                 <a:solidFill>
                   <a:srgbClr val="1A1A1A"/>
                 </a:solidFill>
@@ -8060,20 +8010,38 @@
                 <a:ea typeface="Times New Roman" pitchFamily="34" charset="-122"/>
                 <a:cs typeface="Times New Roman" pitchFamily="34" charset="-120"/>
               </a:rPr>
-              <a:t>La propuesta exhibe el mejor perfil de calidad del benchmark: menor Nabf y mayor SSIM, con significancia estadística; segunda en Qabf, SCD y VIF.</a:t>
-            </a:r>
-            <a:endParaRPr lang="en-US" sz="1350" dirty="0"/>
-          </a:p>
-          <a:p>
-            <a:pPr marL="177800" indent="-177800">
-              <a:spcAft>
-                <a:spcPts val="1100"/>
-              </a:spcAft>
-              <a:buSzPct val="100000"/>
-              <a:buChar char="•"/>
-            </a:pPr>
-            <a:r>
-              <a:rPr lang="en-US" sz="1350" dirty="0">
+              <a:t>La configuración hallada por PSO (r = 25; m = 0,0703) supera a la parametrización manual del operador clásico (r = 5; m = 1) en todas las métricas de calidad de fusión.</a:t>
+            </a:r>
+            <a:endParaRPr lang="en-US" sz="1250" dirty="0"/>
+          </a:p>
+        </p:txBody>
+      </p:sp>
+      <p:sp>
+        <p:nvSpPr>
+          <p:cNvPr id="10" name="Text 8"/>
+          <p:cNvSpPr/>
+          <p:nvPr/>
+        </p:nvSpPr>
+        <p:spPr>
+          <a:xfrm>
+            <a:off x="457200" y="3557016"/>
+            <a:ext cx="640080" cy="411480"/>
+          </a:xfrm>
+          <a:prstGeom prst="rect">
+            <a:avLst/>
+          </a:prstGeom>
+          <a:noFill/>
+          <a:ln/>
+        </p:spPr>
+        <p:txBody>
+          <a:bodyPr wrap="square" lIns="0" tIns="0" rIns="0" bIns="0" rtlCol="0" anchor="ctr"/>
+          <a:lstStyle/>
+          <a:p>
+            <a:pPr indent="0" marL="0">
+              <a:buNone/>
+            </a:pPr>
+            <a:r>
+              <a:rPr lang="en-US" sz="1900" b="1" dirty="0">
                 <a:solidFill>
                   <a:srgbClr val="1A1A1A"/>
                 </a:solidFill>
@@ -8081,20 +8049,77 @@
                 <a:ea typeface="Times New Roman" pitchFamily="34" charset="-122"/>
                 <a:cs typeface="Times New Roman" pitchFamily="34" charset="-120"/>
               </a:rPr>
-              <a:t>Frente a la metodología clásica Top-Hat, mejora todas las métricas de calidad de fusión: el banco de SE y el ajuste automático aportan valor real.</a:t>
-            </a:r>
-            <a:endParaRPr lang="en-US" sz="1350" dirty="0"/>
-          </a:p>
-          <a:p>
-            <a:pPr marL="177800" indent="-177800">
-              <a:spcAft>
-                <a:spcPts val="1100"/>
-              </a:spcAft>
-              <a:buSzPct val="100000"/>
-              <a:buChar char="•"/>
-            </a:pPr>
-            <a:r>
-              <a:rPr lang="en-US" sz="1350" dirty="0">
+              <a:t>H3</a:t>
+            </a:r>
+            <a:endParaRPr lang="en-US" sz="1900" dirty="0"/>
+          </a:p>
+        </p:txBody>
+      </p:sp>
+      <p:sp>
+        <p:nvSpPr>
+          <p:cNvPr id="11" name="Text 9"/>
+          <p:cNvSpPr/>
+          <p:nvPr/>
+        </p:nvSpPr>
+        <p:spPr>
+          <a:xfrm>
+            <a:off x="1143000" y="3593592"/>
+            <a:ext cx="1417320" cy="365760"/>
+          </a:xfrm>
+          <a:prstGeom prst="rect">
+            <a:avLst/>
+          </a:prstGeom>
+          <a:noFill/>
+          <a:ln/>
+        </p:spPr>
+        <p:txBody>
+          <a:bodyPr wrap="square" lIns="0" tIns="0" rIns="0" bIns="0" rtlCol="0" anchor="ctr"/>
+          <a:lstStyle/>
+          <a:p>
+            <a:pPr indent="0" marL="0">
+              <a:buNone/>
+            </a:pPr>
+            <a:r>
+              <a:rPr lang="en-US" sz="1300" b="1" dirty="0">
+                <a:solidFill>
+                  <a:srgbClr val="8B1A1A"/>
+                </a:solidFill>
+                <a:latin typeface="Times New Roman" pitchFamily="34" charset="0"/>
+                <a:ea typeface="Times New Roman" pitchFamily="34" charset="-122"/>
+                <a:cs typeface="Times New Roman" pitchFamily="34" charset="-120"/>
+              </a:rPr>
+              <a:t>PARCIAL</a:t>
+            </a:r>
+            <a:endParaRPr lang="en-US" sz="1300" dirty="0"/>
+          </a:p>
+        </p:txBody>
+      </p:sp>
+      <p:sp>
+        <p:nvSpPr>
+          <p:cNvPr id="12" name="Text 10"/>
+          <p:cNvSpPr/>
+          <p:nvPr/>
+        </p:nvSpPr>
+        <p:spPr>
+          <a:xfrm>
+            <a:off x="2697480" y="3557016"/>
+            <a:ext cx="5989320" cy="1143000"/>
+          </a:xfrm>
+          <a:prstGeom prst="rect">
+            <a:avLst/>
+          </a:prstGeom>
+          <a:noFill/>
+          <a:ln/>
+        </p:spPr>
+        <p:txBody>
+          <a:bodyPr wrap="square" lIns="0" tIns="0" rIns="0" bIns="0" rtlCol="0" anchor="t"/>
+          <a:lstStyle/>
+          <a:p>
+            <a:pPr indent="0" marL="0">
+              <a:buNone/>
+            </a:pPr>
+            <a:r>
+              <a:rPr lang="en-US" sz="1250" dirty="0">
                 <a:solidFill>
                   <a:srgbClr val="1A1A1A"/>
                 </a:solidFill>
@@ -8102,9 +8127,9 @@
                 <a:ea typeface="Times New Roman" pitchFamily="34" charset="-122"/>
                 <a:cs typeface="Times New Roman" pitchFamily="34" charset="-120"/>
               </a:rPr>
-              <a:t>En detección, la superioridad en calidad de imagen no se traslada automáticamente al mAP: la elección del método debe guiarse por el criterio operativo prioritario.</a:t>
-            </a:r>
-            <a:endParaRPr lang="en-US" sz="1350" dirty="0"/>
+              <a:t>La fusión supera al visible solo en detección, pero ninguna fusión supera al infrarrojo solo; la mejor calidad de imagen no garantiza el mejor mAP.</a:t>
+            </a:r>
+            <a:endParaRPr lang="en-US" sz="1250" dirty="0"/>
           </a:p>
         </p:txBody>
       </p:sp>
@@ -8173,7 +8198,7 @@
                 <a:ea typeface="Times New Roman" pitchFamily="34" charset="-122"/>
                 <a:cs typeface="Times New Roman" pitchFamily="34" charset="-120"/>
               </a:rPr>
-              <a:t>Recomendaciones y trabajo futuro</a:t>
+              <a:t>9. Conclusiones</a:t>
             </a:r>
             <a:endParaRPr lang="en-US" sz="2300" dirty="0"/>
           </a:p>
@@ -8212,7 +8237,7 @@
                 <a:ea typeface="Times New Roman" pitchFamily="34" charset="-122"/>
                 <a:cs typeface="Times New Roman" pitchFamily="34" charset="-120"/>
               </a:rPr>
-              <a:t>18 / 19</a:t>
+              <a:t>18 / 20</a:t>
             </a:r>
             <a:endParaRPr lang="en-US" sz="900" dirty="0"/>
           </a:p>
@@ -8255,7 +8280,7 @@
                 <a:ea typeface="Times New Roman" pitchFamily="34" charset="-122"/>
                 <a:cs typeface="Times New Roman" pitchFamily="34" charset="-120"/>
               </a:rPr>
-              <a:t>Extender la evaluación de detección a otros detectores y al conjunto completo de LLVIP.</a:t>
+              <a:t>Se formuló e implementó de forma reproducible un operador Top-Hat de una sola escala con banco de disco + líneas orientadas y suma de ramas.</a:t>
             </a:r>
             <a:endParaRPr lang="en-US" sz="1350" dirty="0"/>
           </a:p>
@@ -8276,7 +8301,7 @@
                 <a:ea typeface="Times New Roman" pitchFamily="34" charset="-122"/>
                 <a:cs typeface="Times New Roman" pitchFamily="34" charset="-120"/>
               </a:rPr>
-              <a:t>Explorar reglas de fusión adaptativas para la rama Black Top-Hat.</a:t>
+              <a:t>El barrido PSO de 25 configuraciones halló el óptimo r = 25, m = 0,0703 (F = 1,9843) de manera consistente.</a:t>
             </a:r>
             <a:endParaRPr lang="en-US" sz="1350" dirty="0"/>
           </a:p>
@@ -8297,7 +8322,7 @@
                 <a:ea typeface="Times New Roman" pitchFamily="34" charset="-122"/>
                 <a:cs typeface="Times New Roman" pitchFamily="34" charset="-120"/>
               </a:rPr>
-              <a:t>Complementar las métricas objetivas con una validación perceptual por observadores.</a:t>
+              <a:t>La propuesta exhibe el mejor perfil de calidad del benchmark: menor Nabf y mayor SSIM, con significancia estadística; segunda en Qabf, SCD y VIF.</a:t>
             </a:r>
             <a:endParaRPr lang="en-US" sz="1350" dirty="0"/>
           </a:p>
@@ -8318,7 +8343,7 @@
                 <a:ea typeface="Times New Roman" pitchFamily="34" charset="-122"/>
                 <a:cs typeface="Times New Roman" pitchFamily="34" charset="-120"/>
               </a:rPr>
-              <a:t>Evaluar la transferencia a otros dominios (imágenes médicas, aéreas).</a:t>
+              <a:t>Frente a la metodología clásica Top-Hat, mejora todas las métricas de calidad de fusión: el banco de SE y el ajuste automático aportan valor real.</a:t>
             </a:r>
             <a:endParaRPr lang="en-US" sz="1350" dirty="0"/>
           </a:p>
@@ -8339,7 +8364,7 @@
                 <a:ea typeface="Times New Roman" pitchFamily="34" charset="-122"/>
                 <a:cs typeface="Times New Roman" pitchFamily="34" charset="-120"/>
               </a:rPr>
-              <a:t>Para aplicaciones donde los artefactos son críticos (interpretación humana, diagnóstico), la propuesta es la opción recomendada; donde prima el contraste bruto, LP sigue siendo competitiva.</a:t>
+              <a:t>En detección, la superioridad en calidad de imagen no se traslada automáticamente al mAP: la elección del método debe guiarse por el criterio operativo prioritario.</a:t>
             </a:r>
             <a:endParaRPr lang="en-US" sz="1350" dirty="0"/>
           </a:p>
@@ -8385,8 +8410,8 @@
         </p:nvSpPr>
         <p:spPr>
           <a:xfrm>
-            <a:off x="457200" y="1828800"/>
-            <a:ext cx="8229600" cy="731520"/>
+            <a:off x="457200" y="256032"/>
+            <a:ext cx="8229600" cy="502920"/>
           </a:xfrm>
           <a:prstGeom prst="rect">
             <a:avLst/>
@@ -8398,11 +8423,11 @@
           <a:bodyPr wrap="square" lIns="0" tIns="0" rIns="0" bIns="0" rtlCol="0" anchor="ctr"/>
           <a:lstStyle/>
           <a:p>
-            <a:pPr algn="ctr" indent="0" marL="0">
+            <a:pPr indent="0" marL="0">
               <a:buNone/>
             </a:pPr>
             <a:r>
-              <a:rPr lang="en-US" sz="3400" b="1" dirty="0">
+              <a:rPr lang="en-US" sz="2300" b="1" dirty="0">
                 <a:solidFill>
                   <a:srgbClr val="1A1A1A"/>
                 </a:solidFill>
@@ -8410,9 +8435,9 @@
                 <a:ea typeface="Times New Roman" pitchFamily="34" charset="-122"/>
                 <a:cs typeface="Times New Roman" pitchFamily="34" charset="-120"/>
               </a:rPr>
-              <a:t>Muchas gracias</a:t>
-            </a:r>
-            <a:endParaRPr lang="en-US" sz="3400" dirty="0"/>
+              <a:t>Recomendaciones y trabajo futuro</a:t>
+            </a:r>
+            <a:endParaRPr lang="en-US" sz="2300" dirty="0"/>
           </a:p>
         </p:txBody>
       </p:sp>
@@ -8424,8 +8449,8 @@
         </p:nvSpPr>
         <p:spPr>
           <a:xfrm>
-            <a:off x="457200" y="2606040"/>
-            <a:ext cx="8229600" cy="365760"/>
+            <a:off x="8229600" y="4828032"/>
+            <a:ext cx="685800" cy="274320"/>
           </a:xfrm>
           <a:prstGeom prst="rect">
             <a:avLst/>
@@ -8437,11 +8462,11 @@
           <a:bodyPr wrap="square" lIns="0" tIns="0" rIns="0" bIns="0" rtlCol="0" anchor="ctr"/>
           <a:lstStyle/>
           <a:p>
-            <a:pPr algn="ctr" indent="0" marL="0">
+            <a:pPr algn="r" indent="0" marL="0">
               <a:buNone/>
             </a:pPr>
             <a:r>
-              <a:rPr lang="en-US" sz="1500" i="1" dirty="0">
+              <a:rPr lang="en-US" sz="900" dirty="0">
                 <a:solidFill>
                   <a:srgbClr val="666666"/>
                 </a:solidFill>
@@ -8449,9 +8474,9 @@
                 <a:ea typeface="Times New Roman" pitchFamily="34" charset="-122"/>
                 <a:cs typeface="Times New Roman" pitchFamily="34" charset="-120"/>
               </a:rPr>
-              <a:t>Preguntas y comentarios</a:t>
-            </a:r>
-            <a:endParaRPr lang="en-US" sz="1500" dirty="0"/>
+              <a:t>19 / 20</a:t>
+            </a:r>
+            <a:endParaRPr lang="en-US" sz="900" dirty="0"/>
           </a:p>
         </p:txBody>
       </p:sp>
@@ -8463,8 +8488,8 @@
         </p:nvSpPr>
         <p:spPr>
           <a:xfrm>
-            <a:off x="457200" y="3383280"/>
-            <a:ext cx="8229600" cy="320040"/>
+            <a:off x="457200" y="914400"/>
+            <a:ext cx="8229600" cy="3931920"/>
           </a:xfrm>
           <a:prstGeom prst="rect">
             <a:avLst/>
@@ -8473,63 +8498,112 @@
           <a:ln/>
         </p:spPr>
         <p:txBody>
-          <a:bodyPr wrap="square" lIns="0" tIns="0" rIns="0" bIns="0" rtlCol="0" anchor="ctr"/>
-          <a:lstStyle/>
-          <a:p>
-            <a:pPr algn="ctr" indent="0" marL="0">
-              <a:buNone/>
-            </a:pPr>
-            <a:r>
-              <a:rPr lang="en-US" sz="1200" dirty="0">
-                <a:solidFill>
-                  <a:srgbClr val="8B1A1A"/>
-                </a:solidFill>
-                <a:latin typeface="Times New Roman" pitchFamily="34" charset="0"/>
-                <a:ea typeface="Times New Roman" pitchFamily="34" charset="-122"/>
-                <a:cs typeface="Times New Roman" pitchFamily="34" charset="-120"/>
-              </a:rPr>
-              <a:t>Código y experimentos reproducibles:  github.com/YanBajac/TFM_Fusion_Imagenes_Propuesta_Oficial</a:t>
-            </a:r>
-            <a:endParaRPr lang="en-US" sz="1200" dirty="0"/>
-          </a:p>
-        </p:txBody>
-      </p:sp>
-      <p:sp>
-        <p:nvSpPr>
-          <p:cNvPr id="5" name="Text 3"/>
-          <p:cNvSpPr/>
-          <p:nvPr/>
-        </p:nvSpPr>
-        <p:spPr>
-          <a:xfrm>
-            <a:off x="457200" y="3794760"/>
-            <a:ext cx="8229600" cy="320040"/>
-          </a:xfrm>
-          <a:prstGeom prst="rect">
-            <a:avLst/>
-          </a:prstGeom>
-          <a:noFill/>
-          <a:ln/>
-        </p:spPr>
-        <p:txBody>
-          <a:bodyPr wrap="square" lIns="0" tIns="0" rIns="0" bIns="0" rtlCol="0" anchor="ctr"/>
-          <a:lstStyle/>
-          <a:p>
-            <a:pPr algn="ctr" indent="0" marL="0">
-              <a:buNone/>
-            </a:pPr>
-            <a:r>
-              <a:rPr lang="en-US" sz="1100" dirty="0">
-                <a:solidFill>
-                  <a:srgbClr val="666666"/>
-                </a:solidFill>
-                <a:latin typeface="Times New Roman" pitchFamily="34" charset="0"/>
-                <a:ea typeface="Times New Roman" pitchFamily="34" charset="-122"/>
-                <a:cs typeface="Times New Roman" pitchFamily="34" charset="-120"/>
-              </a:rPr>
-              <a:t>Lic. Juan Pablo Bazán  ·  Ing. Yan Bajac  —  Orientador: D.Sc. Julio César Mello</a:t>
-            </a:r>
-            <a:endParaRPr lang="en-US" sz="1100" dirty="0"/>
+          <a:bodyPr wrap="square" lIns="0" tIns="0" rIns="0" bIns="0" rtlCol="0" anchor="t"/>
+          <a:lstStyle/>
+          <a:p>
+            <a:pPr marL="177800" indent="-177800">
+              <a:spcAft>
+                <a:spcPts val="1100"/>
+              </a:spcAft>
+              <a:buSzPct val="100000"/>
+              <a:buChar char="•"/>
+            </a:pPr>
+            <a:r>
+              <a:rPr lang="en-US" sz="1350" dirty="0">
+                <a:solidFill>
+                  <a:srgbClr val="1A1A1A"/>
+                </a:solidFill>
+                <a:latin typeface="Times New Roman" pitchFamily="34" charset="0"/>
+                <a:ea typeface="Times New Roman" pitchFamily="34" charset="-122"/>
+                <a:cs typeface="Times New Roman" pitchFamily="34" charset="-120"/>
+              </a:rPr>
+              <a:t>Extender la evaluación de detección a otros detectores y al conjunto completo de LLVIP.</a:t>
+            </a:r>
+            <a:endParaRPr lang="en-US" sz="1350" dirty="0"/>
+          </a:p>
+          <a:p>
+            <a:pPr marL="177800" indent="-177800">
+              <a:spcAft>
+                <a:spcPts val="1100"/>
+              </a:spcAft>
+              <a:buSzPct val="100000"/>
+              <a:buChar char="•"/>
+            </a:pPr>
+            <a:r>
+              <a:rPr lang="en-US" sz="1350" dirty="0">
+                <a:solidFill>
+                  <a:srgbClr val="1A1A1A"/>
+                </a:solidFill>
+                <a:latin typeface="Times New Roman" pitchFamily="34" charset="0"/>
+                <a:ea typeface="Times New Roman" pitchFamily="34" charset="-122"/>
+                <a:cs typeface="Times New Roman" pitchFamily="34" charset="-120"/>
+              </a:rPr>
+              <a:t>Explorar reglas de fusión adaptativas para la rama Black Top-Hat.</a:t>
+            </a:r>
+            <a:endParaRPr lang="en-US" sz="1350" dirty="0"/>
+          </a:p>
+          <a:p>
+            <a:pPr marL="177800" indent="-177800">
+              <a:spcAft>
+                <a:spcPts val="1100"/>
+              </a:spcAft>
+              <a:buSzPct val="100000"/>
+              <a:buChar char="•"/>
+            </a:pPr>
+            <a:r>
+              <a:rPr lang="en-US" sz="1350" dirty="0">
+                <a:solidFill>
+                  <a:srgbClr val="1A1A1A"/>
+                </a:solidFill>
+                <a:latin typeface="Times New Roman" pitchFamily="34" charset="0"/>
+                <a:ea typeface="Times New Roman" pitchFamily="34" charset="-122"/>
+                <a:cs typeface="Times New Roman" pitchFamily="34" charset="-120"/>
+              </a:rPr>
+              <a:t>Complementar las métricas objetivas con una validación perceptual por observadores.</a:t>
+            </a:r>
+            <a:endParaRPr lang="en-US" sz="1350" dirty="0"/>
+          </a:p>
+          <a:p>
+            <a:pPr marL="177800" indent="-177800">
+              <a:spcAft>
+                <a:spcPts val="1100"/>
+              </a:spcAft>
+              <a:buSzPct val="100000"/>
+              <a:buChar char="•"/>
+            </a:pPr>
+            <a:r>
+              <a:rPr lang="en-US" sz="1350" dirty="0">
+                <a:solidFill>
+                  <a:srgbClr val="1A1A1A"/>
+                </a:solidFill>
+                <a:latin typeface="Times New Roman" pitchFamily="34" charset="0"/>
+                <a:ea typeface="Times New Roman" pitchFamily="34" charset="-122"/>
+                <a:cs typeface="Times New Roman" pitchFamily="34" charset="-120"/>
+              </a:rPr>
+              <a:t>Evaluar la transferencia a otros dominios (imágenes médicas, aéreas).</a:t>
+            </a:r>
+            <a:endParaRPr lang="en-US" sz="1350" dirty="0"/>
+          </a:p>
+          <a:p>
+            <a:pPr marL="177800" indent="-177800">
+              <a:spcAft>
+                <a:spcPts val="1100"/>
+              </a:spcAft>
+              <a:buSzPct val="100000"/>
+              <a:buChar char="•"/>
+            </a:pPr>
+            <a:r>
+              <a:rPr lang="en-US" sz="1350" dirty="0">
+                <a:solidFill>
+                  <a:srgbClr val="1A1A1A"/>
+                </a:solidFill>
+                <a:latin typeface="Times New Roman" pitchFamily="34" charset="0"/>
+                <a:ea typeface="Times New Roman" pitchFamily="34" charset="-122"/>
+                <a:cs typeface="Times New Roman" pitchFamily="34" charset="-120"/>
+              </a:rPr>
+              <a:t>Para aplicaciones donde los artefactos son críticos (interpretación humana, diagnóstico), la propuesta es la opción recomendada; donde prima el contraste bruto, LP sigue siendo competitiva.</a:t>
+            </a:r>
+            <a:endParaRPr lang="en-US" sz="1350" dirty="0"/>
           </a:p>
         </p:txBody>
       </p:sp>
@@ -8637,7 +8711,7 @@
                 <a:ea typeface="Times New Roman" pitchFamily="34" charset="-122"/>
                 <a:cs typeface="Times New Roman" pitchFamily="34" charset="-120"/>
               </a:rPr>
-              <a:t>2 / 19</a:t>
+              <a:t>2 / 20</a:t>
             </a:r>
             <a:endParaRPr lang="en-US" sz="900" dirty="0"/>
           </a:p>
@@ -8851,6 +8925,194 @@
               <a:t>9.  Conclusiones y recomendaciones</a:t>
             </a:r>
             <a:endParaRPr lang="en-US" sz="1500" dirty="0"/>
+          </a:p>
+        </p:txBody>
+      </p:sp>
+    </p:spTree>
+  </p:cSld>
+  <p:clrMapOvr>
+    <a:masterClrMapping/>
+  </p:clrMapOvr>
+</p:sld>
+</file>
+
+<file path=ppt/slides/slide20.xml><?xml version="1.0" encoding="utf-8"?>
+<p:sld xmlns:a="http://schemas.openxmlformats.org/drawingml/2006/main" xmlns:r="http://schemas.openxmlformats.org/officeDocument/2006/relationships" xmlns:p="http://schemas.openxmlformats.org/presentationml/2006/main">
+  <p:cSld name="Slide 20">
+    <p:bg>
+      <p:bgPr>
+        <a:solidFill>
+          <a:srgbClr val="FFFFFF"/>
+        </a:solidFill>
+      </p:bgPr>
+    </p:bg>
+    <p:spTree>
+      <p:nvGrpSpPr>
+        <p:cNvPr id="1" name=""/>
+        <p:cNvGrpSpPr/>
+        <p:nvPr/>
+      </p:nvGrpSpPr>
+      <p:grpSpPr>
+        <a:xfrm>
+          <a:off x="0" y="0"/>
+          <a:ext cx="0" cy="0"/>
+          <a:chOff x="0" y="0"/>
+          <a:chExt cx="0" cy="0"/>
+        </a:xfrm>
+      </p:grpSpPr>
+      <p:sp>
+        <p:nvSpPr>
+          <p:cNvPr id="2" name="Text 0"/>
+          <p:cNvSpPr/>
+          <p:nvPr/>
+        </p:nvSpPr>
+        <p:spPr>
+          <a:xfrm>
+            <a:off x="457200" y="1828800"/>
+            <a:ext cx="8229600" cy="731520"/>
+          </a:xfrm>
+          <a:prstGeom prst="rect">
+            <a:avLst/>
+          </a:prstGeom>
+          <a:noFill/>
+          <a:ln/>
+        </p:spPr>
+        <p:txBody>
+          <a:bodyPr wrap="square" lIns="0" tIns="0" rIns="0" bIns="0" rtlCol="0" anchor="ctr"/>
+          <a:lstStyle/>
+          <a:p>
+            <a:pPr algn="ctr" indent="0" marL="0">
+              <a:buNone/>
+            </a:pPr>
+            <a:r>
+              <a:rPr lang="en-US" sz="3400" b="1" dirty="0">
+                <a:solidFill>
+                  <a:srgbClr val="1A1A1A"/>
+                </a:solidFill>
+                <a:latin typeface="Times New Roman" pitchFamily="34" charset="0"/>
+                <a:ea typeface="Times New Roman" pitchFamily="34" charset="-122"/>
+                <a:cs typeface="Times New Roman" pitchFamily="34" charset="-120"/>
+              </a:rPr>
+              <a:t>Muchas gracias</a:t>
+            </a:r>
+            <a:endParaRPr lang="en-US" sz="3400" dirty="0"/>
+          </a:p>
+        </p:txBody>
+      </p:sp>
+      <p:sp>
+        <p:nvSpPr>
+          <p:cNvPr id="3" name="Text 1"/>
+          <p:cNvSpPr/>
+          <p:nvPr/>
+        </p:nvSpPr>
+        <p:spPr>
+          <a:xfrm>
+            <a:off x="457200" y="2606040"/>
+            <a:ext cx="8229600" cy="365760"/>
+          </a:xfrm>
+          <a:prstGeom prst="rect">
+            <a:avLst/>
+          </a:prstGeom>
+          <a:noFill/>
+          <a:ln/>
+        </p:spPr>
+        <p:txBody>
+          <a:bodyPr wrap="square" lIns="0" tIns="0" rIns="0" bIns="0" rtlCol="0" anchor="ctr"/>
+          <a:lstStyle/>
+          <a:p>
+            <a:pPr algn="ctr" indent="0" marL="0">
+              <a:buNone/>
+            </a:pPr>
+            <a:r>
+              <a:rPr lang="en-US" sz="1500" i="1" dirty="0">
+                <a:solidFill>
+                  <a:srgbClr val="666666"/>
+                </a:solidFill>
+                <a:latin typeface="Times New Roman" pitchFamily="34" charset="0"/>
+                <a:ea typeface="Times New Roman" pitchFamily="34" charset="-122"/>
+                <a:cs typeface="Times New Roman" pitchFamily="34" charset="-120"/>
+              </a:rPr>
+              <a:t>Preguntas y comentarios</a:t>
+            </a:r>
+            <a:endParaRPr lang="en-US" sz="1500" dirty="0"/>
+          </a:p>
+        </p:txBody>
+      </p:sp>
+      <p:sp>
+        <p:nvSpPr>
+          <p:cNvPr id="4" name="Text 2"/>
+          <p:cNvSpPr/>
+          <p:nvPr/>
+        </p:nvSpPr>
+        <p:spPr>
+          <a:xfrm>
+            <a:off x="457200" y="3383280"/>
+            <a:ext cx="8229600" cy="320040"/>
+          </a:xfrm>
+          <a:prstGeom prst="rect">
+            <a:avLst/>
+          </a:prstGeom>
+          <a:noFill/>
+          <a:ln/>
+        </p:spPr>
+        <p:txBody>
+          <a:bodyPr wrap="square" lIns="0" tIns="0" rIns="0" bIns="0" rtlCol="0" anchor="ctr"/>
+          <a:lstStyle/>
+          <a:p>
+            <a:pPr algn="ctr" indent="0" marL="0">
+              <a:buNone/>
+            </a:pPr>
+            <a:r>
+              <a:rPr lang="en-US" sz="1200" dirty="0">
+                <a:solidFill>
+                  <a:srgbClr val="8B1A1A"/>
+                </a:solidFill>
+                <a:latin typeface="Times New Roman" pitchFamily="34" charset="0"/>
+                <a:ea typeface="Times New Roman" pitchFamily="34" charset="-122"/>
+                <a:cs typeface="Times New Roman" pitchFamily="34" charset="-120"/>
+              </a:rPr>
+              <a:t>Código y experimentos reproducibles:  github.com/YanBajac/TFM_Fusion_Imagenes_Propuesta_Oficial</a:t>
+            </a:r>
+            <a:endParaRPr lang="en-US" sz="1200" dirty="0"/>
+          </a:p>
+        </p:txBody>
+      </p:sp>
+      <p:sp>
+        <p:nvSpPr>
+          <p:cNvPr id="5" name="Text 3"/>
+          <p:cNvSpPr/>
+          <p:nvPr/>
+        </p:nvSpPr>
+        <p:spPr>
+          <a:xfrm>
+            <a:off x="457200" y="3794760"/>
+            <a:ext cx="8229600" cy="320040"/>
+          </a:xfrm>
+          <a:prstGeom prst="rect">
+            <a:avLst/>
+          </a:prstGeom>
+          <a:noFill/>
+          <a:ln/>
+        </p:spPr>
+        <p:txBody>
+          <a:bodyPr wrap="square" lIns="0" tIns="0" rIns="0" bIns="0" rtlCol="0" anchor="ctr"/>
+          <a:lstStyle/>
+          <a:p>
+            <a:pPr algn="ctr" indent="0" marL="0">
+              <a:buNone/>
+            </a:pPr>
+            <a:r>
+              <a:rPr lang="en-US" sz="1100" dirty="0">
+                <a:solidFill>
+                  <a:srgbClr val="666666"/>
+                </a:solidFill>
+                <a:latin typeface="Times New Roman" pitchFamily="34" charset="0"/>
+                <a:ea typeface="Times New Roman" pitchFamily="34" charset="-122"/>
+                <a:cs typeface="Times New Roman" pitchFamily="34" charset="-120"/>
+              </a:rPr>
+              <a:t>Lic. Juan Pablo Bazán  ·  Ing. Yan Bajac  —  Orientador: D.Sc. Julio César Mello</a:t>
+            </a:r>
+            <a:endParaRPr lang="en-US" sz="1100" dirty="0"/>
           </a:p>
         </p:txBody>
       </p:sp>
@@ -8958,7 +9220,7 @@
                 <a:ea typeface="Times New Roman" pitchFamily="34" charset="-122"/>
                 <a:cs typeface="Times New Roman" pitchFamily="34" charset="-120"/>
               </a:rPr>
-              <a:t>3 / 19</a:t>
+              <a:t>3 / 20</a:t>
             </a:r>
             <a:endParaRPr lang="en-US" sz="900" dirty="0"/>
           </a:p>
@@ -9219,7 +9481,7 @@
                 <a:ea typeface="Times New Roman" pitchFamily="34" charset="-122"/>
                 <a:cs typeface="Times New Roman" pitchFamily="34" charset="-120"/>
               </a:rPr>
-              <a:t>4 / 19</a:t>
+              <a:t>4 / 20</a:t>
             </a:r>
             <a:endParaRPr lang="en-US" sz="900" dirty="0"/>
           </a:p>
@@ -9552,7 +9814,7 @@
                 <a:ea typeface="Times New Roman" pitchFamily="34" charset="-122"/>
                 <a:cs typeface="Times New Roman" pitchFamily="34" charset="-120"/>
               </a:rPr>
-              <a:t>5 / 19</a:t>
+              <a:t>5 / 20</a:t>
             </a:r>
             <a:endParaRPr lang="en-US" sz="900" dirty="0"/>
           </a:p>
@@ -9896,7 +10158,7 @@
                 <a:ea typeface="Times New Roman" pitchFamily="34" charset="-122"/>
                 <a:cs typeface="Times New Roman" pitchFamily="34" charset="-120"/>
               </a:rPr>
-              <a:t>6 / 19</a:t>
+              <a:t>6 / 20</a:t>
             </a:r>
             <a:endParaRPr lang="en-US" sz="900" dirty="0"/>
           </a:p>
@@ -10217,7 +10479,7 @@
                 <a:ea typeface="Times New Roman" pitchFamily="34" charset="-122"/>
                 <a:cs typeface="Times New Roman" pitchFamily="34" charset="-120"/>
               </a:rPr>
-              <a:t>7 / 19</a:t>
+              <a:t>7 / 20</a:t>
             </a:r>
             <a:endParaRPr lang="en-US" sz="900" dirty="0"/>
           </a:p>
@@ -10526,7 +10788,7 @@
                 <a:ea typeface="Times New Roman" pitchFamily="34" charset="-122"/>
                 <a:cs typeface="Times New Roman" pitchFamily="34" charset="-120"/>
               </a:rPr>
-              <a:t>8 / 19</a:t>
+              <a:t>8 / 20</a:t>
             </a:r>
             <a:endParaRPr lang="en-US" sz="900" dirty="0"/>
           </a:p>
@@ -10851,7 +11113,7 @@
                 <a:ea typeface="Times New Roman" pitchFamily="34" charset="-122"/>
                 <a:cs typeface="Times New Roman" pitchFamily="34" charset="-120"/>
               </a:rPr>
-              <a:t>9 / 19</a:t>
+              <a:t>9 / 20</a:t>
             </a:r>
             <a:endParaRPr lang="en-US" sz="900" dirty="0"/>
           </a:p>

</xml_diff>

<commit_message>
Avances, Excel y deck: completa el paralelo F_o vs F_apt en detección
- Avances (31 págs): fila Propuesta_Fo en la tabla LLVIP y en la gráfica de
  barras; línea del Wilcoxon (8/12 a favor de F_apt) en la ablación; nueva
  página 12 (continuación) con la comparación cualitativa de aptitudes.
- Excel: hoja Deteccion_LLVIP con ambas configs (F_apt y Fo); 0 errores.
- Deck (20 láminas): barras de LLVIP con las dos configs de la propuesta
  (F_apt granate, Fo rosa); lámina de ablación con el Wilcoxon 8/12.
</commit_message>
<xml_diff>
--- a/docs/Tesis_Defensa_Presentacion.pptx
+++ b/docs/Tesis_Defensa_Presentacion.pptx
@@ -7187,8 +7187,8 @@
         </p:blipFill>
         <p:spPr>
           <a:xfrm>
-            <a:off x="1179576" y="822960"/>
-            <a:ext cx="6766560" cy="3099816"/>
+            <a:off x="960120" y="822960"/>
+            <a:ext cx="7223760" cy="2761488"/>
           </a:xfrm>
           <a:prstGeom prst="rect">
             <a:avLst/>
@@ -7203,8 +7203,8 @@
         </p:nvSpPr>
         <p:spPr>
           <a:xfrm>
-            <a:off x="457200" y="4023360"/>
-            <a:ext cx="8229600" cy="1005840"/>
+            <a:off x="457200" y="3703320"/>
+            <a:ext cx="8229600" cy="1325880"/>
           </a:xfrm>
           <a:prstGeom prst="rect">
             <a:avLst/>
@@ -7218,7 +7218,7 @@
           <a:p>
             <a:pPr marL="177800" indent="-177800">
               <a:spcAft>
-                <a:spcPts val="400"/>
+                <a:spcPts val="500"/>
               </a:spcAft>
               <a:buSzPct val="100000"/>
               <a:buChar char="•"/>
@@ -7232,14 +7232,14 @@
                 <a:ea typeface="Times New Roman" pitchFamily="34" charset="-122"/>
                 <a:cs typeface="Times New Roman" pitchFamily="34" charset="-120"/>
               </a:rPr>
-              <a:t>Toda fusión supera con claridad al visible solo (+0,12 a +0,14 en mAP@0,5).</a:t>
+              <a:t>Toda fusión supera con claridad al visible solo (+0,12 a +0,14 en mAP@0,5); el IR solo lidera (0,957): en peatones nocturnos domina la firma térmica.</a:t>
             </a:r>
             <a:endParaRPr lang="en-US" sz="1200" dirty="0"/>
           </a:p>
           <a:p>
             <a:pPr marL="177800" indent="-177800">
               <a:spcAft>
-                <a:spcPts val="400"/>
+                <a:spcPts val="500"/>
               </a:spcAft>
               <a:buSzPct val="100000"/>
               <a:buChar char="•"/>
@@ -7253,14 +7253,14 @@
                 <a:ea typeface="Times New Roman" pitchFamily="34" charset="-122"/>
                 <a:cs typeface="Times New Roman" pitchFamily="34" charset="-120"/>
               </a:rPr>
-              <a:t>El infrarrojo solo lidera (0,957): en peatones nocturnos la firma térmica domina.</a:t>
+              <a:t>Las dos configuraciones de la propuesta caen en la banda de las fusiones: F_apt (0,936) y Fo (0,922), pareja con el clásico (0,938).</a:t>
             </a:r>
             <a:endParaRPr lang="en-US" sz="1200" dirty="0"/>
           </a:p>
           <a:p>
             <a:pPr marL="177800" indent="-177800">
               <a:spcAft>
-                <a:spcPts val="400"/>
+                <a:spcPts val="500"/>
               </a:spcAft>
               <a:buSzPct val="100000"/>
               <a:buChar char="•"/>
@@ -7274,7 +7274,7 @@
                 <a:ea typeface="Times New Roman" pitchFamily="34" charset="-122"/>
                 <a:cs typeface="Times New Roman" pitchFamily="34" charset="-120"/>
               </a:rPr>
-              <a:t>Entre las 7 fusiones la banda es estrecha (0,926–0,949); la propuesta es competitiva (0,936), pareja con el clásico (0,938).</a:t>
+              <a:t>La calidad de imagen no se traslada automáticamente al mAP (H3 parcial).</a:t>
             </a:r>
             <a:endParaRPr lang="en-US" sz="1200" dirty="0"/>
           </a:p>
@@ -11278,8 +11278,8 @@
         </p:nvSpPr>
         <p:spPr>
           <a:xfrm>
-            <a:off x="457200" y="4206240"/>
-            <a:ext cx="8229600" cy="548640"/>
+            <a:off x="457200" y="4160520"/>
+            <a:ext cx="8229600" cy="640080"/>
           </a:xfrm>
           <a:prstGeom prst="rect">
             <a:avLst/>
@@ -11295,7 +11295,7 @@
               <a:buNone/>
             </a:pPr>
             <a:r>
-              <a:rPr lang="en-US" sz="1200" i="1" dirty="0">
+              <a:rPr lang="en-US" sz="1150" i="1" dirty="0">
                 <a:solidFill>
                   <a:srgbClr val="8B1A1A"/>
                 </a:solidFill>
@@ -11303,9 +11303,9 @@
                 <a:ea typeface="Times New Roman" pitchFamily="34" charset="-122"/>
                 <a:cs typeface="Times New Roman" pitchFamily="34" charset="-120"/>
               </a:rPr>
-              <a:t>Ambas aptitudes acuerdan el peso del operador con suma; la orientada a la fusión controla además los artefactos (refuerza H2).</a:t>
-            </a:r>
-            <a:endParaRPr lang="en-US" sz="1200" dirty="0"/>
+              <a:t>Wilcoxon entre ambos óptimos: F_apt mejor y significativa en 8/12 métricas (limpieza y estructura). Ambas aptitudes acuerdan el peso del operador; F_apt controla además los artefactos (refuerza H2).</a:t>
+            </a:r>
+            <a:endParaRPr lang="en-US" sz="1150" dirty="0"/>
           </a:p>
         </p:txBody>
       </p:sp>

</xml_diff>

<commit_message>
Reencuadre F_o unica: libro, avances, Excel y deck con 9 metricas y aptitud publicada
- Aptitud F_o (SSIM_avg + E_n + PSNR_n) de Ortega y Espinoza como unico optimizador;
  config r=25, m=0,0703 (optimo global de F_o, verificado con barrido determinista)
- Metricas de evaluacion reducidas a 9 (EN, SD, FE, MG, MI_vis, MI_ir, SF, SSIM, PSNR),
  todas de tipo "mayor es mejor"
- Eliminada F_apt y la ablacion de aptitud de todos los documentos
- Libro: ecuacion (14) reescrita a F_o, tablas 1-11 renumeradas, Figuras 7/8/11
  regeneradas, narrativa coherente sin metricas retiradas
- Avances PDF (29 pags) y Excel (10 hojas) regenerados; deck de defensa (19 laminas)
- Contribucion anclada en la deteccion orientada a tarea (M3FD: clases complementarias)
</commit_message>
<xml_diff>
--- a/docs/Tesis_Defensa_Presentacion.pptx
+++ b/docs/Tesis_Defensa_Presentacion.pptx
@@ -24,10 +24,9 @@
     <p:sldId id="272" r:id="rId18"/>
     <p:sldId id="273" r:id="rId19"/>
     <p:sldId id="274" r:id="rId20"/>
-    <p:sldId id="275" r:id="rId21"/>
   </p:sldIdLst>
   <p:notesMasterIdLst>
-    <p:notesMasterId r:id="rId22"/>
+    <p:notesMasterId r:id="rId21"/>
   </p:notesMasterIdLst>
   <p:sldSz cx="9144000" cy="5143500"/>
   <p:notesSz cx="5143500" cy="9144000"/>
@@ -609,7 +608,7 @@
           <a:p>
             <a:r>
               <a:rPr lang="en-US" dirty="0"/>
-              <a:t>Dos evaluaciones complementarias: calidad de imagen (TNO, sin referencia) y utilidad en tarea (LLVIP, con verdad de campo). En LLVIP solo cambian los píxeles de entrada; las etiquetas son las mismas, así el mAP aísla el efecto de la fusión.</a:t>
+              <a:t>Escena representativa: la propuesta (recuadro rojo) integra la firma térmica de las personas con la textura de la casa y la vegetación, con menos halos y ruido que RP/DWT y más contraste local que el clásico.</a:t>
             </a:r>
             <a:endParaRPr lang="en-US" dirty="0"/>
           </a:p>
@@ -697,7 +696,7 @@
           <a:p>
             <a:r>
               <a:rPr lang="en-US" dirty="0"/>
-              <a:t>Escena representativa: la propuesta (recuadro rojo) integra la firma térmica de las personas con la textura de la casa y la vegetación, con menos halos y ruido que RP/DWT y más contraste local que el clásico.</a:t>
+              <a:t>Negritas = mejor por columna. No hay método universalmente dominante: la propuesta lidera SSIM, LP el contraste (SD) y la información mutua, el Top-Hat clásico la actividad (SF). El perfil de la propuesta es la fidelidad estructural.</a:t>
             </a:r>
             <a:endParaRPr lang="en-US" dirty="0"/>
           </a:p>
@@ -785,7 +784,7 @@
           <a:p>
             <a:r>
               <a:rPr lang="en-US" dirty="0"/>
-              <a:t>Negritas = mejor por columna. No hay método universalmente dominante: DTCWT lidera bordes por una milésima, RP la correlación, LP el contraste. El perfil de la propuesta es limpieza (Nabf) y estructura (SSIM), quedando segunda en el resto a distancias mínimas.</a:t>
+              <a:t>La evidencia estadística sostiene las ventajas donde la propuesta las reclama: limpieza y estructura, con significancia tras corregir por comparaciones múltiples. El ranking global es honesto: la propuesta no domina todo; domina su perfil.</a:t>
             </a:r>
             <a:endParaRPr lang="en-US" dirty="0"/>
           </a:p>
@@ -873,7 +872,7 @@
           <a:p>
             <a:r>
               <a:rPr lang="en-US" dirty="0"/>
-              <a:t>La evidencia estadística sostiene las ventajas donde la propuesta las reclama: limpieza y estructura, con significancia tras corregir por comparaciones múltiples. El ranking global es honesto: la propuesta no domina todo; domina su perfil.</a:t>
+              <a:t>El hallazgo más matizado: fusionar aporta muchísimo frente al VIS, pero ninguna fusión supera al IR puro en esta tarea nocturna. Entre fusiones, las diferencias son pequeñas: la calidad de imagen no se traslada automáticamente al mAP.</a:t>
             </a:r>
             <a:endParaRPr lang="en-US" dirty="0"/>
           </a:p>
@@ -961,7 +960,7 @@
           <a:p>
             <a:r>
               <a:rPr lang="en-US" dirty="0"/>
-              <a:t>El hallazgo más matizado: fusionar aporta muchísimo frente al VIS, pero ninguna fusión supera al IR puro en esta tarea nocturna. Entre fusiones, las diferencias son pequeñas: la calidad de imagen no se traslada automáticamente al mAP.</a:t>
+              <a:t>El experimento que delimita el valor de la fusión: un único YOLOv8n entrenado con VIS+IR mezcladas (4.000 imágenes, 40 épocas) e inferencia por método. Las personas solo se ven bien en IR y las luces solo en VIS; la fusión es la única entrada que detecta ambas a la vez. La propuesta es la mejor fusión del estudio en este escenario: detecta ambas clases complementarias en una sola imagen.</a:t>
             </a:r>
             <a:endParaRPr lang="en-US" dirty="0"/>
           </a:p>
@@ -1049,7 +1048,7 @@
           <a:p>
             <a:r>
               <a:rPr lang="en-US" dirty="0"/>
-              <a:t>El experimento que delimita el valor de la fusión: un único YOLOv8n entrenado con VIS+IR mezcladas (4.000 imágenes, 40 épocas) e inferencia por método. Las personas solo se ven bien en IR y las luces solo en VIS; la fusión es la única entrada que detecta ambas a la vez. La propuesta lidera entre las fusiones y su ventaja sobre el óptimo Fo confirma la elección de la aptitud también en tarea.</a:t>
+              <a:t>Cerrar M3FD con la evidencia visual: dos escenas reales de la validación. En la primera, las personas están bajo el puente a contraluz: invisibles para el detector en VIS, obvias en IR y recuperadas por la fusión. En la segunda, el semáforo y las luces no emiten calor: el IR no los ve, la fusión sí — junto con las personas. Una sola imagen, ambas clases: eso es lo que la fusión compra.</a:t>
             </a:r>
             <a:endParaRPr lang="en-US" dirty="0"/>
           </a:p>
@@ -1137,7 +1136,7 @@
           <a:p>
             <a:r>
               <a:rPr lang="en-US" dirty="0"/>
-              <a:t>Cerrar M3FD con la evidencia visual: dos escenas reales de la validación. En la primera, las personas están bajo el puente a contraluz: invisibles para el detector en VIS, obvias en IR y recuperadas por la fusión. En la segunda, el semáforo y las luces no emiten calor: el IR no los ve, la fusión sí — junto con las personas. Una sola imagen, ambas clases: eso es lo que la fusión compra.</a:t>
+              <a:t>H1 y H2 quedan sostenidas con evidencia estadística. H3 solo parcialmente: es el resultado más honesto del trabajo y anticipa la pregunta natural del tribunal — calidad de imagen y utilidad en tarea son criterios distintos.</a:t>
             </a:r>
             <a:endParaRPr lang="en-US" dirty="0"/>
           </a:p>
@@ -1225,7 +1224,7 @@
           <a:p>
             <a:r>
               <a:rPr lang="en-US" dirty="0"/>
-              <a:t>H1 y H2 quedan sostenidas con evidencia estadística. H3 solo parcialmente: es el resultado más honesto del trabajo y anticipa la pregunta natural del tribunal — calidad de imagen y utilidad en tarea son criterios distintos.</a:t>
+              <a:t>Cinco conclusiones: método formulado, óptimo hallado, perfil de calidad validado, ventaja sobre el clásico demostrada, y la lección sobre calidad vs. tarea.</a:t>
             </a:r>
             <a:endParaRPr lang="en-US" dirty="0"/>
           </a:p>
@@ -1313,7 +1312,7 @@
           <a:p>
             <a:r>
               <a:rPr lang="en-US" dirty="0"/>
-              <a:t>Cinco conclusiones: método formulado, óptimo hallado, perfil de calidad validado, ventaja sobre el clásico demostrada, y la lección sobre calidad vs. tarea.</a:t>
+              <a:t>Cerrar con la recomendación práctica: qué método elegir según el criterio operativo. Dejar claro que el pipeline completo es reproducible desde el repositorio.</a:t>
             </a:r>
             <a:endParaRPr lang="en-US" dirty="0"/>
           </a:p>
@@ -1401,7 +1400,7 @@
           <a:p>
             <a:r>
               <a:rPr lang="en-US" dirty="0"/>
-              <a:t>Cerrar con la recomendación práctica: qué método elegir según el criterio operativo. Dejar claro que el pipeline completo es reproducible desde el repositorio.</a:t>
+              <a:t>Agradecer a la mesa y al orientador. Ofrecer el repositorio para cualquier verificación.</a:t>
             </a:r>
             <a:endParaRPr lang="en-US" dirty="0"/>
           </a:p>
@@ -1531,94 +1530,6 @@
 </p:notes>
 </file>
 
-<file path=ppt/notesSlides/notesSlide20.xml><?xml version="1.0" encoding="utf-8"?>
-<p:notes xmlns:a="http://schemas.openxmlformats.org/drawingml/2006/main" xmlns:r="http://schemas.openxmlformats.org/officeDocument/2006/relationships" xmlns:p="http://schemas.openxmlformats.org/presentationml/2006/main">
-  <p:cSld>
-    <p:spTree>
-      <p:nvGrpSpPr>
-        <p:cNvPr id="1" name=""/>
-        <p:cNvGrpSpPr/>
-        <p:nvPr/>
-      </p:nvGrpSpPr>
-      <p:grpSpPr>
-        <a:xfrm>
-          <a:off x="0" y="0"/>
-          <a:ext cx="0" cy="0"/>
-          <a:chOff x="0" y="0"/>
-          <a:chExt cx="0" cy="0"/>
-        </a:xfrm>
-      </p:grpSpPr>
-      <p:sp>
-        <p:nvSpPr>
-          <p:cNvPr id="2" name="Slide Image Placeholder 1"/>
-          <p:cNvSpPr>
-            <a:spLocks noGrp="1" noRot="1" noChangeAspect="1"/>
-          </p:cNvSpPr>
-          <p:nvPr>
-            <p:ph type="sldImg"/>
-          </p:nvPr>
-        </p:nvSpPr>
-        <p:spPr/>
-      </p:sp>
-      <p:sp>
-        <p:nvSpPr>
-          <p:cNvPr id="3" name="Notes Placeholder 2"/>
-          <p:cNvSpPr>
-            <a:spLocks noGrp="1"/>
-          </p:cNvSpPr>
-          <p:nvPr>
-            <p:ph type="body" idx="1"/>
-          </p:nvPr>
-        </p:nvSpPr>
-        <p:spPr/>
-        <p:txBody>
-          <a:bodyPr/>
-          <a:lstStyle/>
-          <a:p>
-            <a:r>
-              <a:rPr lang="en-US" dirty="0"/>
-              <a:t>Agradecer a la mesa y al orientador. Ofrecer el repositorio para cualquier verificación.</a:t>
-            </a:r>
-            <a:endParaRPr lang="en-US" dirty="0"/>
-          </a:p>
-        </p:txBody>
-      </p:sp>
-      <p:sp>
-        <p:nvSpPr>
-          <p:cNvPr id="4" name="Slide Number Placeholder 3"/>
-          <p:cNvSpPr>
-            <a:spLocks noGrp="1"/>
-          </p:cNvSpPr>
-          <p:nvPr>
-            <p:ph type="sldNum" sz="quarter" idx="10"/>
-          </p:nvPr>
-        </p:nvSpPr>
-        <p:spPr/>
-        <p:txBody>
-          <a:bodyPr/>
-          <a:lstStyle/>
-          <a:p>
-            <a:fld id="{F7021451-1387-4CA6-816F-3879F97B5CBC}" type="slidenum">
-              <a:rPr lang="en-US"/>
-              <a:t>20</a:t>
-            </a:fld>
-            <a:endParaRPr lang="en-US"/>
-          </a:p>
-        </p:txBody>
-      </p:sp>
-    </p:spTree>
-    <p:extLst>
-      <p:ext uri="{BB962C8B-B14F-4D97-AF65-F5344CB8AC3E}">
-        <p14:creationId xmlns:p14="http://schemas.microsoft.com/office/powerpoint/2010/main" val="1024086991"/>
-      </p:ext>
-    </p:extLst>
-  </p:cSld>
-  <p:clrMapOvr>
-    <a:masterClrMapping/>
-  </p:clrMapOvr>
-</p:notes>
-</file>
-
 <file path=ppt/notesSlides/notesSlide3.xml><?xml version="1.0" encoding="utf-8"?>
 <p:notes xmlns:a="http://schemas.openxmlformats.org/drawingml/2006/main" xmlns:r="http://schemas.openxmlformats.org/officeDocument/2006/relationships" xmlns:p="http://schemas.openxmlformats.org/presentationml/2006/main">
   <p:cSld>
@@ -2105,7 +2016,7 @@
           <a:p>
             <a:r>
               <a:rPr lang="en-US" dirty="0"/>
-              <a:t>r controla la escala de las estructuras que se extraen; m cuánto realce se reinyecta. La aptitud combina fidelidad estructural, bordes y correlación, y castiga artefactos. El barrido replica el diseño del trabajo de la FPUNA: el óptimo r=25 con m pequeño (0,07) extrae estructuras grandes pero las pondera suavemente.</a:t>
+              <a:t>r controla la escala de las estructuras que se extraen; m cuánto realce se reinyecta. La aptitud publicada F_o combina fidelidad estructural (SSIM), información (entropía) y baja distorsión (PSNR). El barrido replica el Cuadro 1 de la FPUNA: el óptimo global de F_o para este operador es r=25 con m pequeño (≈0,07), que extrae estructuras grandes pero las pondera suavemente.</a:t>
             </a:r>
             <a:endParaRPr lang="en-US" dirty="0"/>
           </a:p>
@@ -2193,7 +2104,7 @@
           <a:p>
             <a:r>
               <a:rPr lang="en-US" dirty="0"/>
-              <a:t>Respuesta a la pregunta del tribunal sobre la elección de la aptitud: repetimos el barrido con la fórmula del trabajo replicado. Resultado: su propio óptimo cae al piso del rango (m=0,30) y, sin restricciones, coincide con el nuestro (m≈0,07). La aptitud de fidelidad pura además apaga el banco de SE (r=1). La curva demuestra que ningún enjambre puede converger en [0,5-2]: es el paisaje, no la búsqueda.</a:t>
+              <a:t>Dos evaluaciones complementarias: calidad de imagen (TNO, sin referencia) y utilidad en tarea (LLVIP, con verdad de campo). En LLVIP solo cambian los píxeles de entrada; las etiquetas son las mismas, así el mAP aísla el efecto de la fusión.</a:t>
             </a:r>
             <a:endParaRPr lang="en-US" dirty="0"/>
           </a:p>
@@ -2933,7 +2844,7 @@
                 <a:ea typeface="Times New Roman" pitchFamily="34" charset="-122"/>
                 <a:cs typeface="Times New Roman" pitchFamily="34" charset="-120"/>
               </a:rPr>
-              <a:t>6. Diseño experimental</a:t>
+              <a:t>7. Resultados cualitativos</a:t>
             </a:r>
             <a:endParaRPr lang="en-US" sz="2300" dirty="0"/>
           </a:p>
@@ -2972,22 +2883,46 @@
                 <a:ea typeface="Times New Roman" pitchFamily="34" charset="-122"/>
                 <a:cs typeface="Times New Roman" pitchFamily="34" charset="-120"/>
               </a:rPr>
-              <a:t>10 / 20</a:t>
+              <a:t>10 / 19</a:t>
             </a:r>
             <a:endParaRPr lang="en-US" sz="900" dirty="0"/>
           </a:p>
         </p:txBody>
       </p:sp>
-      <p:sp>
-        <p:nvSpPr>
-          <p:cNvPr id="4" name="Text 2"/>
+      <p:pic>
+        <p:nvPicPr>
+          <p:cNvPr id="4" name="Image 0" descr="C:/Users/Usuario/Documents/unv/mastertesis/tesis_mciencias_datos/docs/figures/cualitativas/montaje_07.png">    </p:cNvPr>
+          <p:cNvPicPr>
+            <a:picLocks noChangeAspect="1"/>
+          </p:cNvPicPr>
+          <p:nvPr/>
+        </p:nvPicPr>
+        <p:blipFill>
+          <a:blip r:embed="rId1"/>
+          <a:stretch>
+            <a:fillRect/>
+          </a:stretch>
+        </p:blipFill>
+        <p:spPr>
+          <a:xfrm>
+            <a:off x="1764792" y="777240"/>
+            <a:ext cx="5623560" cy="4005072"/>
+          </a:xfrm>
+          <a:prstGeom prst="rect">
+            <a:avLst/>
+          </a:prstGeom>
+        </p:spPr>
+      </p:pic>
+      <p:sp>
+        <p:nvSpPr>
+          <p:cNvPr id="5" name="Text 2"/>
           <p:cNvSpPr/>
           <p:nvPr/>
         </p:nvSpPr>
         <p:spPr>
           <a:xfrm>
-            <a:off x="457200" y="868680"/>
-            <a:ext cx="4023360" cy="274320"/>
+            <a:off x="457200" y="4828032"/>
+            <a:ext cx="7680960" cy="274320"/>
           </a:xfrm>
           <a:prstGeom prst="rect">
             <a:avLst/>
@@ -3003,247 +2938,17 @@
               <a:buNone/>
             </a:pPr>
             <a:r>
-              <a:rPr lang="en-US" sz="1400" b="1" dirty="0">
-                <a:solidFill>
-                  <a:srgbClr val="8B1A1A"/>
-                </a:solidFill>
-                <a:latin typeface="Times New Roman" pitchFamily="34" charset="0"/>
-                <a:ea typeface="Times New Roman" pitchFamily="34" charset="-122"/>
-                <a:cs typeface="Times New Roman" pitchFamily="34" charset="-120"/>
-              </a:rPr>
-              <a:t>Benchmark de calidad</a:t>
-            </a:r>
-            <a:endParaRPr lang="en-US" sz="1400" dirty="0"/>
-          </a:p>
-        </p:txBody>
-      </p:sp>
-      <p:sp>
-        <p:nvSpPr>
-          <p:cNvPr id="5" name="Text 3"/>
-          <p:cNvSpPr/>
-          <p:nvPr/>
-        </p:nvSpPr>
-        <p:spPr>
-          <a:xfrm>
-            <a:off x="457200" y="1188720"/>
-            <a:ext cx="4023360" cy="3291840"/>
-          </a:xfrm>
-          <a:prstGeom prst="rect">
-            <a:avLst/>
-          </a:prstGeom>
-          <a:noFill/>
-          <a:ln/>
-        </p:spPr>
-        <p:txBody>
-          <a:bodyPr wrap="square" lIns="0" tIns="0" rIns="0" bIns="0" rtlCol="0" anchor="t"/>
-          <a:lstStyle/>
-          <a:p>
-            <a:pPr marL="177800" indent="-177800">
-              <a:spcAft>
-                <a:spcPts val="800"/>
-              </a:spcAft>
-              <a:buSzPct val="100000"/>
-              <a:buChar char="•"/>
-            </a:pPr>
-            <a:r>
-              <a:rPr lang="en-US" sz="1250" dirty="0">
-                <a:solidFill>
-                  <a:srgbClr val="1A1A1A"/>
-                </a:solidFill>
-                <a:latin typeface="Times New Roman" pitchFamily="34" charset="0"/>
-                <a:ea typeface="Times New Roman" pitchFamily="34" charset="-122"/>
-                <a:cs typeface="Times New Roman" pitchFamily="34" charset="-120"/>
-              </a:rPr>
-              <a:t>20 pares VIS/IR del dataset TNO (Toet, 2014).</a:t>
-            </a:r>
-            <a:endParaRPr lang="en-US" sz="1250" dirty="0"/>
-          </a:p>
-          <a:p>
-            <a:pPr marL="177800" indent="-177800">
-              <a:spcAft>
-                <a:spcPts val="800"/>
-              </a:spcAft>
-              <a:buSzPct val="100000"/>
-              <a:buChar char="•"/>
-            </a:pPr>
-            <a:r>
-              <a:rPr lang="en-US" sz="1250" dirty="0">
-                <a:solidFill>
-                  <a:srgbClr val="1A1A1A"/>
-                </a:solidFill>
-                <a:latin typeface="Times New Roman" pitchFamily="34" charset="0"/>
-                <a:ea typeface="Times New Roman" pitchFamily="34" charset="-122"/>
-                <a:cs typeface="Times New Roman" pitchFamily="34" charset="-120"/>
-              </a:rPr>
-              <a:t>7 métodos: LP, RP, DWT, DTCWT, CVT, Top-Hat clásico y Propuesta → 140 fusiones.</a:t>
-            </a:r>
-            <a:endParaRPr lang="en-US" sz="1250" dirty="0"/>
-          </a:p>
-          <a:p>
-            <a:pPr marL="177800" indent="-177800">
-              <a:spcAft>
-                <a:spcPts val="800"/>
-              </a:spcAft>
-              <a:buSzPct val="100000"/>
-              <a:buChar char="•"/>
-            </a:pPr>
-            <a:r>
-              <a:rPr lang="en-US" sz="1250" dirty="0">
-                <a:solidFill>
-                  <a:srgbClr val="1A1A1A"/>
-                </a:solidFill>
-                <a:latin typeface="Times New Roman" pitchFamily="34" charset="0"/>
-                <a:ea typeface="Times New Roman" pitchFamily="34" charset="-122"/>
-                <a:cs typeface="Times New Roman" pitchFamily="34" charset="-120"/>
-              </a:rPr>
-              <a:t>12 métricas sin referencia (+ 4 descriptivas del review de Singh et al., 2023).</a:t>
-            </a:r>
-            <a:endParaRPr lang="en-US" sz="1250" dirty="0"/>
-          </a:p>
-          <a:p>
-            <a:pPr marL="177800" indent="-177800">
-              <a:spcAft>
-                <a:spcPts val="800"/>
-              </a:spcAft>
-              <a:buSzPct val="100000"/>
-              <a:buChar char="•"/>
-            </a:pPr>
-            <a:r>
-              <a:rPr lang="en-US" sz="1250" dirty="0">
-                <a:solidFill>
-                  <a:srgbClr val="1A1A1A"/>
-                </a:solidFill>
-                <a:latin typeface="Times New Roman" pitchFamily="34" charset="0"/>
-                <a:ea typeface="Times New Roman" pitchFamily="34" charset="-122"/>
-                <a:cs typeface="Times New Roman" pitchFamily="34" charset="-120"/>
-              </a:rPr>
-              <a:t>Friedman global + Wilcoxon pareado con corrección de Holm (α = 0,05).</a:t>
-            </a:r>
-            <a:endParaRPr lang="en-US" sz="1250" dirty="0"/>
-          </a:p>
-        </p:txBody>
-      </p:sp>
-      <p:sp>
-        <p:nvSpPr>
-          <p:cNvPr id="6" name="Text 4"/>
-          <p:cNvSpPr/>
-          <p:nvPr/>
-        </p:nvSpPr>
-        <p:spPr>
-          <a:xfrm>
-            <a:off x="4846320" y="868680"/>
-            <a:ext cx="3840480" cy="274320"/>
-          </a:xfrm>
-          <a:prstGeom prst="rect">
-            <a:avLst/>
-          </a:prstGeom>
-          <a:noFill/>
-          <a:ln/>
-        </p:spPr>
-        <p:txBody>
-          <a:bodyPr wrap="square" lIns="0" tIns="0" rIns="0" bIns="0" rtlCol="0" anchor="ctr"/>
-          <a:lstStyle/>
-          <a:p>
-            <a:pPr indent="0" marL="0">
-              <a:buNone/>
-            </a:pPr>
-            <a:r>
-              <a:rPr lang="en-US" sz="1400" b="1" dirty="0">
-                <a:solidFill>
-                  <a:srgbClr val="8B1A1A"/>
-                </a:solidFill>
-                <a:latin typeface="Times New Roman" pitchFamily="34" charset="0"/>
-                <a:ea typeface="Times New Roman" pitchFamily="34" charset="-122"/>
-                <a:cs typeface="Times New Roman" pitchFamily="34" charset="-120"/>
-              </a:rPr>
-              <a:t>Evaluación orientada a tarea</a:t>
-            </a:r>
-            <a:endParaRPr lang="en-US" sz="1400" dirty="0"/>
-          </a:p>
-        </p:txBody>
-      </p:sp>
-      <p:sp>
-        <p:nvSpPr>
-          <p:cNvPr id="7" name="Text 5"/>
-          <p:cNvSpPr/>
-          <p:nvPr/>
-        </p:nvSpPr>
-        <p:spPr>
-          <a:xfrm>
-            <a:off x="4846320" y="1188720"/>
-            <a:ext cx="3840480" cy="3291840"/>
-          </a:xfrm>
-          <a:prstGeom prst="rect">
-            <a:avLst/>
-          </a:prstGeom>
-          <a:noFill/>
-          <a:ln/>
-        </p:spPr>
-        <p:txBody>
-          <a:bodyPr wrap="square" lIns="0" tIns="0" rIns="0" bIns="0" rtlCol="0" anchor="t"/>
-          <a:lstStyle/>
-          <a:p>
-            <a:pPr marL="177800" indent="-177800">
-              <a:spcAft>
-                <a:spcPts val="800"/>
-              </a:spcAft>
-              <a:buSzPct val="100000"/>
-              <a:buChar char="•"/>
-            </a:pPr>
-            <a:r>
-              <a:rPr lang="en-US" sz="1250" dirty="0">
-                <a:solidFill>
-                  <a:srgbClr val="1A1A1A"/>
-                </a:solidFill>
-                <a:latin typeface="Times New Roman" pitchFamily="34" charset="0"/>
-                <a:ea typeface="Times New Roman" pitchFamily="34" charset="-122"/>
-                <a:cs typeface="Times New Roman" pitchFamily="34" charset="-120"/>
-              </a:rPr>
-              <a:t>Dataset etiquetado LLVIP (peatones nocturnos): 2.000 imágenes de entrenamiento y 500 de validación.</a:t>
-            </a:r>
-            <a:endParaRPr lang="en-US" sz="1250" dirty="0"/>
-          </a:p>
-          <a:p>
-            <a:pPr marL="177800" indent="-177800">
-              <a:spcAft>
-                <a:spcPts val="800"/>
-              </a:spcAft>
-              <a:buSzPct val="100000"/>
-              <a:buChar char="•"/>
-            </a:pPr>
-            <a:r>
-              <a:rPr lang="en-US" sz="1250" dirty="0">
-                <a:solidFill>
-                  <a:srgbClr val="1A1A1A"/>
-                </a:solidFill>
-                <a:latin typeface="Times New Roman" pitchFamily="34" charset="0"/>
-                <a:ea typeface="Times New Roman" pitchFamily="34" charset="-122"/>
-                <a:cs typeface="Times New Roman" pitchFamily="34" charset="-120"/>
-              </a:rPr>
-              <a:t>YOLOv8n reentrenado por modalidad (40 épocas), 9 entradas: VIS, IR y las 7 fusiones.</a:t>
-            </a:r>
-            <a:endParaRPr lang="en-US" sz="1250" dirty="0"/>
-          </a:p>
-          <a:p>
-            <a:pPr marL="177800" indent="-177800">
-              <a:spcAft>
-                <a:spcPts val="800"/>
-              </a:spcAft>
-              <a:buSzPct val="100000"/>
-              <a:buChar char="•"/>
-            </a:pPr>
-            <a:r>
-              <a:rPr lang="en-US" sz="1250" dirty="0">
-                <a:solidFill>
-                  <a:srgbClr val="1A1A1A"/>
-                </a:solidFill>
-                <a:latin typeface="Times New Roman" pitchFamily="34" charset="0"/>
-                <a:ea typeface="Times New Roman" pitchFamily="34" charset="-122"/>
-                <a:cs typeface="Times New Roman" pitchFamily="34" charset="-120"/>
-              </a:rPr>
-              <a:t>Etiquetas idénticas entre modalidades: la diferencia de mAP aísla el efecto del método de fusión.</a:t>
-            </a:r>
-            <a:endParaRPr lang="en-US" sz="1250" dirty="0"/>
+              <a:rPr lang="en-US" sz="1000" i="1" dirty="0">
+                <a:solidFill>
+                  <a:srgbClr val="666666"/>
+                </a:solidFill>
+                <a:latin typeface="Times New Roman" pitchFamily="34" charset="0"/>
+                <a:ea typeface="Times New Roman" pitchFamily="34" charset="-122"/>
+                <a:cs typeface="Times New Roman" pitchFamily="34" charset="-120"/>
+              </a:rPr>
+              <a:t>Los 20 montajes por escena están disponibles en el repositorio (docs/figures/cualitativas/).</a:t>
+            </a:r>
+            <a:endParaRPr lang="en-US" sz="1000" dirty="0"/>
           </a:p>
         </p:txBody>
       </p:sp>
@@ -3312,7 +3017,7 @@
                 <a:ea typeface="Times New Roman" pitchFamily="34" charset="-122"/>
                 <a:cs typeface="Times New Roman" pitchFamily="34" charset="-120"/>
               </a:rPr>
-              <a:t>7. Resultados cualitativos</a:t>
+              <a:t>Resultados cuantitativos — medias sobre 20 pares</a:t>
             </a:r>
             <a:endParaRPr lang="en-US" sz="2300" dirty="0"/>
           </a:p>
@@ -3351,180 +3056,7 @@
                 <a:ea typeface="Times New Roman" pitchFamily="34" charset="-122"/>
                 <a:cs typeface="Times New Roman" pitchFamily="34" charset="-120"/>
               </a:rPr>
-              <a:t>11 / 20</a:t>
-            </a:r>
-            <a:endParaRPr lang="en-US" sz="900" dirty="0"/>
-          </a:p>
-        </p:txBody>
-      </p:sp>
-      <p:pic>
-        <p:nvPicPr>
-          <p:cNvPr id="4" name="Image 0" descr="C:/Users/Usuario/Documents/unv/mastertesis/tesis_mciencias_datos/docs/figures/cualitativas/montaje_07.png">    </p:cNvPr>
-          <p:cNvPicPr>
-            <a:picLocks noChangeAspect="1"/>
-          </p:cNvPicPr>
-          <p:nvPr/>
-        </p:nvPicPr>
-        <p:blipFill>
-          <a:blip r:embed="rId1"/>
-          <a:stretch>
-            <a:fillRect/>
-          </a:stretch>
-        </p:blipFill>
-        <p:spPr>
-          <a:xfrm>
-            <a:off x="1764792" y="777240"/>
-            <a:ext cx="5623560" cy="4005072"/>
-          </a:xfrm>
-          <a:prstGeom prst="rect">
-            <a:avLst/>
-          </a:prstGeom>
-        </p:spPr>
-      </p:pic>
-      <p:sp>
-        <p:nvSpPr>
-          <p:cNvPr id="5" name="Text 2"/>
-          <p:cNvSpPr/>
-          <p:nvPr/>
-        </p:nvSpPr>
-        <p:spPr>
-          <a:xfrm>
-            <a:off x="457200" y="4828032"/>
-            <a:ext cx="7680960" cy="274320"/>
-          </a:xfrm>
-          <a:prstGeom prst="rect">
-            <a:avLst/>
-          </a:prstGeom>
-          <a:noFill/>
-          <a:ln/>
-        </p:spPr>
-        <p:txBody>
-          <a:bodyPr wrap="square" lIns="0" tIns="0" rIns="0" bIns="0" rtlCol="0" anchor="ctr"/>
-          <a:lstStyle/>
-          <a:p>
-            <a:pPr indent="0" marL="0">
-              <a:buNone/>
-            </a:pPr>
-            <a:r>
-              <a:rPr lang="en-US" sz="1000" i="1" dirty="0">
-                <a:solidFill>
-                  <a:srgbClr val="666666"/>
-                </a:solidFill>
-                <a:latin typeface="Times New Roman" pitchFamily="34" charset="0"/>
-                <a:ea typeface="Times New Roman" pitchFamily="34" charset="-122"/>
-                <a:cs typeface="Times New Roman" pitchFamily="34" charset="-120"/>
-              </a:rPr>
-              <a:t>Los 20 montajes por escena están disponibles en el repositorio (docs/figures/cualitativas/).</a:t>
-            </a:r>
-            <a:endParaRPr lang="en-US" sz="1000" dirty="0"/>
-          </a:p>
-        </p:txBody>
-      </p:sp>
-    </p:spTree>
-  </p:cSld>
-  <p:clrMapOvr>
-    <a:masterClrMapping/>
-  </p:clrMapOvr>
-</p:sld>
-</file>
-
-<file path=ppt/slides/slide12.xml><?xml version="1.0" encoding="utf-8"?>
-<p:sld xmlns:a="http://schemas.openxmlformats.org/drawingml/2006/main" xmlns:r="http://schemas.openxmlformats.org/officeDocument/2006/relationships" xmlns:p="http://schemas.openxmlformats.org/presentationml/2006/main">
-  <p:cSld name="Slide 12">
-    <p:bg>
-      <p:bgPr>
-        <a:solidFill>
-          <a:srgbClr val="FFFFFF"/>
-        </a:solidFill>
-      </p:bgPr>
-    </p:bg>
-    <p:spTree>
-      <p:nvGrpSpPr>
-        <p:cNvPr id="1" name=""/>
-        <p:cNvGrpSpPr/>
-        <p:nvPr/>
-      </p:nvGrpSpPr>
-      <p:grpSpPr>
-        <a:xfrm>
-          <a:off x="0" y="0"/>
-          <a:ext cx="0" cy="0"/>
-          <a:chOff x="0" y="0"/>
-          <a:chExt cx="0" cy="0"/>
-        </a:xfrm>
-      </p:grpSpPr>
-      <p:sp>
-        <p:nvSpPr>
-          <p:cNvPr id="2" name="Text 0"/>
-          <p:cNvSpPr/>
-          <p:nvPr/>
-        </p:nvSpPr>
-        <p:spPr>
-          <a:xfrm>
-            <a:off x="457200" y="256032"/>
-            <a:ext cx="8229600" cy="502920"/>
-          </a:xfrm>
-          <a:prstGeom prst="rect">
-            <a:avLst/>
-          </a:prstGeom>
-          <a:noFill/>
-          <a:ln/>
-        </p:spPr>
-        <p:txBody>
-          <a:bodyPr wrap="square" lIns="0" tIns="0" rIns="0" bIns="0" rtlCol="0" anchor="ctr"/>
-          <a:lstStyle/>
-          <a:p>
-            <a:pPr indent="0" marL="0">
-              <a:buNone/>
-            </a:pPr>
-            <a:r>
-              <a:rPr lang="en-US" sz="2300" b="1" dirty="0">
-                <a:solidFill>
-                  <a:srgbClr val="1A1A1A"/>
-                </a:solidFill>
-                <a:latin typeface="Times New Roman" pitchFamily="34" charset="0"/>
-                <a:ea typeface="Times New Roman" pitchFamily="34" charset="-122"/>
-                <a:cs typeface="Times New Roman" pitchFamily="34" charset="-120"/>
-              </a:rPr>
-              <a:t>Resultados cuantitativos — medias sobre 20 pares</a:t>
-            </a:r>
-            <a:endParaRPr lang="en-US" sz="2300" dirty="0"/>
-          </a:p>
-        </p:txBody>
-      </p:sp>
-      <p:sp>
-        <p:nvSpPr>
-          <p:cNvPr id="3" name="Text 1"/>
-          <p:cNvSpPr/>
-          <p:nvPr/>
-        </p:nvSpPr>
-        <p:spPr>
-          <a:xfrm>
-            <a:off x="8229600" y="4828032"/>
-            <a:ext cx="685800" cy="274320"/>
-          </a:xfrm>
-          <a:prstGeom prst="rect">
-            <a:avLst/>
-          </a:prstGeom>
-          <a:noFill/>
-          <a:ln/>
-        </p:spPr>
-        <p:txBody>
-          <a:bodyPr wrap="square" lIns="0" tIns="0" rIns="0" bIns="0" rtlCol="0" anchor="ctr"/>
-          <a:lstStyle/>
-          <a:p>
-            <a:pPr algn="r" indent="0" marL="0">
-              <a:buNone/>
-            </a:pPr>
-            <a:r>
-              <a:rPr lang="en-US" sz="900" dirty="0">
-                <a:solidFill>
-                  <a:srgbClr val="666666"/>
-                </a:solidFill>
-                <a:latin typeface="Times New Roman" pitchFamily="34" charset="0"/>
-                <a:ea typeface="Times New Roman" pitchFamily="34" charset="-122"/>
-                <a:cs typeface="Times New Roman" pitchFamily="34" charset="-120"/>
-              </a:rPr>
-              <a:t>12 / 20</a:t>
+              <a:t>11 / 19</a:t>
             </a:r>
             <a:endParaRPr lang="en-US" sz="900" dirty="0"/>
           </a:p>
@@ -3532,7 +3064,7 @@
       </p:sp>
       <p:graphicFrame>
         <p:nvGraphicFramePr>
-          <p:cNvPr id="13" name="Table 0"/>
+          <p:cNvPr id="12" name="Table 0"/>
           <p:cNvGraphicFramePr>
             <a:graphicFrameLocks noGrp="1"/>
           </p:cNvGraphicFramePr>
@@ -3646,7 +3178,7 @@
                           <a:ea typeface="Times New Roman" pitchFamily="34" charset="-122"/>
                           <a:cs typeface="Times New Roman" pitchFamily="34" charset="-120"/>
                         </a:rPr>
-                        <a:t>Qabf ↑</a:t>
+                        <a:t>SSIM ↑</a:t>
                       </a:r>
                       <a:endParaRPr lang="en-US" sz="1200" dirty="0">
                         <a:latin typeface="Times New Roman" charset="0"/>
@@ -3714,7 +3246,7 @@
                           <a:ea typeface="Times New Roman" pitchFamily="34" charset="-122"/>
                           <a:cs typeface="Times New Roman" pitchFamily="34" charset="-120"/>
                         </a:rPr>
-                        <a:t>Nabf ↓</a:t>
+                        <a:t>PSNR ↑</a:t>
                       </a:r>
                       <a:endParaRPr lang="en-US" sz="1200" dirty="0">
                         <a:latin typeface="Times New Roman" charset="0"/>
@@ -3782,7 +3314,7 @@
                           <a:ea typeface="Times New Roman" pitchFamily="34" charset="-122"/>
                           <a:cs typeface="Times New Roman" pitchFamily="34" charset="-120"/>
                         </a:rPr>
-                        <a:t>SSIM ↑</a:t>
+                        <a:t>SF ↑</a:t>
                       </a:r>
                       <a:endParaRPr lang="en-US" sz="1200" dirty="0">
                         <a:latin typeface="Times New Roman" charset="0"/>
@@ -3850,7 +3382,7 @@
                           <a:ea typeface="Times New Roman" pitchFamily="34" charset="-122"/>
                           <a:cs typeface="Times New Roman" pitchFamily="34" charset="-120"/>
                         </a:rPr>
-                        <a:t>SCD ↑</a:t>
+                        <a:t>MI_ir ↑</a:t>
                       </a:r>
                       <a:endParaRPr lang="en-US" sz="1200" dirty="0">
                         <a:latin typeface="Times New Roman" charset="0"/>
@@ -3918,7 +3450,7 @@
                           <a:ea typeface="Times New Roman" pitchFamily="34" charset="-122"/>
                           <a:cs typeface="Times New Roman" pitchFamily="34" charset="-120"/>
                         </a:rPr>
-                        <a:t>VIF ↑</a:t>
+                        <a:t>SD ↑</a:t>
                       </a:r>
                       <a:endParaRPr lang="en-US" sz="1200" dirty="0">
                         <a:latin typeface="Times New Roman" charset="0"/>
@@ -4053,7 +3585,7 @@
                           <a:ea typeface="Times New Roman" pitchFamily="34" charset="-122"/>
                           <a:cs typeface="Times New Roman" pitchFamily="34" charset="-120"/>
                         </a:rPr>
-                        <a:t>0,442</a:t>
+                        <a:t>0,721</a:t>
                       </a:r>
                       <a:endParaRPr lang="en-US" sz="1200" dirty="0">
                         <a:latin typeface="Times New Roman" charset="0"/>
@@ -4118,7 +3650,7 @@
                           <a:ea typeface="Times New Roman" pitchFamily="34" charset="-122"/>
                           <a:cs typeface="Times New Roman" pitchFamily="34" charset="-120"/>
                         </a:rPr>
-                        <a:t>0,108</a:t>
+                        <a:t>20,27</a:t>
                       </a:r>
                       <a:endParaRPr lang="en-US" sz="1200" dirty="0">
                         <a:latin typeface="Times New Roman" charset="0"/>
@@ -4183,72 +3715,7 @@
                           <a:ea typeface="Times New Roman" pitchFamily="34" charset="-122"/>
                           <a:cs typeface="Times New Roman" pitchFamily="34" charset="-120"/>
                         </a:rPr>
-                        <a:t>0,721</a:t>
-                      </a:r>
-                      <a:endParaRPr lang="en-US" sz="1200" dirty="0">
-                        <a:latin typeface="Times New Roman" charset="0"/>
-                        <a:ea typeface="Times New Roman" charset="0"/>
-                        <a:cs typeface="Times New Roman" charset="0"/>
-                      </a:endParaRPr>
-                    </a:p>
-                  </a:txBody>
-                  <a:tcPr marL="91440" marR="91440" marT="45720" marB="45720" anchor="ctr">
-                    <a:lnL w="6350" cap="flat" cmpd="sng" algn="ctr">
-                      <a:solidFill>
-                        <a:srgbClr val="BFBFBF"/>
-                      </a:solidFill>
-                      <a:prstDash val="solid"/>
-                      <a:round/>
-                      <a:headEnd type="none" w="med" len="med"/>
-                      <a:tailEnd type="none" w="med" len="med"/>
-                    </a:lnL>
-                    <a:lnR w="6350" cap="flat" cmpd="sng" algn="ctr">
-                      <a:solidFill>
-                        <a:srgbClr val="BFBFBF"/>
-                      </a:solidFill>
-                      <a:prstDash val="solid"/>
-                      <a:round/>
-                      <a:headEnd type="none" w="med" len="med"/>
-                      <a:tailEnd type="none" w="med" len="med"/>
-                    </a:lnR>
-                    <a:lnT w="6350" cap="flat" cmpd="sng" algn="ctr">
-                      <a:solidFill>
-                        <a:srgbClr val="BFBFBF"/>
-                      </a:solidFill>
-                      <a:prstDash val="solid"/>
-                      <a:round/>
-                      <a:headEnd type="none" w="med" len="med"/>
-                      <a:tailEnd type="none" w="med" len="med"/>
-                    </a:lnT>
-                    <a:lnB w="6350" cap="flat" cmpd="sng" algn="ctr">
-                      <a:solidFill>
-                        <a:srgbClr val="BFBFBF"/>
-                      </a:solidFill>
-                      <a:prstDash val="solid"/>
-                      <a:round/>
-                      <a:headEnd type="none" w="med" len="med"/>
-                      <a:tailEnd type="none" w="med" len="med"/>
-                    </a:lnB>
-                  </a:tcPr>
-                </a:tc>
-                <a:tc>
-                  <a:txBody>
-                    <a:bodyPr/>
-                    <a:lstStyle/>
-                    <a:p>
-                      <a:pPr algn="ctr" indent="0" marL="0">
-                        <a:buNone/>
-                      </a:pPr>
-                      <a:r>
-                        <a:rPr lang="en-US" sz="1200" dirty="0">
-                          <a:solidFill>
-                            <a:srgbClr val="1A1A1A"/>
-                          </a:solidFill>
-                          <a:latin typeface="Times New Roman" pitchFamily="34" charset="0"/>
-                          <a:ea typeface="Times New Roman" pitchFamily="34" charset="-122"/>
-                          <a:cs typeface="Times New Roman" pitchFamily="34" charset="-120"/>
-                        </a:rPr>
-                        <a:t>1,322</a:t>
+                        <a:t>13,04</a:t>
                       </a:r>
                       <a:endParaRPr lang="en-US" sz="1200" dirty="0">
                         <a:latin typeface="Times New Roman" charset="0"/>
@@ -4313,7 +3780,72 @@
                           <a:ea typeface="Times New Roman" pitchFamily="34" charset="-122"/>
                           <a:cs typeface="Times New Roman" pitchFamily="34" charset="-120"/>
                         </a:rPr>
-                        <a:t>0,410</a:t>
+                        <a:t>1,072</a:t>
+                      </a:r>
+                      <a:endParaRPr lang="en-US" sz="1200" dirty="0">
+                        <a:latin typeface="Times New Roman" charset="0"/>
+                        <a:ea typeface="Times New Roman" charset="0"/>
+                        <a:cs typeface="Times New Roman" charset="0"/>
+                      </a:endParaRPr>
+                    </a:p>
+                  </a:txBody>
+                  <a:tcPr marL="91440" marR="91440" marT="45720" marB="45720" anchor="ctr">
+                    <a:lnL w="6350" cap="flat" cmpd="sng" algn="ctr">
+                      <a:solidFill>
+                        <a:srgbClr val="BFBFBF"/>
+                      </a:solidFill>
+                      <a:prstDash val="solid"/>
+                      <a:round/>
+                      <a:headEnd type="none" w="med" len="med"/>
+                      <a:tailEnd type="none" w="med" len="med"/>
+                    </a:lnL>
+                    <a:lnR w="6350" cap="flat" cmpd="sng" algn="ctr">
+                      <a:solidFill>
+                        <a:srgbClr val="BFBFBF"/>
+                      </a:solidFill>
+                      <a:prstDash val="solid"/>
+                      <a:round/>
+                      <a:headEnd type="none" w="med" len="med"/>
+                      <a:tailEnd type="none" w="med" len="med"/>
+                    </a:lnR>
+                    <a:lnT w="6350" cap="flat" cmpd="sng" algn="ctr">
+                      <a:solidFill>
+                        <a:srgbClr val="BFBFBF"/>
+                      </a:solidFill>
+                      <a:prstDash val="solid"/>
+                      <a:round/>
+                      <a:headEnd type="none" w="med" len="med"/>
+                      <a:tailEnd type="none" w="med" len="med"/>
+                    </a:lnT>
+                    <a:lnB w="6350" cap="flat" cmpd="sng" algn="ctr">
+                      <a:solidFill>
+                        <a:srgbClr val="BFBFBF"/>
+                      </a:solidFill>
+                      <a:prstDash val="solid"/>
+                      <a:round/>
+                      <a:headEnd type="none" w="med" len="med"/>
+                      <a:tailEnd type="none" w="med" len="med"/>
+                    </a:lnB>
+                  </a:tcPr>
+                </a:tc>
+                <a:tc>
+                  <a:txBody>
+                    <a:bodyPr/>
+                    <a:lstStyle/>
+                    <a:p>
+                      <a:pPr algn="ctr" indent="0" marL="0">
+                        <a:buNone/>
+                      </a:pPr>
+                      <a:r>
+                        <a:rPr lang="en-US" sz="1200" b="1" dirty="0">
+                          <a:solidFill>
+                            <a:srgbClr val="1A1A1A"/>
+                          </a:solidFill>
+                          <a:latin typeface="Times New Roman" pitchFamily="34" charset="0"/>
+                          <a:ea typeface="Times New Roman" pitchFamily="34" charset="-122"/>
+                          <a:cs typeface="Times New Roman" pitchFamily="34" charset="-120"/>
+                        </a:rPr>
+                        <a:t>0,155</a:t>
                       </a:r>
                       <a:endParaRPr lang="en-US" sz="1200" dirty="0">
                         <a:latin typeface="Times New Roman" charset="0"/>
@@ -4445,7 +3977,7 @@
                           <a:ea typeface="Times New Roman" pitchFamily="34" charset="-122"/>
                           <a:cs typeface="Times New Roman" pitchFamily="34" charset="-120"/>
                         </a:rPr>
-                        <a:t>0,497</a:t>
+                        <a:t>0,721</a:t>
                       </a:r>
                       <a:endParaRPr lang="en-US" sz="1200" dirty="0">
                         <a:latin typeface="Times New Roman" charset="0"/>
@@ -4510,7 +4042,7 @@
                           <a:ea typeface="Times New Roman" pitchFamily="34" charset="-122"/>
                           <a:cs typeface="Times New Roman" pitchFamily="34" charset="-120"/>
                         </a:rPr>
-                        <a:t>0,212</a:t>
+                        <a:t>21,97</a:t>
                       </a:r>
                       <a:endParaRPr lang="en-US" sz="1200" dirty="0">
                         <a:latin typeface="Times New Roman" charset="0"/>
@@ -4575,72 +4107,7 @@
                           <a:ea typeface="Times New Roman" pitchFamily="34" charset="-122"/>
                           <a:cs typeface="Times New Roman" pitchFamily="34" charset="-120"/>
                         </a:rPr>
-                        <a:t>0,721</a:t>
-                      </a:r>
-                      <a:endParaRPr lang="en-US" sz="1200" dirty="0">
-                        <a:latin typeface="Times New Roman" charset="0"/>
-                        <a:ea typeface="Times New Roman" charset="0"/>
-                        <a:cs typeface="Times New Roman" charset="0"/>
-                      </a:endParaRPr>
-                    </a:p>
-                  </a:txBody>
-                  <a:tcPr marL="91440" marR="91440" marT="45720" marB="45720" anchor="ctr">
-                    <a:lnL w="6350" cap="flat" cmpd="sng" algn="ctr">
-                      <a:solidFill>
-                        <a:srgbClr val="BFBFBF"/>
-                      </a:solidFill>
-                      <a:prstDash val="solid"/>
-                      <a:round/>
-                      <a:headEnd type="none" w="med" len="med"/>
-                      <a:tailEnd type="none" w="med" len="med"/>
-                    </a:lnL>
-                    <a:lnR w="6350" cap="flat" cmpd="sng" algn="ctr">
-                      <a:solidFill>
-                        <a:srgbClr val="BFBFBF"/>
-                      </a:solidFill>
-                      <a:prstDash val="solid"/>
-                      <a:round/>
-                      <a:headEnd type="none" w="med" len="med"/>
-                      <a:tailEnd type="none" w="med" len="med"/>
-                    </a:lnR>
-                    <a:lnT w="6350" cap="flat" cmpd="sng" algn="ctr">
-                      <a:solidFill>
-                        <a:srgbClr val="BFBFBF"/>
-                      </a:solidFill>
-                      <a:prstDash val="solid"/>
-                      <a:round/>
-                      <a:headEnd type="none" w="med" len="med"/>
-                      <a:tailEnd type="none" w="med" len="med"/>
-                    </a:lnT>
-                    <a:lnB w="6350" cap="flat" cmpd="sng" algn="ctr">
-                      <a:solidFill>
-                        <a:srgbClr val="BFBFBF"/>
-                      </a:solidFill>
-                      <a:prstDash val="solid"/>
-                      <a:round/>
-                      <a:headEnd type="none" w="med" len="med"/>
-                      <a:tailEnd type="none" w="med" len="med"/>
-                    </a:lnB>
-                  </a:tcPr>
-                </a:tc>
-                <a:tc>
-                  <a:txBody>
-                    <a:bodyPr/>
-                    <a:lstStyle/>
-                    <a:p>
-                      <a:pPr algn="ctr" indent="0" marL="0">
-                        <a:buNone/>
-                      </a:pPr>
-                      <a:r>
-                        <a:rPr lang="en-US" sz="1200" b="1" dirty="0">
-                          <a:solidFill>
-                            <a:srgbClr val="1A1A1A"/>
-                          </a:solidFill>
-                          <a:latin typeface="Times New Roman" pitchFamily="34" charset="0"/>
-                          <a:ea typeface="Times New Roman" pitchFamily="34" charset="-122"/>
-                          <a:cs typeface="Times New Roman" pitchFamily="34" charset="-120"/>
-                        </a:rPr>
-                        <a:t>1,468</a:t>
+                        <a:t>13,34</a:t>
                       </a:r>
                       <a:endParaRPr lang="en-US" sz="1200" dirty="0">
                         <a:latin typeface="Times New Roman" charset="0"/>
@@ -4705,7 +4172,72 @@
                           <a:ea typeface="Times New Roman" pitchFamily="34" charset="-122"/>
                           <a:cs typeface="Times New Roman" pitchFamily="34" charset="-120"/>
                         </a:rPr>
-                        <a:t>0,384</a:t>
+                        <a:t>0,881</a:t>
+                      </a:r>
+                      <a:endParaRPr lang="en-US" sz="1200" dirty="0">
+                        <a:latin typeface="Times New Roman" charset="0"/>
+                        <a:ea typeface="Times New Roman" charset="0"/>
+                        <a:cs typeface="Times New Roman" charset="0"/>
+                      </a:endParaRPr>
+                    </a:p>
+                  </a:txBody>
+                  <a:tcPr marL="91440" marR="91440" marT="45720" marB="45720" anchor="ctr">
+                    <a:lnL w="6350" cap="flat" cmpd="sng" algn="ctr">
+                      <a:solidFill>
+                        <a:srgbClr val="BFBFBF"/>
+                      </a:solidFill>
+                      <a:prstDash val="solid"/>
+                      <a:round/>
+                      <a:headEnd type="none" w="med" len="med"/>
+                      <a:tailEnd type="none" w="med" len="med"/>
+                    </a:lnL>
+                    <a:lnR w="6350" cap="flat" cmpd="sng" algn="ctr">
+                      <a:solidFill>
+                        <a:srgbClr val="BFBFBF"/>
+                      </a:solidFill>
+                      <a:prstDash val="solid"/>
+                      <a:round/>
+                      <a:headEnd type="none" w="med" len="med"/>
+                      <a:tailEnd type="none" w="med" len="med"/>
+                    </a:lnR>
+                    <a:lnT w="6350" cap="flat" cmpd="sng" algn="ctr">
+                      <a:solidFill>
+                        <a:srgbClr val="BFBFBF"/>
+                      </a:solidFill>
+                      <a:prstDash val="solid"/>
+                      <a:round/>
+                      <a:headEnd type="none" w="med" len="med"/>
+                      <a:tailEnd type="none" w="med" len="med"/>
+                    </a:lnT>
+                    <a:lnB w="6350" cap="flat" cmpd="sng" algn="ctr">
+                      <a:solidFill>
+                        <a:srgbClr val="BFBFBF"/>
+                      </a:solidFill>
+                      <a:prstDash val="solid"/>
+                      <a:round/>
+                      <a:headEnd type="none" w="med" len="med"/>
+                      <a:tailEnd type="none" w="med" len="med"/>
+                    </a:lnB>
+                  </a:tcPr>
+                </a:tc>
+                <a:tc>
+                  <a:txBody>
+                    <a:bodyPr/>
+                    <a:lstStyle/>
+                    <a:p>
+                      <a:pPr algn="ctr" indent="0" marL="0">
+                        <a:buNone/>
+                      </a:pPr>
+                      <a:r>
+                        <a:rPr lang="en-US" sz="1200" dirty="0">
+                          <a:solidFill>
+                            <a:srgbClr val="1A1A1A"/>
+                          </a:solidFill>
+                          <a:latin typeface="Times New Roman" pitchFamily="34" charset="0"/>
+                          <a:ea typeface="Times New Roman" pitchFamily="34" charset="-122"/>
+                          <a:cs typeface="Times New Roman" pitchFamily="34" charset="-120"/>
+                        </a:rPr>
+                        <a:t>0,130</a:t>
                       </a:r>
                       <a:endParaRPr lang="en-US" sz="1200" dirty="0">
                         <a:latin typeface="Times New Roman" charset="0"/>
@@ -4837,7 +4369,7 @@
                           <a:ea typeface="Times New Roman" pitchFamily="34" charset="-122"/>
                           <a:cs typeface="Times New Roman" pitchFamily="34" charset="-120"/>
                         </a:rPr>
-                        <a:t>0,490</a:t>
+                        <a:t>0,716</a:t>
                       </a:r>
                       <a:endParaRPr lang="en-US" sz="1200" dirty="0">
                         <a:latin typeface="Times New Roman" charset="0"/>
@@ -4902,7 +4434,7 @@
                           <a:ea typeface="Times New Roman" pitchFamily="34" charset="-122"/>
                           <a:cs typeface="Times New Roman" pitchFamily="34" charset="-120"/>
                         </a:rPr>
-                        <a:t>0,229</a:t>
+                        <a:t>22,78</a:t>
                       </a:r>
                       <a:endParaRPr lang="en-US" sz="1200" dirty="0">
                         <a:latin typeface="Times New Roman" charset="0"/>
@@ -4967,7 +4499,7 @@
                           <a:ea typeface="Times New Roman" pitchFamily="34" charset="-122"/>
                           <a:cs typeface="Times New Roman" pitchFamily="34" charset="-120"/>
                         </a:rPr>
-                        <a:t>0,716</a:t>
+                        <a:t>13,93</a:t>
                       </a:r>
                       <a:endParaRPr lang="en-US" sz="1200" dirty="0">
                         <a:latin typeface="Times New Roman" charset="0"/>
@@ -5032,7 +4564,7 @@
                           <a:ea typeface="Times New Roman" pitchFamily="34" charset="-122"/>
                           <a:cs typeface="Times New Roman" pitchFamily="34" charset="-120"/>
                         </a:rPr>
-                        <a:t>1,322</a:t>
+                        <a:t>0,881</a:t>
                       </a:r>
                       <a:endParaRPr lang="en-US" sz="1200" dirty="0">
                         <a:latin typeface="Times New Roman" charset="0"/>
@@ -5097,7 +4629,7 @@
                           <a:ea typeface="Times New Roman" pitchFamily="34" charset="-122"/>
                           <a:cs typeface="Times New Roman" pitchFamily="34" charset="-120"/>
                         </a:rPr>
-                        <a:t>0,303</a:t>
+                        <a:t>0,120</a:t>
                       </a:r>
                       <a:endParaRPr lang="en-US" sz="1200" dirty="0">
                         <a:latin typeface="Times New Roman" charset="0"/>
@@ -5221,7 +4753,7 @@
                         <a:buNone/>
                       </a:pPr>
                       <a:r>
-                        <a:rPr lang="en-US" sz="1200" b="1" dirty="0">
+                        <a:rPr lang="en-US" sz="1200" dirty="0">
                           <a:solidFill>
                             <a:srgbClr val="1A1A1A"/>
                           </a:solidFill>
@@ -5229,7 +4761,7 @@
                           <a:ea typeface="Times New Roman" pitchFamily="34" charset="-122"/>
                           <a:cs typeface="Times New Roman" pitchFamily="34" charset="-120"/>
                         </a:rPr>
-                        <a:t>0,501</a:t>
+                        <a:t>0,739</a:t>
                       </a:r>
                       <a:endParaRPr lang="en-US" sz="1200" dirty="0">
                         <a:latin typeface="Times New Roman" charset="0"/>
@@ -5294,7 +4826,7 @@
                           <a:ea typeface="Times New Roman" pitchFamily="34" charset="-122"/>
                           <a:cs typeface="Times New Roman" pitchFamily="34" charset="-120"/>
                         </a:rPr>
-                        <a:t>0,151</a:t>
+                        <a:t>22,79</a:t>
                       </a:r>
                       <a:endParaRPr lang="en-US" sz="1200" dirty="0">
                         <a:latin typeface="Times New Roman" charset="0"/>
@@ -5359,7 +4891,7 @@
                           <a:ea typeface="Times New Roman" pitchFamily="34" charset="-122"/>
                           <a:cs typeface="Times New Roman" pitchFamily="34" charset="-120"/>
                         </a:rPr>
-                        <a:t>0,739</a:t>
+                        <a:t>13,03</a:t>
                       </a:r>
                       <a:endParaRPr lang="en-US" sz="1200" dirty="0">
                         <a:latin typeface="Times New Roman" charset="0"/>
@@ -5424,7 +4956,7 @@
                           <a:ea typeface="Times New Roman" pitchFamily="34" charset="-122"/>
                           <a:cs typeface="Times New Roman" pitchFamily="34" charset="-120"/>
                         </a:rPr>
-                        <a:t>1,376</a:t>
+                        <a:t>0,891</a:t>
                       </a:r>
                       <a:endParaRPr lang="en-US" sz="1200" dirty="0">
                         <a:latin typeface="Times New Roman" charset="0"/>
@@ -5489,7 +5021,7 @@
                           <a:ea typeface="Times New Roman" pitchFamily="34" charset="-122"/>
                           <a:cs typeface="Times New Roman" pitchFamily="34" charset="-120"/>
                         </a:rPr>
-                        <a:t>0,360</a:t>
+                        <a:t>0,120</a:t>
                       </a:r>
                       <a:endParaRPr lang="en-US" sz="1200" dirty="0">
                         <a:latin typeface="Times New Roman" charset="0"/>
@@ -5621,7 +5153,72 @@
                           <a:ea typeface="Times New Roman" pitchFamily="34" charset="-122"/>
                           <a:cs typeface="Times New Roman" pitchFamily="34" charset="-120"/>
                         </a:rPr>
-                        <a:t>0,476</a:t>
+                        <a:t>0,731</a:t>
+                      </a:r>
+                      <a:endParaRPr lang="en-US" sz="1200" dirty="0">
+                        <a:latin typeface="Times New Roman" charset="0"/>
+                        <a:ea typeface="Times New Roman" charset="0"/>
+                        <a:cs typeface="Times New Roman" charset="0"/>
+                      </a:endParaRPr>
+                    </a:p>
+                  </a:txBody>
+                  <a:tcPr marL="91440" marR="91440" marT="45720" marB="45720" anchor="ctr">
+                    <a:lnL w="6350" cap="flat" cmpd="sng" algn="ctr">
+                      <a:solidFill>
+                        <a:srgbClr val="BFBFBF"/>
+                      </a:solidFill>
+                      <a:prstDash val="solid"/>
+                      <a:round/>
+                      <a:headEnd type="none" w="med" len="med"/>
+                      <a:tailEnd type="none" w="med" len="med"/>
+                    </a:lnL>
+                    <a:lnR w="6350" cap="flat" cmpd="sng" algn="ctr">
+                      <a:solidFill>
+                        <a:srgbClr val="BFBFBF"/>
+                      </a:solidFill>
+                      <a:prstDash val="solid"/>
+                      <a:round/>
+                      <a:headEnd type="none" w="med" len="med"/>
+                      <a:tailEnd type="none" w="med" len="med"/>
+                    </a:lnR>
+                    <a:lnT w="6350" cap="flat" cmpd="sng" algn="ctr">
+                      <a:solidFill>
+                        <a:srgbClr val="BFBFBF"/>
+                      </a:solidFill>
+                      <a:prstDash val="solid"/>
+                      <a:round/>
+                      <a:headEnd type="none" w="med" len="med"/>
+                      <a:tailEnd type="none" w="med" len="med"/>
+                    </a:lnT>
+                    <a:lnB w="6350" cap="flat" cmpd="sng" algn="ctr">
+                      <a:solidFill>
+                        <a:srgbClr val="BFBFBF"/>
+                      </a:solidFill>
+                      <a:prstDash val="solid"/>
+                      <a:round/>
+                      <a:headEnd type="none" w="med" len="med"/>
+                      <a:tailEnd type="none" w="med" len="med"/>
+                    </a:lnB>
+                  </a:tcPr>
+                </a:tc>
+                <a:tc>
+                  <a:txBody>
+                    <a:bodyPr/>
+                    <a:lstStyle/>
+                    <a:p>
+                      <a:pPr algn="ctr" indent="0" marL="0">
+                        <a:buNone/>
+                      </a:pPr>
+                      <a:r>
+                        <a:rPr lang="en-US" sz="1200" b="1" dirty="0">
+                          <a:solidFill>
+                            <a:srgbClr val="1A1A1A"/>
+                          </a:solidFill>
+                          <a:latin typeface="Times New Roman" pitchFamily="34" charset="0"/>
+                          <a:ea typeface="Times New Roman" pitchFamily="34" charset="-122"/>
+                          <a:cs typeface="Times New Roman" pitchFamily="34" charset="-120"/>
+                        </a:rPr>
+                        <a:t>22,84</a:t>
                       </a:r>
                       <a:endParaRPr lang="en-US" sz="1200" dirty="0">
                         <a:latin typeface="Times New Roman" charset="0"/>
@@ -5686,7 +5283,7 @@
                           <a:ea typeface="Times New Roman" pitchFamily="34" charset="-122"/>
                           <a:cs typeface="Times New Roman" pitchFamily="34" charset="-120"/>
                         </a:rPr>
-                        <a:t>0,192</a:t>
+                        <a:t>13,15</a:t>
                       </a:r>
                       <a:endParaRPr lang="en-US" sz="1200" dirty="0">
                         <a:latin typeface="Times New Roman" charset="0"/>
@@ -5751,7 +5348,7 @@
                           <a:ea typeface="Times New Roman" pitchFamily="34" charset="-122"/>
                           <a:cs typeface="Times New Roman" pitchFamily="34" charset="-120"/>
                         </a:rPr>
-                        <a:t>0,730</a:t>
+                        <a:t>0,884</a:t>
                       </a:r>
                       <a:endParaRPr lang="en-US" sz="1200" dirty="0">
                         <a:latin typeface="Times New Roman" charset="0"/>
@@ -5816,72 +5413,7 @@
                           <a:ea typeface="Times New Roman" pitchFamily="34" charset="-122"/>
                           <a:cs typeface="Times New Roman" pitchFamily="34" charset="-120"/>
                         </a:rPr>
-                        <a:t>1,321</a:t>
-                      </a:r>
-                      <a:endParaRPr lang="en-US" sz="1200" dirty="0">
-                        <a:latin typeface="Times New Roman" charset="0"/>
-                        <a:ea typeface="Times New Roman" charset="0"/>
-                        <a:cs typeface="Times New Roman" charset="0"/>
-                      </a:endParaRPr>
-                    </a:p>
-                  </a:txBody>
-                  <a:tcPr marL="91440" marR="91440" marT="45720" marB="45720" anchor="ctr">
-                    <a:lnL w="6350" cap="flat" cmpd="sng" algn="ctr">
-                      <a:solidFill>
-                        <a:srgbClr val="BFBFBF"/>
-                      </a:solidFill>
-                      <a:prstDash val="solid"/>
-                      <a:round/>
-                      <a:headEnd type="none" w="med" len="med"/>
-                      <a:tailEnd type="none" w="med" len="med"/>
-                    </a:lnL>
-                    <a:lnR w="6350" cap="flat" cmpd="sng" algn="ctr">
-                      <a:solidFill>
-                        <a:srgbClr val="BFBFBF"/>
-                      </a:solidFill>
-                      <a:prstDash val="solid"/>
-                      <a:round/>
-                      <a:headEnd type="none" w="med" len="med"/>
-                      <a:tailEnd type="none" w="med" len="med"/>
-                    </a:lnR>
-                    <a:lnT w="6350" cap="flat" cmpd="sng" algn="ctr">
-                      <a:solidFill>
-                        <a:srgbClr val="BFBFBF"/>
-                      </a:solidFill>
-                      <a:prstDash val="solid"/>
-                      <a:round/>
-                      <a:headEnd type="none" w="med" len="med"/>
-                      <a:tailEnd type="none" w="med" len="med"/>
-                    </a:lnT>
-                    <a:lnB w="6350" cap="flat" cmpd="sng" algn="ctr">
-                      <a:solidFill>
-                        <a:srgbClr val="BFBFBF"/>
-                      </a:solidFill>
-                      <a:prstDash val="solid"/>
-                      <a:round/>
-                      <a:headEnd type="none" w="med" len="med"/>
-                      <a:tailEnd type="none" w="med" len="med"/>
-                    </a:lnB>
-                  </a:tcPr>
-                </a:tc>
-                <a:tc>
-                  <a:txBody>
-                    <a:bodyPr/>
-                    <a:lstStyle/>
-                    <a:p>
-                      <a:pPr algn="ctr" indent="0" marL="0">
-                        <a:buNone/>
-                      </a:pPr>
-                      <a:r>
-                        <a:rPr lang="en-US" sz="1200" dirty="0">
-                          <a:solidFill>
-                            <a:srgbClr val="1A1A1A"/>
-                          </a:solidFill>
-                          <a:latin typeface="Times New Roman" pitchFamily="34" charset="0"/>
-                          <a:ea typeface="Times New Roman" pitchFamily="34" charset="-122"/>
-                          <a:cs typeface="Times New Roman" pitchFamily="34" charset="-120"/>
-                        </a:rPr>
-                        <a:t>0,307</a:t>
+                        <a:t>0,117</a:t>
                       </a:r>
                       <a:endParaRPr lang="en-US" sz="1200" dirty="0">
                         <a:latin typeface="Times New Roman" charset="0"/>
@@ -6013,7 +5545,7 @@
                           <a:ea typeface="Times New Roman" pitchFamily="34" charset="-122"/>
                           <a:cs typeface="Times New Roman" pitchFamily="34" charset="-120"/>
                         </a:rPr>
-                        <a:t>0,305</a:t>
+                        <a:t>0,578</a:t>
                       </a:r>
                       <a:endParaRPr lang="en-US" sz="1200" dirty="0">
                         <a:latin typeface="Times New Roman" charset="0"/>
@@ -6078,7 +5610,72 @@
                           <a:ea typeface="Times New Roman" pitchFamily="34" charset="-122"/>
                           <a:cs typeface="Times New Roman" pitchFamily="34" charset="-120"/>
                         </a:rPr>
-                        <a:t>0,585</a:t>
+                        <a:t>17,49</a:t>
+                      </a:r>
+                      <a:endParaRPr lang="en-US" sz="1200" dirty="0">
+                        <a:latin typeface="Times New Roman" charset="0"/>
+                        <a:ea typeface="Times New Roman" charset="0"/>
+                        <a:cs typeface="Times New Roman" charset="0"/>
+                      </a:endParaRPr>
+                    </a:p>
+                  </a:txBody>
+                  <a:tcPr marL="91440" marR="91440" marT="45720" marB="45720" anchor="ctr">
+                    <a:lnL w="6350" cap="flat" cmpd="sng" algn="ctr">
+                      <a:solidFill>
+                        <a:srgbClr val="BFBFBF"/>
+                      </a:solidFill>
+                      <a:prstDash val="solid"/>
+                      <a:round/>
+                      <a:headEnd type="none" w="med" len="med"/>
+                      <a:tailEnd type="none" w="med" len="med"/>
+                    </a:lnL>
+                    <a:lnR w="6350" cap="flat" cmpd="sng" algn="ctr">
+                      <a:solidFill>
+                        <a:srgbClr val="BFBFBF"/>
+                      </a:solidFill>
+                      <a:prstDash val="solid"/>
+                      <a:round/>
+                      <a:headEnd type="none" w="med" len="med"/>
+                      <a:tailEnd type="none" w="med" len="med"/>
+                    </a:lnR>
+                    <a:lnT w="6350" cap="flat" cmpd="sng" algn="ctr">
+                      <a:solidFill>
+                        <a:srgbClr val="BFBFBF"/>
+                      </a:solidFill>
+                      <a:prstDash val="solid"/>
+                      <a:round/>
+                      <a:headEnd type="none" w="med" len="med"/>
+                      <a:tailEnd type="none" w="med" len="med"/>
+                    </a:lnT>
+                    <a:lnB w="6350" cap="flat" cmpd="sng" algn="ctr">
+                      <a:solidFill>
+                        <a:srgbClr val="BFBFBF"/>
+                      </a:solidFill>
+                      <a:prstDash val="solid"/>
+                      <a:round/>
+                      <a:headEnd type="none" w="med" len="med"/>
+                      <a:tailEnd type="none" w="med" len="med"/>
+                    </a:lnB>
+                  </a:tcPr>
+                </a:tc>
+                <a:tc>
+                  <a:txBody>
+                    <a:bodyPr/>
+                    <a:lstStyle/>
+                    <a:p>
+                      <a:pPr algn="ctr" indent="0" marL="0">
+                        <a:buNone/>
+                      </a:pPr>
+                      <a:r>
+                        <a:rPr lang="en-US" sz="1200" b="1" dirty="0">
+                          <a:solidFill>
+                            <a:srgbClr val="1A1A1A"/>
+                          </a:solidFill>
+                          <a:latin typeface="Times New Roman" pitchFamily="34" charset="0"/>
+                          <a:ea typeface="Times New Roman" pitchFamily="34" charset="-122"/>
+                          <a:cs typeface="Times New Roman" pitchFamily="34" charset="-120"/>
+                        </a:rPr>
+                        <a:t>22,86</a:t>
                       </a:r>
                       <a:endParaRPr lang="en-US" sz="1200" dirty="0">
                         <a:latin typeface="Times New Roman" charset="0"/>
@@ -6143,7 +5740,7 @@
                           <a:ea typeface="Times New Roman" pitchFamily="34" charset="-122"/>
                           <a:cs typeface="Times New Roman" pitchFamily="34" charset="-120"/>
                         </a:rPr>
-                        <a:t>0,578</a:t>
+                        <a:t>0,586</a:t>
                       </a:r>
                       <a:endParaRPr lang="en-US" sz="1200" dirty="0">
                         <a:latin typeface="Times New Roman" charset="0"/>
@@ -6208,72 +5805,7 @@
                           <a:ea typeface="Times New Roman" pitchFamily="34" charset="-122"/>
                           <a:cs typeface="Times New Roman" pitchFamily="34" charset="-120"/>
                         </a:rPr>
-                        <a:t>1,360</a:t>
-                      </a:r>
-                      <a:endParaRPr lang="en-US" sz="1200" dirty="0">
-                        <a:latin typeface="Times New Roman" charset="0"/>
-                        <a:ea typeface="Times New Roman" charset="0"/>
-                        <a:cs typeface="Times New Roman" charset="0"/>
-                      </a:endParaRPr>
-                    </a:p>
-                  </a:txBody>
-                  <a:tcPr marL="91440" marR="91440" marT="45720" marB="45720" anchor="ctr">
-                    <a:lnL w="6350" cap="flat" cmpd="sng" algn="ctr">
-                      <a:solidFill>
-                        <a:srgbClr val="BFBFBF"/>
-                      </a:solidFill>
-                      <a:prstDash val="solid"/>
-                      <a:round/>
-                      <a:headEnd type="none" w="med" len="med"/>
-                      <a:tailEnd type="none" w="med" len="med"/>
-                    </a:lnL>
-                    <a:lnR w="6350" cap="flat" cmpd="sng" algn="ctr">
-                      <a:solidFill>
-                        <a:srgbClr val="BFBFBF"/>
-                      </a:solidFill>
-                      <a:prstDash val="solid"/>
-                      <a:round/>
-                      <a:headEnd type="none" w="med" len="med"/>
-                      <a:tailEnd type="none" w="med" len="med"/>
-                    </a:lnR>
-                    <a:lnT w="6350" cap="flat" cmpd="sng" algn="ctr">
-                      <a:solidFill>
-                        <a:srgbClr val="BFBFBF"/>
-                      </a:solidFill>
-                      <a:prstDash val="solid"/>
-                      <a:round/>
-                      <a:headEnd type="none" w="med" len="med"/>
-                      <a:tailEnd type="none" w="med" len="med"/>
-                    </a:lnT>
-                    <a:lnB w="6350" cap="flat" cmpd="sng" algn="ctr">
-                      <a:solidFill>
-                        <a:srgbClr val="BFBFBF"/>
-                      </a:solidFill>
-                      <a:prstDash val="solid"/>
-                      <a:round/>
-                      <a:headEnd type="none" w="med" len="med"/>
-                      <a:tailEnd type="none" w="med" len="med"/>
-                    </a:lnB>
-                  </a:tcPr>
-                </a:tc>
-                <a:tc>
-                  <a:txBody>
-                    <a:bodyPr/>
-                    <a:lstStyle/>
-                    <a:p>
-                      <a:pPr algn="ctr" indent="0" marL="0">
-                        <a:buNone/>
-                      </a:pPr>
-                      <a:r>
-                        <a:rPr lang="en-US" sz="1200" dirty="0">
-                          <a:solidFill>
-                            <a:srgbClr val="1A1A1A"/>
-                          </a:solidFill>
-                          <a:latin typeface="Times New Roman" pitchFamily="34" charset="0"/>
-                          <a:ea typeface="Times New Roman" pitchFamily="34" charset="-122"/>
-                          <a:cs typeface="Times New Roman" pitchFamily="34" charset="-120"/>
-                        </a:rPr>
-                        <a:t>0,334</a:t>
+                        <a:t>0,139</a:t>
                       </a:r>
                       <a:endParaRPr lang="en-US" sz="1200" dirty="0">
                         <a:latin typeface="Times New Roman" charset="0"/>
@@ -6397,136 +5929,6 @@
                         <a:buNone/>
                       </a:pPr>
                       <a:r>
-                        <a:rPr lang="en-US" sz="1200" dirty="0">
-                          <a:solidFill>
-                            <a:srgbClr val="1A1A1A"/>
-                          </a:solidFill>
-                          <a:latin typeface="Times New Roman" pitchFamily="34" charset="0"/>
-                          <a:ea typeface="Times New Roman" pitchFamily="34" charset="-122"/>
-                          <a:cs typeface="Times New Roman" pitchFamily="34" charset="-120"/>
-                        </a:rPr>
-                        <a:t>0,500</a:t>
-                      </a:r>
-                      <a:endParaRPr lang="en-US" sz="1200" dirty="0">
-                        <a:latin typeface="Times New Roman" charset="0"/>
-                        <a:ea typeface="Times New Roman" charset="0"/>
-                        <a:cs typeface="Times New Roman" charset="0"/>
-                      </a:endParaRPr>
-                    </a:p>
-                  </a:txBody>
-                  <a:tcPr marL="91440" marR="91440" marT="45720" marB="45720" anchor="ctr">
-                    <a:lnL w="6350" cap="flat" cmpd="sng" algn="ctr">
-                      <a:solidFill>
-                        <a:srgbClr val="BFBFBF"/>
-                      </a:solidFill>
-                      <a:prstDash val="solid"/>
-                      <a:round/>
-                      <a:headEnd type="none" w="med" len="med"/>
-                      <a:tailEnd type="none" w="med" len="med"/>
-                    </a:lnL>
-                    <a:lnR w="6350" cap="flat" cmpd="sng" algn="ctr">
-                      <a:solidFill>
-                        <a:srgbClr val="BFBFBF"/>
-                      </a:solidFill>
-                      <a:prstDash val="solid"/>
-                      <a:round/>
-                      <a:headEnd type="none" w="med" len="med"/>
-                      <a:tailEnd type="none" w="med" len="med"/>
-                    </a:lnR>
-                    <a:lnT w="6350" cap="flat" cmpd="sng" algn="ctr">
-                      <a:solidFill>
-                        <a:srgbClr val="BFBFBF"/>
-                      </a:solidFill>
-                      <a:prstDash val="solid"/>
-                      <a:round/>
-                      <a:headEnd type="none" w="med" len="med"/>
-                      <a:tailEnd type="none" w="med" len="med"/>
-                    </a:lnT>
-                    <a:lnB w="6350" cap="flat" cmpd="sng" algn="ctr">
-                      <a:solidFill>
-                        <a:srgbClr val="BFBFBF"/>
-                      </a:solidFill>
-                      <a:prstDash val="solid"/>
-                      <a:round/>
-                      <a:headEnd type="none" w="med" len="med"/>
-                      <a:tailEnd type="none" w="med" len="med"/>
-                    </a:lnB>
-                  </a:tcPr>
-                </a:tc>
-                <a:tc>
-                  <a:txBody>
-                    <a:bodyPr/>
-                    <a:lstStyle/>
-                    <a:p>
-                      <a:pPr algn="ctr" indent="0" marL="0">
-                        <a:buNone/>
-                      </a:pPr>
-                      <a:r>
-                        <a:rPr lang="en-US" sz="1200" b="1" dirty="0">
-                          <a:solidFill>
-                            <a:srgbClr val="8B1A1A"/>
-                          </a:solidFill>
-                          <a:latin typeface="Times New Roman" pitchFamily="34" charset="0"/>
-                          <a:ea typeface="Times New Roman" pitchFamily="34" charset="-122"/>
-                          <a:cs typeface="Times New Roman" pitchFamily="34" charset="-120"/>
-                        </a:rPr>
-                        <a:t>0,041</a:t>
-                      </a:r>
-                      <a:endParaRPr lang="en-US" sz="1200" dirty="0">
-                        <a:latin typeface="Times New Roman" charset="0"/>
-                        <a:ea typeface="Times New Roman" charset="0"/>
-                        <a:cs typeface="Times New Roman" charset="0"/>
-                      </a:endParaRPr>
-                    </a:p>
-                  </a:txBody>
-                  <a:tcPr marL="91440" marR="91440" marT="45720" marB="45720" anchor="ctr">
-                    <a:lnL w="6350" cap="flat" cmpd="sng" algn="ctr">
-                      <a:solidFill>
-                        <a:srgbClr val="BFBFBF"/>
-                      </a:solidFill>
-                      <a:prstDash val="solid"/>
-                      <a:round/>
-                      <a:headEnd type="none" w="med" len="med"/>
-                      <a:tailEnd type="none" w="med" len="med"/>
-                    </a:lnL>
-                    <a:lnR w="6350" cap="flat" cmpd="sng" algn="ctr">
-                      <a:solidFill>
-                        <a:srgbClr val="BFBFBF"/>
-                      </a:solidFill>
-                      <a:prstDash val="solid"/>
-                      <a:round/>
-                      <a:headEnd type="none" w="med" len="med"/>
-                      <a:tailEnd type="none" w="med" len="med"/>
-                    </a:lnR>
-                    <a:lnT w="6350" cap="flat" cmpd="sng" algn="ctr">
-                      <a:solidFill>
-                        <a:srgbClr val="BFBFBF"/>
-                      </a:solidFill>
-                      <a:prstDash val="solid"/>
-                      <a:round/>
-                      <a:headEnd type="none" w="med" len="med"/>
-                      <a:tailEnd type="none" w="med" len="med"/>
-                    </a:lnT>
-                    <a:lnB w="6350" cap="flat" cmpd="sng" algn="ctr">
-                      <a:solidFill>
-                        <a:srgbClr val="BFBFBF"/>
-                      </a:solidFill>
-                      <a:prstDash val="solid"/>
-                      <a:round/>
-                      <a:headEnd type="none" w="med" len="med"/>
-                      <a:tailEnd type="none" w="med" len="med"/>
-                    </a:lnB>
-                  </a:tcPr>
-                </a:tc>
-                <a:tc>
-                  <a:txBody>
-                    <a:bodyPr/>
-                    <a:lstStyle/>
-                    <a:p>
-                      <a:pPr algn="ctr" indent="0" marL="0">
-                        <a:buNone/>
-                      </a:pPr>
-                      <a:r>
                         <a:rPr lang="en-US" sz="1200" b="1" dirty="0">
                           <a:solidFill>
                             <a:srgbClr val="8B1A1A"/>
@@ -6600,7 +6002,7 @@
                           <a:ea typeface="Times New Roman" pitchFamily="34" charset="-122"/>
                           <a:cs typeface="Times New Roman" pitchFamily="34" charset="-120"/>
                         </a:rPr>
-                        <a:t>1,450</a:t>
+                        <a:t>18,73</a:t>
                       </a:r>
                       <a:endParaRPr lang="en-US" sz="1200" dirty="0">
                         <a:latin typeface="Times New Roman" charset="0"/>
@@ -6665,7 +6067,137 @@
                           <a:ea typeface="Times New Roman" pitchFamily="34" charset="-122"/>
                           <a:cs typeface="Times New Roman" pitchFamily="34" charset="-120"/>
                         </a:rPr>
-                        <a:t>0,368</a:t>
+                        <a:t>9,64</a:t>
+                      </a:r>
+                      <a:endParaRPr lang="en-US" sz="1200" dirty="0">
+                        <a:latin typeface="Times New Roman" charset="0"/>
+                        <a:ea typeface="Times New Roman" charset="0"/>
+                        <a:cs typeface="Times New Roman" charset="0"/>
+                      </a:endParaRPr>
+                    </a:p>
+                  </a:txBody>
+                  <a:tcPr marL="91440" marR="91440" marT="45720" marB="45720" anchor="ctr">
+                    <a:lnL w="6350" cap="flat" cmpd="sng" algn="ctr">
+                      <a:solidFill>
+                        <a:srgbClr val="BFBFBF"/>
+                      </a:solidFill>
+                      <a:prstDash val="solid"/>
+                      <a:round/>
+                      <a:headEnd type="none" w="med" len="med"/>
+                      <a:tailEnd type="none" w="med" len="med"/>
+                    </a:lnL>
+                    <a:lnR w="6350" cap="flat" cmpd="sng" algn="ctr">
+                      <a:solidFill>
+                        <a:srgbClr val="BFBFBF"/>
+                      </a:solidFill>
+                      <a:prstDash val="solid"/>
+                      <a:round/>
+                      <a:headEnd type="none" w="med" len="med"/>
+                      <a:tailEnd type="none" w="med" len="med"/>
+                    </a:lnR>
+                    <a:lnT w="6350" cap="flat" cmpd="sng" algn="ctr">
+                      <a:solidFill>
+                        <a:srgbClr val="BFBFBF"/>
+                      </a:solidFill>
+                      <a:prstDash val="solid"/>
+                      <a:round/>
+                      <a:headEnd type="none" w="med" len="med"/>
+                      <a:tailEnd type="none" w="med" len="med"/>
+                    </a:lnT>
+                    <a:lnB w="6350" cap="flat" cmpd="sng" algn="ctr">
+                      <a:solidFill>
+                        <a:srgbClr val="BFBFBF"/>
+                      </a:solidFill>
+                      <a:prstDash val="solid"/>
+                      <a:round/>
+                      <a:headEnd type="none" w="med" len="med"/>
+                      <a:tailEnd type="none" w="med" len="med"/>
+                    </a:lnB>
+                  </a:tcPr>
+                </a:tc>
+                <a:tc>
+                  <a:txBody>
+                    <a:bodyPr/>
+                    <a:lstStyle/>
+                    <a:p>
+                      <a:pPr algn="ctr" indent="0" marL="0">
+                        <a:buNone/>
+                      </a:pPr>
+                      <a:r>
+                        <a:rPr lang="en-US" sz="1200" dirty="0">
+                          <a:solidFill>
+                            <a:srgbClr val="1A1A1A"/>
+                          </a:solidFill>
+                          <a:latin typeface="Times New Roman" pitchFamily="34" charset="0"/>
+                          <a:ea typeface="Times New Roman" pitchFamily="34" charset="-122"/>
+                          <a:cs typeface="Times New Roman" pitchFamily="34" charset="-120"/>
+                        </a:rPr>
+                        <a:t>0,909</a:t>
+                      </a:r>
+                      <a:endParaRPr lang="en-US" sz="1200" dirty="0">
+                        <a:latin typeface="Times New Roman" charset="0"/>
+                        <a:ea typeface="Times New Roman" charset="0"/>
+                        <a:cs typeface="Times New Roman" charset="0"/>
+                      </a:endParaRPr>
+                    </a:p>
+                  </a:txBody>
+                  <a:tcPr marL="91440" marR="91440" marT="45720" marB="45720" anchor="ctr">
+                    <a:lnL w="6350" cap="flat" cmpd="sng" algn="ctr">
+                      <a:solidFill>
+                        <a:srgbClr val="BFBFBF"/>
+                      </a:solidFill>
+                      <a:prstDash val="solid"/>
+                      <a:round/>
+                      <a:headEnd type="none" w="med" len="med"/>
+                      <a:tailEnd type="none" w="med" len="med"/>
+                    </a:lnL>
+                    <a:lnR w="6350" cap="flat" cmpd="sng" algn="ctr">
+                      <a:solidFill>
+                        <a:srgbClr val="BFBFBF"/>
+                      </a:solidFill>
+                      <a:prstDash val="solid"/>
+                      <a:round/>
+                      <a:headEnd type="none" w="med" len="med"/>
+                      <a:tailEnd type="none" w="med" len="med"/>
+                    </a:lnR>
+                    <a:lnT w="6350" cap="flat" cmpd="sng" algn="ctr">
+                      <a:solidFill>
+                        <a:srgbClr val="BFBFBF"/>
+                      </a:solidFill>
+                      <a:prstDash val="solid"/>
+                      <a:round/>
+                      <a:headEnd type="none" w="med" len="med"/>
+                      <a:tailEnd type="none" w="med" len="med"/>
+                    </a:lnT>
+                    <a:lnB w="6350" cap="flat" cmpd="sng" algn="ctr">
+                      <a:solidFill>
+                        <a:srgbClr val="BFBFBF"/>
+                      </a:solidFill>
+                      <a:prstDash val="solid"/>
+                      <a:round/>
+                      <a:headEnd type="none" w="med" len="med"/>
+                      <a:tailEnd type="none" w="med" len="med"/>
+                    </a:lnB>
+                  </a:tcPr>
+                </a:tc>
+                <a:tc>
+                  <a:txBody>
+                    <a:bodyPr/>
+                    <a:lstStyle/>
+                    <a:p>
+                      <a:pPr algn="ctr" indent="0" marL="0">
+                        <a:buNone/>
+                      </a:pPr>
+                      <a:r>
+                        <a:rPr lang="en-US" sz="1200" dirty="0">
+                          <a:solidFill>
+                            <a:srgbClr val="1A1A1A"/>
+                          </a:solidFill>
+                          <a:latin typeface="Times New Roman" pitchFamily="34" charset="0"/>
+                          <a:ea typeface="Times New Roman" pitchFamily="34" charset="-122"/>
+                          <a:cs typeface="Times New Roman" pitchFamily="34" charset="-120"/>
+                        </a:rPr>
+                        <a:t>0,117</a:t>
                       </a:r>
                       <a:endParaRPr lang="en-US" sz="1200" dirty="0">
                         <a:latin typeface="Times New Roman" charset="0"/>
@@ -6755,7 +6287,7 @@
                 <a:ea typeface="Times New Roman" pitchFamily="34" charset="-122"/>
                 <a:cs typeface="Times New Roman" pitchFamily="34" charset="-120"/>
               </a:rPr>
-              <a:t>La propuesta logra la menor tasa de artefactos del estudio (Nabf = 0,041; 2,7 veces menos que el mejor rival) y la mayor similitud estructural (SSIM = 0,782).</a:t>
+              <a:t>La propuesta alcanza la mayor similitud estructural del estudio (SSIM = 0,782), significativa frente a los cinco métodos del estado del arte, y es segunda en información mutua con las fuentes (MI_ir = 0,909).</a:t>
             </a:r>
             <a:endParaRPr lang="en-US" sz="1250" dirty="0"/>
           </a:p>
@@ -6776,9 +6308,288 @@
                 <a:ea typeface="Times New Roman" pitchFamily="34" charset="-122"/>
                 <a:cs typeface="Times New Roman" pitchFamily="34" charset="-120"/>
               </a:rPr>
-              <a:t>Es segunda en Qabf, SCD y VIF, a milésimas del líder de cada métrica; cede en contraste bruto (EN, SD).</a:t>
+              <a:t>Es más conservadora en actividad y contraste (SF, SD, EN): prioriza la fidelidad sobre el realce.</a:t>
             </a:r>
             <a:endParaRPr lang="en-US" sz="1250" dirty="0"/>
+          </a:p>
+        </p:txBody>
+      </p:sp>
+    </p:spTree>
+  </p:cSld>
+  <p:clrMapOvr>
+    <a:masterClrMapping/>
+  </p:clrMapOvr>
+</p:sld>
+</file>
+
+<file path=ppt/slides/slide12.xml><?xml version="1.0" encoding="utf-8"?>
+<p:sld xmlns:a="http://schemas.openxmlformats.org/drawingml/2006/main" xmlns:r="http://schemas.openxmlformats.org/officeDocument/2006/relationships" xmlns:p="http://schemas.openxmlformats.org/presentationml/2006/main">
+  <p:cSld name="Slide 12">
+    <p:bg>
+      <p:bgPr>
+        <a:solidFill>
+          <a:srgbClr val="FFFFFF"/>
+        </a:solidFill>
+      </p:bgPr>
+    </p:bg>
+    <p:spTree>
+      <p:nvGrpSpPr>
+        <p:cNvPr id="1" name=""/>
+        <p:cNvGrpSpPr/>
+        <p:nvPr/>
+      </p:nvGrpSpPr>
+      <p:grpSpPr>
+        <a:xfrm>
+          <a:off x="0" y="0"/>
+          <a:ext cx="0" cy="0"/>
+          <a:chOff x="0" y="0"/>
+          <a:chExt cx="0" cy="0"/>
+        </a:xfrm>
+      </p:grpSpPr>
+      <p:sp>
+        <p:nvSpPr>
+          <p:cNvPr id="2" name="Text 0"/>
+          <p:cNvSpPr/>
+          <p:nvPr/>
+        </p:nvSpPr>
+        <p:spPr>
+          <a:xfrm>
+            <a:off x="457200" y="256032"/>
+            <a:ext cx="8229600" cy="502920"/>
+          </a:xfrm>
+          <a:prstGeom prst="rect">
+            <a:avLst/>
+          </a:prstGeom>
+          <a:noFill/>
+          <a:ln/>
+        </p:spPr>
+        <p:txBody>
+          <a:bodyPr wrap="square" lIns="0" tIns="0" rIns="0" bIns="0" rtlCol="0" anchor="ctr"/>
+          <a:lstStyle/>
+          <a:p>
+            <a:pPr indent="0" marL="0">
+              <a:buNone/>
+            </a:pPr>
+            <a:r>
+              <a:rPr lang="en-US" sz="2300" b="1" dirty="0">
+                <a:solidFill>
+                  <a:srgbClr val="1A1A1A"/>
+                </a:solidFill>
+                <a:latin typeface="Times New Roman" pitchFamily="34" charset="0"/>
+                <a:ea typeface="Times New Roman" pitchFamily="34" charset="-122"/>
+                <a:cs typeface="Times New Roman" pitchFamily="34" charset="-120"/>
+              </a:rPr>
+              <a:t>Análisis estadístico</a:t>
+            </a:r>
+            <a:endParaRPr lang="en-US" sz="2300" dirty="0"/>
+          </a:p>
+        </p:txBody>
+      </p:sp>
+      <p:sp>
+        <p:nvSpPr>
+          <p:cNvPr id="3" name="Text 1"/>
+          <p:cNvSpPr/>
+          <p:nvPr/>
+        </p:nvSpPr>
+        <p:spPr>
+          <a:xfrm>
+            <a:off x="8229600" y="4828032"/>
+            <a:ext cx="685800" cy="274320"/>
+          </a:xfrm>
+          <a:prstGeom prst="rect">
+            <a:avLst/>
+          </a:prstGeom>
+          <a:noFill/>
+          <a:ln/>
+        </p:spPr>
+        <p:txBody>
+          <a:bodyPr wrap="square" lIns="0" tIns="0" rIns="0" bIns="0" rtlCol="0" anchor="ctr"/>
+          <a:lstStyle/>
+          <a:p>
+            <a:pPr algn="r" indent="0" marL="0">
+              <a:buNone/>
+            </a:pPr>
+            <a:r>
+              <a:rPr lang="en-US" sz="900" dirty="0">
+                <a:solidFill>
+                  <a:srgbClr val="666666"/>
+                </a:solidFill>
+                <a:latin typeface="Times New Roman" pitchFamily="34" charset="0"/>
+                <a:ea typeface="Times New Roman" pitchFamily="34" charset="-122"/>
+                <a:cs typeface="Times New Roman" pitchFamily="34" charset="-120"/>
+              </a:rPr>
+              <a:t>12 / 19</a:t>
+            </a:r>
+            <a:endParaRPr lang="en-US" sz="900" dirty="0"/>
+          </a:p>
+        </p:txBody>
+      </p:sp>
+      <p:sp>
+        <p:nvSpPr>
+          <p:cNvPr id="4" name="Text 2"/>
+          <p:cNvSpPr/>
+          <p:nvPr/>
+        </p:nvSpPr>
+        <p:spPr>
+          <a:xfrm>
+            <a:off x="457200" y="914400"/>
+            <a:ext cx="8229600" cy="3931920"/>
+          </a:xfrm>
+          <a:prstGeom prst="rect">
+            <a:avLst/>
+          </a:prstGeom>
+          <a:noFill/>
+          <a:ln/>
+        </p:spPr>
+        <p:txBody>
+          <a:bodyPr wrap="square" lIns="0" tIns="0" rIns="0" bIns="0" rtlCol="0" anchor="t"/>
+          <a:lstStyle/>
+          <a:p>
+            <a:pPr marL="177800" indent="-177800">
+              <a:spcAft>
+                <a:spcPts val="900"/>
+              </a:spcAft>
+              <a:buSzPct val="100000"/>
+              <a:buChar char="•"/>
+            </a:pPr>
+            <a:r>
+              <a:rPr lang="en-US" sz="1300" b="1" dirty="0">
+                <a:solidFill>
+                  <a:srgbClr val="1A1A1A"/>
+                </a:solidFill>
+                <a:latin typeface="Times New Roman" pitchFamily="34" charset="0"/>
+                <a:ea typeface="Times New Roman" pitchFamily="34" charset="-122"/>
+                <a:cs typeface="Times New Roman" pitchFamily="34" charset="-120"/>
+              </a:rPr>
+              <a:t>Friedman: diferencias significativas en las nueve métricas (p &lt; 0,05).</a:t>
+            </a:r>
+            <a:endParaRPr lang="en-US" sz="1300" dirty="0"/>
+          </a:p>
+          <a:p>
+            <a:pPr marL="177800" indent="-177800">
+              <a:spcAft>
+                <a:spcPts val="900"/>
+              </a:spcAft>
+              <a:buSzPct val="100000"/>
+              <a:buChar char="•"/>
+            </a:pPr>
+            <a:r>
+              <a:rPr lang="en-US" sz="1300" dirty="0">
+                <a:solidFill>
+                  <a:srgbClr val="1A1A1A"/>
+                </a:solidFill>
+                <a:latin typeface="Times New Roman" pitchFamily="34" charset="0"/>
+                <a:ea typeface="Times New Roman" pitchFamily="34" charset="-122"/>
+                <a:cs typeface="Times New Roman" pitchFamily="34" charset="-120"/>
+              </a:rPr>
+              <a:t>Wilcoxon pareado (corrección de Holm), Propuesta vs. los 5 métodos del estado del arte:</a:t>
+            </a:r>
+            <a:endParaRPr lang="en-US" sz="1300" dirty="0"/>
+          </a:p>
+          <a:p>
+            <a:pPr lvl="1" marL="304800" indent="-152400">
+              <a:spcAft>
+                <a:spcPts val="900"/>
+              </a:spcAft>
+              <a:buSzPct val="100000"/>
+              <a:buChar char="–"/>
+            </a:pPr>
+            <a:r>
+              <a:rPr lang="en-US" sz="1300" dirty="0">
+                <a:solidFill>
+                  <a:srgbClr val="1A1A1A"/>
+                </a:solidFill>
+                <a:latin typeface="Times New Roman" pitchFamily="34" charset="0"/>
+                <a:ea typeface="Times New Roman" pitchFamily="34" charset="-122"/>
+                <a:cs typeface="Times New Roman" pitchFamily="34" charset="-120"/>
+              </a:rPr>
+              <a:t>SSIM: mejor y significativa frente a los 5 rivales.</a:t>
+            </a:r>
+            <a:endParaRPr lang="en-US" sz="1300" dirty="0"/>
+          </a:p>
+          <a:p>
+            <a:pPr lvl="1" marL="304800" indent="-152400">
+              <a:spcAft>
+                <a:spcPts val="900"/>
+              </a:spcAft>
+              <a:buSzPct val="100000"/>
+              <a:buChar char="–"/>
+            </a:pPr>
+            <a:r>
+              <a:rPr lang="en-US" sz="1300" dirty="0">
+                <a:solidFill>
+                  <a:srgbClr val="1A1A1A"/>
+                </a:solidFill>
+                <a:latin typeface="Times New Roman" pitchFamily="34" charset="0"/>
+                <a:ea typeface="Times New Roman" pitchFamily="34" charset="-122"/>
+                <a:cs typeface="Times New Roman" pitchFamily="34" charset="-120"/>
+              </a:rPr>
+              <a:t>Información mutua (MI_vis, MI_ir): mejor y significativa frente a la mayoría.</a:t>
+            </a:r>
+            <a:endParaRPr lang="en-US" sz="1300" dirty="0"/>
+          </a:p>
+          <a:p>
+            <a:pPr lvl="1" marL="304800" indent="-152400">
+              <a:spcAft>
+                <a:spcPts val="900"/>
+              </a:spcAft>
+              <a:buSzPct val="100000"/>
+              <a:buChar char="–"/>
+            </a:pPr>
+            <a:r>
+              <a:rPr lang="en-US" sz="1300" dirty="0">
+                <a:solidFill>
+                  <a:srgbClr val="1A1A1A"/>
+                </a:solidFill>
+                <a:latin typeface="Times New Roman" pitchFamily="34" charset="0"/>
+                <a:ea typeface="Times New Roman" pitchFamily="34" charset="-122"/>
+                <a:cs typeface="Times New Roman" pitchFamily="34" charset="-120"/>
+              </a:rPr>
+              <a:t>Cede en actividad y contraste (EN, SD, MG, SF): lideran los operadores de mayor realce.</a:t>
+            </a:r>
+            <a:endParaRPr lang="en-US" sz="1300" dirty="0"/>
+          </a:p>
+          <a:p>
+            <a:pPr marL="177800" indent="-177800">
+              <a:spcAft>
+                <a:spcPts val="900"/>
+              </a:spcAft>
+              <a:buSzPct val="100000"/>
+              <a:buChar char="•"/>
+            </a:pPr>
+            <a:r>
+              <a:rPr lang="en-US" sz="1300" dirty="0">
+                <a:solidFill>
+                  <a:srgbClr val="1A1A1A"/>
+                </a:solidFill>
+                <a:latin typeface="Times New Roman" pitchFamily="34" charset="0"/>
+                <a:ea typeface="Times New Roman" pitchFamily="34" charset="-122"/>
+                <a:cs typeface="Times New Roman" pitchFamily="34" charset="-120"/>
+              </a:rPr>
+              <a:t>Frente al Top-Hat clásico, la propuesta eleva la fidelidad estructural (SSIM 0,782 vs 0,578) e información mutua (MI_ir 0,909 vs 0,586), con significancia estadística.</a:t>
+            </a:r>
+            <a:endParaRPr lang="en-US" sz="1300" dirty="0"/>
+          </a:p>
+          <a:p>
+            <a:pPr marL="177800" indent="-177800">
+              <a:spcAft>
+                <a:spcPts val="900"/>
+              </a:spcAft>
+              <a:buSzPct val="100000"/>
+              <a:buChar char="•"/>
+            </a:pPr>
+            <a:r>
+              <a:rPr lang="en-US" sz="1300" dirty="0">
+                <a:solidFill>
+                  <a:srgbClr val="1A1A1A"/>
+                </a:solidFill>
+                <a:latin typeface="Times New Roman" pitchFamily="34" charset="0"/>
+                <a:ea typeface="Times New Roman" pitchFamily="34" charset="-122"/>
+                <a:cs typeface="Times New Roman" pitchFamily="34" charset="-120"/>
+              </a:rPr>
+              <a:t>Ranking global (9 métricas): LP 3,11 · DTCWT 3,78 · TH clásico 3,78 · RP 3,89 · DWT 4,22 · CVT 4,22 · Propuesta 5,00 — el ranking premia la actividad; la propuesta prioriza fidelidad estructural.</a:t>
+            </a:r>
+            <a:endParaRPr lang="en-US" sz="1300" dirty="0"/>
           </a:p>
         </p:txBody>
       </p:sp>
@@ -6847,7 +6658,7 @@
                 <a:ea typeface="Times New Roman" pitchFamily="34" charset="-122"/>
                 <a:cs typeface="Times New Roman" pitchFamily="34" charset="-120"/>
               </a:rPr>
-              <a:t>Análisis estadístico</a:t>
+              <a:t>8. Detección en LLVIP — mAP@0,5</a:t>
             </a:r>
             <a:endParaRPr lang="en-US" sz="2300" dirty="0"/>
           </a:p>
@@ -6886,22 +6697,46 @@
                 <a:ea typeface="Times New Roman" pitchFamily="34" charset="-122"/>
                 <a:cs typeface="Times New Roman" pitchFamily="34" charset="-120"/>
               </a:rPr>
-              <a:t>13 / 20</a:t>
+              <a:t>13 / 19</a:t>
             </a:r>
             <a:endParaRPr lang="en-US" sz="900" dirty="0"/>
           </a:p>
         </p:txBody>
       </p:sp>
-      <p:sp>
-        <p:nvSpPr>
-          <p:cNvPr id="4" name="Text 2"/>
+      <p:pic>
+        <p:nvPicPr>
+          <p:cNvPr id="4" name="Image 0" descr="C:\Users\Usuario\AppData\Local\Temp\claude\C--Users-Usuario-Documents-unv-mastertesis\fa0a2acc-a0da-4701-a920-18b20c70d3b2\scratchpad\pptx_build/assets/map_llvip.png">    </p:cNvPr>
+          <p:cNvPicPr>
+            <a:picLocks noChangeAspect="1"/>
+          </p:cNvPicPr>
+          <p:nvPr/>
+        </p:nvPicPr>
+        <p:blipFill>
+          <a:blip r:embed="rId1"/>
+          <a:stretch>
+            <a:fillRect/>
+          </a:stretch>
+        </p:blipFill>
+        <p:spPr>
+          <a:xfrm>
+            <a:off x="960120" y="822960"/>
+            <a:ext cx="7223760" cy="2761488"/>
+          </a:xfrm>
+          <a:prstGeom prst="rect">
+            <a:avLst/>
+          </a:prstGeom>
+        </p:spPr>
+      </p:pic>
+      <p:sp>
+        <p:nvSpPr>
+          <p:cNvPr id="5" name="Text 2"/>
           <p:cNvSpPr/>
           <p:nvPr/>
         </p:nvSpPr>
         <p:spPr>
           <a:xfrm>
-            <a:off x="457200" y="914400"/>
-            <a:ext cx="8229600" cy="3931920"/>
+            <a:off x="457200" y="3703320"/>
+            <a:ext cx="8229600" cy="1325880"/>
           </a:xfrm>
           <a:prstGeom prst="rect">
             <a:avLst/>
@@ -6915,13 +6750,13 @@
           <a:p>
             <a:pPr marL="177800" indent="-177800">
               <a:spcAft>
-                <a:spcPts val="900"/>
+                <a:spcPts val="500"/>
               </a:spcAft>
               <a:buSzPct val="100000"/>
               <a:buChar char="•"/>
             </a:pPr>
             <a:r>
-              <a:rPr lang="en-US" sz="1300" b="1" dirty="0">
+              <a:rPr lang="en-US" sz="1200" dirty="0">
                 <a:solidFill>
                   <a:srgbClr val="1A1A1A"/>
                 </a:solidFill>
@@ -6929,20 +6764,20 @@
                 <a:ea typeface="Times New Roman" pitchFamily="34" charset="-122"/>
                 <a:cs typeface="Times New Roman" pitchFamily="34" charset="-120"/>
               </a:rPr>
-              <a:t>Friedman: diferencias significativas en las 12 métricas (p &lt; 0,05).</a:t>
-            </a:r>
-            <a:endParaRPr lang="en-US" sz="1300" dirty="0"/>
+              <a:t>Toda fusión supera con claridad al visible solo (+0,12 a +0,14 en mAP@0,5); el IR solo lidera (0,957): en peatones nocturnos domina la firma térmica.</a:t>
+            </a:r>
+            <a:endParaRPr lang="en-US" sz="1200" dirty="0"/>
           </a:p>
           <a:p>
             <a:pPr marL="177800" indent="-177800">
               <a:spcAft>
-                <a:spcPts val="900"/>
+                <a:spcPts val="500"/>
               </a:spcAft>
               <a:buSzPct val="100000"/>
               <a:buChar char="•"/>
             </a:pPr>
             <a:r>
-              <a:rPr lang="en-US" sz="1300" dirty="0">
+              <a:rPr lang="en-US" sz="1200" dirty="0">
                 <a:solidFill>
                   <a:srgbClr val="1A1A1A"/>
                 </a:solidFill>
@@ -6950,83 +6785,20 @@
                 <a:ea typeface="Times New Roman" pitchFamily="34" charset="-122"/>
                 <a:cs typeface="Times New Roman" pitchFamily="34" charset="-120"/>
               </a:rPr>
-              <a:t>Wilcoxon pareado (corrección de Holm), Propuesta vs. los 5 métodos del estado del arte:</a:t>
-            </a:r>
-            <a:endParaRPr lang="en-US" sz="1300" dirty="0"/>
-          </a:p>
-          <a:p>
-            <a:pPr lvl="1" marL="304800" indent="-152400">
-              <a:spcAft>
-                <a:spcPts val="900"/>
-              </a:spcAft>
-              <a:buSzPct val="100000"/>
-              <a:buChar char="–"/>
-            </a:pPr>
-            <a:r>
-              <a:rPr lang="en-US" sz="1300" dirty="0">
-                <a:solidFill>
-                  <a:srgbClr val="1A1A1A"/>
-                </a:solidFill>
-                <a:latin typeface="Times New Roman" pitchFamily="34" charset="0"/>
-                <a:ea typeface="Times New Roman" pitchFamily="34" charset="-122"/>
-                <a:cs typeface="Times New Roman" pitchFamily="34" charset="-120"/>
-              </a:rPr>
-              <a:t>Nabf: mejor y significativa frente a los 5 rivales.</a:t>
-            </a:r>
-            <a:endParaRPr lang="en-US" sz="1300" dirty="0"/>
-          </a:p>
-          <a:p>
-            <a:pPr lvl="1" marL="304800" indent="-152400">
-              <a:spcAft>
-                <a:spcPts val="900"/>
-              </a:spcAft>
-              <a:buSzPct val="100000"/>
-              <a:buChar char="–"/>
-            </a:pPr>
-            <a:r>
-              <a:rPr lang="en-US" sz="1300" dirty="0">
-                <a:solidFill>
-                  <a:srgbClr val="1A1A1A"/>
-                </a:solidFill>
-                <a:latin typeface="Times New Roman" pitchFamily="34" charset="0"/>
-                <a:ea typeface="Times New Roman" pitchFamily="34" charset="-122"/>
-                <a:cs typeface="Times New Roman" pitchFamily="34" charset="-120"/>
-              </a:rPr>
-              <a:t>SSIM: mejor y significativa frente a los 5 rivales.</a:t>
-            </a:r>
-            <a:endParaRPr lang="en-US" sz="1300" dirty="0"/>
-          </a:p>
-          <a:p>
-            <a:pPr lvl="1" marL="304800" indent="-152400">
-              <a:spcAft>
-                <a:spcPts val="900"/>
-              </a:spcAft>
-              <a:buSzPct val="100000"/>
-              <a:buChar char="–"/>
-            </a:pPr>
-            <a:r>
-              <a:rPr lang="en-US" sz="1300" dirty="0">
-                <a:solidFill>
-                  <a:srgbClr val="1A1A1A"/>
-                </a:solidFill>
-                <a:latin typeface="Times New Roman" pitchFamily="34" charset="0"/>
-                <a:ea typeface="Times New Roman" pitchFamily="34" charset="-122"/>
-                <a:cs typeface="Times New Roman" pitchFamily="34" charset="-120"/>
-              </a:rPr>
-              <a:t>SCD y VIF: mejor y significativa frente a 3 de 5; Qabf frente a 2 de 5.</a:t>
-            </a:r>
-            <a:endParaRPr lang="en-US" sz="1300" dirty="0"/>
+              <a:t>La Propuesta Novedosa cae en la banda de las fusiones (0,936), pareja con el Top-Hat clásico (0,938), sin ser la líder.</a:t>
+            </a:r>
+            <a:endParaRPr lang="en-US" sz="1200" dirty="0"/>
           </a:p>
           <a:p>
             <a:pPr marL="177800" indent="-177800">
               <a:spcAft>
-                <a:spcPts val="900"/>
+                <a:spcPts val="500"/>
               </a:spcAft>
               <a:buSzPct val="100000"/>
               <a:buChar char="•"/>
             </a:pPr>
             <a:r>
-              <a:rPr lang="en-US" sz="1300" dirty="0">
+              <a:rPr lang="en-US" sz="1200" dirty="0">
                 <a:solidFill>
                   <a:srgbClr val="1A1A1A"/>
                 </a:solidFill>
@@ -7034,30 +6806,9 @@
                 <a:ea typeface="Times New Roman" pitchFamily="34" charset="-122"/>
                 <a:cs typeface="Times New Roman" pitchFamily="34" charset="-120"/>
               </a:rPr>
-              <a:t>Frente al Top-Hat clásico, la propuesta mejora en todas las métricas de calidad de fusión (Qabf 0,500 vs 0,305 · Nabf 0,041 vs 0,585 · SSIM 0,782 vs 0,578).</a:t>
-            </a:r>
-            <a:endParaRPr lang="en-US" sz="1300" dirty="0"/>
-          </a:p>
-          <a:p>
-            <a:pPr marL="177800" indent="-177800">
-              <a:spcAft>
-                <a:spcPts val="900"/>
-              </a:spcAft>
-              <a:buSzPct val="100000"/>
-              <a:buChar char="•"/>
-            </a:pPr>
-            <a:r>
-              <a:rPr lang="en-US" sz="1300" dirty="0">
-                <a:solidFill>
-                  <a:srgbClr val="1A1A1A"/>
-                </a:solidFill>
-                <a:latin typeface="Times New Roman" pitchFamily="34" charset="0"/>
-                <a:ea typeface="Times New Roman" pitchFamily="34" charset="-122"/>
-                <a:cs typeface="Times New Roman" pitchFamily="34" charset="-120"/>
-              </a:rPr>
-              <a:t>Ranking global (12 métricas): LP 3,17 · RP 3,50 · DTCWT 3,58 · Propuesta 3,92 · TH clásico 4,17 · DWT 4,75 · CVT 4,92 — óptimos de criterios distintos y complementarios.</a:t>
-            </a:r>
-            <a:endParaRPr lang="en-US" sz="1300" dirty="0"/>
+              <a:t>La calidad de imagen no se traslada automáticamente al mAP (H3 parcial).</a:t>
+            </a:r>
+            <a:endParaRPr lang="en-US" sz="1200" dirty="0"/>
           </a:p>
         </p:txBody>
       </p:sp>
@@ -7126,7 +6877,7 @@
                 <a:ea typeface="Times New Roman" pitchFamily="34" charset="-122"/>
                 <a:cs typeface="Times New Roman" pitchFamily="34" charset="-120"/>
               </a:rPr>
-              <a:t>8. Detección en LLVIP — mAP@0,5</a:t>
+              <a:t>Clases complementarias en M3FD — un detector único VIS+IR</a:t>
             </a:r>
             <a:endParaRPr lang="en-US" sz="2300" dirty="0"/>
           </a:p>
@@ -7165,7 +6916,7 @@
                 <a:ea typeface="Times New Roman" pitchFamily="34" charset="-122"/>
                 <a:cs typeface="Times New Roman" pitchFamily="34" charset="-120"/>
               </a:rPr>
-              <a:t>14 / 20</a:t>
+              <a:t>14 / 19</a:t>
             </a:r>
             <a:endParaRPr lang="en-US" sz="900" dirty="0"/>
           </a:p>
@@ -7173,7 +6924,7 @@
       </p:sp>
       <p:pic>
         <p:nvPicPr>
-          <p:cNvPr id="4" name="Image 0" descr="C:\Users\Usuario\AppData\Local\Temp\claude\C--Users-Usuario-Documents-unv-mastertesis\fa0a2acc-a0da-4701-a920-18b20c70d3b2\scratchpad\pptx_build/assets/map_llvip.png">    </p:cNvPr>
+          <p:cNvPr id="4" name="Image 0" descr="C:\Users\Usuario\AppData\Local\Temp\claude\C--Users-Usuario-Documents-unv-mastertesis\fa0a2acc-a0da-4701-a920-18b20c70d3b2\scratchpad\pptx_build/assets/m3fd_par.png">    </p:cNvPr>
           <p:cNvPicPr>
             <a:picLocks noChangeAspect="1"/>
           </p:cNvPicPr>
@@ -7187,8 +6938,8 @@
         </p:blipFill>
         <p:spPr>
           <a:xfrm>
-            <a:off x="960120" y="822960"/>
-            <a:ext cx="7223760" cy="2761488"/>
+            <a:off x="640080" y="868680"/>
+            <a:ext cx="7863840" cy="2944368"/>
           </a:xfrm>
           <a:prstGeom prst="rect">
             <a:avLst/>
@@ -7203,8 +6954,8 @@
         </p:nvSpPr>
         <p:spPr>
           <a:xfrm>
-            <a:off x="457200" y="3703320"/>
-            <a:ext cx="8229600" cy="1325880"/>
+            <a:off x="457200" y="3913632"/>
+            <a:ext cx="8229600" cy="1143000"/>
           </a:xfrm>
           <a:prstGeom prst="rect">
             <a:avLst/>
@@ -7218,13 +6969,13 @@
           <a:p>
             <a:pPr marL="177800" indent="-177800">
               <a:spcAft>
-                <a:spcPts val="500"/>
+                <a:spcPts val="400"/>
               </a:spcAft>
               <a:buSzPct val="100000"/>
               <a:buChar char="•"/>
             </a:pPr>
             <a:r>
-              <a:rPr lang="en-US" sz="1200" dirty="0">
+              <a:rPr lang="en-US" sz="1150" dirty="0">
                 <a:solidFill>
                   <a:srgbClr val="1A1A1A"/>
                 </a:solidFill>
@@ -7232,20 +6983,20 @@
                 <a:ea typeface="Times New Roman" pitchFamily="34" charset="-122"/>
                 <a:cs typeface="Times New Roman" pitchFamily="34" charset="-120"/>
               </a:rPr>
-              <a:t>Toda fusión supera con claridad al visible solo (+0,12 a +0,14 en mAP@0,5); el IR solo lidera (0,957): en peatones nocturnos domina la firma térmica.</a:t>
-            </a:r>
-            <a:endParaRPr lang="en-US" sz="1200" dirty="0"/>
+              <a:t>Complementariedad extrema: el IR domina People (0,220) pero es ciego a Lamp (0,018); el VIS es el espejo (0,178 / 0,135).</a:t>
+            </a:r>
+            <a:endParaRPr lang="en-US" sz="1150" dirty="0"/>
           </a:p>
           <a:p>
             <a:pPr marL="177800" indent="-177800">
               <a:spcAft>
-                <a:spcPts val="500"/>
+                <a:spcPts val="400"/>
               </a:spcAft>
               <a:buSzPct val="100000"/>
               <a:buChar char="•"/>
             </a:pPr>
             <a:r>
-              <a:rPr lang="en-US" sz="1200" dirty="0">
+              <a:rPr lang="en-US" sz="1150" b="1" dirty="0">
                 <a:solidFill>
                   <a:srgbClr val="1A1A1A"/>
                 </a:solidFill>
@@ -7253,20 +7004,20 @@
                 <a:ea typeface="Times New Roman" pitchFamily="34" charset="-122"/>
                 <a:cs typeface="Times New Roman" pitchFamily="34" charset="-120"/>
               </a:rPr>
-              <a:t>Las dos configuraciones de la propuesta caen en la banda de las fusiones: F_apt (0,936) y Fo (0,922), pareja con el clásico (0,938).</a:t>
-            </a:r>
-            <a:endParaRPr lang="en-US" sz="1200" dirty="0"/>
+              <a:t>Las mejores fusiones superan a AMBAS modalidades en el promedio del par (propuesta 0,162; RP 0,165 vs VIS 0,157 e IR 0,119): ambas clases en una sola imagen.</a:t>
+            </a:r>
+            <a:endParaRPr lang="en-US" sz="1150" dirty="0"/>
           </a:p>
           <a:p>
             <a:pPr marL="177800" indent="-177800">
               <a:spcAft>
-                <a:spcPts val="500"/>
+                <a:spcPts val="400"/>
               </a:spcAft>
               <a:buSzPct val="100000"/>
               <a:buChar char="•"/>
             </a:pPr>
             <a:r>
-              <a:rPr lang="en-US" sz="1200" dirty="0">
+              <a:rPr lang="en-US" sz="1150" dirty="0">
                 <a:solidFill>
                   <a:srgbClr val="1A1A1A"/>
                 </a:solidFill>
@@ -7274,9 +7025,9 @@
                 <a:ea typeface="Times New Roman" pitchFamily="34" charset="-122"/>
                 <a:cs typeface="Times New Roman" pitchFamily="34" charset="-120"/>
               </a:rPr>
-              <a:t>La calidad de imagen no se traslada automáticamente al mAP (H3 parcial).</a:t>
-            </a:r>
-            <a:endParaRPr lang="en-US" sz="1200" dirty="0"/>
+              <a:t>La propuesta es la mejor fusión en mAP global (0,239) y en People (0,207), manteniendo las luces cerca del visible: detecta ambos objetos en una sola imagen.</a:t>
+            </a:r>
+            <a:endParaRPr lang="en-US" sz="1150" dirty="0"/>
           </a:p>
         </p:txBody>
       </p:sp>
@@ -7345,7 +7096,7 @@
                 <a:ea typeface="Times New Roman" pitchFamily="34" charset="-122"/>
                 <a:cs typeface="Times New Roman" pitchFamily="34" charset="-120"/>
               </a:rPr>
-              <a:t>Clases complementarias en M3FD — un detector único VIS+IR</a:t>
+              <a:t>La prueba visual: ambas clases en una sola imagen</a:t>
             </a:r>
             <a:endParaRPr lang="en-US" sz="2300" dirty="0"/>
           </a:p>
@@ -7384,7 +7135,7 @@
                 <a:ea typeface="Times New Roman" pitchFamily="34" charset="-122"/>
                 <a:cs typeface="Times New Roman" pitchFamily="34" charset="-120"/>
               </a:rPr>
-              <a:t>15 / 20</a:t>
+              <a:t>15 / 19</a:t>
             </a:r>
             <a:endParaRPr lang="en-US" sz="900" dirty="0"/>
           </a:p>
@@ -7392,7 +7143,7 @@
       </p:sp>
       <p:pic>
         <p:nvPicPr>
-          <p:cNvPr id="4" name="Image 0" descr="C:\Users\Usuario\AppData\Local\Temp\claude\C--Users-Usuario-Documents-unv-mastertesis\fa0a2acc-a0da-4701-a920-18b20c70d3b2\scratchpad\pptx_build/assets/m3fd_par.png">    </p:cNvPr>
+          <p:cNvPr id="4" name="Image 0" descr="C:/Users/Usuario/Documents/unv/mastertesis/tesis_mciencias_datos/docs/figures/fig_m3fd_detecciones.png">    </p:cNvPr>
           <p:cNvPicPr>
             <a:picLocks noChangeAspect="1"/>
           </p:cNvPicPr>
@@ -7406,8 +7157,8 @@
         </p:blipFill>
         <p:spPr>
           <a:xfrm>
-            <a:off x="640080" y="868680"/>
-            <a:ext cx="7863840" cy="2944368"/>
+            <a:off x="1417320" y="822960"/>
+            <a:ext cx="6309360" cy="4069080"/>
           </a:xfrm>
           <a:prstGeom prst="rect">
             <a:avLst/>
@@ -7422,8 +7173,8 @@
         </p:nvSpPr>
         <p:spPr>
           <a:xfrm>
-            <a:off x="457200" y="3913632"/>
-            <a:ext cx="8229600" cy="1143000"/>
+            <a:off x="457200" y="4864608"/>
+            <a:ext cx="7680960" cy="256032"/>
           </a:xfrm>
           <a:prstGeom prst="rect">
             <a:avLst/>
@@ -7432,70 +7183,24 @@
           <a:ln/>
         </p:spPr>
         <p:txBody>
-          <a:bodyPr wrap="square" lIns="0" tIns="0" rIns="0" bIns="0" rtlCol="0" anchor="t"/>
-          <a:lstStyle/>
-          <a:p>
-            <a:pPr marL="177800" indent="-177800">
-              <a:spcAft>
-                <a:spcPts val="400"/>
-              </a:spcAft>
-              <a:buSzPct val="100000"/>
-              <a:buChar char="•"/>
-            </a:pPr>
-            <a:r>
-              <a:rPr lang="en-US" sz="1150" dirty="0">
-                <a:solidFill>
-                  <a:srgbClr val="1A1A1A"/>
-                </a:solidFill>
-                <a:latin typeface="Times New Roman" pitchFamily="34" charset="0"/>
-                <a:ea typeface="Times New Roman" pitchFamily="34" charset="-122"/>
-                <a:cs typeface="Times New Roman" pitchFamily="34" charset="-120"/>
-              </a:rPr>
-              <a:t>Complementariedad extrema: el IR domina People (0,220) pero es ciego a Lamp (0,018); el VIS es el espejo (0,178 / 0,135).</a:t>
-            </a:r>
-            <a:endParaRPr lang="en-US" sz="1150" dirty="0"/>
-          </a:p>
-          <a:p>
-            <a:pPr marL="177800" indent="-177800">
-              <a:spcAft>
-                <a:spcPts val="400"/>
-              </a:spcAft>
-              <a:buSzPct val="100000"/>
-              <a:buChar char="•"/>
-            </a:pPr>
-            <a:r>
-              <a:rPr lang="en-US" sz="1150" b="1" dirty="0">
-                <a:solidFill>
-                  <a:srgbClr val="1A1A1A"/>
-                </a:solidFill>
-                <a:latin typeface="Times New Roman" pitchFamily="34" charset="0"/>
-                <a:ea typeface="Times New Roman" pitchFamily="34" charset="-122"/>
-                <a:cs typeface="Times New Roman" pitchFamily="34" charset="-120"/>
-              </a:rPr>
-              <a:t>Las mejores fusiones superan a AMBAS modalidades en el promedio del par (propuesta 0,162; RP 0,165 vs VIS 0,157 e IR 0,119): ambas clases en una sola imagen.</a:t>
-            </a:r>
-            <a:endParaRPr lang="en-US" sz="1150" dirty="0"/>
-          </a:p>
-          <a:p>
-            <a:pPr marL="177800" indent="-177800">
-              <a:spcAft>
-                <a:spcPts val="400"/>
-              </a:spcAft>
-              <a:buSzPct val="100000"/>
-              <a:buChar char="•"/>
-            </a:pPr>
-            <a:r>
-              <a:rPr lang="en-US" sz="1150" dirty="0">
-                <a:solidFill>
-                  <a:srgbClr val="1A1A1A"/>
-                </a:solidFill>
-                <a:latin typeface="Times New Roman" pitchFamily="34" charset="0"/>
-                <a:ea typeface="Times New Roman" pitchFamily="34" charset="-122"/>
-                <a:cs typeface="Times New Roman" pitchFamily="34" charset="-120"/>
-              </a:rPr>
-              <a:t>La propuesta es la mejor fusión en mAP global (0,239) y en People (0,207); su óptimo F_apt supera al de Fo en las dos clases clave.</a:t>
-            </a:r>
-            <a:endParaRPr lang="en-US" sz="1150" dirty="0"/>
+          <a:bodyPr wrap="square" lIns="0" tIns="0" rIns="0" bIns="0" rtlCol="0" anchor="ctr"/>
+          <a:lstStyle/>
+          <a:p>
+            <a:pPr indent="0" marL="0">
+              <a:buNone/>
+            </a:pPr>
+            <a:r>
+              <a:rPr lang="en-US" sz="1050" i="1" dirty="0">
+                <a:solidFill>
+                  <a:srgbClr val="666666"/>
+                </a:solidFill>
+                <a:latin typeface="Times New Roman" pitchFamily="34" charset="0"/>
+                <a:ea typeface="Times New Roman" pitchFamily="34" charset="-122"/>
+                <a:cs typeface="Times New Roman" pitchFamily="34" charset="-120"/>
+              </a:rPr>
+              <a:t>Arriba: el VIS no detecta a nadie (0 personas) — la fusión las recupera. Abajo: el IR no ve ninguna luz — la fusión las conserva.</a:t>
+            </a:r>
+            <a:endParaRPr lang="en-US" sz="1050" dirty="0"/>
           </a:p>
         </p:txBody>
       </p:sp>
@@ -7564,7 +7269,7 @@
                 <a:ea typeface="Times New Roman" pitchFamily="34" charset="-122"/>
                 <a:cs typeface="Times New Roman" pitchFamily="34" charset="-120"/>
               </a:rPr>
-              <a:t>La prueba visual: ambas clases en una sola imagen</a:t>
+              <a:t>Contraste de hipótesis</a:t>
             </a:r>
             <a:endParaRPr lang="en-US" sz="2300" dirty="0"/>
           </a:p>
@@ -7603,46 +7308,22 @@
                 <a:ea typeface="Times New Roman" pitchFamily="34" charset="-122"/>
                 <a:cs typeface="Times New Roman" pitchFamily="34" charset="-120"/>
               </a:rPr>
-              <a:t>16 / 20</a:t>
+              <a:t>16 / 19</a:t>
             </a:r>
             <a:endParaRPr lang="en-US" sz="900" dirty="0"/>
           </a:p>
         </p:txBody>
       </p:sp>
-      <p:pic>
-        <p:nvPicPr>
-          <p:cNvPr id="4" name="Image 0" descr="C:/Users/Usuario/Documents/unv/mastertesis/tesis_mciencias_datos/docs/figures/fig_m3fd_detecciones.png">    </p:cNvPr>
-          <p:cNvPicPr>
-            <a:picLocks noChangeAspect="1"/>
-          </p:cNvPicPr>
+      <p:sp>
+        <p:nvSpPr>
+          <p:cNvPr id="4" name="Text 2"/>
+          <p:cNvSpPr/>
           <p:nvPr/>
-        </p:nvPicPr>
-        <p:blipFill>
-          <a:blip r:embed="rId1"/>
-          <a:stretch>
-            <a:fillRect/>
-          </a:stretch>
-        </p:blipFill>
+        </p:nvSpPr>
         <p:spPr>
           <a:xfrm>
-            <a:off x="1417320" y="822960"/>
-            <a:ext cx="6309360" cy="4069080"/>
-          </a:xfrm>
-          <a:prstGeom prst="rect">
-            <a:avLst/>
-          </a:prstGeom>
-        </p:spPr>
-      </p:pic>
-      <p:sp>
-        <p:nvSpPr>
-          <p:cNvPr id="5" name="Text 2"/>
-          <p:cNvSpPr/>
-          <p:nvPr/>
-        </p:nvSpPr>
-        <p:spPr>
-          <a:xfrm>
-            <a:off x="457200" y="4864608"/>
-            <a:ext cx="7680960" cy="256032"/>
+            <a:off x="457200" y="960120"/>
+            <a:ext cx="640080" cy="411480"/>
           </a:xfrm>
           <a:prstGeom prst="rect">
             <a:avLst/>
@@ -7658,17 +7339,329 @@
               <a:buNone/>
             </a:pPr>
             <a:r>
-              <a:rPr lang="en-US" sz="1050" i="1" dirty="0">
-                <a:solidFill>
-                  <a:srgbClr val="666666"/>
-                </a:solidFill>
-                <a:latin typeface="Times New Roman" pitchFamily="34" charset="0"/>
-                <a:ea typeface="Times New Roman" pitchFamily="34" charset="-122"/>
-                <a:cs typeface="Times New Roman" pitchFamily="34" charset="-120"/>
-              </a:rPr>
-              <a:t>Arriba: el VIS no detecta a nadie (0 personas) — la fusión las recupera. Abajo: el IR no ve ninguna luz — la fusión las conserva.</a:t>
-            </a:r>
-            <a:endParaRPr lang="en-US" sz="1050" dirty="0"/>
+              <a:rPr lang="en-US" sz="1900" b="1" dirty="0">
+                <a:solidFill>
+                  <a:srgbClr val="1A1A1A"/>
+                </a:solidFill>
+                <a:latin typeface="Times New Roman" pitchFamily="34" charset="0"/>
+                <a:ea typeface="Times New Roman" pitchFamily="34" charset="-122"/>
+                <a:cs typeface="Times New Roman" pitchFamily="34" charset="-120"/>
+              </a:rPr>
+              <a:t>H1</a:t>
+            </a:r>
+            <a:endParaRPr lang="en-US" sz="1900" dirty="0"/>
+          </a:p>
+        </p:txBody>
+      </p:sp>
+      <p:sp>
+        <p:nvSpPr>
+          <p:cNvPr id="5" name="Text 3"/>
+          <p:cNvSpPr/>
+          <p:nvPr/>
+        </p:nvSpPr>
+        <p:spPr>
+          <a:xfrm>
+            <a:off x="1143000" y="996696"/>
+            <a:ext cx="1417320" cy="365760"/>
+          </a:xfrm>
+          <a:prstGeom prst="rect">
+            <a:avLst/>
+          </a:prstGeom>
+          <a:noFill/>
+          <a:ln/>
+        </p:spPr>
+        <p:txBody>
+          <a:bodyPr wrap="square" lIns="0" tIns="0" rIns="0" bIns="0" rtlCol="0" anchor="ctr"/>
+          <a:lstStyle/>
+          <a:p>
+            <a:pPr indent="0" marL="0">
+              <a:buNone/>
+            </a:pPr>
+            <a:r>
+              <a:rPr lang="en-US" sz="1300" b="1" dirty="0">
+                <a:solidFill>
+                  <a:srgbClr val="1F5C2E"/>
+                </a:solidFill>
+                <a:latin typeface="Times New Roman" pitchFamily="34" charset="0"/>
+                <a:ea typeface="Times New Roman" pitchFamily="34" charset="-122"/>
+                <a:cs typeface="Times New Roman" pitchFamily="34" charset="-120"/>
+              </a:rPr>
+              <a:t>SOSTENIDA</a:t>
+            </a:r>
+            <a:endParaRPr lang="en-US" sz="1300" dirty="0"/>
+          </a:p>
+        </p:txBody>
+      </p:sp>
+      <p:sp>
+        <p:nvSpPr>
+          <p:cNvPr id="6" name="Text 4"/>
+          <p:cNvSpPr/>
+          <p:nvPr/>
+        </p:nvSpPr>
+        <p:spPr>
+          <a:xfrm>
+            <a:off x="2697480" y="960120"/>
+            <a:ext cx="5989320" cy="1143000"/>
+          </a:xfrm>
+          <a:prstGeom prst="rect">
+            <a:avLst/>
+          </a:prstGeom>
+          <a:noFill/>
+          <a:ln/>
+        </p:spPr>
+        <p:txBody>
+          <a:bodyPr wrap="square" lIns="0" tIns="0" rIns="0" bIns="0" rtlCol="0" anchor="t"/>
+          <a:lstStyle/>
+          <a:p>
+            <a:pPr indent="0" marL="0">
+              <a:buNone/>
+            </a:pPr>
+            <a:r>
+              <a:rPr lang="en-US" sz="1250" dirty="0">
+                <a:solidFill>
+                  <a:srgbClr val="1A1A1A"/>
+                </a:solidFill>
+                <a:latin typeface="Times New Roman" pitchFamily="34" charset="0"/>
+                <a:ea typeface="Times New Roman" pitchFamily="34" charset="-122"/>
+                <a:cs typeface="Times New Roman" pitchFamily="34" charset="-120"/>
+              </a:rPr>
+              <a:t>El banco disco + líneas con suma de ramas mejora la fidelidad estructural (SSIM 0,782 vs 0,578) y la información mutua (MI_ir 0,909 vs 0,586) frente al Top-Hat clásico, con significancia estadística (Wilcoxon–Holm).</a:t>
+            </a:r>
+            <a:endParaRPr lang="en-US" sz="1250" dirty="0"/>
+          </a:p>
+        </p:txBody>
+      </p:sp>
+      <p:sp>
+        <p:nvSpPr>
+          <p:cNvPr id="7" name="Text 5"/>
+          <p:cNvSpPr/>
+          <p:nvPr/>
+        </p:nvSpPr>
+        <p:spPr>
+          <a:xfrm>
+            <a:off x="457200" y="2258568"/>
+            <a:ext cx="640080" cy="411480"/>
+          </a:xfrm>
+          <a:prstGeom prst="rect">
+            <a:avLst/>
+          </a:prstGeom>
+          <a:noFill/>
+          <a:ln/>
+        </p:spPr>
+        <p:txBody>
+          <a:bodyPr wrap="square" lIns="0" tIns="0" rIns="0" bIns="0" rtlCol="0" anchor="ctr"/>
+          <a:lstStyle/>
+          <a:p>
+            <a:pPr indent="0" marL="0">
+              <a:buNone/>
+            </a:pPr>
+            <a:r>
+              <a:rPr lang="en-US" sz="1900" b="1" dirty="0">
+                <a:solidFill>
+                  <a:srgbClr val="1A1A1A"/>
+                </a:solidFill>
+                <a:latin typeface="Times New Roman" pitchFamily="34" charset="0"/>
+                <a:ea typeface="Times New Roman" pitchFamily="34" charset="-122"/>
+                <a:cs typeface="Times New Roman" pitchFamily="34" charset="-120"/>
+              </a:rPr>
+              <a:t>H2</a:t>
+            </a:r>
+            <a:endParaRPr lang="en-US" sz="1900" dirty="0"/>
+          </a:p>
+        </p:txBody>
+      </p:sp>
+      <p:sp>
+        <p:nvSpPr>
+          <p:cNvPr id="8" name="Text 6"/>
+          <p:cNvSpPr/>
+          <p:nvPr/>
+        </p:nvSpPr>
+        <p:spPr>
+          <a:xfrm>
+            <a:off x="1143000" y="2295144"/>
+            <a:ext cx="1417320" cy="365760"/>
+          </a:xfrm>
+          <a:prstGeom prst="rect">
+            <a:avLst/>
+          </a:prstGeom>
+          <a:noFill/>
+          <a:ln/>
+        </p:spPr>
+        <p:txBody>
+          <a:bodyPr wrap="square" lIns="0" tIns="0" rIns="0" bIns="0" rtlCol="0" anchor="ctr"/>
+          <a:lstStyle/>
+          <a:p>
+            <a:pPr indent="0" marL="0">
+              <a:buNone/>
+            </a:pPr>
+            <a:r>
+              <a:rPr lang="en-US" sz="1300" b="1" dirty="0">
+                <a:solidFill>
+                  <a:srgbClr val="1F5C2E"/>
+                </a:solidFill>
+                <a:latin typeface="Times New Roman" pitchFamily="34" charset="0"/>
+                <a:ea typeface="Times New Roman" pitchFamily="34" charset="-122"/>
+                <a:cs typeface="Times New Roman" pitchFamily="34" charset="-120"/>
+              </a:rPr>
+              <a:t>SOSTENIDA</a:t>
+            </a:r>
+            <a:endParaRPr lang="en-US" sz="1300" dirty="0"/>
+          </a:p>
+        </p:txBody>
+      </p:sp>
+      <p:sp>
+        <p:nvSpPr>
+          <p:cNvPr id="9" name="Text 7"/>
+          <p:cNvSpPr/>
+          <p:nvPr/>
+        </p:nvSpPr>
+        <p:spPr>
+          <a:xfrm>
+            <a:off x="2697480" y="2258568"/>
+            <a:ext cx="5989320" cy="1143000"/>
+          </a:xfrm>
+          <a:prstGeom prst="rect">
+            <a:avLst/>
+          </a:prstGeom>
+          <a:noFill/>
+          <a:ln/>
+        </p:spPr>
+        <p:txBody>
+          <a:bodyPr wrap="square" lIns="0" tIns="0" rIns="0" bIns="0" rtlCol="0" anchor="t"/>
+          <a:lstStyle/>
+          <a:p>
+            <a:pPr indent="0" marL="0">
+              <a:buNone/>
+            </a:pPr>
+            <a:r>
+              <a:rPr lang="en-US" sz="1250" dirty="0">
+                <a:solidFill>
+                  <a:srgbClr val="1A1A1A"/>
+                </a:solidFill>
+                <a:latin typeface="Times New Roman" pitchFamily="34" charset="0"/>
+                <a:ea typeface="Times New Roman" pitchFamily="34" charset="-122"/>
+                <a:cs typeface="Times New Roman" pitchFamily="34" charset="-120"/>
+              </a:rPr>
+              <a:t>La configuración hallada por PSO (r = 25; m = 0,0703) supera a la parametrización manual del operador clásico (r = 5; m = 1) en todas las métricas de calidad de fusión.</a:t>
+            </a:r>
+            <a:endParaRPr lang="en-US" sz="1250" dirty="0"/>
+          </a:p>
+        </p:txBody>
+      </p:sp>
+      <p:sp>
+        <p:nvSpPr>
+          <p:cNvPr id="10" name="Text 8"/>
+          <p:cNvSpPr/>
+          <p:nvPr/>
+        </p:nvSpPr>
+        <p:spPr>
+          <a:xfrm>
+            <a:off x="457200" y="3557016"/>
+            <a:ext cx="640080" cy="411480"/>
+          </a:xfrm>
+          <a:prstGeom prst="rect">
+            <a:avLst/>
+          </a:prstGeom>
+          <a:noFill/>
+          <a:ln/>
+        </p:spPr>
+        <p:txBody>
+          <a:bodyPr wrap="square" lIns="0" tIns="0" rIns="0" bIns="0" rtlCol="0" anchor="ctr"/>
+          <a:lstStyle/>
+          <a:p>
+            <a:pPr indent="0" marL="0">
+              <a:buNone/>
+            </a:pPr>
+            <a:r>
+              <a:rPr lang="en-US" sz="1900" b="1" dirty="0">
+                <a:solidFill>
+                  <a:srgbClr val="1A1A1A"/>
+                </a:solidFill>
+                <a:latin typeface="Times New Roman" pitchFamily="34" charset="0"/>
+                <a:ea typeface="Times New Roman" pitchFamily="34" charset="-122"/>
+                <a:cs typeface="Times New Roman" pitchFamily="34" charset="-120"/>
+              </a:rPr>
+              <a:t>H3</a:t>
+            </a:r>
+            <a:endParaRPr lang="en-US" sz="1900" dirty="0"/>
+          </a:p>
+        </p:txBody>
+      </p:sp>
+      <p:sp>
+        <p:nvSpPr>
+          <p:cNvPr id="11" name="Text 9"/>
+          <p:cNvSpPr/>
+          <p:nvPr/>
+        </p:nvSpPr>
+        <p:spPr>
+          <a:xfrm>
+            <a:off x="1143000" y="3593592"/>
+            <a:ext cx="1417320" cy="365760"/>
+          </a:xfrm>
+          <a:prstGeom prst="rect">
+            <a:avLst/>
+          </a:prstGeom>
+          <a:noFill/>
+          <a:ln/>
+        </p:spPr>
+        <p:txBody>
+          <a:bodyPr wrap="square" lIns="0" tIns="0" rIns="0" bIns="0" rtlCol="0" anchor="ctr"/>
+          <a:lstStyle/>
+          <a:p>
+            <a:pPr indent="0" marL="0">
+              <a:buNone/>
+            </a:pPr>
+            <a:r>
+              <a:rPr lang="en-US" sz="1300" b="1" dirty="0">
+                <a:solidFill>
+                  <a:srgbClr val="8B1A1A"/>
+                </a:solidFill>
+                <a:latin typeface="Times New Roman" pitchFamily="34" charset="0"/>
+                <a:ea typeface="Times New Roman" pitchFamily="34" charset="-122"/>
+                <a:cs typeface="Times New Roman" pitchFamily="34" charset="-120"/>
+              </a:rPr>
+              <a:t>PARCIAL</a:t>
+            </a:r>
+            <a:endParaRPr lang="en-US" sz="1300" dirty="0"/>
+          </a:p>
+        </p:txBody>
+      </p:sp>
+      <p:sp>
+        <p:nvSpPr>
+          <p:cNvPr id="12" name="Text 10"/>
+          <p:cNvSpPr/>
+          <p:nvPr/>
+        </p:nvSpPr>
+        <p:spPr>
+          <a:xfrm>
+            <a:off x="2697480" y="3557016"/>
+            <a:ext cx="5989320" cy="1143000"/>
+          </a:xfrm>
+          <a:prstGeom prst="rect">
+            <a:avLst/>
+          </a:prstGeom>
+          <a:noFill/>
+          <a:ln/>
+        </p:spPr>
+        <p:txBody>
+          <a:bodyPr wrap="square" lIns="0" tIns="0" rIns="0" bIns="0" rtlCol="0" anchor="t"/>
+          <a:lstStyle/>
+          <a:p>
+            <a:pPr indent="0" marL="0">
+              <a:buNone/>
+            </a:pPr>
+            <a:r>
+              <a:rPr lang="en-US" sz="1250" dirty="0">
+                <a:solidFill>
+                  <a:srgbClr val="1A1A1A"/>
+                </a:solidFill>
+                <a:latin typeface="Times New Roman" pitchFamily="34" charset="0"/>
+                <a:ea typeface="Times New Roman" pitchFamily="34" charset="-122"/>
+                <a:cs typeface="Times New Roman" pitchFamily="34" charset="-120"/>
+              </a:rPr>
+              <a:t>La fusión supera al visible solo en detección, pero ninguna fusión supera al infrarrojo solo; la mejor calidad de imagen no garantiza el mejor mAP.</a:t>
+            </a:r>
+            <a:endParaRPr lang="en-US" sz="1250" dirty="0"/>
           </a:p>
         </p:txBody>
       </p:sp>
@@ -7737,7 +7730,7 @@
                 <a:ea typeface="Times New Roman" pitchFamily="34" charset="-122"/>
                 <a:cs typeface="Times New Roman" pitchFamily="34" charset="-120"/>
               </a:rPr>
-              <a:t>Contraste de hipótesis</a:t>
+              <a:t>9. Conclusiones</a:t>
             </a:r>
             <a:endParaRPr lang="en-US" sz="2300" dirty="0"/>
           </a:p>
@@ -7776,7 +7769,7 @@
                 <a:ea typeface="Times New Roman" pitchFamily="34" charset="-122"/>
                 <a:cs typeface="Times New Roman" pitchFamily="34" charset="-120"/>
               </a:rPr>
-              <a:t>17 / 20</a:t>
+              <a:t>17 / 19</a:t>
             </a:r>
             <a:endParaRPr lang="en-US" sz="900" dirty="0"/>
           </a:p>
@@ -7790,8 +7783,8 @@
         </p:nvSpPr>
         <p:spPr>
           <a:xfrm>
-            <a:off x="457200" y="960120"/>
-            <a:ext cx="640080" cy="411480"/>
+            <a:off x="457200" y="914400"/>
+            <a:ext cx="8229600" cy="3931920"/>
           </a:xfrm>
           <a:prstGeom prst="rect">
             <a:avLst/>
@@ -7800,14 +7793,18 @@
           <a:ln/>
         </p:spPr>
         <p:txBody>
-          <a:bodyPr wrap="square" lIns="0" tIns="0" rIns="0" bIns="0" rtlCol="0" anchor="ctr"/>
-          <a:lstStyle/>
-          <a:p>
-            <a:pPr indent="0" marL="0">
-              <a:buNone/>
-            </a:pPr>
-            <a:r>
-              <a:rPr lang="en-US" sz="1900" b="1" dirty="0">
+          <a:bodyPr wrap="square" lIns="0" tIns="0" rIns="0" bIns="0" rtlCol="0" anchor="t"/>
+          <a:lstStyle/>
+          <a:p>
+            <a:pPr marL="177800" indent="-177800">
+              <a:spcAft>
+                <a:spcPts val="1100"/>
+              </a:spcAft>
+              <a:buSzPct val="100000"/>
+              <a:buChar char="•"/>
+            </a:pPr>
+            <a:r>
+              <a:rPr lang="en-US" sz="1350" dirty="0">
                 <a:solidFill>
                   <a:srgbClr val="1A1A1A"/>
                 </a:solidFill>
@@ -7815,77 +7812,20 @@
                 <a:ea typeface="Times New Roman" pitchFamily="34" charset="-122"/>
                 <a:cs typeface="Times New Roman" pitchFamily="34" charset="-120"/>
               </a:rPr>
-              <a:t>H1</a:t>
-            </a:r>
-            <a:endParaRPr lang="en-US" sz="1900" dirty="0"/>
-          </a:p>
-        </p:txBody>
-      </p:sp>
-      <p:sp>
-        <p:nvSpPr>
-          <p:cNvPr id="5" name="Text 3"/>
-          <p:cNvSpPr/>
-          <p:nvPr/>
-        </p:nvSpPr>
-        <p:spPr>
-          <a:xfrm>
-            <a:off x="1143000" y="996696"/>
-            <a:ext cx="1417320" cy="365760"/>
-          </a:xfrm>
-          <a:prstGeom prst="rect">
-            <a:avLst/>
-          </a:prstGeom>
-          <a:noFill/>
-          <a:ln/>
-        </p:spPr>
-        <p:txBody>
-          <a:bodyPr wrap="square" lIns="0" tIns="0" rIns="0" bIns="0" rtlCol="0" anchor="ctr"/>
-          <a:lstStyle/>
-          <a:p>
-            <a:pPr indent="0" marL="0">
-              <a:buNone/>
-            </a:pPr>
-            <a:r>
-              <a:rPr lang="en-US" sz="1300" b="1" dirty="0">
-                <a:solidFill>
-                  <a:srgbClr val="1F5C2E"/>
-                </a:solidFill>
-                <a:latin typeface="Times New Roman" pitchFamily="34" charset="0"/>
-                <a:ea typeface="Times New Roman" pitchFamily="34" charset="-122"/>
-                <a:cs typeface="Times New Roman" pitchFamily="34" charset="-120"/>
-              </a:rPr>
-              <a:t>SOSTENIDA</a:t>
-            </a:r>
-            <a:endParaRPr lang="en-US" sz="1300" dirty="0"/>
-          </a:p>
-        </p:txBody>
-      </p:sp>
-      <p:sp>
-        <p:nvSpPr>
-          <p:cNvPr id="6" name="Text 4"/>
-          <p:cNvSpPr/>
-          <p:nvPr/>
-        </p:nvSpPr>
-        <p:spPr>
-          <a:xfrm>
-            <a:off x="2697480" y="960120"/>
-            <a:ext cx="5989320" cy="1143000"/>
-          </a:xfrm>
-          <a:prstGeom prst="rect">
-            <a:avLst/>
-          </a:prstGeom>
-          <a:noFill/>
-          <a:ln/>
-        </p:spPr>
-        <p:txBody>
-          <a:bodyPr wrap="square" lIns="0" tIns="0" rIns="0" bIns="0" rtlCol="0" anchor="t"/>
-          <a:lstStyle/>
-          <a:p>
-            <a:pPr indent="0" marL="0">
-              <a:buNone/>
-            </a:pPr>
-            <a:r>
-              <a:rPr lang="en-US" sz="1250" dirty="0">
+              <a:t>Se formuló e implementó de forma reproducible un operador Top-Hat de una sola escala con banco de disco + líneas orientadas y suma de ramas.</a:t>
+            </a:r>
+            <a:endParaRPr lang="en-US" sz="1350" dirty="0"/>
+          </a:p>
+          <a:p>
+            <a:pPr marL="177800" indent="-177800">
+              <a:spcAft>
+                <a:spcPts val="1100"/>
+              </a:spcAft>
+              <a:buSzPct val="100000"/>
+              <a:buChar char="•"/>
+            </a:pPr>
+            <a:r>
+              <a:rPr lang="en-US" sz="1350" dirty="0">
                 <a:solidFill>
                   <a:srgbClr val="1A1A1A"/>
                 </a:solidFill>
@@ -7893,38 +7833,20 @@
                 <a:ea typeface="Times New Roman" pitchFamily="34" charset="-122"/>
                 <a:cs typeface="Times New Roman" pitchFamily="34" charset="-120"/>
               </a:rPr>
-              <a:t>El banco disco + líneas con suma de ramas mejora SSIM (0,782 vs 0,578) y reduce Nabf (0,041 vs 0,585) frente al Top-Hat clásico, con significancia estadística (Wilcoxon–Holm).</a:t>
-            </a:r>
-            <a:endParaRPr lang="en-US" sz="1250" dirty="0"/>
-          </a:p>
-        </p:txBody>
-      </p:sp>
-      <p:sp>
-        <p:nvSpPr>
-          <p:cNvPr id="7" name="Text 5"/>
-          <p:cNvSpPr/>
-          <p:nvPr/>
-        </p:nvSpPr>
-        <p:spPr>
-          <a:xfrm>
-            <a:off x="457200" y="2258568"/>
-            <a:ext cx="640080" cy="411480"/>
-          </a:xfrm>
-          <a:prstGeom prst="rect">
-            <a:avLst/>
-          </a:prstGeom>
-          <a:noFill/>
-          <a:ln/>
-        </p:spPr>
-        <p:txBody>
-          <a:bodyPr wrap="square" lIns="0" tIns="0" rIns="0" bIns="0" rtlCol="0" anchor="ctr"/>
-          <a:lstStyle/>
-          <a:p>
-            <a:pPr indent="0" marL="0">
-              <a:buNone/>
-            </a:pPr>
-            <a:r>
-              <a:rPr lang="en-US" sz="1900" b="1" dirty="0">
+              <a:t>El barrido PSO de 25 configuraciones (aptitud publicada F_o) halló el óptimo r = 25, m ≈ 0,07 (F_o = 1,7654) de manera consistente.</a:t>
+            </a:r>
+            <a:endParaRPr lang="en-US" sz="1350" dirty="0"/>
+          </a:p>
+          <a:p>
+            <a:pPr marL="177800" indent="-177800">
+              <a:spcAft>
+                <a:spcPts val="1100"/>
+              </a:spcAft>
+              <a:buSzPct val="100000"/>
+              <a:buChar char="•"/>
+            </a:pPr>
+            <a:r>
+              <a:rPr lang="en-US" sz="1350" dirty="0">
                 <a:solidFill>
                   <a:srgbClr val="1A1A1A"/>
                 </a:solidFill>
@@ -7932,77 +7854,20 @@
                 <a:ea typeface="Times New Roman" pitchFamily="34" charset="-122"/>
                 <a:cs typeface="Times New Roman" pitchFamily="34" charset="-120"/>
               </a:rPr>
-              <a:t>H2</a:t>
-            </a:r>
-            <a:endParaRPr lang="en-US" sz="1900" dirty="0"/>
-          </a:p>
-        </p:txBody>
-      </p:sp>
-      <p:sp>
-        <p:nvSpPr>
-          <p:cNvPr id="8" name="Text 6"/>
-          <p:cNvSpPr/>
-          <p:nvPr/>
-        </p:nvSpPr>
-        <p:spPr>
-          <a:xfrm>
-            <a:off x="1143000" y="2295144"/>
-            <a:ext cx="1417320" cy="365760"/>
-          </a:xfrm>
-          <a:prstGeom prst="rect">
-            <a:avLst/>
-          </a:prstGeom>
-          <a:noFill/>
-          <a:ln/>
-        </p:spPr>
-        <p:txBody>
-          <a:bodyPr wrap="square" lIns="0" tIns="0" rIns="0" bIns="0" rtlCol="0" anchor="ctr"/>
-          <a:lstStyle/>
-          <a:p>
-            <a:pPr indent="0" marL="0">
-              <a:buNone/>
-            </a:pPr>
-            <a:r>
-              <a:rPr lang="en-US" sz="1300" b="1" dirty="0">
-                <a:solidFill>
-                  <a:srgbClr val="1F5C2E"/>
-                </a:solidFill>
-                <a:latin typeface="Times New Roman" pitchFamily="34" charset="0"/>
-                <a:ea typeface="Times New Roman" pitchFamily="34" charset="-122"/>
-                <a:cs typeface="Times New Roman" pitchFamily="34" charset="-120"/>
-              </a:rPr>
-              <a:t>SOSTENIDA</a:t>
-            </a:r>
-            <a:endParaRPr lang="en-US" sz="1300" dirty="0"/>
-          </a:p>
-        </p:txBody>
-      </p:sp>
-      <p:sp>
-        <p:nvSpPr>
-          <p:cNvPr id="9" name="Text 7"/>
-          <p:cNvSpPr/>
-          <p:nvPr/>
-        </p:nvSpPr>
-        <p:spPr>
-          <a:xfrm>
-            <a:off x="2697480" y="2258568"/>
-            <a:ext cx="5989320" cy="1143000"/>
-          </a:xfrm>
-          <a:prstGeom prst="rect">
-            <a:avLst/>
-          </a:prstGeom>
-          <a:noFill/>
-          <a:ln/>
-        </p:spPr>
-        <p:txBody>
-          <a:bodyPr wrap="square" lIns="0" tIns="0" rIns="0" bIns="0" rtlCol="0" anchor="t"/>
-          <a:lstStyle/>
-          <a:p>
-            <a:pPr indent="0" marL="0">
-              <a:buNone/>
-            </a:pPr>
-            <a:r>
-              <a:rPr lang="en-US" sz="1250" dirty="0">
+              <a:t>La propuesta alcanza la mayor similitud estructural del benchmark (SSIM 0,782, significativa frente a los 5 métodos del estado del arte) y es segunda en información mutua con las fuentes.</a:t>
+            </a:r>
+            <a:endParaRPr lang="en-US" sz="1350" dirty="0"/>
+          </a:p>
+          <a:p>
+            <a:pPr marL="177800" indent="-177800">
+              <a:spcAft>
+                <a:spcPts val="1100"/>
+              </a:spcAft>
+              <a:buSzPct val="100000"/>
+              <a:buChar char="•"/>
+            </a:pPr>
+            <a:r>
+              <a:rPr lang="en-US" sz="1350" dirty="0">
                 <a:solidFill>
                   <a:srgbClr val="1A1A1A"/>
                 </a:solidFill>
@@ -8010,38 +7875,20 @@
                 <a:ea typeface="Times New Roman" pitchFamily="34" charset="-122"/>
                 <a:cs typeface="Times New Roman" pitchFamily="34" charset="-120"/>
               </a:rPr>
-              <a:t>La configuración hallada por PSO (r = 25; m = 0,0703) supera a la parametrización manual del operador clásico (r = 5; m = 1) en todas las métricas de calidad de fusión.</a:t>
-            </a:r>
-            <a:endParaRPr lang="en-US" sz="1250" dirty="0"/>
-          </a:p>
-        </p:txBody>
-      </p:sp>
-      <p:sp>
-        <p:nvSpPr>
-          <p:cNvPr id="10" name="Text 8"/>
-          <p:cNvSpPr/>
-          <p:nvPr/>
-        </p:nvSpPr>
-        <p:spPr>
-          <a:xfrm>
-            <a:off x="457200" y="3557016"/>
-            <a:ext cx="640080" cy="411480"/>
-          </a:xfrm>
-          <a:prstGeom prst="rect">
-            <a:avLst/>
-          </a:prstGeom>
-          <a:noFill/>
-          <a:ln/>
-        </p:spPr>
-        <p:txBody>
-          <a:bodyPr wrap="square" lIns="0" tIns="0" rIns="0" bIns="0" rtlCol="0" anchor="ctr"/>
-          <a:lstStyle/>
-          <a:p>
-            <a:pPr indent="0" marL="0">
-              <a:buNone/>
-            </a:pPr>
-            <a:r>
-              <a:rPr lang="en-US" sz="1900" b="1" dirty="0">
+              <a:t>Frente a la metodología clásica Top-Hat, el banco de SE y el ajuste automático elevan la fidelidad estructural y la información mutua con significancia estadística.</a:t>
+            </a:r>
+            <a:endParaRPr lang="en-US" sz="1350" dirty="0"/>
+          </a:p>
+          <a:p>
+            <a:pPr marL="177800" indent="-177800">
+              <a:spcAft>
+                <a:spcPts val="1100"/>
+              </a:spcAft>
+              <a:buSzPct val="100000"/>
+              <a:buChar char="•"/>
+            </a:pPr>
+            <a:r>
+              <a:rPr lang="en-US" sz="1350" dirty="0">
                 <a:solidFill>
                   <a:srgbClr val="1A1A1A"/>
                 </a:solidFill>
@@ -8049,87 +7896,9 @@
                 <a:ea typeface="Times New Roman" pitchFamily="34" charset="-122"/>
                 <a:cs typeface="Times New Roman" pitchFamily="34" charset="-120"/>
               </a:rPr>
-              <a:t>H3</a:t>
-            </a:r>
-            <a:endParaRPr lang="en-US" sz="1900" dirty="0"/>
-          </a:p>
-        </p:txBody>
-      </p:sp>
-      <p:sp>
-        <p:nvSpPr>
-          <p:cNvPr id="11" name="Text 9"/>
-          <p:cNvSpPr/>
-          <p:nvPr/>
-        </p:nvSpPr>
-        <p:spPr>
-          <a:xfrm>
-            <a:off x="1143000" y="3593592"/>
-            <a:ext cx="1417320" cy="365760"/>
-          </a:xfrm>
-          <a:prstGeom prst="rect">
-            <a:avLst/>
-          </a:prstGeom>
-          <a:noFill/>
-          <a:ln/>
-        </p:spPr>
-        <p:txBody>
-          <a:bodyPr wrap="square" lIns="0" tIns="0" rIns="0" bIns="0" rtlCol="0" anchor="ctr"/>
-          <a:lstStyle/>
-          <a:p>
-            <a:pPr indent="0" marL="0">
-              <a:buNone/>
-            </a:pPr>
-            <a:r>
-              <a:rPr lang="en-US" sz="1300" b="1" dirty="0">
-                <a:solidFill>
-                  <a:srgbClr val="8B1A1A"/>
-                </a:solidFill>
-                <a:latin typeface="Times New Roman" pitchFamily="34" charset="0"/>
-                <a:ea typeface="Times New Roman" pitchFamily="34" charset="-122"/>
-                <a:cs typeface="Times New Roman" pitchFamily="34" charset="-120"/>
-              </a:rPr>
-              <a:t>PARCIAL</a:t>
-            </a:r>
-            <a:endParaRPr lang="en-US" sz="1300" dirty="0"/>
-          </a:p>
-        </p:txBody>
-      </p:sp>
-      <p:sp>
-        <p:nvSpPr>
-          <p:cNvPr id="12" name="Text 10"/>
-          <p:cNvSpPr/>
-          <p:nvPr/>
-        </p:nvSpPr>
-        <p:spPr>
-          <a:xfrm>
-            <a:off x="2697480" y="3557016"/>
-            <a:ext cx="5989320" cy="1143000"/>
-          </a:xfrm>
-          <a:prstGeom prst="rect">
-            <a:avLst/>
-          </a:prstGeom>
-          <a:noFill/>
-          <a:ln/>
-        </p:spPr>
-        <p:txBody>
-          <a:bodyPr wrap="square" lIns="0" tIns="0" rIns="0" bIns="0" rtlCol="0" anchor="t"/>
-          <a:lstStyle/>
-          <a:p>
-            <a:pPr indent="0" marL="0">
-              <a:buNone/>
-            </a:pPr>
-            <a:r>
-              <a:rPr lang="en-US" sz="1250" dirty="0">
-                <a:solidFill>
-                  <a:srgbClr val="1A1A1A"/>
-                </a:solidFill>
-                <a:latin typeface="Times New Roman" pitchFamily="34" charset="0"/>
-                <a:ea typeface="Times New Roman" pitchFamily="34" charset="-122"/>
-                <a:cs typeface="Times New Roman" pitchFamily="34" charset="-120"/>
-              </a:rPr>
-              <a:t>La fusión supera al visible solo en detección, pero ninguna fusión supera al infrarrojo solo; la mejor calidad de imagen no garantiza el mejor mAP.</a:t>
-            </a:r>
-            <a:endParaRPr lang="en-US" sz="1250" dirty="0"/>
+              <a:t>Aporte central en detección (M3FD): la fusión detecta en una sola imagen los objetos complementarios —personas (solo en IR) y luces (solo en VIS)— que ninguna modalidad capta por separado; la propuesta es la mejor fusión del estudio.</a:t>
+            </a:r>
+            <a:endParaRPr lang="en-US" sz="1350" dirty="0"/>
           </a:p>
         </p:txBody>
       </p:sp>
@@ -8198,7 +7967,7 @@
                 <a:ea typeface="Times New Roman" pitchFamily="34" charset="-122"/>
                 <a:cs typeface="Times New Roman" pitchFamily="34" charset="-120"/>
               </a:rPr>
-              <a:t>9. Conclusiones</a:t>
+              <a:t>Recomendaciones y trabajo futuro</a:t>
             </a:r>
             <a:endParaRPr lang="en-US" sz="2300" dirty="0"/>
           </a:p>
@@ -8237,7 +8006,7 @@
                 <a:ea typeface="Times New Roman" pitchFamily="34" charset="-122"/>
                 <a:cs typeface="Times New Roman" pitchFamily="34" charset="-120"/>
               </a:rPr>
-              <a:t>18 / 20</a:t>
+              <a:t>18 / 19</a:t>
             </a:r>
             <a:endParaRPr lang="en-US" sz="900" dirty="0"/>
           </a:p>
@@ -8280,7 +8049,7 @@
                 <a:ea typeface="Times New Roman" pitchFamily="34" charset="-122"/>
                 <a:cs typeface="Times New Roman" pitchFamily="34" charset="-120"/>
               </a:rPr>
-              <a:t>Se formuló e implementó de forma reproducible un operador Top-Hat de una sola escala con banco de disco + líneas orientadas y suma de ramas.</a:t>
+              <a:t>Extender la evaluación de detección a otros detectores y al conjunto completo de LLVIP.</a:t>
             </a:r>
             <a:endParaRPr lang="en-US" sz="1350" dirty="0"/>
           </a:p>
@@ -8301,7 +8070,7 @@
                 <a:ea typeface="Times New Roman" pitchFamily="34" charset="-122"/>
                 <a:cs typeface="Times New Roman" pitchFamily="34" charset="-120"/>
               </a:rPr>
-              <a:t>El barrido PSO de 25 configuraciones halló el óptimo r = 25, m = 0,0703 (F = 1,9843) de manera consistente.</a:t>
+              <a:t>Explorar reglas de fusión adaptativas para la rama Black Top-Hat.</a:t>
             </a:r>
             <a:endParaRPr lang="en-US" sz="1350" dirty="0"/>
           </a:p>
@@ -8322,7 +8091,7 @@
                 <a:ea typeface="Times New Roman" pitchFamily="34" charset="-122"/>
                 <a:cs typeface="Times New Roman" pitchFamily="34" charset="-120"/>
               </a:rPr>
-              <a:t>La propuesta exhibe el mejor perfil de calidad del benchmark: menor Nabf y mayor SSIM, con significancia estadística; segunda en Qabf, SCD y VIF.</a:t>
+              <a:t>Complementar las métricas objetivas con una validación perceptual por observadores.</a:t>
             </a:r>
             <a:endParaRPr lang="en-US" sz="1350" dirty="0"/>
           </a:p>
@@ -8343,7 +8112,7 @@
                 <a:ea typeface="Times New Roman" pitchFamily="34" charset="-122"/>
                 <a:cs typeface="Times New Roman" pitchFamily="34" charset="-120"/>
               </a:rPr>
-              <a:t>Frente a la metodología clásica Top-Hat, mejora todas las métricas de calidad de fusión: el banco de SE y el ajuste automático aportan valor real.</a:t>
+              <a:t>Evaluar la transferencia a otros dominios (imágenes médicas, aéreas).</a:t>
             </a:r>
             <a:endParaRPr lang="en-US" sz="1350" dirty="0"/>
           </a:p>
@@ -8364,7 +8133,7 @@
                 <a:ea typeface="Times New Roman" pitchFamily="34" charset="-122"/>
                 <a:cs typeface="Times New Roman" pitchFamily="34" charset="-120"/>
               </a:rPr>
-              <a:t>En detección, la superioridad en calidad de imagen no se traslada automáticamente al mAP: la elección del método debe guiarse por el criterio operativo prioritario.</a:t>
+              <a:t>Para aplicaciones donde prima la fidelidad estructural a las fuentes y la detección de objetos complementarios, la propuesta es la opción recomendada; donde prima el contraste bruto, LP y el Top-Hat clásico siguen siendo competitivos.</a:t>
             </a:r>
             <a:endParaRPr lang="en-US" sz="1350" dirty="0"/>
           </a:p>
@@ -8410,8 +8179,8 @@
         </p:nvSpPr>
         <p:spPr>
           <a:xfrm>
-            <a:off x="457200" y="256032"/>
-            <a:ext cx="8229600" cy="502920"/>
+            <a:off x="457200" y="1828800"/>
+            <a:ext cx="8229600" cy="731520"/>
           </a:xfrm>
           <a:prstGeom prst="rect">
             <a:avLst/>
@@ -8423,11 +8192,11 @@
           <a:bodyPr wrap="square" lIns="0" tIns="0" rIns="0" bIns="0" rtlCol="0" anchor="ctr"/>
           <a:lstStyle/>
           <a:p>
-            <a:pPr indent="0" marL="0">
+            <a:pPr algn="ctr" indent="0" marL="0">
               <a:buNone/>
             </a:pPr>
             <a:r>
-              <a:rPr lang="en-US" sz="2300" b="1" dirty="0">
+              <a:rPr lang="en-US" sz="3400" b="1" dirty="0">
                 <a:solidFill>
                   <a:srgbClr val="1A1A1A"/>
                 </a:solidFill>
@@ -8435,9 +8204,9 @@
                 <a:ea typeface="Times New Roman" pitchFamily="34" charset="-122"/>
                 <a:cs typeface="Times New Roman" pitchFamily="34" charset="-120"/>
               </a:rPr>
-              <a:t>Recomendaciones y trabajo futuro</a:t>
-            </a:r>
-            <a:endParaRPr lang="en-US" sz="2300" dirty="0"/>
+              <a:t>Muchas gracias</a:t>
+            </a:r>
+            <a:endParaRPr lang="en-US" sz="3400" dirty="0"/>
           </a:p>
         </p:txBody>
       </p:sp>
@@ -8449,8 +8218,8 @@
         </p:nvSpPr>
         <p:spPr>
           <a:xfrm>
-            <a:off x="8229600" y="4828032"/>
-            <a:ext cx="685800" cy="274320"/>
+            <a:off x="457200" y="2606040"/>
+            <a:ext cx="8229600" cy="365760"/>
           </a:xfrm>
           <a:prstGeom prst="rect">
             <a:avLst/>
@@ -8462,11 +8231,11 @@
           <a:bodyPr wrap="square" lIns="0" tIns="0" rIns="0" bIns="0" rtlCol="0" anchor="ctr"/>
           <a:lstStyle/>
           <a:p>
-            <a:pPr algn="r" indent="0" marL="0">
+            <a:pPr algn="ctr" indent="0" marL="0">
               <a:buNone/>
             </a:pPr>
             <a:r>
-              <a:rPr lang="en-US" sz="900" dirty="0">
+              <a:rPr lang="en-US" sz="1500" i="1" dirty="0">
                 <a:solidFill>
                   <a:srgbClr val="666666"/>
                 </a:solidFill>
@@ -8474,9 +8243,9 @@
                 <a:ea typeface="Times New Roman" pitchFamily="34" charset="-122"/>
                 <a:cs typeface="Times New Roman" pitchFamily="34" charset="-120"/>
               </a:rPr>
-              <a:t>19 / 20</a:t>
-            </a:r>
-            <a:endParaRPr lang="en-US" sz="900" dirty="0"/>
+              <a:t>Preguntas y comentarios</a:t>
+            </a:r>
+            <a:endParaRPr lang="en-US" sz="1500" dirty="0"/>
           </a:p>
         </p:txBody>
       </p:sp>
@@ -8488,8 +8257,8 @@
         </p:nvSpPr>
         <p:spPr>
           <a:xfrm>
-            <a:off x="457200" y="914400"/>
-            <a:ext cx="8229600" cy="3931920"/>
+            <a:off x="457200" y="3383280"/>
+            <a:ext cx="8229600" cy="320040"/>
           </a:xfrm>
           <a:prstGeom prst="rect">
             <a:avLst/>
@@ -8498,112 +8267,63 @@
           <a:ln/>
         </p:spPr>
         <p:txBody>
-          <a:bodyPr wrap="square" lIns="0" tIns="0" rIns="0" bIns="0" rtlCol="0" anchor="t"/>
-          <a:lstStyle/>
-          <a:p>
-            <a:pPr marL="177800" indent="-177800">
-              <a:spcAft>
-                <a:spcPts val="1100"/>
-              </a:spcAft>
-              <a:buSzPct val="100000"/>
-              <a:buChar char="•"/>
-            </a:pPr>
-            <a:r>
-              <a:rPr lang="en-US" sz="1350" dirty="0">
-                <a:solidFill>
-                  <a:srgbClr val="1A1A1A"/>
-                </a:solidFill>
-                <a:latin typeface="Times New Roman" pitchFamily="34" charset="0"/>
-                <a:ea typeface="Times New Roman" pitchFamily="34" charset="-122"/>
-                <a:cs typeface="Times New Roman" pitchFamily="34" charset="-120"/>
-              </a:rPr>
-              <a:t>Extender la evaluación de detección a otros detectores y al conjunto completo de LLVIP.</a:t>
-            </a:r>
-            <a:endParaRPr lang="en-US" sz="1350" dirty="0"/>
-          </a:p>
-          <a:p>
-            <a:pPr marL="177800" indent="-177800">
-              <a:spcAft>
-                <a:spcPts val="1100"/>
-              </a:spcAft>
-              <a:buSzPct val="100000"/>
-              <a:buChar char="•"/>
-            </a:pPr>
-            <a:r>
-              <a:rPr lang="en-US" sz="1350" dirty="0">
-                <a:solidFill>
-                  <a:srgbClr val="1A1A1A"/>
-                </a:solidFill>
-                <a:latin typeface="Times New Roman" pitchFamily="34" charset="0"/>
-                <a:ea typeface="Times New Roman" pitchFamily="34" charset="-122"/>
-                <a:cs typeface="Times New Roman" pitchFamily="34" charset="-120"/>
-              </a:rPr>
-              <a:t>Explorar reglas de fusión adaptativas para la rama Black Top-Hat.</a:t>
-            </a:r>
-            <a:endParaRPr lang="en-US" sz="1350" dirty="0"/>
-          </a:p>
-          <a:p>
-            <a:pPr marL="177800" indent="-177800">
-              <a:spcAft>
-                <a:spcPts val="1100"/>
-              </a:spcAft>
-              <a:buSzPct val="100000"/>
-              <a:buChar char="•"/>
-            </a:pPr>
-            <a:r>
-              <a:rPr lang="en-US" sz="1350" dirty="0">
-                <a:solidFill>
-                  <a:srgbClr val="1A1A1A"/>
-                </a:solidFill>
-                <a:latin typeface="Times New Roman" pitchFamily="34" charset="0"/>
-                <a:ea typeface="Times New Roman" pitchFamily="34" charset="-122"/>
-                <a:cs typeface="Times New Roman" pitchFamily="34" charset="-120"/>
-              </a:rPr>
-              <a:t>Complementar las métricas objetivas con una validación perceptual por observadores.</a:t>
-            </a:r>
-            <a:endParaRPr lang="en-US" sz="1350" dirty="0"/>
-          </a:p>
-          <a:p>
-            <a:pPr marL="177800" indent="-177800">
-              <a:spcAft>
-                <a:spcPts val="1100"/>
-              </a:spcAft>
-              <a:buSzPct val="100000"/>
-              <a:buChar char="•"/>
-            </a:pPr>
-            <a:r>
-              <a:rPr lang="en-US" sz="1350" dirty="0">
-                <a:solidFill>
-                  <a:srgbClr val="1A1A1A"/>
-                </a:solidFill>
-                <a:latin typeface="Times New Roman" pitchFamily="34" charset="0"/>
-                <a:ea typeface="Times New Roman" pitchFamily="34" charset="-122"/>
-                <a:cs typeface="Times New Roman" pitchFamily="34" charset="-120"/>
-              </a:rPr>
-              <a:t>Evaluar la transferencia a otros dominios (imágenes médicas, aéreas).</a:t>
-            </a:r>
-            <a:endParaRPr lang="en-US" sz="1350" dirty="0"/>
-          </a:p>
-          <a:p>
-            <a:pPr marL="177800" indent="-177800">
-              <a:spcAft>
-                <a:spcPts val="1100"/>
-              </a:spcAft>
-              <a:buSzPct val="100000"/>
-              <a:buChar char="•"/>
-            </a:pPr>
-            <a:r>
-              <a:rPr lang="en-US" sz="1350" dirty="0">
-                <a:solidFill>
-                  <a:srgbClr val="1A1A1A"/>
-                </a:solidFill>
-                <a:latin typeface="Times New Roman" pitchFamily="34" charset="0"/>
-                <a:ea typeface="Times New Roman" pitchFamily="34" charset="-122"/>
-                <a:cs typeface="Times New Roman" pitchFamily="34" charset="-120"/>
-              </a:rPr>
-              <a:t>Para aplicaciones donde los artefactos son críticos (interpretación humana, diagnóstico), la propuesta es la opción recomendada; donde prima el contraste bruto, LP sigue siendo competitiva.</a:t>
-            </a:r>
-            <a:endParaRPr lang="en-US" sz="1350" dirty="0"/>
+          <a:bodyPr wrap="square" lIns="0" tIns="0" rIns="0" bIns="0" rtlCol="0" anchor="ctr"/>
+          <a:lstStyle/>
+          <a:p>
+            <a:pPr algn="ctr" indent="0" marL="0">
+              <a:buNone/>
+            </a:pPr>
+            <a:r>
+              <a:rPr lang="en-US" sz="1200" dirty="0">
+                <a:solidFill>
+                  <a:srgbClr val="8B1A1A"/>
+                </a:solidFill>
+                <a:latin typeface="Times New Roman" pitchFamily="34" charset="0"/>
+                <a:ea typeface="Times New Roman" pitchFamily="34" charset="-122"/>
+                <a:cs typeface="Times New Roman" pitchFamily="34" charset="-120"/>
+              </a:rPr>
+              <a:t>Código y experimentos reproducibles:  github.com/YanBajac/TFM_Fusion_Imagenes_Propuesta_Oficial</a:t>
+            </a:r>
+            <a:endParaRPr lang="en-US" sz="1200" dirty="0"/>
+          </a:p>
+        </p:txBody>
+      </p:sp>
+      <p:sp>
+        <p:nvSpPr>
+          <p:cNvPr id="5" name="Text 3"/>
+          <p:cNvSpPr/>
+          <p:nvPr/>
+        </p:nvSpPr>
+        <p:spPr>
+          <a:xfrm>
+            <a:off x="457200" y="3794760"/>
+            <a:ext cx="8229600" cy="320040"/>
+          </a:xfrm>
+          <a:prstGeom prst="rect">
+            <a:avLst/>
+          </a:prstGeom>
+          <a:noFill/>
+          <a:ln/>
+        </p:spPr>
+        <p:txBody>
+          <a:bodyPr wrap="square" lIns="0" tIns="0" rIns="0" bIns="0" rtlCol="0" anchor="ctr"/>
+          <a:lstStyle/>
+          <a:p>
+            <a:pPr algn="ctr" indent="0" marL="0">
+              <a:buNone/>
+            </a:pPr>
+            <a:r>
+              <a:rPr lang="en-US" sz="1100" dirty="0">
+                <a:solidFill>
+                  <a:srgbClr val="666666"/>
+                </a:solidFill>
+                <a:latin typeface="Times New Roman" pitchFamily="34" charset="0"/>
+                <a:ea typeface="Times New Roman" pitchFamily="34" charset="-122"/>
+                <a:cs typeface="Times New Roman" pitchFamily="34" charset="-120"/>
+              </a:rPr>
+              <a:t>Lic. Juan Pablo Bazán  ·  Ing. Yan Bajac  —  Orientador: D.Sc. Julio César Mello</a:t>
+            </a:r>
+            <a:endParaRPr lang="en-US" sz="1100" dirty="0"/>
           </a:p>
         </p:txBody>
       </p:sp>
@@ -8711,7 +8431,7 @@
                 <a:ea typeface="Times New Roman" pitchFamily="34" charset="-122"/>
                 <a:cs typeface="Times New Roman" pitchFamily="34" charset="-120"/>
               </a:rPr>
-              <a:t>2 / 20</a:t>
+              <a:t>2 / 19</a:t>
             </a:r>
             <a:endParaRPr lang="en-US" sz="900" dirty="0"/>
           </a:p>
@@ -8925,194 +8645,6 @@
               <a:t>9.  Conclusiones y recomendaciones</a:t>
             </a:r>
             <a:endParaRPr lang="en-US" sz="1500" dirty="0"/>
-          </a:p>
-        </p:txBody>
-      </p:sp>
-    </p:spTree>
-  </p:cSld>
-  <p:clrMapOvr>
-    <a:masterClrMapping/>
-  </p:clrMapOvr>
-</p:sld>
-</file>
-
-<file path=ppt/slides/slide20.xml><?xml version="1.0" encoding="utf-8"?>
-<p:sld xmlns:a="http://schemas.openxmlformats.org/drawingml/2006/main" xmlns:r="http://schemas.openxmlformats.org/officeDocument/2006/relationships" xmlns:p="http://schemas.openxmlformats.org/presentationml/2006/main">
-  <p:cSld name="Slide 20">
-    <p:bg>
-      <p:bgPr>
-        <a:solidFill>
-          <a:srgbClr val="FFFFFF"/>
-        </a:solidFill>
-      </p:bgPr>
-    </p:bg>
-    <p:spTree>
-      <p:nvGrpSpPr>
-        <p:cNvPr id="1" name=""/>
-        <p:cNvGrpSpPr/>
-        <p:nvPr/>
-      </p:nvGrpSpPr>
-      <p:grpSpPr>
-        <a:xfrm>
-          <a:off x="0" y="0"/>
-          <a:ext cx="0" cy="0"/>
-          <a:chOff x="0" y="0"/>
-          <a:chExt cx="0" cy="0"/>
-        </a:xfrm>
-      </p:grpSpPr>
-      <p:sp>
-        <p:nvSpPr>
-          <p:cNvPr id="2" name="Text 0"/>
-          <p:cNvSpPr/>
-          <p:nvPr/>
-        </p:nvSpPr>
-        <p:spPr>
-          <a:xfrm>
-            <a:off x="457200" y="1828800"/>
-            <a:ext cx="8229600" cy="731520"/>
-          </a:xfrm>
-          <a:prstGeom prst="rect">
-            <a:avLst/>
-          </a:prstGeom>
-          <a:noFill/>
-          <a:ln/>
-        </p:spPr>
-        <p:txBody>
-          <a:bodyPr wrap="square" lIns="0" tIns="0" rIns="0" bIns="0" rtlCol="0" anchor="ctr"/>
-          <a:lstStyle/>
-          <a:p>
-            <a:pPr algn="ctr" indent="0" marL="0">
-              <a:buNone/>
-            </a:pPr>
-            <a:r>
-              <a:rPr lang="en-US" sz="3400" b="1" dirty="0">
-                <a:solidFill>
-                  <a:srgbClr val="1A1A1A"/>
-                </a:solidFill>
-                <a:latin typeface="Times New Roman" pitchFamily="34" charset="0"/>
-                <a:ea typeface="Times New Roman" pitchFamily="34" charset="-122"/>
-                <a:cs typeface="Times New Roman" pitchFamily="34" charset="-120"/>
-              </a:rPr>
-              <a:t>Muchas gracias</a:t>
-            </a:r>
-            <a:endParaRPr lang="en-US" sz="3400" dirty="0"/>
-          </a:p>
-        </p:txBody>
-      </p:sp>
-      <p:sp>
-        <p:nvSpPr>
-          <p:cNvPr id="3" name="Text 1"/>
-          <p:cNvSpPr/>
-          <p:nvPr/>
-        </p:nvSpPr>
-        <p:spPr>
-          <a:xfrm>
-            <a:off x="457200" y="2606040"/>
-            <a:ext cx="8229600" cy="365760"/>
-          </a:xfrm>
-          <a:prstGeom prst="rect">
-            <a:avLst/>
-          </a:prstGeom>
-          <a:noFill/>
-          <a:ln/>
-        </p:spPr>
-        <p:txBody>
-          <a:bodyPr wrap="square" lIns="0" tIns="0" rIns="0" bIns="0" rtlCol="0" anchor="ctr"/>
-          <a:lstStyle/>
-          <a:p>
-            <a:pPr algn="ctr" indent="0" marL="0">
-              <a:buNone/>
-            </a:pPr>
-            <a:r>
-              <a:rPr lang="en-US" sz="1500" i="1" dirty="0">
-                <a:solidFill>
-                  <a:srgbClr val="666666"/>
-                </a:solidFill>
-                <a:latin typeface="Times New Roman" pitchFamily="34" charset="0"/>
-                <a:ea typeface="Times New Roman" pitchFamily="34" charset="-122"/>
-                <a:cs typeface="Times New Roman" pitchFamily="34" charset="-120"/>
-              </a:rPr>
-              <a:t>Preguntas y comentarios</a:t>
-            </a:r>
-            <a:endParaRPr lang="en-US" sz="1500" dirty="0"/>
-          </a:p>
-        </p:txBody>
-      </p:sp>
-      <p:sp>
-        <p:nvSpPr>
-          <p:cNvPr id="4" name="Text 2"/>
-          <p:cNvSpPr/>
-          <p:nvPr/>
-        </p:nvSpPr>
-        <p:spPr>
-          <a:xfrm>
-            <a:off x="457200" y="3383280"/>
-            <a:ext cx="8229600" cy="320040"/>
-          </a:xfrm>
-          <a:prstGeom prst="rect">
-            <a:avLst/>
-          </a:prstGeom>
-          <a:noFill/>
-          <a:ln/>
-        </p:spPr>
-        <p:txBody>
-          <a:bodyPr wrap="square" lIns="0" tIns="0" rIns="0" bIns="0" rtlCol="0" anchor="ctr"/>
-          <a:lstStyle/>
-          <a:p>
-            <a:pPr algn="ctr" indent="0" marL="0">
-              <a:buNone/>
-            </a:pPr>
-            <a:r>
-              <a:rPr lang="en-US" sz="1200" dirty="0">
-                <a:solidFill>
-                  <a:srgbClr val="8B1A1A"/>
-                </a:solidFill>
-                <a:latin typeface="Times New Roman" pitchFamily="34" charset="0"/>
-                <a:ea typeface="Times New Roman" pitchFamily="34" charset="-122"/>
-                <a:cs typeface="Times New Roman" pitchFamily="34" charset="-120"/>
-              </a:rPr>
-              <a:t>Código y experimentos reproducibles:  github.com/YanBajac/TFM_Fusion_Imagenes_Propuesta_Oficial</a:t>
-            </a:r>
-            <a:endParaRPr lang="en-US" sz="1200" dirty="0"/>
-          </a:p>
-        </p:txBody>
-      </p:sp>
-      <p:sp>
-        <p:nvSpPr>
-          <p:cNvPr id="5" name="Text 3"/>
-          <p:cNvSpPr/>
-          <p:nvPr/>
-        </p:nvSpPr>
-        <p:spPr>
-          <a:xfrm>
-            <a:off x="457200" y="3794760"/>
-            <a:ext cx="8229600" cy="320040"/>
-          </a:xfrm>
-          <a:prstGeom prst="rect">
-            <a:avLst/>
-          </a:prstGeom>
-          <a:noFill/>
-          <a:ln/>
-        </p:spPr>
-        <p:txBody>
-          <a:bodyPr wrap="square" lIns="0" tIns="0" rIns="0" bIns="0" rtlCol="0" anchor="ctr"/>
-          <a:lstStyle/>
-          <a:p>
-            <a:pPr algn="ctr" indent="0" marL="0">
-              <a:buNone/>
-            </a:pPr>
-            <a:r>
-              <a:rPr lang="en-US" sz="1100" dirty="0">
-                <a:solidFill>
-                  <a:srgbClr val="666666"/>
-                </a:solidFill>
-                <a:latin typeface="Times New Roman" pitchFamily="34" charset="0"/>
-                <a:ea typeface="Times New Roman" pitchFamily="34" charset="-122"/>
-                <a:cs typeface="Times New Roman" pitchFamily="34" charset="-120"/>
-              </a:rPr>
-              <a:t>Lic. Juan Pablo Bazán  ·  Ing. Yan Bajac  —  Orientador: D.Sc. Julio César Mello</a:t>
-            </a:r>
-            <a:endParaRPr lang="en-US" sz="1100" dirty="0"/>
           </a:p>
         </p:txBody>
       </p:sp>
@@ -9220,7 +8752,7 @@
                 <a:ea typeface="Times New Roman" pitchFamily="34" charset="-122"/>
                 <a:cs typeface="Times New Roman" pitchFamily="34" charset="-120"/>
               </a:rPr>
-              <a:t>3 / 20</a:t>
+              <a:t>3 / 19</a:t>
             </a:r>
             <a:endParaRPr lang="en-US" sz="900" dirty="0"/>
           </a:p>
@@ -9481,7 +9013,7 @@
                 <a:ea typeface="Times New Roman" pitchFamily="34" charset="-122"/>
                 <a:cs typeface="Times New Roman" pitchFamily="34" charset="-120"/>
               </a:rPr>
-              <a:t>4 / 20</a:t>
+              <a:t>4 / 19</a:t>
             </a:r>
             <a:endParaRPr lang="en-US" sz="900" dirty="0"/>
           </a:p>
@@ -9683,7 +9215,7 @@
                 <a:ea typeface="Times New Roman" pitchFamily="34" charset="-122"/>
                 <a:cs typeface="Times New Roman" pitchFamily="34" charset="-120"/>
               </a:rPr>
-              <a:t>Comparar con la fusión Top-Hat clásica y cinco métodos del estado del arte (LP, RP, DWT, DTCWT, CVT) sobre doce métricas, con pruebas de Friedman y Wilcoxon–Holm.</a:t>
+              <a:t>Comparar con la fusión Top-Hat clásica y cinco métodos del estado del arte (LP, RP, DWT, DTCWT, CVT) sobre nueve métricas, con pruebas de Friedman y Wilcoxon–Holm.</a:t>
             </a:r>
             <a:endParaRPr lang="en-US" sz="1300" dirty="0"/>
           </a:p>
@@ -9814,7 +9346,7 @@
                 <a:ea typeface="Times New Roman" pitchFamily="34" charset="-122"/>
                 <a:cs typeface="Times New Roman" pitchFamily="34" charset="-120"/>
               </a:rPr>
-              <a:t>5 / 20</a:t>
+              <a:t>5 / 19</a:t>
             </a:r>
             <a:endParaRPr lang="en-US" sz="900" dirty="0"/>
           </a:p>
@@ -9892,7 +9424,7 @@
                 <a:ea typeface="Times New Roman" pitchFamily="34" charset="-122"/>
                 <a:cs typeface="Times New Roman" pitchFamily="34" charset="-120"/>
               </a:rPr>
-              <a:t>La combinación del disco con las líneas orientadas —promediadas y sumadas— mejora la fidelidad estructural (SSIM) y reduce los artefactos (Nabf) frente a la metodología clásica de fusión Top-Hat.</a:t>
+              <a:t>La combinación del disco con las líneas orientadas —promediadas y sumadas— mejora la fidelidad estructural (SSIM) frente a la metodología clásica de fusión Top-Hat y a los métodos del estado del arte.</a:t>
             </a:r>
             <a:endParaRPr lang="en-US" sz="1350" dirty="0"/>
           </a:p>
@@ -10158,7 +9690,7 @@
                 <a:ea typeface="Times New Roman" pitchFamily="34" charset="-122"/>
                 <a:cs typeface="Times New Roman" pitchFamily="34" charset="-120"/>
               </a:rPr>
-              <a:t>6 / 20</a:t>
+              <a:t>6 / 19</a:t>
             </a:r>
             <a:endParaRPr lang="en-US" sz="900" dirty="0"/>
           </a:p>
@@ -10479,7 +10011,7 @@
                 <a:ea typeface="Times New Roman" pitchFamily="34" charset="-122"/>
                 <a:cs typeface="Times New Roman" pitchFamily="34" charset="-120"/>
               </a:rPr>
-              <a:t>7 / 20</a:t>
+              <a:t>7 / 19</a:t>
             </a:r>
             <a:endParaRPr lang="en-US" sz="900" dirty="0"/>
           </a:p>
@@ -10788,7 +10320,7 @@
                 <a:ea typeface="Times New Roman" pitchFamily="34" charset="-122"/>
                 <a:cs typeface="Times New Roman" pitchFamily="34" charset="-120"/>
               </a:rPr>
-              <a:t>8 / 20</a:t>
+              <a:t>8 / 19</a:t>
             </a:r>
             <a:endParaRPr lang="en-US" sz="900" dirty="0"/>
           </a:p>
@@ -10852,7 +10384,7 @@
                 <a:ea typeface="Times New Roman" pitchFamily="34" charset="-122"/>
                 <a:cs typeface="Times New Roman" pitchFamily="34" charset="-120"/>
               </a:rPr>
-              <a:t>Aptitud orientada a la fusión (cuatro métricas de calidad):</a:t>
+              <a:t>Aptitud publicada de Ortega y Espinoza (2025), sin pesos arbitrarios:</a:t>
             </a:r>
             <a:endParaRPr lang="en-US" sz="1300" dirty="0"/>
           </a:p>
@@ -10875,7 +10407,7 @@
         <p:spPr>
           <a:xfrm>
             <a:off x="640080" y="2148840"/>
-            <a:ext cx="3840480" cy="439826"/>
+            <a:ext cx="3383280" cy="384048"/>
           </a:xfrm>
           <a:prstGeom prst="rect">
             <a:avLst/>
@@ -10940,7 +10472,7 @@
                 <a:ea typeface="Times New Roman" pitchFamily="34" charset="-122"/>
                 <a:cs typeface="Times New Roman" pitchFamily="34" charset="-120"/>
               </a:rPr>
-              <a:t>Óptimo: r = 25, m = 0,0703 (F = 1,9843), alcanzado de forma consistente con n = 10 y T ≥ 30.</a:t>
+              <a:t>Óptimo: r = 25, m ≈ 0,07 (Fo = 1,7654), alcanzado de forma consistente con n = 10 y T ≥ 30; config operativa m = 0,0703.</a:t>
             </a:r>
             <a:endParaRPr lang="en-US" sz="1300" dirty="0"/>
           </a:p>
@@ -11074,7 +10606,7 @@
                 <a:ea typeface="Times New Roman" pitchFamily="34" charset="-122"/>
                 <a:cs typeface="Times New Roman" pitchFamily="34" charset="-120"/>
               </a:rPr>
-              <a:t>Ablación de la función de aptitud (pedido de la revisión)</a:t>
+              <a:t>6. Diseño experimental</a:t>
             </a:r>
             <a:endParaRPr lang="en-US" sz="2300" dirty="0"/>
           </a:p>
@@ -11113,46 +10645,22 @@
                 <a:ea typeface="Times New Roman" pitchFamily="34" charset="-122"/>
                 <a:cs typeface="Times New Roman" pitchFamily="34" charset="-120"/>
               </a:rPr>
-              <a:t>9 / 20</a:t>
+              <a:t>9 / 19</a:t>
             </a:r>
             <a:endParaRPr lang="en-US" sz="900" dirty="0"/>
           </a:p>
         </p:txBody>
       </p:sp>
-      <p:pic>
-        <p:nvPicPr>
-          <p:cNvPr id="4" name="Image 0" descr="C:/Users/Usuario/Documents/unv/mastertesis/tesis_mciencias_datos/docs/figures/fig_aptitud_vs_m.png">    </p:cNvPr>
-          <p:cNvPicPr>
-            <a:picLocks noChangeAspect="1"/>
-          </p:cNvPicPr>
+      <p:sp>
+        <p:nvSpPr>
+          <p:cNvPr id="4" name="Text 2"/>
+          <p:cNvSpPr/>
           <p:nvPr/>
-        </p:nvPicPr>
-        <p:blipFill>
-          <a:blip r:embed="rId1"/>
-          <a:stretch>
-            <a:fillRect/>
-          </a:stretch>
-        </p:blipFill>
+        </p:nvSpPr>
         <p:spPr>
           <a:xfrm>
-            <a:off x="411480" y="1051560"/>
-            <a:ext cx="5212080" cy="2734056"/>
-          </a:xfrm>
-          <a:prstGeom prst="rect">
-            <a:avLst/>
-          </a:prstGeom>
-        </p:spPr>
-      </p:pic>
-      <p:sp>
-        <p:nvSpPr>
-          <p:cNvPr id="5" name="Text 2"/>
-          <p:cNvSpPr/>
-          <p:nvPr/>
-        </p:nvSpPr>
-        <p:spPr>
-          <a:xfrm>
-            <a:off x="5760720" y="1051560"/>
-            <a:ext cx="2971800" cy="3291840"/>
+            <a:off x="457200" y="868680"/>
+            <a:ext cx="4023360" cy="274320"/>
           </a:xfrm>
           <a:prstGeom prst="rect">
             <a:avLst/>
@@ -11161,125 +10669,37 @@
           <a:ln/>
         </p:spPr>
         <p:txBody>
-          <a:bodyPr wrap="square" lIns="0" tIns="0" rIns="0" bIns="0" rtlCol="0" anchor="t"/>
-          <a:lstStyle/>
-          <a:p>
-            <a:pPr marL="177800" indent="-177800">
-              <a:spcAft>
-                <a:spcPts val="700"/>
-              </a:spcAft>
-              <a:buSzPct val="100000"/>
-              <a:buChar char="•"/>
-            </a:pPr>
-            <a:r>
-              <a:rPr lang="en-US" sz="1150" dirty="0">
-                <a:solidFill>
-                  <a:srgbClr val="1A1A1A"/>
-                </a:solidFill>
-                <a:latin typeface="Times New Roman" pitchFamily="34" charset="0"/>
-                <a:ea typeface="Times New Roman" pitchFamily="34" charset="-122"/>
-                <a:cs typeface="Times New Roman" pitchFamily="34" charset="-120"/>
-              </a:rPr>
-              <a:t>Mismo barrido 5×5 con la Fo del trabajo de referencia (SSIM_avg + E_n + PSNR_n) y su rango m ∈ [0,3–2,0].</a:t>
-            </a:r>
-            <a:endParaRPr lang="en-US" sz="1150" dirty="0"/>
-          </a:p>
-          <a:p>
-            <a:pPr marL="177800" indent="-177800">
-              <a:spcAft>
-                <a:spcPts val="700"/>
-              </a:spcAft>
-              <a:buSzPct val="100000"/>
-              <a:buChar char="•"/>
-            </a:pPr>
-            <a:r>
-              <a:rPr lang="en-US" sz="1150" b="1" dirty="0">
-                <a:solidFill>
-                  <a:srgbClr val="1A1A1A"/>
-                </a:solidFill>
-                <a:latin typeface="Times New Roman" pitchFamily="34" charset="0"/>
-                <a:ea typeface="Times New Roman" pitchFamily="34" charset="-122"/>
-                <a:cs typeface="Times New Roman" pitchFamily="34" charset="-120"/>
-              </a:rPr>
-              <a:t>En las 50 corridas, m* = 0,30: el piso del rango.</a:t>
-            </a:r>
-            <a:endParaRPr lang="en-US" sz="1150" dirty="0"/>
-          </a:p>
-          <a:p>
-            <a:pPr marL="177800" indent="-177800">
-              <a:spcAft>
-                <a:spcPts val="700"/>
-              </a:spcAft>
-              <a:buSzPct val="100000"/>
-              <a:buChar char="•"/>
-            </a:pPr>
-            <a:r>
-              <a:rPr lang="en-US" sz="1150" dirty="0">
-                <a:solidFill>
-                  <a:srgbClr val="1A1A1A"/>
-                </a:solidFill>
-                <a:latin typeface="Times New Roman" pitchFamily="34" charset="0"/>
-                <a:ea typeface="Times New Roman" pitchFamily="34" charset="-122"/>
-                <a:cs typeface="Times New Roman" pitchFamily="34" charset="-120"/>
-              </a:rPr>
-              <a:t>Las tres curvas decrecen en [0,5–2]: ningún tamaño de enjambre ni número de iteraciones puede converger allí.</a:t>
-            </a:r>
-            <a:endParaRPr lang="en-US" sz="1150" dirty="0"/>
-          </a:p>
-          <a:p>
-            <a:pPr marL="177800" indent="-177800">
-              <a:spcAft>
-                <a:spcPts val="700"/>
-              </a:spcAft>
-              <a:buSzPct val="100000"/>
-              <a:buChar char="•"/>
-            </a:pPr>
-            <a:r>
-              <a:rPr lang="en-US" sz="1150" b="1" dirty="0">
-                <a:solidFill>
-                  <a:srgbClr val="1A1A1A"/>
-                </a:solidFill>
-                <a:latin typeface="Times New Roman" pitchFamily="34" charset="0"/>
-                <a:ea typeface="Times New Roman" pitchFamily="34" charset="-122"/>
-                <a:cs typeface="Times New Roman" pitchFamily="34" charset="-120"/>
-              </a:rPr>
-              <a:t>El máximo real de Fo sobre la propuesta está en m ≈ 0,07 — coincide con nuestro óptimo (0,0703).</a:t>
-            </a:r>
-            <a:endParaRPr lang="en-US" sz="1150" dirty="0"/>
-          </a:p>
-          <a:p>
-            <a:pPr marL="177800" indent="-177800">
-              <a:spcAft>
-                <a:spcPts val="700"/>
-              </a:spcAft>
-              <a:buSzPct val="100000"/>
-              <a:buChar char="•"/>
-            </a:pPr>
-            <a:r>
-              <a:rPr lang="en-US" sz="1150" dirty="0">
-                <a:solidFill>
-                  <a:srgbClr val="1A1A1A"/>
-                </a:solidFill>
-                <a:latin typeface="Times New Roman" pitchFamily="34" charset="0"/>
-                <a:ea typeface="Times New Roman" pitchFamily="34" charset="-122"/>
-                <a:cs typeface="Times New Roman" pitchFamily="34" charset="-120"/>
-              </a:rPr>
-              <a:t>Sobre la propuesta, Fo elige r = 1 (óptimo trivial); sobre el clásico, r = 25 con 4,5× más artefactos que F_apt.</a:t>
-            </a:r>
-            <a:endParaRPr lang="en-US" sz="1150" dirty="0"/>
-          </a:p>
-        </p:txBody>
-      </p:sp>
-      <p:sp>
-        <p:nvSpPr>
-          <p:cNvPr id="6" name="Text 3"/>
+          <a:bodyPr wrap="square" lIns="0" tIns="0" rIns="0" bIns="0" rtlCol="0" anchor="ctr"/>
+          <a:lstStyle/>
+          <a:p>
+            <a:pPr indent="0" marL="0">
+              <a:buNone/>
+            </a:pPr>
+            <a:r>
+              <a:rPr lang="en-US" sz="1400" b="1" dirty="0">
+                <a:solidFill>
+                  <a:srgbClr val="8B1A1A"/>
+                </a:solidFill>
+                <a:latin typeface="Times New Roman" pitchFamily="34" charset="0"/>
+                <a:ea typeface="Times New Roman" pitchFamily="34" charset="-122"/>
+                <a:cs typeface="Times New Roman" pitchFamily="34" charset="-120"/>
+              </a:rPr>
+              <a:t>Benchmark de calidad</a:t>
+            </a:r>
+            <a:endParaRPr lang="en-US" sz="1400" dirty="0"/>
+          </a:p>
+        </p:txBody>
+      </p:sp>
+      <p:sp>
+        <p:nvSpPr>
+          <p:cNvPr id="5" name="Text 3"/>
           <p:cNvSpPr/>
           <p:nvPr/>
         </p:nvSpPr>
         <p:spPr>
           <a:xfrm>
-            <a:off x="457200" y="4160520"/>
-            <a:ext cx="8229600" cy="640080"/>
+            <a:off x="457200" y="1188720"/>
+            <a:ext cx="4023360" cy="3291840"/>
           </a:xfrm>
           <a:prstGeom prst="rect">
             <a:avLst/>
@@ -11288,6 +10708,112 @@
           <a:ln/>
         </p:spPr>
         <p:txBody>
+          <a:bodyPr wrap="square" lIns="0" tIns="0" rIns="0" bIns="0" rtlCol="0" anchor="t"/>
+          <a:lstStyle/>
+          <a:p>
+            <a:pPr marL="177800" indent="-177800">
+              <a:spcAft>
+                <a:spcPts val="800"/>
+              </a:spcAft>
+              <a:buSzPct val="100000"/>
+              <a:buChar char="•"/>
+            </a:pPr>
+            <a:r>
+              <a:rPr lang="en-US" sz="1250" dirty="0">
+                <a:solidFill>
+                  <a:srgbClr val="1A1A1A"/>
+                </a:solidFill>
+                <a:latin typeface="Times New Roman" pitchFamily="34" charset="0"/>
+                <a:ea typeface="Times New Roman" pitchFamily="34" charset="-122"/>
+                <a:cs typeface="Times New Roman" pitchFamily="34" charset="-120"/>
+              </a:rPr>
+              <a:t>20 pares VIS/IR del dataset TNO (Toet, 2014).</a:t>
+            </a:r>
+            <a:endParaRPr lang="en-US" sz="1250" dirty="0"/>
+          </a:p>
+          <a:p>
+            <a:pPr marL="177800" indent="-177800">
+              <a:spcAft>
+                <a:spcPts val="800"/>
+              </a:spcAft>
+              <a:buSzPct val="100000"/>
+              <a:buChar char="•"/>
+            </a:pPr>
+            <a:r>
+              <a:rPr lang="en-US" sz="1250" dirty="0">
+                <a:solidFill>
+                  <a:srgbClr val="1A1A1A"/>
+                </a:solidFill>
+                <a:latin typeface="Times New Roman" pitchFamily="34" charset="0"/>
+                <a:ea typeface="Times New Roman" pitchFamily="34" charset="-122"/>
+                <a:cs typeface="Times New Roman" pitchFamily="34" charset="-120"/>
+              </a:rPr>
+              <a:t>7 métodos: LP, RP, DWT, DTCWT, CVT, Top-Hat clásico y Propuesta → 140 fusiones.</a:t>
+            </a:r>
+            <a:endParaRPr lang="en-US" sz="1250" dirty="0"/>
+          </a:p>
+          <a:p>
+            <a:pPr marL="177800" indent="-177800">
+              <a:spcAft>
+                <a:spcPts val="800"/>
+              </a:spcAft>
+              <a:buSzPct val="100000"/>
+              <a:buChar char="•"/>
+            </a:pPr>
+            <a:r>
+              <a:rPr lang="en-US" sz="1250" dirty="0">
+                <a:solidFill>
+                  <a:srgbClr val="1A1A1A"/>
+                </a:solidFill>
+                <a:latin typeface="Times New Roman" pitchFamily="34" charset="0"/>
+                <a:ea typeface="Times New Roman" pitchFamily="34" charset="-122"/>
+                <a:cs typeface="Times New Roman" pitchFamily="34" charset="-120"/>
+              </a:rPr>
+              <a:t>Nueve métricas sin referencia (EN, SD, FE, MG, MI_vis, MI_ir, SF, SSIM, PSNR).</a:t>
+            </a:r>
+            <a:endParaRPr lang="en-US" sz="1250" dirty="0"/>
+          </a:p>
+          <a:p>
+            <a:pPr marL="177800" indent="-177800">
+              <a:spcAft>
+                <a:spcPts val="800"/>
+              </a:spcAft>
+              <a:buSzPct val="100000"/>
+              <a:buChar char="•"/>
+            </a:pPr>
+            <a:r>
+              <a:rPr lang="en-US" sz="1250" dirty="0">
+                <a:solidFill>
+                  <a:srgbClr val="1A1A1A"/>
+                </a:solidFill>
+                <a:latin typeface="Times New Roman" pitchFamily="34" charset="0"/>
+                <a:ea typeface="Times New Roman" pitchFamily="34" charset="-122"/>
+                <a:cs typeface="Times New Roman" pitchFamily="34" charset="-120"/>
+              </a:rPr>
+              <a:t>Friedman global + Wilcoxon pareado con corrección de Holm (α = 0,05).</a:t>
+            </a:r>
+            <a:endParaRPr lang="en-US" sz="1250" dirty="0"/>
+          </a:p>
+        </p:txBody>
+      </p:sp>
+      <p:sp>
+        <p:nvSpPr>
+          <p:cNvPr id="6" name="Text 4"/>
+          <p:cNvSpPr/>
+          <p:nvPr/>
+        </p:nvSpPr>
+        <p:spPr>
+          <a:xfrm>
+            <a:off x="4846320" y="868680"/>
+            <a:ext cx="3840480" cy="274320"/>
+          </a:xfrm>
+          <a:prstGeom prst="rect">
+            <a:avLst/>
+          </a:prstGeom>
+          <a:noFill/>
+          <a:ln/>
+        </p:spPr>
+        <p:txBody>
           <a:bodyPr wrap="square" lIns="0" tIns="0" rIns="0" bIns="0" rtlCol="0" anchor="ctr"/>
           <a:lstStyle/>
           <a:p>
@@ -11295,7 +10821,7 @@
               <a:buNone/>
             </a:pPr>
             <a:r>
-              <a:rPr lang="en-US" sz="1150" i="1" dirty="0">
+              <a:rPr lang="en-US" sz="1400" b="1" dirty="0">
                 <a:solidFill>
                   <a:srgbClr val="8B1A1A"/>
                 </a:solidFill>
@@ -11303,9 +10829,94 @@
                 <a:ea typeface="Times New Roman" pitchFamily="34" charset="-122"/>
                 <a:cs typeface="Times New Roman" pitchFamily="34" charset="-120"/>
               </a:rPr>
-              <a:t>Wilcoxon entre ambos óptimos: F_apt mejor y significativa en 8/12 métricas (limpieza y estructura). Ambas aptitudes acuerdan el peso del operador; F_apt controla además los artefactos (refuerza H2).</a:t>
-            </a:r>
-            <a:endParaRPr lang="en-US" sz="1150" dirty="0"/>
+              <a:t>Evaluación orientada a tarea</a:t>
+            </a:r>
+            <a:endParaRPr lang="en-US" sz="1400" dirty="0"/>
+          </a:p>
+        </p:txBody>
+      </p:sp>
+      <p:sp>
+        <p:nvSpPr>
+          <p:cNvPr id="7" name="Text 5"/>
+          <p:cNvSpPr/>
+          <p:nvPr/>
+        </p:nvSpPr>
+        <p:spPr>
+          <a:xfrm>
+            <a:off x="4846320" y="1188720"/>
+            <a:ext cx="3840480" cy="3291840"/>
+          </a:xfrm>
+          <a:prstGeom prst="rect">
+            <a:avLst/>
+          </a:prstGeom>
+          <a:noFill/>
+          <a:ln/>
+        </p:spPr>
+        <p:txBody>
+          <a:bodyPr wrap="square" lIns="0" tIns="0" rIns="0" bIns="0" rtlCol="0" anchor="t"/>
+          <a:lstStyle/>
+          <a:p>
+            <a:pPr marL="177800" indent="-177800">
+              <a:spcAft>
+                <a:spcPts val="800"/>
+              </a:spcAft>
+              <a:buSzPct val="100000"/>
+              <a:buChar char="•"/>
+            </a:pPr>
+            <a:r>
+              <a:rPr lang="en-US" sz="1250" dirty="0">
+                <a:solidFill>
+                  <a:srgbClr val="1A1A1A"/>
+                </a:solidFill>
+                <a:latin typeface="Times New Roman" pitchFamily="34" charset="0"/>
+                <a:ea typeface="Times New Roman" pitchFamily="34" charset="-122"/>
+                <a:cs typeface="Times New Roman" pitchFamily="34" charset="-120"/>
+              </a:rPr>
+              <a:t>Dataset etiquetado LLVIP (peatones nocturnos): 2.000 imágenes de entrenamiento y 500 de validación.</a:t>
+            </a:r>
+            <a:endParaRPr lang="en-US" sz="1250" dirty="0"/>
+          </a:p>
+          <a:p>
+            <a:pPr marL="177800" indent="-177800">
+              <a:spcAft>
+                <a:spcPts val="800"/>
+              </a:spcAft>
+              <a:buSzPct val="100000"/>
+              <a:buChar char="•"/>
+            </a:pPr>
+            <a:r>
+              <a:rPr lang="en-US" sz="1250" dirty="0">
+                <a:solidFill>
+                  <a:srgbClr val="1A1A1A"/>
+                </a:solidFill>
+                <a:latin typeface="Times New Roman" pitchFamily="34" charset="0"/>
+                <a:ea typeface="Times New Roman" pitchFamily="34" charset="-122"/>
+                <a:cs typeface="Times New Roman" pitchFamily="34" charset="-120"/>
+              </a:rPr>
+              <a:t>YOLOv8n reentrenado por modalidad (40 épocas), 9 entradas: VIS, IR y las 7 fusiones.</a:t>
+            </a:r>
+            <a:endParaRPr lang="en-US" sz="1250" dirty="0"/>
+          </a:p>
+          <a:p>
+            <a:pPr marL="177800" indent="-177800">
+              <a:spcAft>
+                <a:spcPts val="800"/>
+              </a:spcAft>
+              <a:buSzPct val="100000"/>
+              <a:buChar char="•"/>
+            </a:pPr>
+            <a:r>
+              <a:rPr lang="en-US" sz="1250" dirty="0">
+                <a:solidFill>
+                  <a:srgbClr val="1A1A1A"/>
+                </a:solidFill>
+                <a:latin typeface="Times New Roman" pitchFamily="34" charset="0"/>
+                <a:ea typeface="Times New Roman" pitchFamily="34" charset="-122"/>
+                <a:cs typeface="Times New Roman" pitchFamily="34" charset="-120"/>
+              </a:rPr>
+              <a:t>Etiquetas idénticas entre modalidades: la diferencia de mAP aísla el efecto del método de fusión.</a:t>
+            </a:r>
+            <a:endParaRPr lang="en-US" sz="1250" dirty="0"/>
           </a:p>
         </p:txBody>
       </p:sp>

</xml_diff>